<commit_message>
Add participating agencies list and rebalance boardroom slide layout
Show the 9 fixed-branch agencies as compact tags plus a visually
separated "Jefe Móvil" tag (roving role covering every branch, not a
fixed agency), matching the raw survey export. Tightened header/KPI/
message-box spacing so the priority matrix bands have enough height
for their tags instead of being visually cramped.

Co-Authored-By: Claude Sonnet 5 <noreply@anthropic.com>
Claude-Session: https://claude.ai/code/session_01KND4cYnTdx53ydNLfQdR3S
</commit_message>
<xml_diff>
--- a/Dashboard_Ejecutivo_EVERTEC_JuntaDirectiva.pptx
+++ b/Dashboard_Ejecutivo_EVERTEC_JuntaDirectiva.pptx
@@ -1064,7 +1064,7 @@
         </p:nvSpPr>
         <p:spPr>
           <a:xfrm>
-            <a:off x="384048" y="1371600"/>
+            <a:off x="384048" y="1225296"/>
             <a:ext cx="11423599" cy="16459"/>
           </a:xfrm>
           <a:prstGeom prst="rect">
@@ -1084,12 +1084,12 @@
         </p:nvSpPr>
         <p:spPr>
           <a:xfrm>
-            <a:off x="384048" y="1517904"/>
-            <a:ext cx="2718740" cy="749808"/>
+            <a:off x="384048" y="1353312"/>
+            <a:ext cx="2718740" cy="658368"/>
           </a:xfrm>
           <a:prstGeom prst="roundRect">
             <a:avLst>
-              <a:gd name="adj" fmla="val 8537"/>
+              <a:gd name="adj" fmla="val 9722"/>
             </a:avLst>
           </a:prstGeom>
           <a:solidFill>
@@ -1118,7 +1118,7 @@
         </p:nvSpPr>
         <p:spPr>
           <a:xfrm>
-            <a:off x="585216" y="1682496"/>
+            <a:off x="585216" y="1517904"/>
             <a:ext cx="420624" cy="420624"/>
           </a:xfrm>
           <a:prstGeom prst="ellipse">
@@ -1146,7 +1146,7 @@
         </p:blipFill>
         <p:spPr>
           <a:xfrm>
-            <a:off x="677753" y="1775033"/>
+            <a:off x="677753" y="1610441"/>
             <a:ext cx="235549" cy="235549"/>
           </a:xfrm>
           <a:prstGeom prst="rect">
@@ -1162,7 +1162,7 @@
         </p:nvSpPr>
         <p:spPr>
           <a:xfrm>
-            <a:off x="1152144" y="1636776"/>
+            <a:off x="1152144" y="1472184"/>
             <a:ext cx="1786052" cy="384048"/>
           </a:xfrm>
           <a:prstGeom prst="rect">
@@ -1201,7 +1201,7 @@
         </p:nvSpPr>
         <p:spPr>
           <a:xfrm>
-            <a:off x="585216" y="2157984"/>
+            <a:off x="585216" y="1993392"/>
             <a:ext cx="2316404" cy="182880"/>
           </a:xfrm>
           <a:prstGeom prst="rect">
@@ -1240,12 +1240,12 @@
         </p:nvSpPr>
         <p:spPr>
           <a:xfrm>
-            <a:off x="3285668" y="1517904"/>
-            <a:ext cx="2718740" cy="749808"/>
+            <a:off x="3285668" y="1353312"/>
+            <a:ext cx="2718740" cy="658368"/>
           </a:xfrm>
           <a:prstGeom prst="roundRect">
             <a:avLst>
-              <a:gd name="adj" fmla="val 8537"/>
+              <a:gd name="adj" fmla="val 9722"/>
             </a:avLst>
           </a:prstGeom>
           <a:solidFill>
@@ -1274,7 +1274,7 @@
         </p:nvSpPr>
         <p:spPr>
           <a:xfrm>
-            <a:off x="3486836" y="1682496"/>
+            <a:off x="3486836" y="1517904"/>
             <a:ext cx="420624" cy="420624"/>
           </a:xfrm>
           <a:prstGeom prst="ellipse">
@@ -1302,7 +1302,7 @@
         </p:blipFill>
         <p:spPr>
           <a:xfrm>
-            <a:off x="3579373" y="1775033"/>
+            <a:off x="3579373" y="1610441"/>
             <a:ext cx="235549" cy="235549"/>
           </a:xfrm>
           <a:prstGeom prst="rect">
@@ -1318,7 +1318,7 @@
         </p:nvSpPr>
         <p:spPr>
           <a:xfrm>
-            <a:off x="4053764" y="1636776"/>
+            <a:off x="4053764" y="1472184"/>
             <a:ext cx="1786052" cy="384048"/>
           </a:xfrm>
           <a:prstGeom prst="rect">
@@ -1357,7 +1357,7 @@
         </p:nvSpPr>
         <p:spPr>
           <a:xfrm>
-            <a:off x="3486836" y="2157984"/>
+            <a:off x="3486836" y="1993392"/>
             <a:ext cx="2316404" cy="182880"/>
           </a:xfrm>
           <a:prstGeom prst="rect">
@@ -1396,12 +1396,12 @@
         </p:nvSpPr>
         <p:spPr>
           <a:xfrm>
-            <a:off x="6187288" y="1517904"/>
-            <a:ext cx="2718740" cy="749808"/>
+            <a:off x="6187288" y="1353312"/>
+            <a:ext cx="2718740" cy="658368"/>
           </a:xfrm>
           <a:prstGeom prst="roundRect">
             <a:avLst>
-              <a:gd name="adj" fmla="val 8537"/>
+              <a:gd name="adj" fmla="val 9722"/>
             </a:avLst>
           </a:prstGeom>
           <a:solidFill>
@@ -1430,7 +1430,7 @@
         </p:nvSpPr>
         <p:spPr>
           <a:xfrm>
-            <a:off x="6388456" y="1682496"/>
+            <a:off x="6388456" y="1517904"/>
             <a:ext cx="420624" cy="420624"/>
           </a:xfrm>
           <a:prstGeom prst="ellipse">
@@ -1458,7 +1458,7 @@
         </p:blipFill>
         <p:spPr>
           <a:xfrm>
-            <a:off x="6480993" y="1775033"/>
+            <a:off x="6480993" y="1610441"/>
             <a:ext cx="235549" cy="235549"/>
           </a:xfrm>
           <a:prstGeom prst="rect">
@@ -1474,7 +1474,7 @@
         </p:nvSpPr>
         <p:spPr>
           <a:xfrm>
-            <a:off x="6955384" y="1636776"/>
+            <a:off x="6955384" y="1472184"/>
             <a:ext cx="1786052" cy="384048"/>
           </a:xfrm>
           <a:prstGeom prst="rect">
@@ -1513,7 +1513,7 @@
         </p:nvSpPr>
         <p:spPr>
           <a:xfrm>
-            <a:off x="6388456" y="2157984"/>
+            <a:off x="6388456" y="1993392"/>
             <a:ext cx="2316404" cy="182880"/>
           </a:xfrm>
           <a:prstGeom prst="rect">
@@ -1552,12 +1552,12 @@
         </p:nvSpPr>
         <p:spPr>
           <a:xfrm>
-            <a:off x="9088907" y="1517904"/>
-            <a:ext cx="2718740" cy="749808"/>
+            <a:off x="9088907" y="1353312"/>
+            <a:ext cx="2718740" cy="658368"/>
           </a:xfrm>
           <a:prstGeom prst="roundRect">
             <a:avLst>
-              <a:gd name="adj" fmla="val 8537"/>
+              <a:gd name="adj" fmla="val 9722"/>
             </a:avLst>
           </a:prstGeom>
           <a:solidFill>
@@ -1586,7 +1586,7 @@
         </p:nvSpPr>
         <p:spPr>
           <a:xfrm>
-            <a:off x="9290075" y="1682496"/>
+            <a:off x="9290075" y="1517904"/>
             <a:ext cx="420624" cy="420624"/>
           </a:xfrm>
           <a:prstGeom prst="ellipse">
@@ -1614,7 +1614,7 @@
         </p:blipFill>
         <p:spPr>
           <a:xfrm>
-            <a:off x="9382613" y="1775033"/>
+            <a:off x="9382613" y="1610441"/>
             <a:ext cx="235549" cy="235549"/>
           </a:xfrm>
           <a:prstGeom prst="rect">
@@ -1630,7 +1630,7 @@
         </p:nvSpPr>
         <p:spPr>
           <a:xfrm>
-            <a:off x="9857003" y="1636776"/>
+            <a:off x="9857003" y="1472184"/>
             <a:ext cx="1786052" cy="384048"/>
           </a:xfrm>
           <a:prstGeom prst="rect">
@@ -1669,7 +1669,7 @@
         </p:nvSpPr>
         <p:spPr>
           <a:xfrm>
-            <a:off x="9290075" y="2157984"/>
+            <a:off x="9290075" y="1993392"/>
             <a:ext cx="2316404" cy="182880"/>
           </a:xfrm>
           <a:prstGeom prst="rect">
@@ -1702,18 +1702,716 @@
       </p:sp>
       <p:sp>
         <p:nvSpPr>
-          <p:cNvPr id="28" name="Shape 22"/>
-          <p:cNvSpPr/>
-          <p:nvPr/>
-        </p:nvSpPr>
-        <p:spPr>
-          <a:xfrm>
-            <a:off x="384048" y="2468880"/>
-            <a:ext cx="4892040" cy="3383280"/>
+          <p:cNvPr id="28" name="Text 22"/>
+          <p:cNvSpPr txBox="1"/>
+          <p:nvPr/>
+        </p:nvSpPr>
+        <p:spPr>
+          <a:xfrm>
+            <a:off x="384048" y="2103120"/>
+            <a:ext cx="1828800" cy="274320"/>
+          </a:xfrm>
+          <a:prstGeom prst="rect">
+            <a:avLst/>
+          </a:prstGeom>
+          <a:noFill/>
+          <a:ln/>
+        </p:spPr>
+        <p:txBody>
+          <a:bodyPr wrap="square" lIns="0" tIns="0" rIns="0" bIns="0" rtlCol="0" anchor="ctr"/>
+          <a:lstStyle/>
+          <a:p>
+            <a:pPr algn="l" indent="0" marL="0">
+              <a:buNone/>
+            </a:pPr>
+            <a:r>
+              <a:rPr lang="en-US" sz="800" b="1" spc="40" kern="0" dirty="0">
+                <a:solidFill>
+                  <a:srgbClr val="5B6B82"/>
+                </a:solidFill>
+                <a:latin typeface="Calibri" pitchFamily="34" charset="0"/>
+                <a:ea typeface="Calibri" pitchFamily="34" charset="-122"/>
+                <a:cs typeface="Calibri" pitchFamily="34" charset="-120"/>
+              </a:rPr>
+              <a:t>AGENCIAS PARTICIPANTES</a:t>
+            </a:r>
+            <a:endParaRPr lang="en-US" sz="800" dirty="0"/>
+          </a:p>
+        </p:txBody>
+      </p:sp>
+      <p:sp>
+        <p:nvSpPr>
+          <p:cNvPr id="29" name="Shape 23"/>
+          <p:cNvSpPr/>
+          <p:nvPr/>
+        </p:nvSpPr>
+        <p:spPr>
+          <a:xfrm>
+            <a:off x="2258568" y="2130552"/>
+            <a:ext cx="816153" cy="219456"/>
           </a:xfrm>
           <a:prstGeom prst="roundRect">
             <a:avLst>
-              <a:gd name="adj" fmla="val 2162"/>
+              <a:gd name="adj" fmla="val 16667"/>
+            </a:avLst>
+          </a:prstGeom>
+          <a:solidFill>
+            <a:srgbClr val="F2F5F9"/>
+          </a:solidFill>
+          <a:ln/>
+        </p:spPr>
+      </p:sp>
+      <p:sp>
+        <p:nvSpPr>
+          <p:cNvPr id="30" name="Text 24"/>
+          <p:cNvSpPr txBox="1"/>
+          <p:nvPr/>
+        </p:nvSpPr>
+        <p:spPr>
+          <a:xfrm>
+            <a:off x="2295144" y="2130552"/>
+            <a:ext cx="743001" cy="219456"/>
+          </a:xfrm>
+          <a:prstGeom prst="rect">
+            <a:avLst/>
+          </a:prstGeom>
+          <a:noFill/>
+          <a:ln/>
+        </p:spPr>
+        <p:txBody>
+          <a:bodyPr wrap="square" lIns="0" tIns="0" rIns="0" bIns="0" rtlCol="0" anchor="ctr"/>
+          <a:lstStyle/>
+          <a:p>
+            <a:pPr algn="ctr" indent="0" marL="0">
+              <a:buNone/>
+            </a:pPr>
+            <a:r>
+              <a:rPr lang="en-US" sz="730" b="1" dirty="0">
+                <a:solidFill>
+                  <a:srgbClr val="243044"/>
+                </a:solidFill>
+                <a:latin typeface="Calibri" pitchFamily="34" charset="0"/>
+                <a:ea typeface="Calibri" pitchFamily="34" charset="-122"/>
+                <a:cs typeface="Calibri" pitchFamily="34" charset="-120"/>
+              </a:rPr>
+              <a:t>San Miguel</a:t>
+            </a:r>
+            <a:endParaRPr lang="en-US" sz="730" dirty="0"/>
+          </a:p>
+        </p:txBody>
+      </p:sp>
+      <p:sp>
+        <p:nvSpPr>
+          <p:cNvPr id="31" name="Shape 25"/>
+          <p:cNvSpPr/>
+          <p:nvPr/>
+        </p:nvSpPr>
+        <p:spPr>
+          <a:xfrm>
+            <a:off x="3138729" y="2130552"/>
+            <a:ext cx="816153" cy="219456"/>
+          </a:xfrm>
+          <a:prstGeom prst="roundRect">
+            <a:avLst>
+              <a:gd name="adj" fmla="val 16667"/>
+            </a:avLst>
+          </a:prstGeom>
+          <a:solidFill>
+            <a:srgbClr val="F2F5F9"/>
+          </a:solidFill>
+          <a:ln/>
+        </p:spPr>
+      </p:sp>
+      <p:sp>
+        <p:nvSpPr>
+          <p:cNvPr id="32" name="Text 26"/>
+          <p:cNvSpPr txBox="1"/>
+          <p:nvPr/>
+        </p:nvSpPr>
+        <p:spPr>
+          <a:xfrm>
+            <a:off x="3175305" y="2130552"/>
+            <a:ext cx="743001" cy="219456"/>
+          </a:xfrm>
+          <a:prstGeom prst="rect">
+            <a:avLst/>
+          </a:prstGeom>
+          <a:noFill/>
+          <a:ln/>
+        </p:spPr>
+        <p:txBody>
+          <a:bodyPr wrap="square" lIns="0" tIns="0" rIns="0" bIns="0" rtlCol="0" anchor="ctr"/>
+          <a:lstStyle/>
+          <a:p>
+            <a:pPr algn="ctr" indent="0" marL="0">
+              <a:buNone/>
+            </a:pPr>
+            <a:r>
+              <a:rPr lang="en-US" sz="730" b="1" dirty="0">
+                <a:solidFill>
+                  <a:srgbClr val="243044"/>
+                </a:solidFill>
+                <a:latin typeface="Calibri" pitchFamily="34" charset="0"/>
+                <a:ea typeface="Calibri" pitchFamily="34" charset="-122"/>
+                <a:cs typeface="Calibri" pitchFamily="34" charset="-120"/>
+              </a:rPr>
+              <a:t>Colonia Médica</a:t>
+            </a:r>
+            <a:endParaRPr lang="en-US" sz="730" dirty="0"/>
+          </a:p>
+        </p:txBody>
+      </p:sp>
+      <p:sp>
+        <p:nvSpPr>
+          <p:cNvPr id="33" name="Shape 27"/>
+          <p:cNvSpPr/>
+          <p:nvPr/>
+        </p:nvSpPr>
+        <p:spPr>
+          <a:xfrm>
+            <a:off x="4018890" y="2130552"/>
+            <a:ext cx="816153" cy="219456"/>
+          </a:xfrm>
+          <a:prstGeom prst="roundRect">
+            <a:avLst>
+              <a:gd name="adj" fmla="val 16667"/>
+            </a:avLst>
+          </a:prstGeom>
+          <a:solidFill>
+            <a:srgbClr val="F2F5F9"/>
+          </a:solidFill>
+          <a:ln/>
+        </p:spPr>
+      </p:sp>
+      <p:sp>
+        <p:nvSpPr>
+          <p:cNvPr id="34" name="Text 28"/>
+          <p:cNvSpPr txBox="1"/>
+          <p:nvPr/>
+        </p:nvSpPr>
+        <p:spPr>
+          <a:xfrm>
+            <a:off x="4055466" y="2130552"/>
+            <a:ext cx="743001" cy="219456"/>
+          </a:xfrm>
+          <a:prstGeom prst="rect">
+            <a:avLst/>
+          </a:prstGeom>
+          <a:noFill/>
+          <a:ln/>
+        </p:spPr>
+        <p:txBody>
+          <a:bodyPr wrap="square" lIns="0" tIns="0" rIns="0" bIns="0" rtlCol="0" anchor="ctr"/>
+          <a:lstStyle/>
+          <a:p>
+            <a:pPr algn="ctr" indent="0" marL="0">
+              <a:buNone/>
+            </a:pPr>
+            <a:r>
+              <a:rPr lang="en-US" sz="730" b="1" dirty="0">
+                <a:solidFill>
+                  <a:srgbClr val="243044"/>
+                </a:solidFill>
+                <a:latin typeface="Calibri" pitchFamily="34" charset="0"/>
+                <a:ea typeface="Calibri" pitchFamily="34" charset="-122"/>
+                <a:cs typeface="Calibri" pitchFamily="34" charset="-120"/>
+              </a:rPr>
+              <a:t>Sonsonate</a:t>
+            </a:r>
+            <a:endParaRPr lang="en-US" sz="730" dirty="0"/>
+          </a:p>
+        </p:txBody>
+      </p:sp>
+      <p:sp>
+        <p:nvSpPr>
+          <p:cNvPr id="35" name="Shape 29"/>
+          <p:cNvSpPr/>
+          <p:nvPr/>
+        </p:nvSpPr>
+        <p:spPr>
+          <a:xfrm>
+            <a:off x="4899050" y="2130552"/>
+            <a:ext cx="816153" cy="219456"/>
+          </a:xfrm>
+          <a:prstGeom prst="roundRect">
+            <a:avLst>
+              <a:gd name="adj" fmla="val 16667"/>
+            </a:avLst>
+          </a:prstGeom>
+          <a:solidFill>
+            <a:srgbClr val="F2F5F9"/>
+          </a:solidFill>
+          <a:ln/>
+        </p:spPr>
+      </p:sp>
+      <p:sp>
+        <p:nvSpPr>
+          <p:cNvPr id="36" name="Text 30"/>
+          <p:cNvSpPr txBox="1"/>
+          <p:nvPr/>
+        </p:nvSpPr>
+        <p:spPr>
+          <a:xfrm>
+            <a:off x="4935626" y="2130552"/>
+            <a:ext cx="743001" cy="219456"/>
+          </a:xfrm>
+          <a:prstGeom prst="rect">
+            <a:avLst/>
+          </a:prstGeom>
+          <a:noFill/>
+          <a:ln/>
+        </p:spPr>
+        <p:txBody>
+          <a:bodyPr wrap="square" lIns="0" tIns="0" rIns="0" bIns="0" rtlCol="0" anchor="ctr"/>
+          <a:lstStyle/>
+          <a:p>
+            <a:pPr algn="ctr" indent="0" marL="0">
+              <a:buNone/>
+            </a:pPr>
+            <a:r>
+              <a:rPr lang="en-US" sz="730" b="1" dirty="0">
+                <a:solidFill>
+                  <a:srgbClr val="243044"/>
+                </a:solidFill>
+                <a:latin typeface="Calibri" pitchFamily="34" charset="0"/>
+                <a:ea typeface="Calibri" pitchFamily="34" charset="-122"/>
+                <a:cs typeface="Calibri" pitchFamily="34" charset="-120"/>
+              </a:rPr>
+              <a:t>Santa Ana</a:t>
+            </a:r>
+            <a:endParaRPr lang="en-US" sz="730" dirty="0"/>
+          </a:p>
+        </p:txBody>
+      </p:sp>
+      <p:sp>
+        <p:nvSpPr>
+          <p:cNvPr id="37" name="Shape 31"/>
+          <p:cNvSpPr/>
+          <p:nvPr/>
+        </p:nvSpPr>
+        <p:spPr>
+          <a:xfrm>
+            <a:off x="5779211" y="2130552"/>
+            <a:ext cx="816153" cy="219456"/>
+          </a:xfrm>
+          <a:prstGeom prst="roundRect">
+            <a:avLst>
+              <a:gd name="adj" fmla="val 16667"/>
+            </a:avLst>
+          </a:prstGeom>
+          <a:solidFill>
+            <a:srgbClr val="F2F5F9"/>
+          </a:solidFill>
+          <a:ln/>
+        </p:spPr>
+      </p:sp>
+      <p:sp>
+        <p:nvSpPr>
+          <p:cNvPr id="38" name="Text 32"/>
+          <p:cNvSpPr txBox="1"/>
+          <p:nvPr/>
+        </p:nvSpPr>
+        <p:spPr>
+          <a:xfrm>
+            <a:off x="5815787" y="2130552"/>
+            <a:ext cx="743001" cy="219456"/>
+          </a:xfrm>
+          <a:prstGeom prst="rect">
+            <a:avLst/>
+          </a:prstGeom>
+          <a:noFill/>
+          <a:ln/>
+        </p:spPr>
+        <p:txBody>
+          <a:bodyPr wrap="square" lIns="0" tIns="0" rIns="0" bIns="0" rtlCol="0" anchor="ctr"/>
+          <a:lstStyle/>
+          <a:p>
+            <a:pPr algn="ctr" indent="0" marL="0">
+              <a:buNone/>
+            </a:pPr>
+            <a:r>
+              <a:rPr lang="en-US" sz="730" b="1" dirty="0">
+                <a:solidFill>
+                  <a:srgbClr val="243044"/>
+                </a:solidFill>
+                <a:latin typeface="Calibri" pitchFamily="34" charset="0"/>
+                <a:ea typeface="Calibri" pitchFamily="34" charset="-122"/>
+                <a:cs typeface="Calibri" pitchFamily="34" charset="-120"/>
+              </a:rPr>
+              <a:t>Plaza Mundo</a:t>
+            </a:r>
+            <a:endParaRPr lang="en-US" sz="730" dirty="0"/>
+          </a:p>
+        </p:txBody>
+      </p:sp>
+      <p:sp>
+        <p:nvSpPr>
+          <p:cNvPr id="39" name="Shape 33"/>
+          <p:cNvSpPr/>
+          <p:nvPr/>
+        </p:nvSpPr>
+        <p:spPr>
+          <a:xfrm>
+            <a:off x="6659372" y="2130552"/>
+            <a:ext cx="816153" cy="219456"/>
+          </a:xfrm>
+          <a:prstGeom prst="roundRect">
+            <a:avLst>
+              <a:gd name="adj" fmla="val 16667"/>
+            </a:avLst>
+          </a:prstGeom>
+          <a:solidFill>
+            <a:srgbClr val="F2F5F9"/>
+          </a:solidFill>
+          <a:ln/>
+        </p:spPr>
+      </p:sp>
+      <p:sp>
+        <p:nvSpPr>
+          <p:cNvPr id="40" name="Text 34"/>
+          <p:cNvSpPr txBox="1"/>
+          <p:nvPr/>
+        </p:nvSpPr>
+        <p:spPr>
+          <a:xfrm>
+            <a:off x="6695948" y="2130552"/>
+            <a:ext cx="743001" cy="219456"/>
+          </a:xfrm>
+          <a:prstGeom prst="rect">
+            <a:avLst/>
+          </a:prstGeom>
+          <a:noFill/>
+          <a:ln/>
+        </p:spPr>
+        <p:txBody>
+          <a:bodyPr wrap="square" lIns="0" tIns="0" rIns="0" bIns="0" rtlCol="0" anchor="ctr"/>
+          <a:lstStyle/>
+          <a:p>
+            <a:pPr algn="ctr" indent="0" marL="0">
+              <a:buNone/>
+            </a:pPr>
+            <a:r>
+              <a:rPr lang="en-US" sz="730" b="1" dirty="0">
+                <a:solidFill>
+                  <a:srgbClr val="243044"/>
+                </a:solidFill>
+                <a:latin typeface="Calibri" pitchFamily="34" charset="0"/>
+                <a:ea typeface="Calibri" pitchFamily="34" charset="-122"/>
+                <a:cs typeface="Calibri" pitchFamily="34" charset="-120"/>
+              </a:rPr>
+              <a:t>Plaza Merliot</a:t>
+            </a:r>
+            <a:endParaRPr lang="en-US" sz="730" dirty="0"/>
+          </a:p>
+        </p:txBody>
+      </p:sp>
+      <p:sp>
+        <p:nvSpPr>
+          <p:cNvPr id="41" name="Shape 35"/>
+          <p:cNvSpPr/>
+          <p:nvPr/>
+        </p:nvSpPr>
+        <p:spPr>
+          <a:xfrm>
+            <a:off x="7539533" y="2130552"/>
+            <a:ext cx="816153" cy="219456"/>
+          </a:xfrm>
+          <a:prstGeom prst="roundRect">
+            <a:avLst>
+              <a:gd name="adj" fmla="val 16667"/>
+            </a:avLst>
+          </a:prstGeom>
+          <a:solidFill>
+            <a:srgbClr val="F2F5F9"/>
+          </a:solidFill>
+          <a:ln/>
+        </p:spPr>
+      </p:sp>
+      <p:sp>
+        <p:nvSpPr>
+          <p:cNvPr id="42" name="Text 36"/>
+          <p:cNvSpPr txBox="1"/>
+          <p:nvPr/>
+        </p:nvSpPr>
+        <p:spPr>
+          <a:xfrm>
+            <a:off x="7576109" y="2130552"/>
+            <a:ext cx="743001" cy="219456"/>
+          </a:xfrm>
+          <a:prstGeom prst="rect">
+            <a:avLst/>
+          </a:prstGeom>
+          <a:noFill/>
+          <a:ln/>
+        </p:spPr>
+        <p:txBody>
+          <a:bodyPr wrap="square" lIns="0" tIns="0" rIns="0" bIns="0" rtlCol="0" anchor="ctr"/>
+          <a:lstStyle/>
+          <a:p>
+            <a:pPr algn="ctr" indent="0" marL="0">
+              <a:buNone/>
+            </a:pPr>
+            <a:r>
+              <a:rPr lang="en-US" sz="730" b="1" dirty="0">
+                <a:solidFill>
+                  <a:srgbClr val="243044"/>
+                </a:solidFill>
+                <a:latin typeface="Calibri" pitchFamily="34" charset="0"/>
+                <a:ea typeface="Calibri" pitchFamily="34" charset="-122"/>
+                <a:cs typeface="Calibri" pitchFamily="34" charset="-120"/>
+              </a:rPr>
+              <a:t>Colegio Médico</a:t>
+            </a:r>
+            <a:endParaRPr lang="en-US" sz="730" dirty="0"/>
+          </a:p>
+        </p:txBody>
+      </p:sp>
+      <p:sp>
+        <p:nvSpPr>
+          <p:cNvPr id="43" name="Shape 37"/>
+          <p:cNvSpPr/>
+          <p:nvPr/>
+        </p:nvSpPr>
+        <p:spPr>
+          <a:xfrm>
+            <a:off x="8419694" y="2130552"/>
+            <a:ext cx="816153" cy="219456"/>
+          </a:xfrm>
+          <a:prstGeom prst="roundRect">
+            <a:avLst>
+              <a:gd name="adj" fmla="val 16667"/>
+            </a:avLst>
+          </a:prstGeom>
+          <a:solidFill>
+            <a:srgbClr val="F2F5F9"/>
+          </a:solidFill>
+          <a:ln/>
+        </p:spPr>
+      </p:sp>
+      <p:sp>
+        <p:nvSpPr>
+          <p:cNvPr id="44" name="Text 38"/>
+          <p:cNvSpPr txBox="1"/>
+          <p:nvPr/>
+        </p:nvSpPr>
+        <p:spPr>
+          <a:xfrm>
+            <a:off x="8456270" y="2130552"/>
+            <a:ext cx="743001" cy="219456"/>
+          </a:xfrm>
+          <a:prstGeom prst="rect">
+            <a:avLst/>
+          </a:prstGeom>
+          <a:noFill/>
+          <a:ln/>
+        </p:spPr>
+        <p:txBody>
+          <a:bodyPr wrap="square" lIns="0" tIns="0" rIns="0" bIns="0" rtlCol="0" anchor="ctr"/>
+          <a:lstStyle/>
+          <a:p>
+            <a:pPr algn="ctr" indent="0" marL="0">
+              <a:buNone/>
+            </a:pPr>
+            <a:r>
+              <a:rPr lang="en-US" sz="730" b="1" dirty="0">
+                <a:solidFill>
+                  <a:srgbClr val="243044"/>
+                </a:solidFill>
+                <a:latin typeface="Calibri" pitchFamily="34" charset="0"/>
+                <a:ea typeface="Calibri" pitchFamily="34" charset="-122"/>
+                <a:cs typeface="Calibri" pitchFamily="34" charset="-120"/>
+              </a:rPr>
+              <a:t>Usulután</a:t>
+            </a:r>
+            <a:endParaRPr lang="en-US" sz="730" dirty="0"/>
+          </a:p>
+        </p:txBody>
+      </p:sp>
+      <p:sp>
+        <p:nvSpPr>
+          <p:cNvPr id="45" name="Shape 39"/>
+          <p:cNvSpPr/>
+          <p:nvPr/>
+        </p:nvSpPr>
+        <p:spPr>
+          <a:xfrm>
+            <a:off x="9299854" y="2130552"/>
+            <a:ext cx="816153" cy="219456"/>
+          </a:xfrm>
+          <a:prstGeom prst="roundRect">
+            <a:avLst>
+              <a:gd name="adj" fmla="val 16667"/>
+            </a:avLst>
+          </a:prstGeom>
+          <a:solidFill>
+            <a:srgbClr val="F2F5F9"/>
+          </a:solidFill>
+          <a:ln/>
+        </p:spPr>
+      </p:sp>
+      <p:sp>
+        <p:nvSpPr>
+          <p:cNvPr id="46" name="Text 40"/>
+          <p:cNvSpPr txBox="1"/>
+          <p:nvPr/>
+        </p:nvSpPr>
+        <p:spPr>
+          <a:xfrm>
+            <a:off x="9336430" y="2130552"/>
+            <a:ext cx="743001" cy="219456"/>
+          </a:xfrm>
+          <a:prstGeom prst="rect">
+            <a:avLst/>
+          </a:prstGeom>
+          <a:noFill/>
+          <a:ln/>
+        </p:spPr>
+        <p:txBody>
+          <a:bodyPr wrap="square" lIns="0" tIns="0" rIns="0" bIns="0" rtlCol="0" anchor="ctr"/>
+          <a:lstStyle/>
+          <a:p>
+            <a:pPr algn="ctr" indent="0" marL="0">
+              <a:buNone/>
+            </a:pPr>
+            <a:r>
+              <a:rPr lang="en-US" sz="730" b="1" dirty="0">
+                <a:solidFill>
+                  <a:srgbClr val="243044"/>
+                </a:solidFill>
+                <a:latin typeface="Calibri" pitchFamily="34" charset="0"/>
+                <a:ea typeface="Calibri" pitchFamily="34" charset="-122"/>
+                <a:cs typeface="Calibri" pitchFamily="34" charset="-120"/>
+              </a:rPr>
+              <a:t>Central</a:t>
+            </a:r>
+            <a:endParaRPr lang="en-US" sz="730" dirty="0"/>
+          </a:p>
+        </p:txBody>
+      </p:sp>
+      <p:sp>
+        <p:nvSpPr>
+          <p:cNvPr id="47" name="Shape 41"/>
+          <p:cNvSpPr/>
+          <p:nvPr/>
+        </p:nvSpPr>
+        <p:spPr>
+          <a:xfrm>
+            <a:off x="10161727" y="2103120"/>
+            <a:ext cx="1645920" cy="274320"/>
+          </a:xfrm>
+          <a:prstGeom prst="roundRect">
+            <a:avLst>
+              <a:gd name="adj" fmla="val 20000"/>
+            </a:avLst>
+          </a:prstGeom>
+          <a:solidFill>
+            <a:srgbClr val="E8F1FA"/>
+          </a:solidFill>
+          <a:ln w="9525">
+            <a:solidFill>
+              <a:srgbClr val="1D63A1"/>
+            </a:solidFill>
+            <a:prstDash val="solid"/>
+          </a:ln>
+        </p:spPr>
+      </p:sp>
+      <p:pic>
+        <p:nvPicPr>
+          <p:cNvPr id="48" name="Image 4" descr="/tmp/claude-0/-home-user-riesgo/579fb8c8-70e5-51d5-80ec-6ed51cc2e8df/scratchpad/pptx-build/icons/truck_1D63A1.png">    </p:cNvPr>
+          <p:cNvPicPr>
+            <a:picLocks noChangeAspect="1"/>
+          </p:cNvPicPr>
+          <p:nvPr/>
+        </p:nvPicPr>
+        <p:blipFill>
+          <a:blip r:embed="rId5"/>
+          <a:stretch>
+            <a:fillRect/>
+          </a:stretch>
+        </p:blipFill>
+        <p:spPr>
+          <a:xfrm>
+            <a:off x="10234879" y="2157984"/>
+            <a:ext cx="164592" cy="164592"/>
+          </a:xfrm>
+          <a:prstGeom prst="rect">
+            <a:avLst/>
+          </a:prstGeom>
+        </p:spPr>
+      </p:pic>
+      <p:sp>
+        <p:nvSpPr>
+          <p:cNvPr id="49" name="Text 42"/>
+          <p:cNvSpPr txBox="1"/>
+          <p:nvPr/>
+        </p:nvSpPr>
+        <p:spPr>
+          <a:xfrm>
+            <a:off x="10436047" y="2103120"/>
+            <a:ext cx="1325880" cy="274320"/>
+          </a:xfrm>
+          <a:prstGeom prst="rect">
+            <a:avLst/>
+          </a:prstGeom>
+          <a:noFill/>
+          <a:ln/>
+        </p:spPr>
+        <p:txBody>
+          <a:bodyPr wrap="square" lIns="0" tIns="0" rIns="0" bIns="0" rtlCol="0" anchor="ctr"/>
+          <a:lstStyle/>
+          <a:p>
+            <a:pPr algn="l" indent="0" marL="0">
+              <a:lnSpc>
+                <a:spcPct val="100000"/>
+              </a:lnSpc>
+              <a:buNone/>
+            </a:pPr>
+            <a:r>
+              <a:rPr lang="en-US" sz="760" b="1" dirty="0">
+                <a:solidFill>
+                  <a:srgbClr val="1D63A1"/>
+                </a:solidFill>
+                <a:latin typeface="Calibri" pitchFamily="34" charset="0"/>
+                <a:ea typeface="Calibri" pitchFamily="34" charset="-122"/>
+                <a:cs typeface="Calibri" pitchFamily="34" charset="-120"/>
+              </a:rPr>
+              <a:t>Jefe Móvil </a:t>
+            </a:r>
+            <a:pPr algn="l" indent="0" marL="0">
+              <a:lnSpc>
+                <a:spcPct val="100000"/>
+              </a:lnSpc>
+              <a:buNone/>
+            </a:pPr>
+            <a:r>
+              <a:rPr lang="en-US" sz="660" i="1" dirty="0">
+                <a:solidFill>
+                  <a:srgbClr val="1D63A1"/>
+                </a:solidFill>
+                <a:latin typeface="Calibri" pitchFamily="34" charset="0"/>
+                <a:ea typeface="Calibri" pitchFamily="34" charset="-122"/>
+                <a:cs typeface="Calibri" pitchFamily="34" charset="-120"/>
+              </a:rPr>
+              <a:t>— cobertura nacional</a:t>
+            </a:r>
+            <a:endParaRPr lang="en-US" sz="760" dirty="0"/>
+          </a:p>
+        </p:txBody>
+      </p:sp>
+      <p:sp>
+        <p:nvSpPr>
+          <p:cNvPr id="50" name="Shape 43"/>
+          <p:cNvSpPr/>
+          <p:nvPr/>
+        </p:nvSpPr>
+        <p:spPr>
+          <a:xfrm>
+            <a:off x="384048" y="2487168"/>
+            <a:ext cx="4892040" cy="3547872"/>
+          </a:xfrm>
+          <a:prstGeom prst="roundRect">
+            <a:avLst>
+              <a:gd name="adj" fmla="val 2062"/>
             </a:avLst>
           </a:prstGeom>
           <a:solidFill>
@@ -1736,13 +2434,13 @@
       </p:sp>
       <p:sp>
         <p:nvSpPr>
-          <p:cNvPr id="29" name="Shape 23"/>
-          <p:cNvSpPr/>
-          <p:nvPr/>
-        </p:nvSpPr>
-        <p:spPr>
-          <a:xfrm>
-            <a:off x="384048" y="2468880"/>
+          <p:cNvPr id="51" name="Shape 44"/>
+          <p:cNvSpPr/>
+          <p:nvPr/>
+        </p:nvSpPr>
+        <p:spPr>
+          <a:xfrm>
+            <a:off x="384048" y="2487168"/>
             <a:ext cx="4892040" cy="45720"/>
           </a:xfrm>
           <a:prstGeom prst="rect">
@@ -1756,18 +2454,18 @@
       </p:sp>
       <p:sp>
         <p:nvSpPr>
-          <p:cNvPr id="30" name="Shape 24"/>
-          <p:cNvSpPr/>
-          <p:nvPr/>
-        </p:nvSpPr>
-        <p:spPr>
-          <a:xfrm>
-            <a:off x="384048" y="2468880"/>
-            <a:ext cx="4892040" cy="3383280"/>
+          <p:cNvPr id="52" name="Shape 45"/>
+          <p:cNvSpPr/>
+          <p:nvPr/>
+        </p:nvSpPr>
+        <p:spPr>
+          <a:xfrm>
+            <a:off x="384048" y="2487168"/>
+            <a:ext cx="4892040" cy="3547872"/>
           </a:xfrm>
           <a:prstGeom prst="roundRect">
             <a:avLst>
-              <a:gd name="adj" fmla="val 1892"/>
+              <a:gd name="adj" fmla="val 1804"/>
             </a:avLst>
           </a:prstGeom>
           <a:solidFill>
@@ -1790,14 +2488,14 @@
       </p:sp>
       <p:sp>
         <p:nvSpPr>
-          <p:cNvPr id="31" name="Shape 25"/>
-          <p:cNvSpPr/>
-          <p:nvPr/>
-        </p:nvSpPr>
-        <p:spPr>
-          <a:xfrm>
-            <a:off x="566928" y="2633472"/>
-            <a:ext cx="274320" cy="274320"/>
+          <p:cNvPr id="53" name="Shape 46"/>
+          <p:cNvSpPr/>
+          <p:nvPr/>
+        </p:nvSpPr>
+        <p:spPr>
+          <a:xfrm>
+            <a:off x="548640" y="2615184"/>
+            <a:ext cx="201168" cy="201168"/>
           </a:xfrm>
           <a:prstGeom prst="ellipse">
             <a:avLst/>
@@ -1810,22 +2508,22 @@
       </p:sp>
       <p:pic>
         <p:nvPicPr>
-          <p:cNvPr id="32" name="Image 4" descr="/tmp/claude-0/-home-user-riesgo/579fb8c8-70e5-51d5-80ec-6ed51cc2e8df/scratchpad/pptx-build/icons/thumbsup_1E8449.png">    </p:cNvPr>
+          <p:cNvPr id="54" name="Image 5" descr="/tmp/claude-0/-home-user-riesgo/579fb8c8-70e5-51d5-80ec-6ed51cc2e8df/scratchpad/pptx-build/icons/thumbsup_1E8449.png">    </p:cNvPr>
           <p:cNvPicPr>
             <a:picLocks noChangeAspect="1"/>
           </p:cNvPicPr>
           <p:nvPr/>
         </p:nvPicPr>
         <p:blipFill>
-          <a:blip r:embed="rId5"/>
+          <a:blip r:embed="rId6"/>
           <a:stretch>
             <a:fillRect/>
           </a:stretch>
         </p:blipFill>
         <p:spPr>
           <a:xfrm>
-            <a:off x="621792" y="2688336"/>
-            <a:ext cx="164592" cy="164592"/>
+            <a:off x="588874" y="2655418"/>
+            <a:ext cx="120701" cy="120701"/>
           </a:xfrm>
           <a:prstGeom prst="rect">
             <a:avLst/>
@@ -1834,14 +2532,14 @@
       </p:pic>
       <p:sp>
         <p:nvSpPr>
-          <p:cNvPr id="33" name="Text 26"/>
+          <p:cNvPr id="55" name="Text 47"/>
           <p:cNvSpPr txBox="1"/>
           <p:nvPr/>
         </p:nvSpPr>
         <p:spPr>
           <a:xfrm>
-            <a:off x="969264" y="2606040"/>
-            <a:ext cx="4123944" cy="329184"/>
+            <a:off x="859536" y="2587752"/>
+            <a:ext cx="4251960" cy="256032"/>
           </a:xfrm>
           <a:prstGeom prst="rect">
             <a:avLst/>
@@ -1857,7 +2555,7 @@
               <a:buNone/>
             </a:pPr>
             <a:r>
-              <a:rPr lang="en-US" sz="1350" b="1" dirty="0">
+              <a:rPr lang="en-US" sz="1150" b="1" dirty="0">
                 <a:solidFill>
                   <a:srgbClr val="1E8449"/>
                 </a:solidFill>
@@ -1867,27 +2565,27 @@
               </a:rPr>
               <a:t>Fortalezas del Servicio</a:t>
             </a:r>
-            <a:endParaRPr lang="en-US" sz="1350" dirty="0"/>
+            <a:endParaRPr lang="en-US" sz="1150" dirty="0"/>
           </a:p>
         </p:txBody>
       </p:sp>
       <p:pic>
         <p:nvPicPr>
-          <p:cNvPr id="34" name="Image 5" descr="/tmp/claude-0/-home-user-riesgo/579fb8c8-70e5-51d5-80ec-6ed51cc2e8df/scratchpad/pptx-build/icons/checkcircle_1E8449.png">    </p:cNvPr>
+          <p:cNvPr id="56" name="Image 6" descr="/tmp/claude-0/-home-user-riesgo/579fb8c8-70e5-51d5-80ec-6ed51cc2e8df/scratchpad/pptx-build/icons/checkcircle_1E8449.png">    </p:cNvPr>
           <p:cNvPicPr>
             <a:picLocks noChangeAspect="1"/>
           </p:cNvPicPr>
           <p:nvPr/>
         </p:nvPicPr>
         <p:blipFill>
-          <a:blip r:embed="rId6"/>
+          <a:blip r:embed="rId7"/>
           <a:stretch>
             <a:fillRect/>
           </a:stretch>
         </p:blipFill>
         <p:spPr>
           <a:xfrm>
-            <a:off x="603504" y="3118104"/>
+            <a:off x="603504" y="2971800"/>
             <a:ext cx="182880" cy="182880"/>
           </a:xfrm>
           <a:prstGeom prst="rect">
@@ -1897,13 +2595,13 @@
       </p:pic>
       <p:sp>
         <p:nvSpPr>
-          <p:cNvPr id="35" name="Text 27"/>
+          <p:cNvPr id="57" name="Text 48"/>
           <p:cNvSpPr txBox="1"/>
           <p:nvPr/>
         </p:nvSpPr>
         <p:spPr>
           <a:xfrm>
-            <a:off x="914400" y="3081528"/>
+            <a:off x="914400" y="2935224"/>
             <a:ext cx="4142232" cy="274320"/>
           </a:xfrm>
           <a:prstGeom prst="rect">
@@ -1939,21 +2637,21 @@
       </p:sp>
       <p:pic>
         <p:nvPicPr>
-          <p:cNvPr id="36" name="Image 6" descr="/tmp/claude-0/-home-user-riesgo/579fb8c8-70e5-51d5-80ec-6ed51cc2e8df/scratchpad/pptx-build/icons/checkcircle_1E8449.png">    </p:cNvPr>
+          <p:cNvPr id="58" name="Image 7" descr="/tmp/claude-0/-home-user-riesgo/579fb8c8-70e5-51d5-80ec-6ed51cc2e8df/scratchpad/pptx-build/icons/checkcircle_1E8449.png">    </p:cNvPr>
           <p:cNvPicPr>
             <a:picLocks noChangeAspect="1"/>
           </p:cNvPicPr>
           <p:nvPr/>
         </p:nvPicPr>
         <p:blipFill>
-          <a:blip r:embed="rId7"/>
+          <a:blip r:embed="rId8"/>
           <a:stretch>
             <a:fillRect/>
           </a:stretch>
         </p:blipFill>
         <p:spPr>
           <a:xfrm>
-            <a:off x="603504" y="3465576"/>
+            <a:off x="603504" y="3319272"/>
             <a:ext cx="182880" cy="182880"/>
           </a:xfrm>
           <a:prstGeom prst="rect">
@@ -1963,13 +2661,13 @@
       </p:pic>
       <p:sp>
         <p:nvSpPr>
-          <p:cNvPr id="37" name="Text 28"/>
+          <p:cNvPr id="59" name="Text 49"/>
           <p:cNvSpPr txBox="1"/>
           <p:nvPr/>
         </p:nvSpPr>
         <p:spPr>
           <a:xfrm>
-            <a:off x="914400" y="3429000"/>
+            <a:off x="914400" y="3282696"/>
             <a:ext cx="4142232" cy="274320"/>
           </a:xfrm>
           <a:prstGeom prst="rect">
@@ -2005,21 +2703,21 @@
       </p:sp>
       <p:pic>
         <p:nvPicPr>
-          <p:cNvPr id="38" name="Image 7" descr="/tmp/claude-0/-home-user-riesgo/579fb8c8-70e5-51d5-80ec-6ed51cc2e8df/scratchpad/pptx-build/icons/checkcircle_1E8449.png">    </p:cNvPr>
+          <p:cNvPr id="60" name="Image 8" descr="/tmp/claude-0/-home-user-riesgo/579fb8c8-70e5-51d5-80ec-6ed51cc2e8df/scratchpad/pptx-build/icons/checkcircle_1E8449.png">    </p:cNvPr>
           <p:cNvPicPr>
             <a:picLocks noChangeAspect="1"/>
           </p:cNvPicPr>
           <p:nvPr/>
         </p:nvPicPr>
         <p:blipFill>
-          <a:blip r:embed="rId8"/>
+          <a:blip r:embed="rId9"/>
           <a:stretch>
             <a:fillRect/>
           </a:stretch>
         </p:blipFill>
         <p:spPr>
           <a:xfrm>
-            <a:off x="603504" y="3813048"/>
+            <a:off x="603504" y="3666744"/>
             <a:ext cx="182880" cy="182880"/>
           </a:xfrm>
           <a:prstGeom prst="rect">
@@ -2029,13 +2727,13 @@
       </p:pic>
       <p:sp>
         <p:nvSpPr>
-          <p:cNvPr id="39" name="Text 29"/>
+          <p:cNvPr id="61" name="Text 50"/>
           <p:cNvSpPr txBox="1"/>
           <p:nvPr/>
         </p:nvSpPr>
         <p:spPr>
           <a:xfrm>
-            <a:off x="914400" y="3776472"/>
+            <a:off x="914400" y="3630168"/>
             <a:ext cx="4142232" cy="274320"/>
           </a:xfrm>
           <a:prstGeom prst="rect">
@@ -2071,21 +2769,21 @@
       </p:sp>
       <p:pic>
         <p:nvPicPr>
-          <p:cNvPr id="40" name="Image 8" descr="/tmp/claude-0/-home-user-riesgo/579fb8c8-70e5-51d5-80ec-6ed51cc2e8df/scratchpad/pptx-build/icons/checkcircle_1E8449.png">    </p:cNvPr>
+          <p:cNvPr id="62" name="Image 9" descr="/tmp/claude-0/-home-user-riesgo/579fb8c8-70e5-51d5-80ec-6ed51cc2e8df/scratchpad/pptx-build/icons/checkcircle_1E8449.png">    </p:cNvPr>
           <p:cNvPicPr>
             <a:picLocks noChangeAspect="1"/>
           </p:cNvPicPr>
           <p:nvPr/>
         </p:nvPicPr>
         <p:blipFill>
-          <a:blip r:embed="rId9"/>
+          <a:blip r:embed="rId10"/>
           <a:stretch>
             <a:fillRect/>
           </a:stretch>
         </p:blipFill>
         <p:spPr>
           <a:xfrm>
-            <a:off x="603504" y="4160520"/>
+            <a:off x="603504" y="4014216"/>
             <a:ext cx="182880" cy="182880"/>
           </a:xfrm>
           <a:prstGeom prst="rect">
@@ -2095,13 +2793,13 @@
       </p:pic>
       <p:sp>
         <p:nvSpPr>
-          <p:cNvPr id="41" name="Text 30"/>
+          <p:cNvPr id="63" name="Text 51"/>
           <p:cNvSpPr txBox="1"/>
           <p:nvPr/>
         </p:nvSpPr>
         <p:spPr>
           <a:xfrm>
-            <a:off x="914400" y="4123944"/>
+            <a:off x="914400" y="3977640"/>
             <a:ext cx="4142232" cy="274320"/>
           </a:xfrm>
           <a:prstGeom prst="rect">
@@ -2137,21 +2835,21 @@
       </p:sp>
       <p:pic>
         <p:nvPicPr>
-          <p:cNvPr id="42" name="Image 9" descr="/tmp/claude-0/-home-user-riesgo/579fb8c8-70e5-51d5-80ec-6ed51cc2e8df/scratchpad/pptx-build/icons/checkcircle_1E8449.png">    </p:cNvPr>
+          <p:cNvPr id="64" name="Image 10" descr="/tmp/claude-0/-home-user-riesgo/579fb8c8-70e5-51d5-80ec-6ed51cc2e8df/scratchpad/pptx-build/icons/checkcircle_1E8449.png">    </p:cNvPr>
           <p:cNvPicPr>
             <a:picLocks noChangeAspect="1"/>
           </p:cNvPicPr>
           <p:nvPr/>
         </p:nvPicPr>
         <p:blipFill>
-          <a:blip r:embed="rId10"/>
+          <a:blip r:embed="rId11"/>
           <a:stretch>
             <a:fillRect/>
           </a:stretch>
         </p:blipFill>
         <p:spPr>
           <a:xfrm>
-            <a:off x="603504" y="4507992"/>
+            <a:off x="603504" y="4361688"/>
             <a:ext cx="182880" cy="182880"/>
           </a:xfrm>
           <a:prstGeom prst="rect">
@@ -2161,13 +2859,13 @@
       </p:pic>
       <p:sp>
         <p:nvSpPr>
-          <p:cNvPr id="43" name="Text 31"/>
+          <p:cNvPr id="65" name="Text 52"/>
           <p:cNvSpPr txBox="1"/>
           <p:nvPr/>
         </p:nvSpPr>
         <p:spPr>
           <a:xfrm>
-            <a:off x="914400" y="4471416"/>
+            <a:off x="914400" y="4325112"/>
             <a:ext cx="4142232" cy="420624"/>
           </a:xfrm>
           <a:prstGeom prst="rect">
@@ -2203,18 +2901,18 @@
       </p:sp>
       <p:sp>
         <p:nvSpPr>
-          <p:cNvPr id="44" name="Shape 32"/>
-          <p:cNvSpPr/>
-          <p:nvPr/>
-        </p:nvSpPr>
-        <p:spPr>
-          <a:xfrm>
-            <a:off x="5495544" y="2468880"/>
-            <a:ext cx="6312103" cy="1826971"/>
+          <p:cNvPr id="66" name="Shape 53"/>
+          <p:cNvSpPr/>
+          <p:nvPr/>
+        </p:nvSpPr>
+        <p:spPr>
+          <a:xfrm>
+            <a:off x="5458968" y="2487168"/>
+            <a:ext cx="6348679" cy="1632021"/>
           </a:xfrm>
           <a:prstGeom prst="roundRect">
             <a:avLst>
-              <a:gd name="adj" fmla="val 4004"/>
+              <a:gd name="adj" fmla="val 4482"/>
             </a:avLst>
           </a:prstGeom>
           <a:solidFill>
@@ -2237,14 +2935,14 @@
       </p:sp>
       <p:sp>
         <p:nvSpPr>
-          <p:cNvPr id="45" name="Shape 33"/>
-          <p:cNvSpPr/>
-          <p:nvPr/>
-        </p:nvSpPr>
-        <p:spPr>
-          <a:xfrm>
-            <a:off x="5495544" y="2468880"/>
-            <a:ext cx="6312103" cy="45720"/>
+          <p:cNvPr id="67" name="Shape 54"/>
+          <p:cNvSpPr/>
+          <p:nvPr/>
+        </p:nvSpPr>
+        <p:spPr>
+          <a:xfrm>
+            <a:off x="5458968" y="2487168"/>
+            <a:ext cx="6348679" cy="45720"/>
           </a:xfrm>
           <a:prstGeom prst="rect">
             <a:avLst/>
@@ -2257,18 +2955,18 @@
       </p:sp>
       <p:sp>
         <p:nvSpPr>
-          <p:cNvPr id="46" name="Shape 34"/>
-          <p:cNvSpPr/>
-          <p:nvPr/>
-        </p:nvSpPr>
-        <p:spPr>
-          <a:xfrm>
-            <a:off x="5495544" y="2468880"/>
-            <a:ext cx="6312103" cy="1826971"/>
+          <p:cNvPr id="68" name="Shape 55"/>
+          <p:cNvSpPr/>
+          <p:nvPr/>
+        </p:nvSpPr>
+        <p:spPr>
+          <a:xfrm>
+            <a:off x="5458968" y="2487168"/>
+            <a:ext cx="6348679" cy="1632021"/>
           </a:xfrm>
           <a:prstGeom prst="roundRect">
             <a:avLst>
-              <a:gd name="adj" fmla="val 3504"/>
+              <a:gd name="adj" fmla="val 3922"/>
             </a:avLst>
           </a:prstGeom>
           <a:solidFill>
@@ -2291,14 +2989,14 @@
       </p:sp>
       <p:sp>
         <p:nvSpPr>
-          <p:cNvPr id="47" name="Shape 35"/>
-          <p:cNvSpPr/>
-          <p:nvPr/>
-        </p:nvSpPr>
-        <p:spPr>
-          <a:xfrm>
-            <a:off x="5678424" y="2633472"/>
-            <a:ext cx="274320" cy="274320"/>
+          <p:cNvPr id="69" name="Shape 56"/>
+          <p:cNvSpPr/>
+          <p:nvPr/>
+        </p:nvSpPr>
+        <p:spPr>
+          <a:xfrm>
+            <a:off x="5623560" y="2615184"/>
+            <a:ext cx="201168" cy="201168"/>
           </a:xfrm>
           <a:prstGeom prst="ellipse">
             <a:avLst/>
@@ -2311,22 +3009,22 @@
       </p:sp>
       <p:pic>
         <p:nvPicPr>
-          <p:cNvPr id="48" name="Image 10" descr="/tmp/claude-0/-home-user-riesgo/579fb8c8-70e5-51d5-80ec-6ed51cc2e8df/scratchpad/pptx-build/icons/alerttriangle_E0392B.png">    </p:cNvPr>
+          <p:cNvPr id="70" name="Image 11" descr="/tmp/claude-0/-home-user-riesgo/579fb8c8-70e5-51d5-80ec-6ed51cc2e8df/scratchpad/pptx-build/icons/alerttriangle_E0392B.png">    </p:cNvPr>
           <p:cNvPicPr>
             <a:picLocks noChangeAspect="1"/>
           </p:cNvPicPr>
           <p:nvPr/>
         </p:nvPicPr>
         <p:blipFill>
-          <a:blip r:embed="rId11"/>
+          <a:blip r:embed="rId12"/>
           <a:stretch>
             <a:fillRect/>
           </a:stretch>
         </p:blipFill>
         <p:spPr>
           <a:xfrm>
-            <a:off x="5733288" y="2688336"/>
-            <a:ext cx="164592" cy="164592"/>
+            <a:off x="5663794" y="2655418"/>
+            <a:ext cx="120701" cy="120701"/>
           </a:xfrm>
           <a:prstGeom prst="rect">
             <a:avLst/>
@@ -2335,14 +3033,14 @@
       </p:pic>
       <p:sp>
         <p:nvSpPr>
-          <p:cNvPr id="49" name="Text 36"/>
+          <p:cNvPr id="71" name="Text 57"/>
           <p:cNvSpPr txBox="1"/>
           <p:nvPr/>
         </p:nvSpPr>
         <p:spPr>
           <a:xfrm>
-            <a:off x="6080760" y="2606040"/>
-            <a:ext cx="5544007" cy="329184"/>
+            <a:off x="5934456" y="2587752"/>
+            <a:ext cx="5708599" cy="256032"/>
           </a:xfrm>
           <a:prstGeom prst="rect">
             <a:avLst/>
@@ -2358,7 +3056,7 @@
               <a:buNone/>
             </a:pPr>
             <a:r>
-              <a:rPr lang="en-US" sz="1350" b="1" dirty="0">
+              <a:rPr lang="en-US" sz="1150" b="1" dirty="0">
                 <a:solidFill>
                   <a:srgbClr val="E0392B"/>
                 </a:solidFill>
@@ -2368,24 +3066,24 @@
               </a:rPr>
               <a:t>Principales Oportunidades de Mejora</a:t>
             </a:r>
-            <a:endParaRPr lang="en-US" sz="1350" dirty="0"/>
-          </a:p>
-        </p:txBody>
-      </p:sp>
-      <p:sp>
-        <p:nvSpPr>
-          <p:cNvPr id="50" name="Shape 37"/>
-          <p:cNvSpPr/>
-          <p:nvPr/>
-        </p:nvSpPr>
-        <p:spPr>
-          <a:xfrm>
-            <a:off x="5715000" y="3108960"/>
-            <a:ext cx="2863444" cy="264719"/>
+            <a:endParaRPr lang="en-US" sz="1150" dirty="0"/>
+          </a:p>
+        </p:txBody>
+      </p:sp>
+      <p:sp>
+        <p:nvSpPr>
+          <p:cNvPr id="72" name="Shape 58"/>
+          <p:cNvSpPr/>
+          <p:nvPr/>
+        </p:nvSpPr>
+        <p:spPr>
+          <a:xfrm>
+            <a:off x="5678424" y="2944368"/>
+            <a:ext cx="2890876" cy="244556"/>
           </a:xfrm>
           <a:prstGeom prst="roundRect">
             <a:avLst>
-              <a:gd name="adj" fmla="val 20725"/>
+              <a:gd name="adj" fmla="val 22434"/>
             </a:avLst>
           </a:prstGeom>
           <a:solidFill>
@@ -2396,21 +3094,21 @@
       </p:sp>
       <p:pic>
         <p:nvPicPr>
-          <p:cNvPr id="51" name="Image 11" descr="/tmp/claude-0/-home-user-riesgo/579fb8c8-70e5-51d5-80ec-6ed51cc2e8df/scratchpad/pptx-build/icons/alerttriangle_E0392B.png">    </p:cNvPr>
+          <p:cNvPr id="73" name="Image 12" descr="/tmp/claude-0/-home-user-riesgo/579fb8c8-70e5-51d5-80ec-6ed51cc2e8df/scratchpad/pptx-build/icons/alerttriangle_E0392B.png">    </p:cNvPr>
           <p:cNvPicPr>
             <a:picLocks noChangeAspect="1"/>
           </p:cNvPicPr>
           <p:nvPr/>
         </p:nvPicPr>
         <p:blipFill>
-          <a:blip r:embed="rId12"/>
+          <a:blip r:embed="rId13"/>
           <a:stretch>
             <a:fillRect/>
           </a:stretch>
         </p:blipFill>
         <p:spPr>
           <a:xfrm>
-            <a:off x="5824728" y="3149879"/>
+            <a:off x="5788152" y="2975206"/>
             <a:ext cx="182880" cy="182880"/>
           </a:xfrm>
           <a:prstGeom prst="rect">
@@ -2420,14 +3118,14 @@
       </p:pic>
       <p:sp>
         <p:nvSpPr>
-          <p:cNvPr id="52" name="Text 38"/>
+          <p:cNvPr id="74" name="Text 59"/>
           <p:cNvSpPr txBox="1"/>
           <p:nvPr/>
         </p:nvSpPr>
         <p:spPr>
           <a:xfrm>
-            <a:off x="6089904" y="3108960"/>
-            <a:ext cx="2397100" cy="264719"/>
+            <a:off x="6053328" y="2944368"/>
+            <a:ext cx="2424532" cy="244556"/>
           </a:xfrm>
           <a:prstGeom prst="rect">
             <a:avLst/>
@@ -2462,18 +3160,18 @@
       </p:sp>
       <p:sp>
         <p:nvSpPr>
-          <p:cNvPr id="53" name="Shape 39"/>
-          <p:cNvSpPr/>
-          <p:nvPr/>
-        </p:nvSpPr>
-        <p:spPr>
-          <a:xfrm>
-            <a:off x="8724748" y="3108960"/>
-            <a:ext cx="2863444" cy="264719"/>
+          <p:cNvPr id="75" name="Shape 60"/>
+          <p:cNvSpPr/>
+          <p:nvPr/>
+        </p:nvSpPr>
+        <p:spPr>
+          <a:xfrm>
+            <a:off x="8697316" y="2944368"/>
+            <a:ext cx="2890876" cy="244556"/>
           </a:xfrm>
           <a:prstGeom prst="roundRect">
             <a:avLst>
-              <a:gd name="adj" fmla="val 20725"/>
+              <a:gd name="adj" fmla="val 22434"/>
             </a:avLst>
           </a:prstGeom>
           <a:solidFill>
@@ -2484,21 +3182,21 @@
       </p:sp>
       <p:pic>
         <p:nvPicPr>
-          <p:cNvPr id="54" name="Image 12" descr="/tmp/claude-0/-home-user-riesgo/579fb8c8-70e5-51d5-80ec-6ed51cc2e8df/scratchpad/pptx-build/icons/copy_E0392B.png">    </p:cNvPr>
+          <p:cNvPr id="76" name="Image 13" descr="/tmp/claude-0/-home-user-riesgo/579fb8c8-70e5-51d5-80ec-6ed51cc2e8df/scratchpad/pptx-build/icons/copy_E0392B.png">    </p:cNvPr>
           <p:cNvPicPr>
             <a:picLocks noChangeAspect="1"/>
           </p:cNvPicPr>
           <p:nvPr/>
         </p:nvPicPr>
         <p:blipFill>
-          <a:blip r:embed="rId13"/>
+          <a:blip r:embed="rId14"/>
           <a:stretch>
             <a:fillRect/>
           </a:stretch>
         </p:blipFill>
         <p:spPr>
           <a:xfrm>
-            <a:off x="8834476" y="3149879"/>
+            <a:off x="8807044" y="2975206"/>
             <a:ext cx="182880" cy="182880"/>
           </a:xfrm>
           <a:prstGeom prst="rect">
@@ -2508,14 +3206,14 @@
       </p:pic>
       <p:sp>
         <p:nvSpPr>
-          <p:cNvPr id="55" name="Text 40"/>
+          <p:cNvPr id="77" name="Text 61"/>
           <p:cNvSpPr txBox="1"/>
           <p:nvPr/>
         </p:nvSpPr>
         <p:spPr>
           <a:xfrm>
-            <a:off x="9099652" y="3108960"/>
-            <a:ext cx="2397100" cy="264719"/>
+            <a:off x="9072220" y="2944368"/>
+            <a:ext cx="2424532" cy="244556"/>
           </a:xfrm>
           <a:prstGeom prst="rect">
             <a:avLst/>
@@ -2550,18 +3248,18 @@
       </p:sp>
       <p:sp>
         <p:nvSpPr>
-          <p:cNvPr id="56" name="Shape 41"/>
-          <p:cNvSpPr/>
-          <p:nvPr/>
-        </p:nvSpPr>
-        <p:spPr>
-          <a:xfrm>
-            <a:off x="5715000" y="3428543"/>
-            <a:ext cx="2863444" cy="264719"/>
+          <p:cNvPr id="78" name="Shape 62"/>
+          <p:cNvSpPr/>
+          <p:nvPr/>
+        </p:nvSpPr>
+        <p:spPr>
+          <a:xfrm>
+            <a:off x="5678424" y="3230072"/>
+            <a:ext cx="2890876" cy="244556"/>
           </a:xfrm>
           <a:prstGeom prst="roundRect">
             <a:avLst>
-              <a:gd name="adj" fmla="val 20725"/>
+              <a:gd name="adj" fmla="val 22434"/>
             </a:avLst>
           </a:prstGeom>
           <a:solidFill>
@@ -2572,21 +3270,21 @@
       </p:sp>
       <p:pic>
         <p:nvPicPr>
-          <p:cNvPr id="57" name="Image 13" descr="/tmp/claude-0/-home-user-riesgo/579fb8c8-70e5-51d5-80ec-6ed51cc2e8df/scratchpad/pptx-build/icons/refreshcw_E0392B.png">    </p:cNvPr>
+          <p:cNvPr id="79" name="Image 14" descr="/tmp/claude-0/-home-user-riesgo/579fb8c8-70e5-51d5-80ec-6ed51cc2e8df/scratchpad/pptx-build/icons/refreshcw_E0392B.png">    </p:cNvPr>
           <p:cNvPicPr>
             <a:picLocks noChangeAspect="1"/>
           </p:cNvPicPr>
           <p:nvPr/>
         </p:nvPicPr>
         <p:blipFill>
-          <a:blip r:embed="rId14"/>
+          <a:blip r:embed="rId15"/>
           <a:stretch>
             <a:fillRect/>
           </a:stretch>
         </p:blipFill>
         <p:spPr>
           <a:xfrm>
-            <a:off x="5824728" y="3469462"/>
+            <a:off x="5788152" y="3260910"/>
             <a:ext cx="182880" cy="182880"/>
           </a:xfrm>
           <a:prstGeom prst="rect">
@@ -2596,14 +3294,14 @@
       </p:pic>
       <p:sp>
         <p:nvSpPr>
-          <p:cNvPr id="58" name="Text 42"/>
+          <p:cNvPr id="80" name="Text 63"/>
           <p:cNvSpPr txBox="1"/>
           <p:nvPr/>
         </p:nvSpPr>
         <p:spPr>
           <a:xfrm>
-            <a:off x="6089904" y="3428543"/>
-            <a:ext cx="2397100" cy="264719"/>
+            <a:off x="6053328" y="3230072"/>
+            <a:ext cx="2424532" cy="244556"/>
           </a:xfrm>
           <a:prstGeom prst="rect">
             <a:avLst/>
@@ -2638,18 +3336,18 @@
       </p:sp>
       <p:sp>
         <p:nvSpPr>
-          <p:cNvPr id="59" name="Shape 43"/>
-          <p:cNvSpPr/>
-          <p:nvPr/>
-        </p:nvSpPr>
-        <p:spPr>
-          <a:xfrm>
-            <a:off x="8724748" y="3428543"/>
-            <a:ext cx="2863444" cy="264719"/>
+          <p:cNvPr id="81" name="Shape 64"/>
+          <p:cNvSpPr/>
+          <p:nvPr/>
+        </p:nvSpPr>
+        <p:spPr>
+          <a:xfrm>
+            <a:off x="8697316" y="3230072"/>
+            <a:ext cx="2890876" cy="244556"/>
           </a:xfrm>
           <a:prstGeom prst="roundRect">
             <a:avLst>
-              <a:gd name="adj" fmla="val 20725"/>
+              <a:gd name="adj" fmla="val 22434"/>
             </a:avLst>
           </a:prstGeom>
           <a:solidFill>
@@ -2660,21 +3358,21 @@
       </p:sp>
       <p:pic>
         <p:nvPicPr>
-          <p:cNvPr id="60" name="Image 14" descr="/tmp/claude-0/-home-user-riesgo/579fb8c8-70e5-51d5-80ec-6ed51cc2e8df/scratchpad/pptx-build/icons/clock_A6650F.png">    </p:cNvPr>
+          <p:cNvPr id="82" name="Image 15" descr="/tmp/claude-0/-home-user-riesgo/579fb8c8-70e5-51d5-80ec-6ed51cc2e8df/scratchpad/pptx-build/icons/clock_A6650F.png">    </p:cNvPr>
           <p:cNvPicPr>
             <a:picLocks noChangeAspect="1"/>
           </p:cNvPicPr>
           <p:nvPr/>
         </p:nvPicPr>
         <p:blipFill>
-          <a:blip r:embed="rId15"/>
+          <a:blip r:embed="rId16"/>
           <a:stretch>
             <a:fillRect/>
           </a:stretch>
         </p:blipFill>
         <p:spPr>
           <a:xfrm>
-            <a:off x="8834476" y="3469462"/>
+            <a:off x="8807044" y="3260910"/>
             <a:ext cx="182880" cy="182880"/>
           </a:xfrm>
           <a:prstGeom prst="rect">
@@ -2684,14 +3382,14 @@
       </p:pic>
       <p:sp>
         <p:nvSpPr>
-          <p:cNvPr id="61" name="Text 44"/>
+          <p:cNvPr id="83" name="Text 65"/>
           <p:cNvSpPr txBox="1"/>
           <p:nvPr/>
         </p:nvSpPr>
         <p:spPr>
           <a:xfrm>
-            <a:off x="9099652" y="3428543"/>
-            <a:ext cx="2397100" cy="264719"/>
+            <a:off x="9072220" y="3230072"/>
+            <a:ext cx="2424532" cy="244556"/>
           </a:xfrm>
           <a:prstGeom prst="rect">
             <a:avLst/>
@@ -2726,18 +3424,18 @@
       </p:sp>
       <p:sp>
         <p:nvSpPr>
-          <p:cNvPr id="62" name="Shape 45"/>
-          <p:cNvSpPr/>
-          <p:nvPr/>
-        </p:nvSpPr>
-        <p:spPr>
-          <a:xfrm>
-            <a:off x="5715000" y="3748126"/>
-            <a:ext cx="2863444" cy="264719"/>
+          <p:cNvPr id="84" name="Shape 66"/>
+          <p:cNvSpPr/>
+          <p:nvPr/>
+        </p:nvSpPr>
+        <p:spPr>
+          <a:xfrm>
+            <a:off x="5678424" y="3515777"/>
+            <a:ext cx="2890876" cy="244556"/>
           </a:xfrm>
           <a:prstGeom prst="roundRect">
             <a:avLst>
-              <a:gd name="adj" fmla="val 20725"/>
+              <a:gd name="adj" fmla="val 22434"/>
             </a:avLst>
           </a:prstGeom>
           <a:solidFill>
@@ -2748,21 +3446,21 @@
       </p:sp>
       <p:pic>
         <p:nvPicPr>
-          <p:cNvPr id="63" name="Image 15" descr="/tmp/claude-0/-home-user-riesgo/579fb8c8-70e5-51d5-80ec-6ed51cc2e8df/scratchpad/pptx-build/icons/headphones_A6650F.png">    </p:cNvPr>
+          <p:cNvPr id="85" name="Image 16" descr="/tmp/claude-0/-home-user-riesgo/579fb8c8-70e5-51d5-80ec-6ed51cc2e8df/scratchpad/pptx-build/icons/headphones_A6650F.png">    </p:cNvPr>
           <p:cNvPicPr>
             <a:picLocks noChangeAspect="1"/>
           </p:cNvPicPr>
           <p:nvPr/>
         </p:nvPicPr>
         <p:blipFill>
-          <a:blip r:embed="rId16"/>
+          <a:blip r:embed="rId17"/>
           <a:stretch>
             <a:fillRect/>
           </a:stretch>
         </p:blipFill>
         <p:spPr>
           <a:xfrm>
-            <a:off x="5824728" y="3789045"/>
+            <a:off x="5788152" y="3546615"/>
             <a:ext cx="182880" cy="182880"/>
           </a:xfrm>
           <a:prstGeom prst="rect">
@@ -2772,14 +3470,14 @@
       </p:pic>
       <p:sp>
         <p:nvSpPr>
-          <p:cNvPr id="64" name="Text 46"/>
+          <p:cNvPr id="86" name="Text 67"/>
           <p:cNvSpPr txBox="1"/>
           <p:nvPr/>
         </p:nvSpPr>
         <p:spPr>
           <a:xfrm>
-            <a:off x="6089904" y="3748126"/>
-            <a:ext cx="2397100" cy="264719"/>
+            <a:off x="6053328" y="3515777"/>
+            <a:ext cx="2424532" cy="244556"/>
           </a:xfrm>
           <a:prstGeom prst="rect">
             <a:avLst/>
@@ -2814,18 +3512,18 @@
       </p:sp>
       <p:sp>
         <p:nvSpPr>
-          <p:cNvPr id="65" name="Shape 47"/>
-          <p:cNvSpPr/>
-          <p:nvPr/>
-        </p:nvSpPr>
-        <p:spPr>
-          <a:xfrm>
-            <a:off x="8724748" y="3748126"/>
-            <a:ext cx="2863444" cy="264719"/>
+          <p:cNvPr id="87" name="Shape 68"/>
+          <p:cNvSpPr/>
+          <p:nvPr/>
+        </p:nvSpPr>
+        <p:spPr>
+          <a:xfrm>
+            <a:off x="8697316" y="3515777"/>
+            <a:ext cx="2890876" cy="244556"/>
           </a:xfrm>
           <a:prstGeom prst="roundRect">
             <a:avLst>
-              <a:gd name="adj" fmla="val 20725"/>
+              <a:gd name="adj" fmla="val 22434"/>
             </a:avLst>
           </a:prstGeom>
           <a:solidFill>
@@ -2836,21 +3534,21 @@
       </p:sp>
       <p:pic>
         <p:nvPicPr>
-          <p:cNvPr id="66" name="Image 16" descr="/tmp/claude-0/-home-user-riesgo/579fb8c8-70e5-51d5-80ec-6ed51cc2e8df/scratchpad/pptx-build/icons/creditcard_E0392B.png">    </p:cNvPr>
+          <p:cNvPr id="88" name="Image 17" descr="/tmp/claude-0/-home-user-riesgo/579fb8c8-70e5-51d5-80ec-6ed51cc2e8df/scratchpad/pptx-build/icons/creditcard_E0392B.png">    </p:cNvPr>
           <p:cNvPicPr>
             <a:picLocks noChangeAspect="1"/>
           </p:cNvPicPr>
           <p:nvPr/>
         </p:nvPicPr>
         <p:blipFill>
-          <a:blip r:embed="rId17"/>
+          <a:blip r:embed="rId18"/>
           <a:stretch>
             <a:fillRect/>
           </a:stretch>
         </p:blipFill>
         <p:spPr>
           <a:xfrm>
-            <a:off x="8834476" y="3789045"/>
+            <a:off x="8807044" y="3546615"/>
             <a:ext cx="182880" cy="182880"/>
           </a:xfrm>
           <a:prstGeom prst="rect">
@@ -2860,14 +3558,14 @@
       </p:pic>
       <p:sp>
         <p:nvSpPr>
-          <p:cNvPr id="67" name="Text 48"/>
+          <p:cNvPr id="89" name="Text 69"/>
           <p:cNvSpPr txBox="1"/>
           <p:nvPr/>
         </p:nvSpPr>
         <p:spPr>
           <a:xfrm>
-            <a:off x="9099652" y="3748126"/>
-            <a:ext cx="2397100" cy="264719"/>
+            <a:off x="9072220" y="3515777"/>
+            <a:ext cx="2424532" cy="244556"/>
           </a:xfrm>
           <a:prstGeom prst="rect">
             <a:avLst/>
@@ -2902,18 +3600,18 @@
       </p:sp>
       <p:sp>
         <p:nvSpPr>
-          <p:cNvPr id="68" name="Shape 49"/>
-          <p:cNvSpPr/>
-          <p:nvPr/>
-        </p:nvSpPr>
-        <p:spPr>
-          <a:xfrm>
-            <a:off x="5715000" y="4067708"/>
-            <a:ext cx="2863444" cy="264719"/>
+          <p:cNvPr id="90" name="Shape 70"/>
+          <p:cNvSpPr/>
+          <p:nvPr/>
+        </p:nvSpPr>
+        <p:spPr>
+          <a:xfrm>
+            <a:off x="5678424" y="3801481"/>
+            <a:ext cx="2890876" cy="244556"/>
           </a:xfrm>
           <a:prstGeom prst="roundRect">
             <a:avLst>
-              <a:gd name="adj" fmla="val 20725"/>
+              <a:gd name="adj" fmla="val 22434"/>
             </a:avLst>
           </a:prstGeom>
           <a:solidFill>
@@ -2924,21 +3622,21 @@
       </p:sp>
       <p:pic>
         <p:nvPicPr>
-          <p:cNvPr id="69" name="Image 17" descr="/tmp/claude-0/-home-user-riesgo/579fb8c8-70e5-51d5-80ec-6ed51cc2e8df/scratchpad/pptx-build/icons/shield_A6650F.png">    </p:cNvPr>
+          <p:cNvPr id="91" name="Image 18" descr="/tmp/claude-0/-home-user-riesgo/579fb8c8-70e5-51d5-80ec-6ed51cc2e8df/scratchpad/pptx-build/icons/shield_A6650F.png">    </p:cNvPr>
           <p:cNvPicPr>
             <a:picLocks noChangeAspect="1"/>
           </p:cNvPicPr>
           <p:nvPr/>
         </p:nvPicPr>
         <p:blipFill>
-          <a:blip r:embed="rId18"/>
+          <a:blip r:embed="rId19"/>
           <a:stretch>
             <a:fillRect/>
           </a:stretch>
         </p:blipFill>
         <p:spPr>
           <a:xfrm>
-            <a:off x="5824728" y="4108628"/>
+            <a:off x="5788152" y="3832319"/>
             <a:ext cx="182880" cy="182880"/>
           </a:xfrm>
           <a:prstGeom prst="rect">
@@ -2948,14 +3646,14 @@
       </p:pic>
       <p:sp>
         <p:nvSpPr>
-          <p:cNvPr id="70" name="Text 50"/>
+          <p:cNvPr id="92" name="Text 71"/>
           <p:cNvSpPr txBox="1"/>
           <p:nvPr/>
         </p:nvSpPr>
         <p:spPr>
           <a:xfrm>
-            <a:off x="6089904" y="4067708"/>
-            <a:ext cx="2397100" cy="264719"/>
+            <a:off x="6053328" y="3801481"/>
+            <a:ext cx="2424532" cy="244556"/>
           </a:xfrm>
           <a:prstGeom prst="rect">
             <a:avLst/>
@@ -2990,18 +3688,18 @@
       </p:sp>
       <p:sp>
         <p:nvSpPr>
-          <p:cNvPr id="71" name="Shape 51"/>
-          <p:cNvSpPr/>
-          <p:nvPr/>
-        </p:nvSpPr>
-        <p:spPr>
-          <a:xfrm>
-            <a:off x="8724748" y="4067708"/>
-            <a:ext cx="2863444" cy="264719"/>
+          <p:cNvPr id="93" name="Shape 72"/>
+          <p:cNvSpPr/>
+          <p:nvPr/>
+        </p:nvSpPr>
+        <p:spPr>
+          <a:xfrm>
+            <a:off x="8697316" y="3801481"/>
+            <a:ext cx="2890876" cy="244556"/>
           </a:xfrm>
           <a:prstGeom prst="roundRect">
             <a:avLst>
-              <a:gd name="adj" fmla="val 20725"/>
+              <a:gd name="adj" fmla="val 22434"/>
             </a:avLst>
           </a:prstGeom>
           <a:solidFill>
@@ -3012,21 +3710,21 @@
       </p:sp>
       <p:pic>
         <p:nvPicPr>
-          <p:cNvPr id="72" name="Image 18" descr="/tmp/claude-0/-home-user-riesgo/579fb8c8-70e5-51d5-80ec-6ed51cc2e8df/scratchpad/pptx-build/icons/tag_A6650F.png">    </p:cNvPr>
+          <p:cNvPr id="94" name="Image 19" descr="/tmp/claude-0/-home-user-riesgo/579fb8c8-70e5-51d5-80ec-6ed51cc2e8df/scratchpad/pptx-build/icons/tag_A6650F.png">    </p:cNvPr>
           <p:cNvPicPr>
             <a:picLocks noChangeAspect="1"/>
           </p:cNvPicPr>
           <p:nvPr/>
         </p:nvPicPr>
         <p:blipFill>
-          <a:blip r:embed="rId19"/>
+          <a:blip r:embed="rId20"/>
           <a:stretch>
             <a:fillRect/>
           </a:stretch>
         </p:blipFill>
         <p:spPr>
           <a:xfrm>
-            <a:off x="8834476" y="4108628"/>
+            <a:off x="8807044" y="3832319"/>
             <a:ext cx="182880" cy="182880"/>
           </a:xfrm>
           <a:prstGeom prst="rect">
@@ -3036,14 +3734,14 @@
       </p:pic>
       <p:sp>
         <p:nvSpPr>
-          <p:cNvPr id="73" name="Text 52"/>
+          <p:cNvPr id="95" name="Text 73"/>
           <p:cNvSpPr txBox="1"/>
           <p:nvPr/>
         </p:nvSpPr>
         <p:spPr>
           <a:xfrm>
-            <a:off x="9099652" y="4067708"/>
-            <a:ext cx="2397100" cy="264719"/>
+            <a:off x="9072220" y="3801481"/>
+            <a:ext cx="2424532" cy="244556"/>
           </a:xfrm>
           <a:prstGeom prst="rect">
             <a:avLst/>
@@ -3078,18 +3776,18 @@
       </p:sp>
       <p:sp>
         <p:nvSpPr>
-          <p:cNvPr id="74" name="Shape 53"/>
-          <p:cNvSpPr/>
-          <p:nvPr/>
-        </p:nvSpPr>
-        <p:spPr>
-          <a:xfrm>
-            <a:off x="5495544" y="4478731"/>
-            <a:ext cx="6312103" cy="1373429"/>
+          <p:cNvPr id="96" name="Shape 74"/>
+          <p:cNvSpPr/>
+          <p:nvPr/>
+        </p:nvSpPr>
+        <p:spPr>
+          <a:xfrm>
+            <a:off x="5458968" y="4247205"/>
+            <a:ext cx="6348679" cy="1787835"/>
           </a:xfrm>
           <a:prstGeom prst="roundRect">
             <a:avLst>
-              <a:gd name="adj" fmla="val 5326"/>
+              <a:gd name="adj" fmla="val 4092"/>
             </a:avLst>
           </a:prstGeom>
           <a:solidFill>
@@ -3112,14 +3810,14 @@
       </p:sp>
       <p:sp>
         <p:nvSpPr>
-          <p:cNvPr id="75" name="Shape 54"/>
-          <p:cNvSpPr/>
-          <p:nvPr/>
-        </p:nvSpPr>
-        <p:spPr>
-          <a:xfrm>
-            <a:off x="5495544" y="4478731"/>
-            <a:ext cx="6312103" cy="45720"/>
+          <p:cNvPr id="97" name="Shape 75"/>
+          <p:cNvSpPr/>
+          <p:nvPr/>
+        </p:nvSpPr>
+        <p:spPr>
+          <a:xfrm>
+            <a:off x="5458968" y="4247205"/>
+            <a:ext cx="6348679" cy="45720"/>
           </a:xfrm>
           <a:prstGeom prst="rect">
             <a:avLst/>
@@ -3132,18 +3830,18 @@
       </p:sp>
       <p:sp>
         <p:nvSpPr>
-          <p:cNvPr id="76" name="Shape 55"/>
-          <p:cNvSpPr/>
-          <p:nvPr/>
-        </p:nvSpPr>
-        <p:spPr>
-          <a:xfrm>
-            <a:off x="5495544" y="4478731"/>
-            <a:ext cx="6312103" cy="1373429"/>
+          <p:cNvPr id="98" name="Shape 76"/>
+          <p:cNvSpPr/>
+          <p:nvPr/>
+        </p:nvSpPr>
+        <p:spPr>
+          <a:xfrm>
+            <a:off x="5458968" y="4247205"/>
+            <a:ext cx="6348679" cy="1787835"/>
           </a:xfrm>
           <a:prstGeom prst="roundRect">
             <a:avLst>
-              <a:gd name="adj" fmla="val 4660"/>
+              <a:gd name="adj" fmla="val 3580"/>
             </a:avLst>
           </a:prstGeom>
           <a:solidFill>
@@ -3166,14 +3864,14 @@
       </p:sp>
       <p:sp>
         <p:nvSpPr>
-          <p:cNvPr id="77" name="Shape 56"/>
-          <p:cNvSpPr/>
-          <p:nvPr/>
-        </p:nvSpPr>
-        <p:spPr>
-          <a:xfrm>
-            <a:off x="5678424" y="4643323"/>
-            <a:ext cx="274320" cy="274320"/>
+          <p:cNvPr id="99" name="Shape 77"/>
+          <p:cNvSpPr/>
+          <p:nvPr/>
+        </p:nvSpPr>
+        <p:spPr>
+          <a:xfrm>
+            <a:off x="5623560" y="4375221"/>
+            <a:ext cx="201168" cy="201168"/>
           </a:xfrm>
           <a:prstGeom prst="ellipse">
             <a:avLst/>
@@ -3186,22 +3884,22 @@
       </p:sp>
       <p:pic>
         <p:nvPicPr>
-          <p:cNvPr id="78" name="Image 19" descr="/tmp/claude-0/-home-user-riesgo/579fb8c8-70e5-51d5-80ec-6ed51cc2e8df/scratchpad/pptx-build/icons/flag_133B6C.png">    </p:cNvPr>
+          <p:cNvPr id="100" name="Image 20" descr="/tmp/claude-0/-home-user-riesgo/579fb8c8-70e5-51d5-80ec-6ed51cc2e8df/scratchpad/pptx-build/icons/flag_133B6C.png">    </p:cNvPr>
           <p:cNvPicPr>
             <a:picLocks noChangeAspect="1"/>
           </p:cNvPicPr>
           <p:nvPr/>
         </p:nvPicPr>
         <p:blipFill>
-          <a:blip r:embed="rId20"/>
+          <a:blip r:embed="rId21"/>
           <a:stretch>
             <a:fillRect/>
           </a:stretch>
         </p:blipFill>
         <p:spPr>
           <a:xfrm>
-            <a:off x="5733288" y="4698187"/>
-            <a:ext cx="164592" cy="164592"/>
+            <a:off x="5663794" y="4415455"/>
+            <a:ext cx="120701" cy="120701"/>
           </a:xfrm>
           <a:prstGeom prst="rect">
             <a:avLst/>
@@ -3210,14 +3908,14 @@
       </p:pic>
       <p:sp>
         <p:nvSpPr>
-          <p:cNvPr id="79" name="Text 57"/>
+          <p:cNvPr id="101" name="Text 78"/>
           <p:cNvSpPr txBox="1"/>
           <p:nvPr/>
         </p:nvSpPr>
         <p:spPr>
           <a:xfrm>
-            <a:off x="6080760" y="4615891"/>
-            <a:ext cx="5544007" cy="329184"/>
+            <a:off x="5934456" y="4347789"/>
+            <a:ext cx="5708599" cy="256032"/>
           </a:xfrm>
           <a:prstGeom prst="rect">
             <a:avLst/>
@@ -3233,7 +3931,7 @@
               <a:buNone/>
             </a:pPr>
             <a:r>
-              <a:rPr lang="en-US" sz="1350" b="1" dirty="0">
+              <a:rPr lang="en-US" sz="1150" b="1" dirty="0">
                 <a:solidFill>
                   <a:srgbClr val="133B6C"/>
                 </a:solidFill>
@@ -3243,24 +3941,24 @@
               </a:rPr>
               <a:t>Matriz de Prioridades — Impacto vs. Urgencia</a:t>
             </a:r>
-            <a:endParaRPr lang="en-US" sz="1350" dirty="0"/>
-          </a:p>
-        </p:txBody>
-      </p:sp>
-      <p:sp>
-        <p:nvSpPr>
-          <p:cNvPr id="80" name="Shape 58"/>
-          <p:cNvSpPr/>
-          <p:nvPr/>
-        </p:nvSpPr>
-        <p:spPr>
-          <a:xfrm>
-            <a:off x="5678424" y="5091379"/>
-            <a:ext cx="5946343" cy="217018"/>
+            <a:endParaRPr lang="en-US" sz="1150" dirty="0"/>
+          </a:p>
+        </p:txBody>
+      </p:sp>
+      <p:sp>
+        <p:nvSpPr>
+          <p:cNvPr id="102" name="Shape 79"/>
+          <p:cNvSpPr/>
+          <p:nvPr/>
+        </p:nvSpPr>
+        <p:spPr>
+          <a:xfrm>
+            <a:off x="5641848" y="4686117"/>
+            <a:ext cx="5982919" cy="425257"/>
           </a:xfrm>
           <a:prstGeom prst="roundRect">
             <a:avLst>
-              <a:gd name="adj" fmla="val 25281"/>
+              <a:gd name="adj" fmla="val 12901"/>
             </a:avLst>
           </a:prstGeom>
           <a:solidFill>
@@ -3271,14 +3969,14 @@
       </p:sp>
       <p:sp>
         <p:nvSpPr>
-          <p:cNvPr id="81" name="Shape 59"/>
-          <p:cNvSpPr/>
-          <p:nvPr/>
-        </p:nvSpPr>
-        <p:spPr>
-          <a:xfrm>
-            <a:off x="5769864" y="5062728"/>
-            <a:ext cx="1051560" cy="274320"/>
+          <p:cNvPr id="103" name="Shape 80"/>
+          <p:cNvSpPr/>
+          <p:nvPr/>
+        </p:nvSpPr>
+        <p:spPr>
+          <a:xfrm>
+            <a:off x="5733288" y="4789018"/>
+            <a:ext cx="914400" cy="219456"/>
           </a:xfrm>
           <a:prstGeom prst="roundRect">
             <a:avLst>
@@ -3293,14 +3991,14 @@
       </p:sp>
       <p:sp>
         <p:nvSpPr>
-          <p:cNvPr id="82" name="Text 60"/>
+          <p:cNvPr id="104" name="Text 81"/>
           <p:cNvSpPr txBox="1"/>
           <p:nvPr/>
         </p:nvSpPr>
         <p:spPr>
           <a:xfrm>
-            <a:off x="5769864" y="5062728"/>
-            <a:ext cx="1051560" cy="274320"/>
+            <a:off x="5733288" y="4789018"/>
+            <a:ext cx="914400" cy="219456"/>
           </a:xfrm>
           <a:prstGeom prst="rect">
             <a:avLst/>
@@ -3316,7 +4014,7 @@
               <a:buNone/>
             </a:pPr>
             <a:r>
-              <a:rPr lang="en-US" sz="900" b="1" spc="40" kern="0" dirty="0">
+              <a:rPr lang="en-US" sz="800" b="1" spc="40" kern="0" dirty="0">
                 <a:solidFill>
                   <a:srgbClr val="FFFFFF"/>
                 </a:solidFill>
@@ -3326,24 +4024,24 @@
               </a:rPr>
               <a:t>ALTA</a:t>
             </a:r>
-            <a:endParaRPr lang="en-US" sz="900" dirty="0"/>
-          </a:p>
-        </p:txBody>
-      </p:sp>
-      <p:sp>
-        <p:nvSpPr>
-          <p:cNvPr id="83" name="Shape 61"/>
-          <p:cNvSpPr/>
-          <p:nvPr/>
-        </p:nvSpPr>
-        <p:spPr>
-          <a:xfrm>
-            <a:off x="6967728" y="5164531"/>
-            <a:ext cx="1077392" cy="70714"/>
+            <a:endParaRPr lang="en-US" sz="800" dirty="0"/>
+          </a:p>
+        </p:txBody>
+      </p:sp>
+      <p:sp>
+        <p:nvSpPr>
+          <p:cNvPr id="105" name="Shape 82"/>
+          <p:cNvSpPr/>
+          <p:nvPr/>
+        </p:nvSpPr>
+        <p:spPr>
+          <a:xfrm>
+            <a:off x="6775704" y="4722693"/>
+            <a:ext cx="1136828" cy="352105"/>
           </a:xfrm>
           <a:prstGeom prst="roundRect">
             <a:avLst>
-              <a:gd name="adj" fmla="val 64655"/>
+              <a:gd name="adj" fmla="val 12985"/>
             </a:avLst>
           </a:prstGeom>
           <a:solidFill>
@@ -3359,14 +4057,14 @@
       </p:sp>
       <p:sp>
         <p:nvSpPr>
-          <p:cNvPr id="84" name="Text 62"/>
+          <p:cNvPr id="106" name="Text 83"/>
           <p:cNvSpPr txBox="1"/>
           <p:nvPr/>
         </p:nvSpPr>
         <p:spPr>
           <a:xfrm>
-            <a:off x="7040880" y="5164531"/>
-            <a:ext cx="931088" cy="70714"/>
+            <a:off x="6830568" y="4722693"/>
+            <a:ext cx="1027100" cy="352105"/>
           </a:xfrm>
           <a:prstGeom prst="rect">
             <a:avLst/>
@@ -3380,12 +4078,12 @@
           <a:p>
             <a:pPr algn="ctr" indent="0" marL="0">
               <a:lnSpc>
-                <a:spcPct val="102000"/>
+                <a:spcPct val="98000"/>
               </a:lnSpc>
               <a:buNone/>
             </a:pPr>
             <a:r>
-              <a:rPr lang="en-US" sz="860" b="1" dirty="0">
+              <a:rPr lang="en-US" sz="780" b="1" dirty="0">
                 <a:solidFill>
                   <a:srgbClr val="E0392B"/>
                 </a:solidFill>
@@ -3395,24 +4093,24 @@
               </a:rPr>
               <a:t>Estabilidad de la plataforma</a:t>
             </a:r>
-            <a:endParaRPr lang="en-US" sz="860" dirty="0"/>
-          </a:p>
-        </p:txBody>
-      </p:sp>
-      <p:sp>
-        <p:nvSpPr>
-          <p:cNvPr id="85" name="Shape 63"/>
-          <p:cNvSpPr/>
-          <p:nvPr/>
-        </p:nvSpPr>
-        <p:spPr>
-          <a:xfrm>
-            <a:off x="8118272" y="5164531"/>
-            <a:ext cx="1077392" cy="70714"/>
+            <a:endParaRPr lang="en-US" sz="780" dirty="0"/>
+          </a:p>
+        </p:txBody>
+      </p:sp>
+      <p:sp>
+        <p:nvSpPr>
+          <p:cNvPr id="107" name="Shape 84"/>
+          <p:cNvSpPr/>
+          <p:nvPr/>
+        </p:nvSpPr>
+        <p:spPr>
+          <a:xfrm>
+            <a:off x="7976540" y="4722693"/>
+            <a:ext cx="1136828" cy="352105"/>
           </a:xfrm>
           <a:prstGeom prst="roundRect">
             <a:avLst>
-              <a:gd name="adj" fmla="val 64655"/>
+              <a:gd name="adj" fmla="val 12985"/>
             </a:avLst>
           </a:prstGeom>
           <a:solidFill>
@@ -3428,14 +4126,14 @@
       </p:sp>
       <p:sp>
         <p:nvSpPr>
-          <p:cNvPr id="86" name="Text 64"/>
+          <p:cNvPr id="108" name="Text 85"/>
           <p:cNvSpPr txBox="1"/>
           <p:nvPr/>
         </p:nvSpPr>
         <p:spPr>
           <a:xfrm>
-            <a:off x="8191424" y="5164531"/>
-            <a:ext cx="931088" cy="70714"/>
+            <a:off x="8031404" y="4722693"/>
+            <a:ext cx="1027100" cy="352105"/>
           </a:xfrm>
           <a:prstGeom prst="rect">
             <a:avLst/>
@@ -3449,12 +4147,12 @@
           <a:p>
             <a:pPr algn="ctr" indent="0" marL="0">
               <a:lnSpc>
-                <a:spcPct val="102000"/>
+                <a:spcPct val="98000"/>
               </a:lnSpc>
               <a:buNone/>
             </a:pPr>
             <a:r>
-              <a:rPr lang="en-US" sz="860" b="1" dirty="0">
+              <a:rPr lang="en-US" sz="780" b="1" dirty="0">
                 <a:solidFill>
                   <a:srgbClr val="E0392B"/>
                 </a:solidFill>
@@ -3464,24 +4162,24 @@
               </a:rPr>
               <a:t>Reversas de transacciones</a:t>
             </a:r>
-            <a:endParaRPr lang="en-US" sz="860" dirty="0"/>
-          </a:p>
-        </p:txBody>
-      </p:sp>
-      <p:sp>
-        <p:nvSpPr>
-          <p:cNvPr id="87" name="Shape 65"/>
-          <p:cNvSpPr/>
-          <p:nvPr/>
-        </p:nvSpPr>
-        <p:spPr>
-          <a:xfrm>
-            <a:off x="9268816" y="5164531"/>
-            <a:ext cx="1077392" cy="70714"/>
+            <a:endParaRPr lang="en-US" sz="780" dirty="0"/>
+          </a:p>
+        </p:txBody>
+      </p:sp>
+      <p:sp>
+        <p:nvSpPr>
+          <p:cNvPr id="109" name="Shape 86"/>
+          <p:cNvSpPr/>
+          <p:nvPr/>
+        </p:nvSpPr>
+        <p:spPr>
+          <a:xfrm>
+            <a:off x="9177376" y="4722693"/>
+            <a:ext cx="1136828" cy="352105"/>
           </a:xfrm>
           <a:prstGeom prst="roundRect">
             <a:avLst>
-              <a:gd name="adj" fmla="val 64655"/>
+              <a:gd name="adj" fmla="val 12985"/>
             </a:avLst>
           </a:prstGeom>
           <a:solidFill>
@@ -3497,14 +4195,14 @@
       </p:sp>
       <p:sp>
         <p:nvSpPr>
-          <p:cNvPr id="88" name="Text 66"/>
+          <p:cNvPr id="110" name="Text 87"/>
           <p:cNvSpPr txBox="1"/>
           <p:nvPr/>
         </p:nvSpPr>
         <p:spPr>
           <a:xfrm>
-            <a:off x="9341968" y="5164531"/>
-            <a:ext cx="931088" cy="70714"/>
+            <a:off x="9232240" y="4722693"/>
+            <a:ext cx="1027100" cy="352105"/>
           </a:xfrm>
           <a:prstGeom prst="rect">
             <a:avLst/>
@@ -3518,12 +4216,12 @@
           <a:p>
             <a:pPr algn="ctr" indent="0" marL="0">
               <a:lnSpc>
-                <a:spcPct val="102000"/>
+                <a:spcPct val="98000"/>
               </a:lnSpc>
               <a:buNone/>
             </a:pPr>
             <a:r>
-              <a:rPr lang="en-US" sz="860" b="1" dirty="0">
+              <a:rPr lang="en-US" sz="780" b="1" dirty="0">
                 <a:solidFill>
                   <a:srgbClr val="E0392B"/>
                 </a:solidFill>
@@ -3533,24 +4231,24 @@
               </a:rPr>
               <a:t>Duplicidad de pagos</a:t>
             </a:r>
-            <a:endParaRPr lang="en-US" sz="860" dirty="0"/>
-          </a:p>
-        </p:txBody>
-      </p:sp>
-      <p:sp>
-        <p:nvSpPr>
-          <p:cNvPr id="89" name="Shape 67"/>
-          <p:cNvSpPr/>
-          <p:nvPr/>
-        </p:nvSpPr>
-        <p:spPr>
-          <a:xfrm>
-            <a:off x="10419359" y="5164531"/>
-            <a:ext cx="1077392" cy="70714"/>
+            <a:endParaRPr lang="en-US" sz="780" dirty="0"/>
+          </a:p>
+        </p:txBody>
+      </p:sp>
+      <p:sp>
+        <p:nvSpPr>
+          <p:cNvPr id="111" name="Shape 88"/>
+          <p:cNvSpPr/>
+          <p:nvPr/>
+        </p:nvSpPr>
+        <p:spPr>
+          <a:xfrm>
+            <a:off x="10378211" y="4722693"/>
+            <a:ext cx="1136828" cy="352105"/>
           </a:xfrm>
           <a:prstGeom prst="roundRect">
             <a:avLst>
-              <a:gd name="adj" fmla="val 64655"/>
+              <a:gd name="adj" fmla="val 12985"/>
             </a:avLst>
           </a:prstGeom>
           <a:solidFill>
@@ -3566,14 +4264,14 @@
       </p:sp>
       <p:sp>
         <p:nvSpPr>
-          <p:cNvPr id="90" name="Text 68"/>
+          <p:cNvPr id="112" name="Text 89"/>
           <p:cNvSpPr txBox="1"/>
           <p:nvPr/>
         </p:nvSpPr>
         <p:spPr>
           <a:xfrm>
-            <a:off x="10492511" y="5164531"/>
-            <a:ext cx="931088" cy="70714"/>
+            <a:off x="10433075" y="4722693"/>
+            <a:ext cx="1027100" cy="352105"/>
           </a:xfrm>
           <a:prstGeom prst="rect">
             <a:avLst/>
@@ -3587,12 +4285,12 @@
           <a:p>
             <a:pPr algn="ctr" indent="0" marL="0">
               <a:lnSpc>
-                <a:spcPct val="102000"/>
+                <a:spcPct val="98000"/>
               </a:lnSpc>
               <a:buNone/>
             </a:pPr>
             <a:r>
-              <a:rPr lang="en-US" sz="860" b="1" dirty="0">
+              <a:rPr lang="en-US" sz="780" b="1" dirty="0">
                 <a:solidFill>
                   <a:srgbClr val="E0392B"/>
                 </a:solidFill>
@@ -3602,24 +4300,24 @@
               </a:rPr>
               <a:t>Tiempo de resolución</a:t>
             </a:r>
-            <a:endParaRPr lang="en-US" sz="860" dirty="0"/>
-          </a:p>
-        </p:txBody>
-      </p:sp>
-      <p:sp>
-        <p:nvSpPr>
-          <p:cNvPr id="91" name="Shape 69"/>
-          <p:cNvSpPr/>
-          <p:nvPr/>
-        </p:nvSpPr>
-        <p:spPr>
-          <a:xfrm>
-            <a:off x="5678424" y="5363261"/>
-            <a:ext cx="5946343" cy="217018"/>
+            <a:endParaRPr lang="en-US" sz="780" dirty="0"/>
+          </a:p>
+        </p:txBody>
+      </p:sp>
+      <p:sp>
+        <p:nvSpPr>
+          <p:cNvPr id="113" name="Shape 90"/>
+          <p:cNvSpPr/>
+          <p:nvPr/>
+        </p:nvSpPr>
+        <p:spPr>
+          <a:xfrm>
+            <a:off x="5641848" y="5147950"/>
+            <a:ext cx="5982919" cy="425257"/>
           </a:xfrm>
           <a:prstGeom prst="roundRect">
             <a:avLst>
-              <a:gd name="adj" fmla="val 25281"/>
+              <a:gd name="adj" fmla="val 12901"/>
             </a:avLst>
           </a:prstGeom>
           <a:solidFill>
@@ -3630,14 +4328,14 @@
       </p:sp>
       <p:sp>
         <p:nvSpPr>
-          <p:cNvPr id="92" name="Shape 70"/>
-          <p:cNvSpPr/>
-          <p:nvPr/>
-        </p:nvSpPr>
-        <p:spPr>
-          <a:xfrm>
-            <a:off x="5769864" y="5334610"/>
-            <a:ext cx="1051560" cy="274320"/>
+          <p:cNvPr id="114" name="Shape 91"/>
+          <p:cNvSpPr/>
+          <p:nvPr/>
+        </p:nvSpPr>
+        <p:spPr>
+          <a:xfrm>
+            <a:off x="5733288" y="5250851"/>
+            <a:ext cx="914400" cy="219456"/>
           </a:xfrm>
           <a:prstGeom prst="roundRect">
             <a:avLst>
@@ -3652,14 +4350,14 @@
       </p:sp>
       <p:sp>
         <p:nvSpPr>
-          <p:cNvPr id="93" name="Text 71"/>
+          <p:cNvPr id="115" name="Text 92"/>
           <p:cNvSpPr txBox="1"/>
           <p:nvPr/>
         </p:nvSpPr>
         <p:spPr>
           <a:xfrm>
-            <a:off x="5769864" y="5334610"/>
-            <a:ext cx="1051560" cy="274320"/>
+            <a:off x="5733288" y="5250851"/>
+            <a:ext cx="914400" cy="219456"/>
           </a:xfrm>
           <a:prstGeom prst="rect">
             <a:avLst/>
@@ -3675,7 +4373,7 @@
               <a:buNone/>
             </a:pPr>
             <a:r>
-              <a:rPr lang="en-US" sz="900" b="1" spc="40" kern="0" dirty="0">
+              <a:rPr lang="en-US" sz="800" b="1" spc="40" kern="0" dirty="0">
                 <a:solidFill>
                   <a:srgbClr val="FFFFFF"/>
                 </a:solidFill>
@@ -3685,24 +4383,24 @@
               </a:rPr>
               <a:t>MEDIA</a:t>
             </a:r>
-            <a:endParaRPr lang="en-US" sz="900" dirty="0"/>
-          </a:p>
-        </p:txBody>
-      </p:sp>
-      <p:sp>
-        <p:nvSpPr>
-          <p:cNvPr id="94" name="Shape 72"/>
-          <p:cNvSpPr/>
-          <p:nvPr/>
-        </p:nvSpPr>
-        <p:spPr>
-          <a:xfrm>
-            <a:off x="6967728" y="5436413"/>
-            <a:ext cx="1460906" cy="70714"/>
+            <a:endParaRPr lang="en-US" sz="800" dirty="0"/>
+          </a:p>
+        </p:txBody>
+      </p:sp>
+      <p:sp>
+        <p:nvSpPr>
+          <p:cNvPr id="116" name="Shape 93"/>
+          <p:cNvSpPr/>
+          <p:nvPr/>
+        </p:nvSpPr>
+        <p:spPr>
+          <a:xfrm>
+            <a:off x="6775704" y="5184526"/>
+            <a:ext cx="1537106" cy="352105"/>
           </a:xfrm>
           <a:prstGeom prst="roundRect">
             <a:avLst>
-              <a:gd name="adj" fmla="val 64655"/>
+              <a:gd name="adj" fmla="val 12985"/>
             </a:avLst>
           </a:prstGeom>
           <a:solidFill>
@@ -3718,14 +4416,14 @@
       </p:sp>
       <p:sp>
         <p:nvSpPr>
-          <p:cNvPr id="95" name="Text 73"/>
+          <p:cNvPr id="117" name="Text 94"/>
           <p:cNvSpPr txBox="1"/>
           <p:nvPr/>
         </p:nvSpPr>
         <p:spPr>
           <a:xfrm>
-            <a:off x="7040880" y="5436413"/>
-            <a:ext cx="1314602" cy="70714"/>
+            <a:off x="6830568" y="5184526"/>
+            <a:ext cx="1427378" cy="352105"/>
           </a:xfrm>
           <a:prstGeom prst="rect">
             <a:avLst/>
@@ -3739,12 +4437,12 @@
           <a:p>
             <a:pPr algn="ctr" indent="0" marL="0">
               <a:lnSpc>
-                <a:spcPct val="102000"/>
+                <a:spcPct val="98000"/>
               </a:lnSpc>
               <a:buNone/>
             </a:pPr>
             <a:r>
-              <a:rPr lang="en-US" sz="860" b="1" dirty="0">
+              <a:rPr lang="en-US" sz="780" b="1" dirty="0">
                 <a:solidFill>
                   <a:srgbClr val="A6650F"/>
                 </a:solidFill>
@@ -3754,24 +4452,24 @@
               </a:rPr>
               <a:t>Comunicación y soporte</a:t>
             </a:r>
-            <a:endParaRPr lang="en-US" sz="860" dirty="0"/>
-          </a:p>
-        </p:txBody>
-      </p:sp>
-      <p:sp>
-        <p:nvSpPr>
-          <p:cNvPr id="96" name="Shape 74"/>
-          <p:cNvSpPr/>
-          <p:nvPr/>
-        </p:nvSpPr>
-        <p:spPr>
-          <a:xfrm>
-            <a:off x="8501786" y="5436413"/>
-            <a:ext cx="1460906" cy="70714"/>
+            <a:endParaRPr lang="en-US" sz="780" dirty="0"/>
+          </a:p>
+        </p:txBody>
+      </p:sp>
+      <p:sp>
+        <p:nvSpPr>
+          <p:cNvPr id="118" name="Shape 95"/>
+          <p:cNvSpPr/>
+          <p:nvPr/>
+        </p:nvSpPr>
+        <p:spPr>
+          <a:xfrm>
+            <a:off x="8376818" y="5184526"/>
+            <a:ext cx="1537106" cy="352105"/>
           </a:xfrm>
           <a:prstGeom prst="roundRect">
             <a:avLst>
-              <a:gd name="adj" fmla="val 64655"/>
+              <a:gd name="adj" fmla="val 12985"/>
             </a:avLst>
           </a:prstGeom>
           <a:solidFill>
@@ -3787,14 +4485,14 @@
       </p:sp>
       <p:sp>
         <p:nvSpPr>
-          <p:cNvPr id="97" name="Text 75"/>
+          <p:cNvPr id="119" name="Text 96"/>
           <p:cNvSpPr txBox="1"/>
           <p:nvPr/>
         </p:nvSpPr>
         <p:spPr>
           <a:xfrm>
-            <a:off x="8574938" y="5436413"/>
-            <a:ext cx="1314602" cy="70714"/>
+            <a:off x="8431682" y="5184526"/>
+            <a:ext cx="1427378" cy="352105"/>
           </a:xfrm>
           <a:prstGeom prst="rect">
             <a:avLst/>
@@ -3808,12 +4506,12 @@
           <a:p>
             <a:pPr algn="ctr" indent="0" marL="0">
               <a:lnSpc>
-                <a:spcPct val="102000"/>
+                <a:spcPct val="98000"/>
               </a:lnSpc>
               <a:buNone/>
             </a:pPr>
             <a:r>
-              <a:rPr lang="en-US" sz="860" b="1" dirty="0">
+              <a:rPr lang="en-US" sz="780" b="1" dirty="0">
                 <a:solidFill>
                   <a:srgbClr val="A6650F"/>
                 </a:solidFill>
@@ -3823,24 +4521,24 @@
               </a:rPr>
               <a:t>Procesos de reposición</a:t>
             </a:r>
-            <a:endParaRPr lang="en-US" sz="860" dirty="0"/>
-          </a:p>
-        </p:txBody>
-      </p:sp>
-      <p:sp>
-        <p:nvSpPr>
-          <p:cNvPr id="98" name="Shape 76"/>
-          <p:cNvSpPr/>
-          <p:nvPr/>
-        </p:nvSpPr>
-        <p:spPr>
-          <a:xfrm>
-            <a:off x="10035845" y="5436413"/>
-            <a:ext cx="1460906" cy="70714"/>
+            <a:endParaRPr lang="en-US" sz="780" dirty="0"/>
+          </a:p>
+        </p:txBody>
+      </p:sp>
+      <p:sp>
+        <p:nvSpPr>
+          <p:cNvPr id="120" name="Shape 97"/>
+          <p:cNvSpPr/>
+          <p:nvPr/>
+        </p:nvSpPr>
+        <p:spPr>
+          <a:xfrm>
+            <a:off x="9977933" y="5184526"/>
+            <a:ext cx="1537106" cy="352105"/>
           </a:xfrm>
           <a:prstGeom prst="roundRect">
             <a:avLst>
-              <a:gd name="adj" fmla="val 64655"/>
+              <a:gd name="adj" fmla="val 12985"/>
             </a:avLst>
           </a:prstGeom>
           <a:solidFill>
@@ -3856,14 +4554,14 @@
       </p:sp>
       <p:sp>
         <p:nvSpPr>
-          <p:cNvPr id="99" name="Text 77"/>
+          <p:cNvPr id="121" name="Text 98"/>
           <p:cNvSpPr txBox="1"/>
           <p:nvPr/>
         </p:nvSpPr>
         <p:spPr>
           <a:xfrm>
-            <a:off x="10108997" y="5436413"/>
-            <a:ext cx="1314602" cy="70714"/>
+            <a:off x="10032797" y="5184526"/>
+            <a:ext cx="1427378" cy="352105"/>
           </a:xfrm>
           <a:prstGeom prst="rect">
             <a:avLst/>
@@ -3877,12 +4575,12 @@
           <a:p>
             <a:pPr algn="ctr" indent="0" marL="0">
               <a:lnSpc>
-                <a:spcPct val="102000"/>
+                <a:spcPct val="98000"/>
               </a:lnSpc>
               <a:buNone/>
             </a:pPr>
             <a:r>
-              <a:rPr lang="en-US" sz="860" b="1" dirty="0">
+              <a:rPr lang="en-US" sz="780" b="1" dirty="0">
                 <a:solidFill>
                   <a:srgbClr val="A6650F"/>
                 </a:solidFill>
@@ -3892,24 +4590,24 @@
               </a:rPr>
               <a:t>Fraudes y contracargos</a:t>
             </a:r>
-            <a:endParaRPr lang="en-US" sz="860" dirty="0"/>
-          </a:p>
-        </p:txBody>
-      </p:sp>
-      <p:sp>
-        <p:nvSpPr>
-          <p:cNvPr id="100" name="Shape 78"/>
-          <p:cNvSpPr/>
-          <p:nvPr/>
-        </p:nvSpPr>
-        <p:spPr>
-          <a:xfrm>
-            <a:off x="5678424" y="5635142"/>
-            <a:ext cx="5946343" cy="217018"/>
+            <a:endParaRPr lang="en-US" sz="780" dirty="0"/>
+          </a:p>
+        </p:txBody>
+      </p:sp>
+      <p:sp>
+        <p:nvSpPr>
+          <p:cNvPr id="122" name="Shape 99"/>
+          <p:cNvSpPr/>
+          <p:nvPr/>
+        </p:nvSpPr>
+        <p:spPr>
+          <a:xfrm>
+            <a:off x="5641848" y="5609783"/>
+            <a:ext cx="5982919" cy="425257"/>
           </a:xfrm>
           <a:prstGeom prst="roundRect">
             <a:avLst>
-              <a:gd name="adj" fmla="val 25281"/>
+              <a:gd name="adj" fmla="val 12901"/>
             </a:avLst>
           </a:prstGeom>
           <a:solidFill>
@@ -3920,14 +4618,14 @@
       </p:sp>
       <p:sp>
         <p:nvSpPr>
-          <p:cNvPr id="101" name="Shape 79"/>
-          <p:cNvSpPr/>
-          <p:nvPr/>
-        </p:nvSpPr>
-        <p:spPr>
-          <a:xfrm>
-            <a:off x="5769864" y="5606491"/>
-            <a:ext cx="1051560" cy="274320"/>
+          <p:cNvPr id="123" name="Shape 100"/>
+          <p:cNvSpPr/>
+          <p:nvPr/>
+        </p:nvSpPr>
+        <p:spPr>
+          <a:xfrm>
+            <a:off x="5733288" y="5712684"/>
+            <a:ext cx="914400" cy="219456"/>
           </a:xfrm>
           <a:prstGeom prst="roundRect">
             <a:avLst>
@@ -3942,14 +4640,14 @@
       </p:sp>
       <p:sp>
         <p:nvSpPr>
-          <p:cNvPr id="102" name="Text 80"/>
+          <p:cNvPr id="124" name="Text 101"/>
           <p:cNvSpPr txBox="1"/>
           <p:nvPr/>
         </p:nvSpPr>
         <p:spPr>
           <a:xfrm>
-            <a:off x="5769864" y="5606491"/>
-            <a:ext cx="1051560" cy="274320"/>
+            <a:off x="5733288" y="5712684"/>
+            <a:ext cx="914400" cy="219456"/>
           </a:xfrm>
           <a:prstGeom prst="rect">
             <a:avLst/>
@@ -3965,7 +4663,7 @@
               <a:buNone/>
             </a:pPr>
             <a:r>
-              <a:rPr lang="en-US" sz="900" b="1" spc="40" kern="0" dirty="0">
+              <a:rPr lang="en-US" sz="800" b="1" spc="40" kern="0" dirty="0">
                 <a:solidFill>
                   <a:srgbClr val="FFFFFF"/>
                 </a:solidFill>
@@ -3975,24 +4673,24 @@
               </a:rPr>
               <a:t>BAJA</a:t>
             </a:r>
-            <a:endParaRPr lang="en-US" sz="900" dirty="0"/>
-          </a:p>
-        </p:txBody>
-      </p:sp>
-      <p:sp>
-        <p:nvSpPr>
-          <p:cNvPr id="103" name="Shape 81"/>
-          <p:cNvSpPr/>
-          <p:nvPr/>
-        </p:nvSpPr>
-        <p:spPr>
-          <a:xfrm>
-            <a:off x="6967728" y="5708294"/>
-            <a:ext cx="2227936" cy="70714"/>
+            <a:endParaRPr lang="en-US" sz="800" dirty="0"/>
+          </a:p>
+        </p:txBody>
+      </p:sp>
+      <p:sp>
+        <p:nvSpPr>
+          <p:cNvPr id="125" name="Shape 102"/>
+          <p:cNvSpPr/>
+          <p:nvPr/>
+        </p:nvSpPr>
+        <p:spPr>
+          <a:xfrm>
+            <a:off x="6775704" y="5646359"/>
+            <a:ext cx="2337664" cy="352105"/>
           </a:xfrm>
           <a:prstGeom prst="roundRect">
             <a:avLst>
-              <a:gd name="adj" fmla="val 64655"/>
+              <a:gd name="adj" fmla="val 12985"/>
             </a:avLst>
           </a:prstGeom>
           <a:solidFill>
@@ -4008,14 +4706,14 @@
       </p:sp>
       <p:sp>
         <p:nvSpPr>
-          <p:cNvPr id="104" name="Text 82"/>
+          <p:cNvPr id="126" name="Text 103"/>
           <p:cNvSpPr txBox="1"/>
           <p:nvPr/>
         </p:nvSpPr>
         <p:spPr>
           <a:xfrm>
-            <a:off x="7040880" y="5708294"/>
-            <a:ext cx="2081632" cy="70714"/>
+            <a:off x="6830568" y="5646359"/>
+            <a:ext cx="2227936" cy="352105"/>
           </a:xfrm>
           <a:prstGeom prst="rect">
             <a:avLst/>
@@ -4029,12 +4727,12 @@
           <a:p>
             <a:pPr algn="ctr" indent="0" marL="0">
               <a:lnSpc>
-                <a:spcPct val="102000"/>
+                <a:spcPct val="98000"/>
               </a:lnSpc>
               <a:buNone/>
             </a:pPr>
             <a:r>
-              <a:rPr lang="en-US" sz="860" b="1" dirty="0">
+              <a:rPr lang="en-US" sz="780" b="1" dirty="0">
                 <a:solidFill>
                   <a:srgbClr val="1E8449"/>
                 </a:solidFill>
@@ -4044,24 +4742,24 @@
               </a:rPr>
               <a:t>Visualización de promociones</a:t>
             </a:r>
-            <a:endParaRPr lang="en-US" sz="860" dirty="0"/>
-          </a:p>
-        </p:txBody>
-      </p:sp>
-      <p:sp>
-        <p:nvSpPr>
-          <p:cNvPr id="105" name="Shape 83"/>
-          <p:cNvSpPr/>
-          <p:nvPr/>
-        </p:nvSpPr>
-        <p:spPr>
-          <a:xfrm>
-            <a:off x="9268816" y="5708294"/>
-            <a:ext cx="2227936" cy="70714"/>
+            <a:endParaRPr lang="en-US" sz="780" dirty="0"/>
+          </a:p>
+        </p:txBody>
+      </p:sp>
+      <p:sp>
+        <p:nvSpPr>
+          <p:cNvPr id="127" name="Shape 104"/>
+          <p:cNvSpPr/>
+          <p:nvPr/>
+        </p:nvSpPr>
+        <p:spPr>
+          <a:xfrm>
+            <a:off x="9177376" y="5646359"/>
+            <a:ext cx="2337664" cy="352105"/>
           </a:xfrm>
           <a:prstGeom prst="roundRect">
             <a:avLst>
-              <a:gd name="adj" fmla="val 64655"/>
+              <a:gd name="adj" fmla="val 12985"/>
             </a:avLst>
           </a:prstGeom>
           <a:solidFill>
@@ -4077,14 +4775,14 @@
       </p:sp>
       <p:sp>
         <p:nvSpPr>
-          <p:cNvPr id="106" name="Text 84"/>
+          <p:cNvPr id="128" name="Text 105"/>
           <p:cNvSpPr txBox="1"/>
           <p:nvPr/>
         </p:nvSpPr>
         <p:spPr>
           <a:xfrm>
-            <a:off x="9341968" y="5708294"/>
-            <a:ext cx="2081632" cy="70714"/>
+            <a:off x="9232240" y="5646359"/>
+            <a:ext cx="2227936" cy="352105"/>
           </a:xfrm>
           <a:prstGeom prst="rect">
             <a:avLst/>
@@ -4098,12 +4796,12 @@
           <a:p>
             <a:pPr algn="ctr" indent="0" marL="0">
               <a:lnSpc>
-                <a:spcPct val="102000"/>
+                <a:spcPct val="98000"/>
               </a:lnSpc>
               <a:buNone/>
             </a:pPr>
             <a:r>
-              <a:rPr lang="en-US" sz="860" b="1" dirty="0">
+              <a:rPr lang="en-US" sz="780" b="1" dirty="0">
                 <a:solidFill>
                   <a:srgbClr val="1E8449"/>
                 </a:solidFill>
@@ -4113,24 +4811,24 @@
               </a:rPr>
               <a:t>Mejoras operativas menores</a:t>
             </a:r>
-            <a:endParaRPr lang="en-US" sz="860" dirty="0"/>
-          </a:p>
-        </p:txBody>
-      </p:sp>
-      <p:sp>
-        <p:nvSpPr>
-          <p:cNvPr id="107" name="Shape 85"/>
-          <p:cNvSpPr/>
-          <p:nvPr/>
-        </p:nvSpPr>
-        <p:spPr>
-          <a:xfrm>
-            <a:off x="384048" y="5998464"/>
-            <a:ext cx="11423599" cy="713232"/>
+            <a:endParaRPr lang="en-US" sz="780" dirty="0"/>
+          </a:p>
+        </p:txBody>
+      </p:sp>
+      <p:sp>
+        <p:nvSpPr>
+          <p:cNvPr id="129" name="Shape 106"/>
+          <p:cNvSpPr/>
+          <p:nvPr/>
+        </p:nvSpPr>
+        <p:spPr>
+          <a:xfrm>
+            <a:off x="384048" y="6144768"/>
+            <a:ext cx="11423599" cy="585216"/>
           </a:xfrm>
           <a:prstGeom prst="roundRect">
             <a:avLst>
-              <a:gd name="adj" fmla="val 10256"/>
+              <a:gd name="adj" fmla="val 12500"/>
             </a:avLst>
           </a:prstGeom>
           <a:solidFill>
@@ -4141,14 +4839,14 @@
       </p:sp>
       <p:sp>
         <p:nvSpPr>
-          <p:cNvPr id="108" name="Shape 86"/>
-          <p:cNvSpPr/>
-          <p:nvPr/>
-        </p:nvSpPr>
-        <p:spPr>
-          <a:xfrm>
-            <a:off x="384048" y="5998464"/>
-            <a:ext cx="54864" cy="713232"/>
+          <p:cNvPr id="130" name="Shape 107"/>
+          <p:cNvSpPr/>
+          <p:nvPr/>
+        </p:nvSpPr>
+        <p:spPr>
+          <a:xfrm>
+            <a:off x="384048" y="6144768"/>
+            <a:ext cx="54864" cy="585216"/>
           </a:xfrm>
           <a:prstGeom prst="rect">
             <a:avLst/>
@@ -4161,22 +4859,22 @@
       </p:sp>
       <p:pic>
         <p:nvPicPr>
-          <p:cNvPr id="109" name="Image 20" descr="/tmp/claude-0/-home-user-riesgo/579fb8c8-70e5-51d5-80ec-6ed51cc2e8df/scratchpad/pptx-build/icons/flag_FFFFFF.png">    </p:cNvPr>
+          <p:cNvPr id="131" name="Image 21" descr="/tmp/claude-0/-home-user-riesgo/579fb8c8-70e5-51d5-80ec-6ed51cc2e8df/scratchpad/pptx-build/icons/flag_FFFFFF.png">    </p:cNvPr>
           <p:cNvPicPr>
             <a:picLocks noChangeAspect="1"/>
           </p:cNvPicPr>
           <p:nvPr/>
         </p:nvPicPr>
         <p:blipFill>
-          <a:blip r:embed="rId21"/>
+          <a:blip r:embed="rId22"/>
           <a:stretch>
             <a:fillRect/>
           </a:stretch>
         </p:blipFill>
         <p:spPr>
           <a:xfrm>
-            <a:off x="603504" y="6199632"/>
-            <a:ext cx="310896" cy="310896"/>
+            <a:off x="585216" y="6309360"/>
+            <a:ext cx="256032" cy="256032"/>
           </a:xfrm>
           <a:prstGeom prst="rect">
             <a:avLst/>
@@ -4185,14 +4883,14 @@
       </p:pic>
       <p:sp>
         <p:nvSpPr>
-          <p:cNvPr id="110" name="Text 87"/>
+          <p:cNvPr id="132" name="Text 108"/>
           <p:cNvSpPr txBox="1"/>
           <p:nvPr/>
         </p:nvSpPr>
         <p:spPr>
           <a:xfrm>
-            <a:off x="1042416" y="6071616"/>
-            <a:ext cx="10509199" cy="566928"/>
+            <a:off x="950976" y="6199632"/>
+            <a:ext cx="10646359" cy="475488"/>
           </a:xfrm>
           <a:prstGeom prst="rect">
             <a:avLst/>
@@ -4206,12 +4904,12 @@
           <a:p>
             <a:pPr algn="l" indent="0" marL="0">
               <a:lnSpc>
-                <a:spcPct val="118000"/>
+                <a:spcPct val="110000"/>
               </a:lnSpc>
               <a:buNone/>
             </a:pPr>
             <a:r>
-              <a:rPr lang="en-US" sz="1100" i="1" dirty="0">
+              <a:rPr lang="en-US" sz="980" i="1" dirty="0">
                 <a:solidFill>
                   <a:srgbClr val="FFFFFF"/>
                 </a:solidFill>
@@ -4221,7 +4919,7 @@
               </a:rPr>
               <a:t>Los resultados reflejan una percepción favorable del servicio de procesamiento de tarjetas de crédito; sin embargo, existen oportunidades críticas de mejora relacionadas con la estabilidad operativa, reversas, duplicidad de pagos y tiempos de respuesta. La atención de estos aspectos permitirá fortalecer la continuidad operativa, la experiencia de las agencias y la satisfacción de los asociados.</a:t>
             </a:r>
-            <a:endParaRPr lang="en-US" sz="1100" dirty="0"/>
+            <a:endParaRPr lang="en-US" sz="980" dirty="0"/>
           </a:p>
         </p:txBody>
       </p:sp>

</xml_diff>

<commit_message>
Add second slide with survey questions and full open-ended responses
New slide 2: a compact 5-tile strip with stacked bars for each closed
survey question, plus a full-width panel listing all 17 open-ended
comments verbatim, each attributed to its agency (matching row order
from the source spreadsheet).

Co-Authored-By: Claude Sonnet 5 <noreply@anthropic.com>
Claude-Session: https://claude.ai/code/session_01KND4cYnTdx53ydNLfQdR3S
</commit_message>
<xml_diff>
--- a/Dashboard_Ejecutivo_EVERTEC_JuntaDirectiva.pptx
+++ b/Dashboard_Ejecutivo_EVERTEC_JuntaDirectiva.pptx
@@ -6,9 +6,10 @@
   </p:sldMasterIdLst>
   <p:sldIdLst>
     <p:sldId id="256" r:id="rId2"/>
+    <p:sldId id="257" r:id="rId3"/>
   </p:sldIdLst>
   <p:notesMasterIdLst>
-    <p:notesMasterId r:id="rId3"/>
+    <p:notesMasterId r:id="rId4"/>
   </p:notesMasterIdLst>
   <p:sldSz cx="12191695" cy="6858000"/>
   <p:notesSz cx="6858000" cy="12191695"/>
@@ -544,6 +545,94 @@
 </p:notes>
 </file>
 
+<file path=ppt/notesSlides/notesSlide2.xml><?xml version="1.0" encoding="utf-8"?>
+<p:notes xmlns:a="http://schemas.openxmlformats.org/drawingml/2006/main" xmlns:r="http://schemas.openxmlformats.org/officeDocument/2006/relationships" xmlns:p="http://schemas.openxmlformats.org/presentationml/2006/main">
+  <p:cSld>
+    <p:spTree>
+      <p:nvGrpSpPr>
+        <p:cNvPr id="1" name=""/>
+        <p:cNvGrpSpPr/>
+        <p:nvPr/>
+      </p:nvGrpSpPr>
+      <p:grpSpPr>
+        <a:xfrm>
+          <a:off x="0" y="0"/>
+          <a:ext cx="0" cy="0"/>
+          <a:chOff x="0" y="0"/>
+          <a:chExt cx="0" cy="0"/>
+        </a:xfrm>
+      </p:grpSpPr>
+      <p:sp>
+        <p:nvSpPr>
+          <p:cNvPr id="2" name="Slide Image Placeholder 1"/>
+          <p:cNvSpPr>
+            <a:spLocks noGrp="1" noRot="1" noChangeAspect="1"/>
+          </p:cNvSpPr>
+          <p:nvPr>
+            <p:ph type="sldImg"/>
+          </p:nvPr>
+        </p:nvSpPr>
+        <p:spPr/>
+      </p:sp>
+      <p:sp>
+        <p:nvSpPr>
+          <p:cNvPr id="3" name="Notes Placeholder 2"/>
+          <p:cNvSpPr>
+            <a:spLocks noGrp="1"/>
+          </p:cNvSpPr>
+          <p:nvPr>
+            <p:ph type="body" idx="1"/>
+          </p:nvPr>
+        </p:nvSpPr>
+        <p:spPr/>
+        <p:txBody>
+          <a:bodyPr/>
+          <a:lstStyle/>
+          <a:p>
+            <a:r>
+              <a:rPr lang="en-US" dirty="0"/>
+              <a:t/>
+            </a:r>
+            <a:endParaRPr lang="en-US" dirty="0"/>
+          </a:p>
+        </p:txBody>
+      </p:sp>
+      <p:sp>
+        <p:nvSpPr>
+          <p:cNvPr id="4" name="Slide Number Placeholder 3"/>
+          <p:cNvSpPr>
+            <a:spLocks noGrp="1"/>
+          </p:cNvSpPr>
+          <p:nvPr>
+            <p:ph type="sldNum" sz="quarter" idx="10"/>
+          </p:nvPr>
+        </p:nvSpPr>
+        <p:spPr/>
+        <p:txBody>
+          <a:bodyPr/>
+          <a:lstStyle/>
+          <a:p>
+            <a:fld id="{F7021451-1387-4CA6-816F-3879F97B5CBC}" type="slidenum">
+              <a:rPr lang="en-US"/>
+              <a:t>2</a:t>
+            </a:fld>
+            <a:endParaRPr lang="en-US"/>
+          </a:p>
+        </p:txBody>
+      </p:sp>
+    </p:spTree>
+    <p:extLst>
+      <p:ext uri="{BB962C8B-B14F-4D97-AF65-F5344CB8AC3E}">
+        <p14:creationId xmlns:p14="http://schemas.microsoft.com/office/powerpoint/2010/main" val="1024086991"/>
+      </p:ext>
+    </p:extLst>
+  </p:cSld>
+  <p:clrMapOvr>
+    <a:masterClrMapping/>
+  </p:clrMapOvr>
+</p:notes>
+</file>
+
 <file path=ppt/slideLayouts/slideLayout1.xml><?xml version="1.0" encoding="utf-8"?>
 <p:sldLayout xmlns:a="http://schemas.openxmlformats.org/drawingml/2006/main" xmlns:r="http://schemas.openxmlformats.org/officeDocument/2006/relationships" xmlns:p="http://schemas.openxmlformats.org/presentationml/2006/main" preserve="1">
   <p:cSld name="DEFAULT">
@@ -4920,6 +5009,3094 @@
               <a:t>Los resultados reflejan una percepción favorable del servicio de procesamiento de tarjetas de crédito; sin embargo, existen oportunidades críticas de mejora relacionadas con la estabilidad operativa, reversas, duplicidad de pagos y tiempos de respuesta. La atención de estos aspectos permitirá fortalecer la continuidad operativa, la experiencia de las agencias y la satisfacción de los asociados.</a:t>
             </a:r>
             <a:endParaRPr lang="en-US" sz="980" dirty="0"/>
+          </a:p>
+        </p:txBody>
+      </p:sp>
+    </p:spTree>
+  </p:cSld>
+  <p:clrMapOvr>
+    <a:masterClrMapping/>
+  </p:clrMapOvr>
+</p:sld>
+</file>
+
+<file path=ppt/slides/slide2.xml><?xml version="1.0" encoding="utf-8"?>
+<p:sld xmlns:a="http://schemas.openxmlformats.org/drawingml/2006/main" xmlns:r="http://schemas.openxmlformats.org/officeDocument/2006/relationships" xmlns:p="http://schemas.openxmlformats.org/presentationml/2006/main">
+  <p:cSld name="Slide 2">
+    <p:bg>
+      <p:bgPr>
+        <a:solidFill>
+          <a:srgbClr val="FFFFFF"/>
+        </a:solidFill>
+      </p:bgPr>
+    </p:bg>
+    <p:spTree>
+      <p:nvGrpSpPr>
+        <p:cNvPr id="1" name=""/>
+        <p:cNvGrpSpPr/>
+        <p:nvPr/>
+      </p:nvGrpSpPr>
+      <p:grpSpPr>
+        <a:xfrm>
+          <a:off x="0" y="0"/>
+          <a:ext cx="0" cy="0"/>
+          <a:chOff x="0" y="0"/>
+          <a:chExt cx="0" cy="0"/>
+        </a:xfrm>
+      </p:grpSpPr>
+      <p:sp>
+        <p:nvSpPr>
+          <p:cNvPr id="2" name="Text 0"/>
+          <p:cNvSpPr txBox="1"/>
+          <p:nvPr/>
+        </p:nvSpPr>
+        <p:spPr>
+          <a:xfrm>
+            <a:off x="384048" y="219456"/>
+            <a:ext cx="8778240" cy="182880"/>
+          </a:xfrm>
+          <a:prstGeom prst="rect">
+            <a:avLst/>
+          </a:prstGeom>
+          <a:noFill/>
+          <a:ln/>
+        </p:spPr>
+        <p:txBody>
+          <a:bodyPr wrap="square" lIns="0" tIns="0" rIns="0" bIns="0" rtlCol="0" anchor="ctr"/>
+          <a:lstStyle/>
+          <a:p>
+            <a:pPr algn="l" indent="0" marL="0">
+              <a:buNone/>
+            </a:pPr>
+            <a:r>
+              <a:rPr lang="en-US" sz="950" b="1" spc="160" kern="0" dirty="0">
+                <a:solidFill>
+                  <a:srgbClr val="17A9B0"/>
+                </a:solidFill>
+                <a:latin typeface="Calibri" pitchFamily="34" charset="0"/>
+                <a:ea typeface="Calibri" pitchFamily="34" charset="-122"/>
+                <a:cs typeface="Calibri" pitchFamily="34" charset="-120"/>
+              </a:rPr>
+              <a:t>EVALUACIÓN DE SERVICIO  ·  GERENCIA DE TECNOLOGÍA</a:t>
+            </a:r>
+            <a:endParaRPr lang="en-US" sz="950" dirty="0"/>
+          </a:p>
+        </p:txBody>
+      </p:sp>
+      <p:sp>
+        <p:nvSpPr>
+          <p:cNvPr id="3" name="Text 1"/>
+          <p:cNvSpPr txBox="1"/>
+          <p:nvPr/>
+        </p:nvSpPr>
+        <p:spPr>
+          <a:xfrm>
+            <a:off x="384048" y="411480"/>
+            <a:ext cx="9418320" cy="329184"/>
+          </a:xfrm>
+          <a:prstGeom prst="rect">
+            <a:avLst/>
+          </a:prstGeom>
+          <a:noFill/>
+          <a:ln/>
+        </p:spPr>
+        <p:txBody>
+          <a:bodyPr wrap="square" lIns="0" tIns="0" rIns="0" bIns="0" rtlCol="0" anchor="t"/>
+          <a:lstStyle/>
+          <a:p>
+            <a:pPr algn="l" indent="0" marL="0">
+              <a:buNone/>
+            </a:pPr>
+            <a:r>
+              <a:rPr lang="en-US" sz="1700" b="1" dirty="0">
+                <a:solidFill>
+                  <a:srgbClr val="17223A"/>
+                </a:solidFill>
+                <a:latin typeface="Calibri" pitchFamily="34" charset="0"/>
+                <a:ea typeface="Calibri" pitchFamily="34" charset="-122"/>
+                <a:cs typeface="Calibri" pitchFamily="34" charset="-120"/>
+              </a:rPr>
+              <a:t>Preguntas de la Encuesta y Distribución de Respuestas — EVERTEC</a:t>
+            </a:r>
+            <a:endParaRPr lang="en-US" sz="1700" dirty="0"/>
+          </a:p>
+        </p:txBody>
+      </p:sp>
+      <p:sp>
+        <p:nvSpPr>
+          <p:cNvPr id="4" name="Text 2"/>
+          <p:cNvSpPr txBox="1"/>
+          <p:nvPr/>
+        </p:nvSpPr>
+        <p:spPr>
+          <a:xfrm>
+            <a:off x="384048" y="749808"/>
+            <a:ext cx="9418320" cy="219456"/>
+          </a:xfrm>
+          <a:prstGeom prst="rect">
+            <a:avLst/>
+          </a:prstGeom>
+          <a:noFill/>
+          <a:ln/>
+        </p:spPr>
+        <p:txBody>
+          <a:bodyPr wrap="square" lIns="0" tIns="0" rIns="0" bIns="0" rtlCol="0" anchor="ctr"/>
+          <a:lstStyle/>
+          <a:p>
+            <a:pPr algn="l" indent="0" marL="0">
+              <a:buNone/>
+            </a:pPr>
+            <a:r>
+              <a:rPr lang="en-US" sz="1000" i="1" dirty="0">
+                <a:solidFill>
+                  <a:srgbClr val="5B6B82"/>
+                </a:solidFill>
+                <a:latin typeface="Calibri" pitchFamily="34" charset="0"/>
+                <a:ea typeface="Calibri" pitchFamily="34" charset="-122"/>
+                <a:cs typeface="Calibri" pitchFamily="34" charset="-120"/>
+              </a:rPr>
+              <a:t>Resultados cerrados por pregunta y comentarios textuales de las 17 agencias participantes</a:t>
+            </a:r>
+            <a:endParaRPr lang="en-US" sz="1000" dirty="0"/>
+          </a:p>
+        </p:txBody>
+      </p:sp>
+      <p:sp>
+        <p:nvSpPr>
+          <p:cNvPr id="5" name="Shape 3"/>
+          <p:cNvSpPr/>
+          <p:nvPr/>
+        </p:nvSpPr>
+        <p:spPr>
+          <a:xfrm>
+            <a:off x="10436047" y="256032"/>
+            <a:ext cx="1371600" cy="329184"/>
+          </a:xfrm>
+          <a:prstGeom prst="roundRect">
+            <a:avLst>
+              <a:gd name="adj" fmla="val 16667"/>
+            </a:avLst>
+          </a:prstGeom>
+          <a:solidFill>
+            <a:srgbClr val="133B6C"/>
+          </a:solidFill>
+          <a:ln/>
+        </p:spPr>
+      </p:sp>
+      <p:sp>
+        <p:nvSpPr>
+          <p:cNvPr id="6" name="Text 4"/>
+          <p:cNvSpPr txBox="1"/>
+          <p:nvPr/>
+        </p:nvSpPr>
+        <p:spPr>
+          <a:xfrm>
+            <a:off x="10436047" y="256032"/>
+            <a:ext cx="1371600" cy="329184"/>
+          </a:xfrm>
+          <a:prstGeom prst="rect">
+            <a:avLst/>
+          </a:prstGeom>
+          <a:noFill/>
+          <a:ln/>
+        </p:spPr>
+        <p:txBody>
+          <a:bodyPr wrap="square" lIns="0" tIns="0" rIns="0" bIns="0" rtlCol="0" anchor="ctr"/>
+          <a:lstStyle/>
+          <a:p>
+            <a:pPr algn="ctr" indent="0" marL="0">
+              <a:buNone/>
+            </a:pPr>
+            <a:r>
+              <a:rPr lang="en-US" sz="900" b="1" dirty="0">
+                <a:solidFill>
+                  <a:srgbClr val="FFFFFF"/>
+                </a:solidFill>
+                <a:latin typeface="Calibri" pitchFamily="34" charset="0"/>
+                <a:ea typeface="Calibri" pitchFamily="34" charset="-122"/>
+                <a:cs typeface="Calibri" pitchFamily="34" charset="-120"/>
+              </a:rPr>
+              <a:t>17 RESPUESTAS</a:t>
+            </a:r>
+            <a:endParaRPr lang="en-US" sz="900" dirty="0"/>
+          </a:p>
+        </p:txBody>
+      </p:sp>
+      <p:sp>
+        <p:nvSpPr>
+          <p:cNvPr id="7" name="Shape 5"/>
+          <p:cNvSpPr/>
+          <p:nvPr/>
+        </p:nvSpPr>
+        <p:spPr>
+          <a:xfrm>
+            <a:off x="384048" y="1005840"/>
+            <a:ext cx="11423599" cy="16459"/>
+          </a:xfrm>
+          <a:prstGeom prst="rect">
+            <a:avLst/>
+          </a:prstGeom>
+          <a:solidFill>
+            <a:srgbClr val="17A9B0"/>
+          </a:solidFill>
+          <a:ln/>
+        </p:spPr>
+      </p:sp>
+      <p:sp>
+        <p:nvSpPr>
+          <p:cNvPr id="8" name="Shape 6"/>
+          <p:cNvSpPr/>
+          <p:nvPr/>
+        </p:nvSpPr>
+        <p:spPr>
+          <a:xfrm>
+            <a:off x="384048" y="1133856"/>
+            <a:ext cx="2182307" cy="1207008"/>
+          </a:xfrm>
+          <a:prstGeom prst="roundRect">
+            <a:avLst>
+              <a:gd name="adj" fmla="val 4545"/>
+            </a:avLst>
+          </a:prstGeom>
+          <a:solidFill>
+            <a:srgbClr val="FFFFFF"/>
+          </a:solidFill>
+          <a:ln w="9525">
+            <a:solidFill>
+              <a:srgbClr val="E7EAF0"/>
+            </a:solidFill>
+            <a:prstDash val="solid"/>
+          </a:ln>
+          <a:effectLst>
+            <a:outerShdw sx="100000" sy="100000" kx="0" ky="0" algn="bl" rotWithShape="0" blurRad="63500" dist="19050" dir="5400000">
+              <a:srgbClr val="0F2F4E">
+                <a:alpha val="9000"/>
+              </a:srgbClr>
+            </a:outerShdw>
+          </a:effectLst>
+        </p:spPr>
+      </p:sp>
+      <p:sp>
+        <p:nvSpPr>
+          <p:cNvPr id="9" name="Shape 7"/>
+          <p:cNvSpPr/>
+          <p:nvPr/>
+        </p:nvSpPr>
+        <p:spPr>
+          <a:xfrm>
+            <a:off x="493776" y="1225296"/>
+            <a:ext cx="173736" cy="173736"/>
+          </a:xfrm>
+          <a:prstGeom prst="ellipse">
+            <a:avLst/>
+          </a:prstGeom>
+          <a:solidFill>
+            <a:srgbClr val="133B6C"/>
+          </a:solidFill>
+          <a:ln/>
+        </p:spPr>
+      </p:sp>
+      <p:sp>
+        <p:nvSpPr>
+          <p:cNvPr id="10" name="Text 8"/>
+          <p:cNvSpPr txBox="1"/>
+          <p:nvPr/>
+        </p:nvSpPr>
+        <p:spPr>
+          <a:xfrm>
+            <a:off x="493776" y="1225296"/>
+            <a:ext cx="173736" cy="173736"/>
+          </a:xfrm>
+          <a:prstGeom prst="rect">
+            <a:avLst/>
+          </a:prstGeom>
+          <a:noFill/>
+          <a:ln/>
+        </p:spPr>
+        <p:txBody>
+          <a:bodyPr wrap="square" lIns="0" tIns="0" rIns="0" bIns="0" rtlCol="0" anchor="ctr"/>
+          <a:lstStyle/>
+          <a:p>
+            <a:pPr algn="ctr" indent="0" marL="0">
+              <a:buNone/>
+            </a:pPr>
+            <a:r>
+              <a:rPr lang="en-US" sz="900" b="1" dirty="0">
+                <a:solidFill>
+                  <a:srgbClr val="FFFFFF"/>
+                </a:solidFill>
+                <a:latin typeface="Calibri" pitchFamily="34" charset="0"/>
+                <a:ea typeface="Calibri" pitchFamily="34" charset="-122"/>
+                <a:cs typeface="Calibri" pitchFamily="34" charset="-120"/>
+              </a:rPr>
+              <a:t>1</a:t>
+            </a:r>
+            <a:endParaRPr lang="en-US" sz="900" dirty="0"/>
+          </a:p>
+        </p:txBody>
+      </p:sp>
+      <p:sp>
+        <p:nvSpPr>
+          <p:cNvPr id="11" name="Text 9"/>
+          <p:cNvSpPr txBox="1"/>
+          <p:nvPr/>
+        </p:nvSpPr>
+        <p:spPr>
+          <a:xfrm>
+            <a:off x="740664" y="1207008"/>
+            <a:ext cx="1715963" cy="457200"/>
+          </a:xfrm>
+          <a:prstGeom prst="rect">
+            <a:avLst/>
+          </a:prstGeom>
+          <a:noFill/>
+          <a:ln/>
+        </p:spPr>
+        <p:txBody>
+          <a:bodyPr wrap="square" lIns="0" tIns="0" rIns="0" bIns="0" rtlCol="0" anchor="t"/>
+          <a:lstStyle/>
+          <a:p>
+            <a:pPr algn="l" indent="0" marL="0">
+              <a:lnSpc>
+                <a:spcPct val="112000"/>
+              </a:lnSpc>
+              <a:buNone/>
+            </a:pPr>
+            <a:r>
+              <a:rPr lang="en-US" sz="950" b="1" dirty="0">
+                <a:solidFill>
+                  <a:srgbClr val="17223A"/>
+                </a:solidFill>
+                <a:latin typeface="Calibri" pitchFamily="34" charset="0"/>
+                <a:ea typeface="Calibri" pitchFamily="34" charset="-122"/>
+                <a:cs typeface="Calibri" pitchFamily="34" charset="-120"/>
+              </a:rPr>
+              <a:t>¿Con qué frecuencia se presentan fallas del sistema?</a:t>
+            </a:r>
+            <a:endParaRPr lang="en-US" sz="950" dirty="0"/>
+          </a:p>
+        </p:txBody>
+      </p:sp>
+      <p:sp>
+        <p:nvSpPr>
+          <p:cNvPr id="12" name="Shape 10"/>
+          <p:cNvSpPr/>
+          <p:nvPr/>
+        </p:nvSpPr>
+        <p:spPr>
+          <a:xfrm>
+            <a:off x="493776" y="1664208"/>
+            <a:ext cx="1962851" cy="118872"/>
+          </a:xfrm>
+          <a:prstGeom prst="roundRect">
+            <a:avLst>
+              <a:gd name="adj" fmla="val 15385"/>
+            </a:avLst>
+          </a:prstGeom>
+          <a:solidFill>
+            <a:srgbClr val="EEF1F5"/>
+          </a:solidFill>
+          <a:ln/>
+        </p:spPr>
+      </p:sp>
+      <p:sp>
+        <p:nvSpPr>
+          <p:cNvPr id="13" name="Shape 11"/>
+          <p:cNvSpPr/>
+          <p:nvPr/>
+        </p:nvSpPr>
+        <p:spPr>
+          <a:xfrm>
+            <a:off x="493776" y="1664208"/>
+            <a:ext cx="692886" cy="118872"/>
+          </a:xfrm>
+          <a:prstGeom prst="rect">
+            <a:avLst/>
+          </a:prstGeom>
+          <a:solidFill>
+            <a:srgbClr val="E0392B"/>
+          </a:solidFill>
+          <a:ln/>
+        </p:spPr>
+      </p:sp>
+      <p:sp>
+        <p:nvSpPr>
+          <p:cNvPr id="14" name="Shape 12"/>
+          <p:cNvSpPr/>
+          <p:nvPr/>
+        </p:nvSpPr>
+        <p:spPr>
+          <a:xfrm>
+            <a:off x="1186662" y="1664208"/>
+            <a:ext cx="1038348" cy="118872"/>
+          </a:xfrm>
+          <a:prstGeom prst="rect">
+            <a:avLst/>
+          </a:prstGeom>
+          <a:solidFill>
+            <a:srgbClr val="A6650F"/>
+          </a:solidFill>
+          <a:ln/>
+        </p:spPr>
+      </p:sp>
+      <p:sp>
+        <p:nvSpPr>
+          <p:cNvPr id="15" name="Shape 13"/>
+          <p:cNvSpPr/>
+          <p:nvPr/>
+        </p:nvSpPr>
+        <p:spPr>
+          <a:xfrm>
+            <a:off x="2225011" y="1664208"/>
+            <a:ext cx="231616" cy="118872"/>
+          </a:xfrm>
+          <a:prstGeom prst="rect">
+            <a:avLst/>
+          </a:prstGeom>
+          <a:solidFill>
+            <a:srgbClr val="1E8449"/>
+          </a:solidFill>
+          <a:ln/>
+        </p:spPr>
+      </p:sp>
+      <p:sp>
+        <p:nvSpPr>
+          <p:cNvPr id="16" name="Shape 14"/>
+          <p:cNvSpPr/>
+          <p:nvPr/>
+        </p:nvSpPr>
+        <p:spPr>
+          <a:xfrm>
+            <a:off x="493776" y="1856232"/>
+            <a:ext cx="54864" cy="54864"/>
+          </a:xfrm>
+          <a:prstGeom prst="ellipse">
+            <a:avLst/>
+          </a:prstGeom>
+          <a:solidFill>
+            <a:srgbClr val="E0392B"/>
+          </a:solidFill>
+          <a:ln/>
+        </p:spPr>
+      </p:sp>
+      <p:sp>
+        <p:nvSpPr>
+          <p:cNvPr id="17" name="Text 15"/>
+          <p:cNvSpPr txBox="1"/>
+          <p:nvPr/>
+        </p:nvSpPr>
+        <p:spPr>
+          <a:xfrm>
+            <a:off x="594360" y="1819656"/>
+            <a:ext cx="1862267" cy="128016"/>
+          </a:xfrm>
+          <a:prstGeom prst="rect">
+            <a:avLst/>
+          </a:prstGeom>
+          <a:noFill/>
+          <a:ln/>
+        </p:spPr>
+        <p:txBody>
+          <a:bodyPr wrap="square" lIns="0" tIns="0" rIns="0" bIns="0" rtlCol="0" anchor="ctr"/>
+          <a:lstStyle/>
+          <a:p>
+            <a:pPr algn="l" indent="0" marL="0">
+              <a:buNone/>
+            </a:pPr>
+            <a:r>
+              <a:rPr lang="en-US" sz="760" b="1" dirty="0">
+                <a:solidFill>
+                  <a:srgbClr val="E0392B"/>
+                </a:solidFill>
+                <a:latin typeface="Calibri" pitchFamily="34" charset="0"/>
+                <a:ea typeface="Calibri" pitchFamily="34" charset="-122"/>
+                <a:cs typeface="Calibri" pitchFamily="34" charset="-120"/>
+              </a:rPr>
+              <a:t>35.3% Frecuente</a:t>
+            </a:r>
+            <a:endParaRPr lang="en-US" sz="760" dirty="0"/>
+          </a:p>
+        </p:txBody>
+      </p:sp>
+      <p:sp>
+        <p:nvSpPr>
+          <p:cNvPr id="18" name="Shape 16"/>
+          <p:cNvSpPr/>
+          <p:nvPr/>
+        </p:nvSpPr>
+        <p:spPr>
+          <a:xfrm>
+            <a:off x="493776" y="1997964"/>
+            <a:ext cx="54864" cy="54864"/>
+          </a:xfrm>
+          <a:prstGeom prst="ellipse">
+            <a:avLst/>
+          </a:prstGeom>
+          <a:solidFill>
+            <a:srgbClr val="A6650F"/>
+          </a:solidFill>
+          <a:ln/>
+        </p:spPr>
+      </p:sp>
+      <p:sp>
+        <p:nvSpPr>
+          <p:cNvPr id="19" name="Text 17"/>
+          <p:cNvSpPr txBox="1"/>
+          <p:nvPr/>
+        </p:nvSpPr>
+        <p:spPr>
+          <a:xfrm>
+            <a:off x="594360" y="1961388"/>
+            <a:ext cx="1862267" cy="128016"/>
+          </a:xfrm>
+          <a:prstGeom prst="rect">
+            <a:avLst/>
+          </a:prstGeom>
+          <a:noFill/>
+          <a:ln/>
+        </p:spPr>
+        <p:txBody>
+          <a:bodyPr wrap="square" lIns="0" tIns="0" rIns="0" bIns="0" rtlCol="0" anchor="ctr"/>
+          <a:lstStyle/>
+          <a:p>
+            <a:pPr algn="l" indent="0" marL="0">
+              <a:buNone/>
+            </a:pPr>
+            <a:r>
+              <a:rPr lang="en-US" sz="760" b="1" dirty="0">
+                <a:solidFill>
+                  <a:srgbClr val="A6650F"/>
+                </a:solidFill>
+                <a:latin typeface="Calibri" pitchFamily="34" charset="0"/>
+                <a:ea typeface="Calibri" pitchFamily="34" charset="-122"/>
+                <a:cs typeface="Calibri" pitchFamily="34" charset="-120"/>
+              </a:rPr>
+              <a:t>52.9% Algunas veces</a:t>
+            </a:r>
+            <a:endParaRPr lang="en-US" sz="760" dirty="0"/>
+          </a:p>
+        </p:txBody>
+      </p:sp>
+      <p:sp>
+        <p:nvSpPr>
+          <p:cNvPr id="20" name="Shape 18"/>
+          <p:cNvSpPr/>
+          <p:nvPr/>
+        </p:nvSpPr>
+        <p:spPr>
+          <a:xfrm>
+            <a:off x="493776" y="2139696"/>
+            <a:ext cx="54864" cy="54864"/>
+          </a:xfrm>
+          <a:prstGeom prst="ellipse">
+            <a:avLst/>
+          </a:prstGeom>
+          <a:solidFill>
+            <a:srgbClr val="1E8449"/>
+          </a:solidFill>
+          <a:ln/>
+        </p:spPr>
+      </p:sp>
+      <p:sp>
+        <p:nvSpPr>
+          <p:cNvPr id="21" name="Text 19"/>
+          <p:cNvSpPr txBox="1"/>
+          <p:nvPr/>
+        </p:nvSpPr>
+        <p:spPr>
+          <a:xfrm>
+            <a:off x="594360" y="2103120"/>
+            <a:ext cx="1862267" cy="128016"/>
+          </a:xfrm>
+          <a:prstGeom prst="rect">
+            <a:avLst/>
+          </a:prstGeom>
+          <a:noFill/>
+          <a:ln/>
+        </p:spPr>
+        <p:txBody>
+          <a:bodyPr wrap="square" lIns="0" tIns="0" rIns="0" bIns="0" rtlCol="0" anchor="ctr"/>
+          <a:lstStyle/>
+          <a:p>
+            <a:pPr algn="l" indent="0" marL="0">
+              <a:buNone/>
+            </a:pPr>
+            <a:r>
+              <a:rPr lang="en-US" sz="760" b="1" dirty="0">
+                <a:solidFill>
+                  <a:srgbClr val="1E8449"/>
+                </a:solidFill>
+                <a:latin typeface="Calibri" pitchFamily="34" charset="0"/>
+                <a:ea typeface="Calibri" pitchFamily="34" charset="-122"/>
+                <a:cs typeface="Calibri" pitchFamily="34" charset="-120"/>
+              </a:rPr>
+              <a:t>11.8% Rara vez</a:t>
+            </a:r>
+            <a:endParaRPr lang="en-US" sz="760" dirty="0"/>
+          </a:p>
+        </p:txBody>
+      </p:sp>
+      <p:sp>
+        <p:nvSpPr>
+          <p:cNvPr id="22" name="Shape 20"/>
+          <p:cNvSpPr/>
+          <p:nvPr/>
+        </p:nvSpPr>
+        <p:spPr>
+          <a:xfrm>
+            <a:off x="2694371" y="1133856"/>
+            <a:ext cx="2182307" cy="1207008"/>
+          </a:xfrm>
+          <a:prstGeom prst="roundRect">
+            <a:avLst>
+              <a:gd name="adj" fmla="val 4545"/>
+            </a:avLst>
+          </a:prstGeom>
+          <a:solidFill>
+            <a:srgbClr val="FFFFFF"/>
+          </a:solidFill>
+          <a:ln w="9525">
+            <a:solidFill>
+              <a:srgbClr val="E7EAF0"/>
+            </a:solidFill>
+            <a:prstDash val="solid"/>
+          </a:ln>
+          <a:effectLst>
+            <a:outerShdw sx="100000" sy="100000" kx="0" ky="0" algn="bl" rotWithShape="0" blurRad="63500" dist="19050" dir="5400000">
+              <a:srgbClr val="0F2F4E">
+                <a:alpha val="9000"/>
+              </a:srgbClr>
+            </a:outerShdw>
+          </a:effectLst>
+        </p:spPr>
+      </p:sp>
+      <p:sp>
+        <p:nvSpPr>
+          <p:cNvPr id="23" name="Shape 21"/>
+          <p:cNvSpPr/>
+          <p:nvPr/>
+        </p:nvSpPr>
+        <p:spPr>
+          <a:xfrm>
+            <a:off x="2804099" y="1225296"/>
+            <a:ext cx="173736" cy="173736"/>
+          </a:xfrm>
+          <a:prstGeom prst="ellipse">
+            <a:avLst/>
+          </a:prstGeom>
+          <a:solidFill>
+            <a:srgbClr val="133B6C"/>
+          </a:solidFill>
+          <a:ln/>
+        </p:spPr>
+      </p:sp>
+      <p:sp>
+        <p:nvSpPr>
+          <p:cNvPr id="24" name="Text 22"/>
+          <p:cNvSpPr txBox="1"/>
+          <p:nvPr/>
+        </p:nvSpPr>
+        <p:spPr>
+          <a:xfrm>
+            <a:off x="2804099" y="1225296"/>
+            <a:ext cx="173736" cy="173736"/>
+          </a:xfrm>
+          <a:prstGeom prst="rect">
+            <a:avLst/>
+          </a:prstGeom>
+          <a:noFill/>
+          <a:ln/>
+        </p:spPr>
+        <p:txBody>
+          <a:bodyPr wrap="square" lIns="0" tIns="0" rIns="0" bIns="0" rtlCol="0" anchor="ctr"/>
+          <a:lstStyle/>
+          <a:p>
+            <a:pPr algn="ctr" indent="0" marL="0">
+              <a:buNone/>
+            </a:pPr>
+            <a:r>
+              <a:rPr lang="en-US" sz="900" b="1" dirty="0">
+                <a:solidFill>
+                  <a:srgbClr val="FFFFFF"/>
+                </a:solidFill>
+                <a:latin typeface="Calibri" pitchFamily="34" charset="0"/>
+                <a:ea typeface="Calibri" pitchFamily="34" charset="-122"/>
+                <a:cs typeface="Calibri" pitchFamily="34" charset="-120"/>
+              </a:rPr>
+              <a:t>2</a:t>
+            </a:r>
+            <a:endParaRPr lang="en-US" sz="900" dirty="0"/>
+          </a:p>
+        </p:txBody>
+      </p:sp>
+      <p:sp>
+        <p:nvSpPr>
+          <p:cNvPr id="25" name="Text 23"/>
+          <p:cNvSpPr txBox="1"/>
+          <p:nvPr/>
+        </p:nvSpPr>
+        <p:spPr>
+          <a:xfrm>
+            <a:off x="3050987" y="1207008"/>
+            <a:ext cx="1715963" cy="457200"/>
+          </a:xfrm>
+          <a:prstGeom prst="rect">
+            <a:avLst/>
+          </a:prstGeom>
+          <a:noFill/>
+          <a:ln/>
+        </p:spPr>
+        <p:txBody>
+          <a:bodyPr wrap="square" lIns="0" tIns="0" rIns="0" bIns="0" rtlCol="0" anchor="t"/>
+          <a:lstStyle/>
+          <a:p>
+            <a:pPr algn="l" indent="0" marL="0">
+              <a:lnSpc>
+                <a:spcPct val="112000"/>
+              </a:lnSpc>
+              <a:buNone/>
+            </a:pPr>
+            <a:r>
+              <a:rPr lang="en-US" sz="950" b="1" dirty="0">
+                <a:solidFill>
+                  <a:srgbClr val="17223A"/>
+                </a:solidFill>
+                <a:latin typeface="Calibri" pitchFamily="34" charset="0"/>
+                <a:ea typeface="Calibri" pitchFamily="34" charset="-122"/>
+                <a:cs typeface="Calibri" pitchFamily="34" charset="-120"/>
+              </a:rPr>
+              <a:t>¿El soporte de EVERTEC atiende oportunamente?</a:t>
+            </a:r>
+            <a:endParaRPr lang="en-US" sz="950" dirty="0"/>
+          </a:p>
+        </p:txBody>
+      </p:sp>
+      <p:sp>
+        <p:nvSpPr>
+          <p:cNvPr id="26" name="Shape 24"/>
+          <p:cNvSpPr/>
+          <p:nvPr/>
+        </p:nvSpPr>
+        <p:spPr>
+          <a:xfrm>
+            <a:off x="2804099" y="1664208"/>
+            <a:ext cx="1962851" cy="118872"/>
+          </a:xfrm>
+          <a:prstGeom prst="roundRect">
+            <a:avLst>
+              <a:gd name="adj" fmla="val 15385"/>
+            </a:avLst>
+          </a:prstGeom>
+          <a:solidFill>
+            <a:srgbClr val="EEF1F5"/>
+          </a:solidFill>
+          <a:ln/>
+        </p:spPr>
+      </p:sp>
+      <p:sp>
+        <p:nvSpPr>
+          <p:cNvPr id="27" name="Shape 25"/>
+          <p:cNvSpPr/>
+          <p:nvPr/>
+        </p:nvSpPr>
+        <p:spPr>
+          <a:xfrm>
+            <a:off x="2804099" y="1664208"/>
+            <a:ext cx="1385773" cy="118872"/>
+          </a:xfrm>
+          <a:prstGeom prst="rect">
+            <a:avLst/>
+          </a:prstGeom>
+          <a:solidFill>
+            <a:srgbClr val="1E8449"/>
+          </a:solidFill>
+          <a:ln/>
+        </p:spPr>
+      </p:sp>
+      <p:sp>
+        <p:nvSpPr>
+          <p:cNvPr id="28" name="Shape 26"/>
+          <p:cNvSpPr/>
+          <p:nvPr/>
+        </p:nvSpPr>
+        <p:spPr>
+          <a:xfrm>
+            <a:off x="4189872" y="1664208"/>
+            <a:ext cx="345462" cy="118872"/>
+          </a:xfrm>
+          <a:prstGeom prst="rect">
+            <a:avLst/>
+          </a:prstGeom>
+          <a:solidFill>
+            <a:srgbClr val="A6650F"/>
+          </a:solidFill>
+          <a:ln/>
+        </p:spPr>
+      </p:sp>
+      <p:sp>
+        <p:nvSpPr>
+          <p:cNvPr id="29" name="Shape 27"/>
+          <p:cNvSpPr/>
+          <p:nvPr/>
+        </p:nvSpPr>
+        <p:spPr>
+          <a:xfrm>
+            <a:off x="4535334" y="1664208"/>
+            <a:ext cx="231616" cy="118872"/>
+          </a:xfrm>
+          <a:prstGeom prst="rect">
+            <a:avLst/>
+          </a:prstGeom>
+          <a:solidFill>
+            <a:srgbClr val="1D63A1"/>
+          </a:solidFill>
+          <a:ln/>
+        </p:spPr>
+      </p:sp>
+      <p:sp>
+        <p:nvSpPr>
+          <p:cNvPr id="30" name="Shape 28"/>
+          <p:cNvSpPr/>
+          <p:nvPr/>
+        </p:nvSpPr>
+        <p:spPr>
+          <a:xfrm>
+            <a:off x="2804099" y="1856232"/>
+            <a:ext cx="54864" cy="54864"/>
+          </a:xfrm>
+          <a:prstGeom prst="ellipse">
+            <a:avLst/>
+          </a:prstGeom>
+          <a:solidFill>
+            <a:srgbClr val="1E8449"/>
+          </a:solidFill>
+          <a:ln/>
+        </p:spPr>
+      </p:sp>
+      <p:sp>
+        <p:nvSpPr>
+          <p:cNvPr id="31" name="Text 29"/>
+          <p:cNvSpPr txBox="1"/>
+          <p:nvPr/>
+        </p:nvSpPr>
+        <p:spPr>
+          <a:xfrm>
+            <a:off x="2904683" y="1819656"/>
+            <a:ext cx="1862267" cy="128016"/>
+          </a:xfrm>
+          <a:prstGeom prst="rect">
+            <a:avLst/>
+          </a:prstGeom>
+          <a:noFill/>
+          <a:ln/>
+        </p:spPr>
+        <p:txBody>
+          <a:bodyPr wrap="square" lIns="0" tIns="0" rIns="0" bIns="0" rtlCol="0" anchor="ctr"/>
+          <a:lstStyle/>
+          <a:p>
+            <a:pPr algn="l" indent="0" marL="0">
+              <a:buNone/>
+            </a:pPr>
+            <a:r>
+              <a:rPr lang="en-US" sz="760" b="1" dirty="0">
+                <a:solidFill>
+                  <a:srgbClr val="1E8449"/>
+                </a:solidFill>
+                <a:latin typeface="Calibri" pitchFamily="34" charset="0"/>
+                <a:ea typeface="Calibri" pitchFamily="34" charset="-122"/>
+                <a:cs typeface="Calibri" pitchFamily="34" charset="-120"/>
+              </a:rPr>
+              <a:t>70.6% Oportuno</a:t>
+            </a:r>
+            <a:endParaRPr lang="en-US" sz="760" dirty="0"/>
+          </a:p>
+        </p:txBody>
+      </p:sp>
+      <p:sp>
+        <p:nvSpPr>
+          <p:cNvPr id="32" name="Shape 30"/>
+          <p:cNvSpPr/>
+          <p:nvPr/>
+        </p:nvSpPr>
+        <p:spPr>
+          <a:xfrm>
+            <a:off x="2804099" y="1997964"/>
+            <a:ext cx="54864" cy="54864"/>
+          </a:xfrm>
+          <a:prstGeom prst="ellipse">
+            <a:avLst/>
+          </a:prstGeom>
+          <a:solidFill>
+            <a:srgbClr val="A6650F"/>
+          </a:solidFill>
+          <a:ln/>
+        </p:spPr>
+      </p:sp>
+      <p:sp>
+        <p:nvSpPr>
+          <p:cNvPr id="33" name="Text 31"/>
+          <p:cNvSpPr txBox="1"/>
+          <p:nvPr/>
+        </p:nvSpPr>
+        <p:spPr>
+          <a:xfrm>
+            <a:off x="2904683" y="1961388"/>
+            <a:ext cx="1862267" cy="128016"/>
+          </a:xfrm>
+          <a:prstGeom prst="rect">
+            <a:avLst/>
+          </a:prstGeom>
+          <a:noFill/>
+          <a:ln/>
+        </p:spPr>
+        <p:txBody>
+          <a:bodyPr wrap="square" lIns="0" tIns="0" rIns="0" bIns="0" rtlCol="0" anchor="ctr"/>
+          <a:lstStyle/>
+          <a:p>
+            <a:pPr algn="l" indent="0" marL="0">
+              <a:buNone/>
+            </a:pPr>
+            <a:r>
+              <a:rPr lang="en-US" sz="760" b="1" dirty="0">
+                <a:solidFill>
+                  <a:srgbClr val="A6650F"/>
+                </a:solidFill>
+                <a:latin typeface="Calibri" pitchFamily="34" charset="0"/>
+                <a:ea typeface="Calibri" pitchFamily="34" charset="-122"/>
+                <a:cs typeface="Calibri" pitchFamily="34" charset="-120"/>
+              </a:rPr>
+              <a:t>17.6% Regular</a:t>
+            </a:r>
+            <a:endParaRPr lang="en-US" sz="760" dirty="0"/>
+          </a:p>
+        </p:txBody>
+      </p:sp>
+      <p:sp>
+        <p:nvSpPr>
+          <p:cNvPr id="34" name="Shape 32"/>
+          <p:cNvSpPr/>
+          <p:nvPr/>
+        </p:nvSpPr>
+        <p:spPr>
+          <a:xfrm>
+            <a:off x="2804099" y="2139696"/>
+            <a:ext cx="54864" cy="54864"/>
+          </a:xfrm>
+          <a:prstGeom prst="ellipse">
+            <a:avLst/>
+          </a:prstGeom>
+          <a:solidFill>
+            <a:srgbClr val="1D63A1"/>
+          </a:solidFill>
+          <a:ln/>
+        </p:spPr>
+      </p:sp>
+      <p:sp>
+        <p:nvSpPr>
+          <p:cNvPr id="35" name="Text 33"/>
+          <p:cNvSpPr txBox="1"/>
+          <p:nvPr/>
+        </p:nvSpPr>
+        <p:spPr>
+          <a:xfrm>
+            <a:off x="2904683" y="2103120"/>
+            <a:ext cx="1862267" cy="128016"/>
+          </a:xfrm>
+          <a:prstGeom prst="rect">
+            <a:avLst/>
+          </a:prstGeom>
+          <a:noFill/>
+          <a:ln/>
+        </p:spPr>
+        <p:txBody>
+          <a:bodyPr wrap="square" lIns="0" tIns="0" rIns="0" bIns="0" rtlCol="0" anchor="ctr"/>
+          <a:lstStyle/>
+          <a:p>
+            <a:pPr algn="l" indent="0" marL="0">
+              <a:buNone/>
+            </a:pPr>
+            <a:r>
+              <a:rPr lang="en-US" sz="760" b="1" dirty="0">
+                <a:solidFill>
+                  <a:srgbClr val="1D63A1"/>
+                </a:solidFill>
+                <a:latin typeface="Calibri" pitchFamily="34" charset="0"/>
+                <a:ea typeface="Calibri" pitchFamily="34" charset="-122"/>
+                <a:cs typeface="Calibri" pitchFamily="34" charset="-120"/>
+              </a:rPr>
+              <a:t>11.8% Muy oportuno</a:t>
+            </a:r>
+            <a:endParaRPr lang="en-US" sz="760" dirty="0"/>
+          </a:p>
+        </p:txBody>
+      </p:sp>
+      <p:sp>
+        <p:nvSpPr>
+          <p:cNvPr id="36" name="Shape 34"/>
+          <p:cNvSpPr/>
+          <p:nvPr/>
+        </p:nvSpPr>
+        <p:spPr>
+          <a:xfrm>
+            <a:off x="5004694" y="1133856"/>
+            <a:ext cx="2182307" cy="1207008"/>
+          </a:xfrm>
+          <a:prstGeom prst="roundRect">
+            <a:avLst>
+              <a:gd name="adj" fmla="val 4545"/>
+            </a:avLst>
+          </a:prstGeom>
+          <a:solidFill>
+            <a:srgbClr val="FFFFFF"/>
+          </a:solidFill>
+          <a:ln w="9525">
+            <a:solidFill>
+              <a:srgbClr val="E7EAF0"/>
+            </a:solidFill>
+            <a:prstDash val="solid"/>
+          </a:ln>
+          <a:effectLst>
+            <a:outerShdw sx="100000" sy="100000" kx="0" ky="0" algn="bl" rotWithShape="0" blurRad="63500" dist="19050" dir="5400000">
+              <a:srgbClr val="0F2F4E">
+                <a:alpha val="9000"/>
+              </a:srgbClr>
+            </a:outerShdw>
+          </a:effectLst>
+        </p:spPr>
+      </p:sp>
+      <p:sp>
+        <p:nvSpPr>
+          <p:cNvPr id="37" name="Shape 35"/>
+          <p:cNvSpPr/>
+          <p:nvPr/>
+        </p:nvSpPr>
+        <p:spPr>
+          <a:xfrm>
+            <a:off x="5114422" y="1225296"/>
+            <a:ext cx="173736" cy="173736"/>
+          </a:xfrm>
+          <a:prstGeom prst="ellipse">
+            <a:avLst/>
+          </a:prstGeom>
+          <a:solidFill>
+            <a:srgbClr val="133B6C"/>
+          </a:solidFill>
+          <a:ln/>
+        </p:spPr>
+      </p:sp>
+      <p:sp>
+        <p:nvSpPr>
+          <p:cNvPr id="38" name="Text 36"/>
+          <p:cNvSpPr txBox="1"/>
+          <p:nvPr/>
+        </p:nvSpPr>
+        <p:spPr>
+          <a:xfrm>
+            <a:off x="5114422" y="1225296"/>
+            <a:ext cx="173736" cy="173736"/>
+          </a:xfrm>
+          <a:prstGeom prst="rect">
+            <a:avLst/>
+          </a:prstGeom>
+          <a:noFill/>
+          <a:ln/>
+        </p:spPr>
+        <p:txBody>
+          <a:bodyPr wrap="square" lIns="0" tIns="0" rIns="0" bIns="0" rtlCol="0" anchor="ctr"/>
+          <a:lstStyle/>
+          <a:p>
+            <a:pPr algn="ctr" indent="0" marL="0">
+              <a:buNone/>
+            </a:pPr>
+            <a:r>
+              <a:rPr lang="en-US" sz="900" b="1" dirty="0">
+                <a:solidFill>
+                  <a:srgbClr val="FFFFFF"/>
+                </a:solidFill>
+                <a:latin typeface="Calibri" pitchFamily="34" charset="0"/>
+                <a:ea typeface="Calibri" pitchFamily="34" charset="-122"/>
+                <a:cs typeface="Calibri" pitchFamily="34" charset="-120"/>
+              </a:rPr>
+              <a:t>3</a:t>
+            </a:r>
+            <a:endParaRPr lang="en-US" sz="900" dirty="0"/>
+          </a:p>
+        </p:txBody>
+      </p:sp>
+      <p:sp>
+        <p:nvSpPr>
+          <p:cNvPr id="39" name="Text 37"/>
+          <p:cNvSpPr txBox="1"/>
+          <p:nvPr/>
+        </p:nvSpPr>
+        <p:spPr>
+          <a:xfrm>
+            <a:off x="5361310" y="1207008"/>
+            <a:ext cx="1715963" cy="457200"/>
+          </a:xfrm>
+          <a:prstGeom prst="rect">
+            <a:avLst/>
+          </a:prstGeom>
+          <a:noFill/>
+          <a:ln/>
+        </p:spPr>
+        <p:txBody>
+          <a:bodyPr wrap="square" lIns="0" tIns="0" rIns="0" bIns="0" rtlCol="0" anchor="t"/>
+          <a:lstStyle/>
+          <a:p>
+            <a:pPr algn="l" indent="0" marL="0">
+              <a:lnSpc>
+                <a:spcPct val="112000"/>
+              </a:lnSpc>
+              <a:buNone/>
+            </a:pPr>
+            <a:r>
+              <a:rPr lang="en-US" sz="950" b="1" dirty="0">
+                <a:solidFill>
+                  <a:srgbClr val="17223A"/>
+                </a:solidFill>
+                <a:latin typeface="Calibri" pitchFamily="34" charset="0"/>
+                <a:ea typeface="Calibri" pitchFamily="34" charset="-122"/>
+                <a:cs typeface="Calibri" pitchFamily="34" charset="-120"/>
+              </a:rPr>
+              <a:t>¿Con qué frecuencia hay reclamos de asociados?</a:t>
+            </a:r>
+            <a:endParaRPr lang="en-US" sz="950" dirty="0"/>
+          </a:p>
+        </p:txBody>
+      </p:sp>
+      <p:sp>
+        <p:nvSpPr>
+          <p:cNvPr id="40" name="Shape 38"/>
+          <p:cNvSpPr/>
+          <p:nvPr/>
+        </p:nvSpPr>
+        <p:spPr>
+          <a:xfrm>
+            <a:off x="5114422" y="1664208"/>
+            <a:ext cx="1962851" cy="118872"/>
+          </a:xfrm>
+          <a:prstGeom prst="roundRect">
+            <a:avLst>
+              <a:gd name="adj" fmla="val 15385"/>
+            </a:avLst>
+          </a:prstGeom>
+          <a:solidFill>
+            <a:srgbClr val="EEF1F5"/>
+          </a:solidFill>
+          <a:ln/>
+        </p:spPr>
+      </p:sp>
+      <p:sp>
+        <p:nvSpPr>
+          <p:cNvPr id="41" name="Shape 39"/>
+          <p:cNvSpPr/>
+          <p:nvPr/>
+        </p:nvSpPr>
+        <p:spPr>
+          <a:xfrm>
+            <a:off x="5114422" y="1664208"/>
+            <a:ext cx="808695" cy="118872"/>
+          </a:xfrm>
+          <a:prstGeom prst="rect">
+            <a:avLst/>
+          </a:prstGeom>
+          <a:solidFill>
+            <a:srgbClr val="E0392B"/>
+          </a:solidFill>
+          <a:ln/>
+        </p:spPr>
+      </p:sp>
+      <p:sp>
+        <p:nvSpPr>
+          <p:cNvPr id="42" name="Shape 40"/>
+          <p:cNvSpPr/>
+          <p:nvPr/>
+        </p:nvSpPr>
+        <p:spPr>
+          <a:xfrm>
+            <a:off x="5923117" y="1664208"/>
+            <a:ext cx="692886" cy="118872"/>
+          </a:xfrm>
+          <a:prstGeom prst="rect">
+            <a:avLst/>
+          </a:prstGeom>
+          <a:solidFill>
+            <a:srgbClr val="A6650F"/>
+          </a:solidFill>
+          <a:ln/>
+        </p:spPr>
+      </p:sp>
+      <p:sp>
+        <p:nvSpPr>
+          <p:cNvPr id="43" name="Shape 41"/>
+          <p:cNvSpPr/>
+          <p:nvPr/>
+        </p:nvSpPr>
+        <p:spPr>
+          <a:xfrm>
+            <a:off x="6616003" y="1664208"/>
+            <a:ext cx="461270" cy="118872"/>
+          </a:xfrm>
+          <a:prstGeom prst="rect">
+            <a:avLst/>
+          </a:prstGeom>
+          <a:solidFill>
+            <a:srgbClr val="1E8449"/>
+          </a:solidFill>
+          <a:ln/>
+        </p:spPr>
+      </p:sp>
+      <p:sp>
+        <p:nvSpPr>
+          <p:cNvPr id="44" name="Shape 42"/>
+          <p:cNvSpPr/>
+          <p:nvPr/>
+        </p:nvSpPr>
+        <p:spPr>
+          <a:xfrm>
+            <a:off x="5114422" y="1856232"/>
+            <a:ext cx="54864" cy="54864"/>
+          </a:xfrm>
+          <a:prstGeom prst="ellipse">
+            <a:avLst/>
+          </a:prstGeom>
+          <a:solidFill>
+            <a:srgbClr val="E0392B"/>
+          </a:solidFill>
+          <a:ln/>
+        </p:spPr>
+      </p:sp>
+      <p:sp>
+        <p:nvSpPr>
+          <p:cNvPr id="45" name="Text 43"/>
+          <p:cNvSpPr txBox="1"/>
+          <p:nvPr/>
+        </p:nvSpPr>
+        <p:spPr>
+          <a:xfrm>
+            <a:off x="5215006" y="1819656"/>
+            <a:ext cx="1862267" cy="128016"/>
+          </a:xfrm>
+          <a:prstGeom prst="rect">
+            <a:avLst/>
+          </a:prstGeom>
+          <a:noFill/>
+          <a:ln/>
+        </p:spPr>
+        <p:txBody>
+          <a:bodyPr wrap="square" lIns="0" tIns="0" rIns="0" bIns="0" rtlCol="0" anchor="ctr"/>
+          <a:lstStyle/>
+          <a:p>
+            <a:pPr algn="l" indent="0" marL="0">
+              <a:buNone/>
+            </a:pPr>
+            <a:r>
+              <a:rPr lang="en-US" sz="760" b="1" dirty="0">
+                <a:solidFill>
+                  <a:srgbClr val="E0392B"/>
+                </a:solidFill>
+                <a:latin typeface="Calibri" pitchFamily="34" charset="0"/>
+                <a:ea typeface="Calibri" pitchFamily="34" charset="-122"/>
+                <a:cs typeface="Calibri" pitchFamily="34" charset="-120"/>
+              </a:rPr>
+              <a:t>41.2% Frecuente</a:t>
+            </a:r>
+            <a:endParaRPr lang="en-US" sz="760" dirty="0"/>
+          </a:p>
+        </p:txBody>
+      </p:sp>
+      <p:sp>
+        <p:nvSpPr>
+          <p:cNvPr id="46" name="Shape 44"/>
+          <p:cNvSpPr/>
+          <p:nvPr/>
+        </p:nvSpPr>
+        <p:spPr>
+          <a:xfrm>
+            <a:off x="5114422" y="1997964"/>
+            <a:ext cx="54864" cy="54864"/>
+          </a:xfrm>
+          <a:prstGeom prst="ellipse">
+            <a:avLst/>
+          </a:prstGeom>
+          <a:solidFill>
+            <a:srgbClr val="A6650F"/>
+          </a:solidFill>
+          <a:ln/>
+        </p:spPr>
+      </p:sp>
+      <p:sp>
+        <p:nvSpPr>
+          <p:cNvPr id="47" name="Text 45"/>
+          <p:cNvSpPr txBox="1"/>
+          <p:nvPr/>
+        </p:nvSpPr>
+        <p:spPr>
+          <a:xfrm>
+            <a:off x="5215006" y="1961388"/>
+            <a:ext cx="1862267" cy="128016"/>
+          </a:xfrm>
+          <a:prstGeom prst="rect">
+            <a:avLst/>
+          </a:prstGeom>
+          <a:noFill/>
+          <a:ln/>
+        </p:spPr>
+        <p:txBody>
+          <a:bodyPr wrap="square" lIns="0" tIns="0" rIns="0" bIns="0" rtlCol="0" anchor="ctr"/>
+          <a:lstStyle/>
+          <a:p>
+            <a:pPr algn="l" indent="0" marL="0">
+              <a:buNone/>
+            </a:pPr>
+            <a:r>
+              <a:rPr lang="en-US" sz="760" b="1" dirty="0">
+                <a:solidFill>
+                  <a:srgbClr val="A6650F"/>
+                </a:solidFill>
+                <a:latin typeface="Calibri" pitchFamily="34" charset="0"/>
+                <a:ea typeface="Calibri" pitchFamily="34" charset="-122"/>
+                <a:cs typeface="Calibri" pitchFamily="34" charset="-120"/>
+              </a:rPr>
+              <a:t>35.3% Algunas veces</a:t>
+            </a:r>
+            <a:endParaRPr lang="en-US" sz="760" dirty="0"/>
+          </a:p>
+        </p:txBody>
+      </p:sp>
+      <p:sp>
+        <p:nvSpPr>
+          <p:cNvPr id="48" name="Shape 46"/>
+          <p:cNvSpPr/>
+          <p:nvPr/>
+        </p:nvSpPr>
+        <p:spPr>
+          <a:xfrm>
+            <a:off x="5114422" y="2139696"/>
+            <a:ext cx="54864" cy="54864"/>
+          </a:xfrm>
+          <a:prstGeom prst="ellipse">
+            <a:avLst/>
+          </a:prstGeom>
+          <a:solidFill>
+            <a:srgbClr val="1E8449"/>
+          </a:solidFill>
+          <a:ln/>
+        </p:spPr>
+      </p:sp>
+      <p:sp>
+        <p:nvSpPr>
+          <p:cNvPr id="49" name="Text 47"/>
+          <p:cNvSpPr txBox="1"/>
+          <p:nvPr/>
+        </p:nvSpPr>
+        <p:spPr>
+          <a:xfrm>
+            <a:off x="5215006" y="2103120"/>
+            <a:ext cx="1862267" cy="128016"/>
+          </a:xfrm>
+          <a:prstGeom prst="rect">
+            <a:avLst/>
+          </a:prstGeom>
+          <a:noFill/>
+          <a:ln/>
+        </p:spPr>
+        <p:txBody>
+          <a:bodyPr wrap="square" lIns="0" tIns="0" rIns="0" bIns="0" rtlCol="0" anchor="ctr"/>
+          <a:lstStyle/>
+          <a:p>
+            <a:pPr algn="l" indent="0" marL="0">
+              <a:buNone/>
+            </a:pPr>
+            <a:r>
+              <a:rPr lang="en-US" sz="760" b="1" dirty="0">
+                <a:solidFill>
+                  <a:srgbClr val="1E8449"/>
+                </a:solidFill>
+                <a:latin typeface="Calibri" pitchFamily="34" charset="0"/>
+                <a:ea typeface="Calibri" pitchFamily="34" charset="-122"/>
+                <a:cs typeface="Calibri" pitchFamily="34" charset="-120"/>
+              </a:rPr>
+              <a:t>23.5% Rara vez</a:t>
+            </a:r>
+            <a:endParaRPr lang="en-US" sz="760" dirty="0"/>
+          </a:p>
+        </p:txBody>
+      </p:sp>
+      <p:sp>
+        <p:nvSpPr>
+          <p:cNvPr id="50" name="Shape 48"/>
+          <p:cNvSpPr/>
+          <p:nvPr/>
+        </p:nvSpPr>
+        <p:spPr>
+          <a:xfrm>
+            <a:off x="7315017" y="1133856"/>
+            <a:ext cx="2182307" cy="1207008"/>
+          </a:xfrm>
+          <a:prstGeom prst="roundRect">
+            <a:avLst>
+              <a:gd name="adj" fmla="val 4545"/>
+            </a:avLst>
+          </a:prstGeom>
+          <a:solidFill>
+            <a:srgbClr val="FFFFFF"/>
+          </a:solidFill>
+          <a:ln w="9525">
+            <a:solidFill>
+              <a:srgbClr val="E7EAF0"/>
+            </a:solidFill>
+            <a:prstDash val="solid"/>
+          </a:ln>
+          <a:effectLst>
+            <a:outerShdw sx="100000" sy="100000" kx="0" ky="0" algn="bl" rotWithShape="0" blurRad="63500" dist="19050" dir="5400000">
+              <a:srgbClr val="0F2F4E">
+                <a:alpha val="9000"/>
+              </a:srgbClr>
+            </a:outerShdw>
+          </a:effectLst>
+        </p:spPr>
+      </p:sp>
+      <p:sp>
+        <p:nvSpPr>
+          <p:cNvPr id="51" name="Shape 49"/>
+          <p:cNvSpPr/>
+          <p:nvPr/>
+        </p:nvSpPr>
+        <p:spPr>
+          <a:xfrm>
+            <a:off x="7424745" y="1225296"/>
+            <a:ext cx="173736" cy="173736"/>
+          </a:xfrm>
+          <a:prstGeom prst="ellipse">
+            <a:avLst/>
+          </a:prstGeom>
+          <a:solidFill>
+            <a:srgbClr val="133B6C"/>
+          </a:solidFill>
+          <a:ln/>
+        </p:spPr>
+      </p:sp>
+      <p:sp>
+        <p:nvSpPr>
+          <p:cNvPr id="52" name="Text 50"/>
+          <p:cNvSpPr txBox="1"/>
+          <p:nvPr/>
+        </p:nvSpPr>
+        <p:spPr>
+          <a:xfrm>
+            <a:off x="7424745" y="1225296"/>
+            <a:ext cx="173736" cy="173736"/>
+          </a:xfrm>
+          <a:prstGeom prst="rect">
+            <a:avLst/>
+          </a:prstGeom>
+          <a:noFill/>
+          <a:ln/>
+        </p:spPr>
+        <p:txBody>
+          <a:bodyPr wrap="square" lIns="0" tIns="0" rIns="0" bIns="0" rtlCol="0" anchor="ctr"/>
+          <a:lstStyle/>
+          <a:p>
+            <a:pPr algn="ctr" indent="0" marL="0">
+              <a:buNone/>
+            </a:pPr>
+            <a:r>
+              <a:rPr lang="en-US" sz="900" b="1" dirty="0">
+                <a:solidFill>
+                  <a:srgbClr val="FFFFFF"/>
+                </a:solidFill>
+                <a:latin typeface="Calibri" pitchFamily="34" charset="0"/>
+                <a:ea typeface="Calibri" pitchFamily="34" charset="-122"/>
+                <a:cs typeface="Calibri" pitchFamily="34" charset="-120"/>
+              </a:rPr>
+              <a:t>4</a:t>
+            </a:r>
+            <a:endParaRPr lang="en-US" sz="900" dirty="0"/>
+          </a:p>
+        </p:txBody>
+      </p:sp>
+      <p:sp>
+        <p:nvSpPr>
+          <p:cNvPr id="53" name="Text 51"/>
+          <p:cNvSpPr txBox="1"/>
+          <p:nvPr/>
+        </p:nvSpPr>
+        <p:spPr>
+          <a:xfrm>
+            <a:off x="7671633" y="1207008"/>
+            <a:ext cx="1715963" cy="457200"/>
+          </a:xfrm>
+          <a:prstGeom prst="rect">
+            <a:avLst/>
+          </a:prstGeom>
+          <a:noFill/>
+          <a:ln/>
+        </p:spPr>
+        <p:txBody>
+          <a:bodyPr wrap="square" lIns="0" tIns="0" rIns="0" bIns="0" rtlCol="0" anchor="t"/>
+          <a:lstStyle/>
+          <a:p>
+            <a:pPr algn="l" indent="0" marL="0">
+              <a:lnSpc>
+                <a:spcPct val="112000"/>
+              </a:lnSpc>
+              <a:buNone/>
+            </a:pPr>
+            <a:r>
+              <a:rPr lang="en-US" sz="950" b="1" dirty="0">
+                <a:solidFill>
+                  <a:srgbClr val="17223A"/>
+                </a:solidFill>
+                <a:latin typeface="Calibri" pitchFamily="34" charset="0"/>
+                <a:ea typeface="Calibri" pitchFamily="34" charset="-122"/>
+                <a:cs typeface="Calibri" pitchFamily="34" charset="-120"/>
+              </a:rPr>
+              <a:t>¿Qué tan fácil es gestionar incidencias/reversas?</a:t>
+            </a:r>
+            <a:endParaRPr lang="en-US" sz="950" dirty="0"/>
+          </a:p>
+        </p:txBody>
+      </p:sp>
+      <p:sp>
+        <p:nvSpPr>
+          <p:cNvPr id="54" name="Shape 52"/>
+          <p:cNvSpPr/>
+          <p:nvPr/>
+        </p:nvSpPr>
+        <p:spPr>
+          <a:xfrm>
+            <a:off x="7424745" y="1664208"/>
+            <a:ext cx="1962851" cy="118872"/>
+          </a:xfrm>
+          <a:prstGeom prst="roundRect">
+            <a:avLst>
+              <a:gd name="adj" fmla="val 15385"/>
+            </a:avLst>
+          </a:prstGeom>
+          <a:solidFill>
+            <a:srgbClr val="EEF1F5"/>
+          </a:solidFill>
+          <a:ln/>
+        </p:spPr>
+      </p:sp>
+      <p:sp>
+        <p:nvSpPr>
+          <p:cNvPr id="55" name="Shape 53"/>
+          <p:cNvSpPr/>
+          <p:nvPr/>
+        </p:nvSpPr>
+        <p:spPr>
+          <a:xfrm>
+            <a:off x="7424745" y="1664208"/>
+            <a:ext cx="1038348" cy="118872"/>
+          </a:xfrm>
+          <a:prstGeom prst="rect">
+            <a:avLst/>
+          </a:prstGeom>
+          <a:solidFill>
+            <a:srgbClr val="A6650F"/>
+          </a:solidFill>
+          <a:ln/>
+        </p:spPr>
+      </p:sp>
+      <p:sp>
+        <p:nvSpPr>
+          <p:cNvPr id="56" name="Shape 54"/>
+          <p:cNvSpPr/>
+          <p:nvPr/>
+        </p:nvSpPr>
+        <p:spPr>
+          <a:xfrm>
+            <a:off x="8463093" y="1664208"/>
+            <a:ext cx="692886" cy="118872"/>
+          </a:xfrm>
+          <a:prstGeom prst="rect">
+            <a:avLst/>
+          </a:prstGeom>
+          <a:solidFill>
+            <a:srgbClr val="1E8449"/>
+          </a:solidFill>
+          <a:ln/>
+        </p:spPr>
+      </p:sp>
+      <p:sp>
+        <p:nvSpPr>
+          <p:cNvPr id="57" name="Shape 55"/>
+          <p:cNvSpPr/>
+          <p:nvPr/>
+        </p:nvSpPr>
+        <p:spPr>
+          <a:xfrm>
+            <a:off x="9155980" y="1664208"/>
+            <a:ext cx="231616" cy="118872"/>
+          </a:xfrm>
+          <a:prstGeom prst="rect">
+            <a:avLst/>
+          </a:prstGeom>
+          <a:solidFill>
+            <a:srgbClr val="5B6B82"/>
+          </a:solidFill>
+          <a:ln/>
+        </p:spPr>
+      </p:sp>
+      <p:sp>
+        <p:nvSpPr>
+          <p:cNvPr id="58" name="Shape 56"/>
+          <p:cNvSpPr/>
+          <p:nvPr/>
+        </p:nvSpPr>
+        <p:spPr>
+          <a:xfrm>
+            <a:off x="7424745" y="1856232"/>
+            <a:ext cx="54864" cy="54864"/>
+          </a:xfrm>
+          <a:prstGeom prst="ellipse">
+            <a:avLst/>
+          </a:prstGeom>
+          <a:solidFill>
+            <a:srgbClr val="A6650F"/>
+          </a:solidFill>
+          <a:ln/>
+        </p:spPr>
+      </p:sp>
+      <p:sp>
+        <p:nvSpPr>
+          <p:cNvPr id="59" name="Text 57"/>
+          <p:cNvSpPr txBox="1"/>
+          <p:nvPr/>
+        </p:nvSpPr>
+        <p:spPr>
+          <a:xfrm>
+            <a:off x="7525329" y="1819656"/>
+            <a:ext cx="1862267" cy="128016"/>
+          </a:xfrm>
+          <a:prstGeom prst="rect">
+            <a:avLst/>
+          </a:prstGeom>
+          <a:noFill/>
+          <a:ln/>
+        </p:spPr>
+        <p:txBody>
+          <a:bodyPr wrap="square" lIns="0" tIns="0" rIns="0" bIns="0" rtlCol="0" anchor="ctr"/>
+          <a:lstStyle/>
+          <a:p>
+            <a:pPr algn="l" indent="0" marL="0">
+              <a:buNone/>
+            </a:pPr>
+            <a:r>
+              <a:rPr lang="en-US" sz="760" b="1" dirty="0">
+                <a:solidFill>
+                  <a:srgbClr val="A6650F"/>
+                </a:solidFill>
+                <a:latin typeface="Calibri" pitchFamily="34" charset="0"/>
+                <a:ea typeface="Calibri" pitchFamily="34" charset="-122"/>
+                <a:cs typeface="Calibri" pitchFamily="34" charset="-120"/>
+              </a:rPr>
+              <a:t>52.9% Regular</a:t>
+            </a:r>
+            <a:endParaRPr lang="en-US" sz="760" dirty="0"/>
+          </a:p>
+        </p:txBody>
+      </p:sp>
+      <p:sp>
+        <p:nvSpPr>
+          <p:cNvPr id="60" name="Shape 58"/>
+          <p:cNvSpPr/>
+          <p:nvPr/>
+        </p:nvSpPr>
+        <p:spPr>
+          <a:xfrm>
+            <a:off x="7424745" y="1997964"/>
+            <a:ext cx="54864" cy="54864"/>
+          </a:xfrm>
+          <a:prstGeom prst="ellipse">
+            <a:avLst/>
+          </a:prstGeom>
+          <a:solidFill>
+            <a:srgbClr val="1E8449"/>
+          </a:solidFill>
+          <a:ln/>
+        </p:spPr>
+      </p:sp>
+      <p:sp>
+        <p:nvSpPr>
+          <p:cNvPr id="61" name="Text 59"/>
+          <p:cNvSpPr txBox="1"/>
+          <p:nvPr/>
+        </p:nvSpPr>
+        <p:spPr>
+          <a:xfrm>
+            <a:off x="7525329" y="1961388"/>
+            <a:ext cx="1862267" cy="128016"/>
+          </a:xfrm>
+          <a:prstGeom prst="rect">
+            <a:avLst/>
+          </a:prstGeom>
+          <a:noFill/>
+          <a:ln/>
+        </p:spPr>
+        <p:txBody>
+          <a:bodyPr wrap="square" lIns="0" tIns="0" rIns="0" bIns="0" rtlCol="0" anchor="ctr"/>
+          <a:lstStyle/>
+          <a:p>
+            <a:pPr algn="l" indent="0" marL="0">
+              <a:buNone/>
+            </a:pPr>
+            <a:r>
+              <a:rPr lang="en-US" sz="760" b="1" dirty="0">
+                <a:solidFill>
+                  <a:srgbClr val="1E8449"/>
+                </a:solidFill>
+                <a:latin typeface="Calibri" pitchFamily="34" charset="0"/>
+                <a:ea typeface="Calibri" pitchFamily="34" charset="-122"/>
+                <a:cs typeface="Calibri" pitchFamily="34" charset="-120"/>
+              </a:rPr>
+              <a:t>35.3% Fácil</a:t>
+            </a:r>
+            <a:endParaRPr lang="en-US" sz="760" dirty="0"/>
+          </a:p>
+        </p:txBody>
+      </p:sp>
+      <p:sp>
+        <p:nvSpPr>
+          <p:cNvPr id="62" name="Shape 60"/>
+          <p:cNvSpPr/>
+          <p:nvPr/>
+        </p:nvSpPr>
+        <p:spPr>
+          <a:xfrm>
+            <a:off x="7424745" y="2139696"/>
+            <a:ext cx="54864" cy="54864"/>
+          </a:xfrm>
+          <a:prstGeom prst="ellipse">
+            <a:avLst/>
+          </a:prstGeom>
+          <a:solidFill>
+            <a:srgbClr val="5B6B82"/>
+          </a:solidFill>
+          <a:ln/>
+        </p:spPr>
+      </p:sp>
+      <p:sp>
+        <p:nvSpPr>
+          <p:cNvPr id="63" name="Text 61"/>
+          <p:cNvSpPr txBox="1"/>
+          <p:nvPr/>
+        </p:nvSpPr>
+        <p:spPr>
+          <a:xfrm>
+            <a:off x="7525329" y="2103120"/>
+            <a:ext cx="1862267" cy="128016"/>
+          </a:xfrm>
+          <a:prstGeom prst="rect">
+            <a:avLst/>
+          </a:prstGeom>
+          <a:noFill/>
+          <a:ln/>
+        </p:spPr>
+        <p:txBody>
+          <a:bodyPr wrap="square" lIns="0" tIns="0" rIns="0" bIns="0" rtlCol="0" anchor="ctr"/>
+          <a:lstStyle/>
+          <a:p>
+            <a:pPr algn="l" indent="0" marL="0">
+              <a:buNone/>
+            </a:pPr>
+            <a:r>
+              <a:rPr lang="en-US" sz="760" b="1" dirty="0">
+                <a:solidFill>
+                  <a:srgbClr val="5B6B82"/>
+                </a:solidFill>
+                <a:latin typeface="Calibri" pitchFamily="34" charset="0"/>
+                <a:ea typeface="Calibri" pitchFamily="34" charset="-122"/>
+                <a:cs typeface="Calibri" pitchFamily="34" charset="-120"/>
+              </a:rPr>
+              <a:t>11.8% Difícil</a:t>
+            </a:r>
+            <a:endParaRPr lang="en-US" sz="760" dirty="0"/>
+          </a:p>
+        </p:txBody>
+      </p:sp>
+      <p:sp>
+        <p:nvSpPr>
+          <p:cNvPr id="64" name="Shape 62"/>
+          <p:cNvSpPr/>
+          <p:nvPr/>
+        </p:nvSpPr>
+        <p:spPr>
+          <a:xfrm>
+            <a:off x="9625340" y="1133856"/>
+            <a:ext cx="2182307" cy="1207008"/>
+          </a:xfrm>
+          <a:prstGeom prst="roundRect">
+            <a:avLst>
+              <a:gd name="adj" fmla="val 4545"/>
+            </a:avLst>
+          </a:prstGeom>
+          <a:solidFill>
+            <a:srgbClr val="FFFFFF"/>
+          </a:solidFill>
+          <a:ln w="9525">
+            <a:solidFill>
+              <a:srgbClr val="E7EAF0"/>
+            </a:solidFill>
+            <a:prstDash val="solid"/>
+          </a:ln>
+          <a:effectLst>
+            <a:outerShdw sx="100000" sy="100000" kx="0" ky="0" algn="bl" rotWithShape="0" blurRad="63500" dist="19050" dir="5400000">
+              <a:srgbClr val="0F2F4E">
+                <a:alpha val="9000"/>
+              </a:srgbClr>
+            </a:outerShdw>
+          </a:effectLst>
+        </p:spPr>
+      </p:sp>
+      <p:sp>
+        <p:nvSpPr>
+          <p:cNvPr id="65" name="Shape 63"/>
+          <p:cNvSpPr/>
+          <p:nvPr/>
+        </p:nvSpPr>
+        <p:spPr>
+          <a:xfrm>
+            <a:off x="9735068" y="1225296"/>
+            <a:ext cx="173736" cy="173736"/>
+          </a:xfrm>
+          <a:prstGeom prst="ellipse">
+            <a:avLst/>
+          </a:prstGeom>
+          <a:solidFill>
+            <a:srgbClr val="133B6C"/>
+          </a:solidFill>
+          <a:ln/>
+        </p:spPr>
+      </p:sp>
+      <p:sp>
+        <p:nvSpPr>
+          <p:cNvPr id="66" name="Text 64"/>
+          <p:cNvSpPr txBox="1"/>
+          <p:nvPr/>
+        </p:nvSpPr>
+        <p:spPr>
+          <a:xfrm>
+            <a:off x="9735068" y="1225296"/>
+            <a:ext cx="173736" cy="173736"/>
+          </a:xfrm>
+          <a:prstGeom prst="rect">
+            <a:avLst/>
+          </a:prstGeom>
+          <a:noFill/>
+          <a:ln/>
+        </p:spPr>
+        <p:txBody>
+          <a:bodyPr wrap="square" lIns="0" tIns="0" rIns="0" bIns="0" rtlCol="0" anchor="ctr"/>
+          <a:lstStyle/>
+          <a:p>
+            <a:pPr algn="ctr" indent="0" marL="0">
+              <a:buNone/>
+            </a:pPr>
+            <a:r>
+              <a:rPr lang="en-US" sz="900" b="1" dirty="0">
+                <a:solidFill>
+                  <a:srgbClr val="FFFFFF"/>
+                </a:solidFill>
+                <a:latin typeface="Calibri" pitchFamily="34" charset="0"/>
+                <a:ea typeface="Calibri" pitchFamily="34" charset="-122"/>
+                <a:cs typeface="Calibri" pitchFamily="34" charset="-120"/>
+              </a:rPr>
+              <a:t>5</a:t>
+            </a:r>
+            <a:endParaRPr lang="en-US" sz="900" dirty="0"/>
+          </a:p>
+        </p:txBody>
+      </p:sp>
+      <p:sp>
+        <p:nvSpPr>
+          <p:cNvPr id="67" name="Text 65"/>
+          <p:cNvSpPr txBox="1"/>
+          <p:nvPr/>
+        </p:nvSpPr>
+        <p:spPr>
+          <a:xfrm>
+            <a:off x="9981956" y="1207008"/>
+            <a:ext cx="1715963" cy="457200"/>
+          </a:xfrm>
+          <a:prstGeom prst="rect">
+            <a:avLst/>
+          </a:prstGeom>
+          <a:noFill/>
+          <a:ln/>
+        </p:spPr>
+        <p:txBody>
+          <a:bodyPr wrap="square" lIns="0" tIns="0" rIns="0" bIns="0" rtlCol="0" anchor="t"/>
+          <a:lstStyle/>
+          <a:p>
+            <a:pPr algn="l" indent="0" marL="0">
+              <a:lnSpc>
+                <a:spcPct val="112000"/>
+              </a:lnSpc>
+              <a:buNone/>
+            </a:pPr>
+            <a:r>
+              <a:rPr lang="en-US" sz="950" b="1" dirty="0">
+                <a:solidFill>
+                  <a:srgbClr val="17223A"/>
+                </a:solidFill>
+                <a:latin typeface="Calibri" pitchFamily="34" charset="0"/>
+                <a:ea typeface="Calibri" pitchFamily="34" charset="-122"/>
+                <a:cs typeface="Calibri" pitchFamily="34" charset="-120"/>
+              </a:rPr>
+              <a:t>Calificación general del servicio (escala 1–5)</a:t>
+            </a:r>
+            <a:endParaRPr lang="en-US" sz="950" dirty="0"/>
+          </a:p>
+        </p:txBody>
+      </p:sp>
+      <p:sp>
+        <p:nvSpPr>
+          <p:cNvPr id="68" name="Shape 66"/>
+          <p:cNvSpPr/>
+          <p:nvPr/>
+        </p:nvSpPr>
+        <p:spPr>
+          <a:xfrm>
+            <a:off x="9735068" y="1664208"/>
+            <a:ext cx="1962851" cy="118872"/>
+          </a:xfrm>
+          <a:prstGeom prst="roundRect">
+            <a:avLst>
+              <a:gd name="adj" fmla="val 15385"/>
+            </a:avLst>
+          </a:prstGeom>
+          <a:solidFill>
+            <a:srgbClr val="EEF1F5"/>
+          </a:solidFill>
+          <a:ln/>
+        </p:spPr>
+      </p:sp>
+      <p:sp>
+        <p:nvSpPr>
+          <p:cNvPr id="69" name="Shape 67"/>
+          <p:cNvSpPr/>
+          <p:nvPr/>
+        </p:nvSpPr>
+        <p:spPr>
+          <a:xfrm>
+            <a:off x="9735068" y="1664208"/>
+            <a:ext cx="1617389" cy="118872"/>
+          </a:xfrm>
+          <a:prstGeom prst="rect">
+            <a:avLst/>
+          </a:prstGeom>
+          <a:solidFill>
+            <a:srgbClr val="1E8449"/>
+          </a:solidFill>
+          <a:ln/>
+        </p:spPr>
+      </p:sp>
+      <p:sp>
+        <p:nvSpPr>
+          <p:cNvPr id="70" name="Shape 68"/>
+          <p:cNvSpPr/>
+          <p:nvPr/>
+        </p:nvSpPr>
+        <p:spPr>
+          <a:xfrm>
+            <a:off x="11352457" y="1664208"/>
+            <a:ext cx="345462" cy="118872"/>
+          </a:xfrm>
+          <a:prstGeom prst="rect">
+            <a:avLst/>
+          </a:prstGeom>
+          <a:solidFill>
+            <a:srgbClr val="A6650F"/>
+          </a:solidFill>
+          <a:ln/>
+        </p:spPr>
+      </p:sp>
+      <p:sp>
+        <p:nvSpPr>
+          <p:cNvPr id="71" name="Shape 69"/>
+          <p:cNvSpPr/>
+          <p:nvPr/>
+        </p:nvSpPr>
+        <p:spPr>
+          <a:xfrm>
+            <a:off x="9735068" y="1856232"/>
+            <a:ext cx="54864" cy="54864"/>
+          </a:xfrm>
+          <a:prstGeom prst="ellipse">
+            <a:avLst/>
+          </a:prstGeom>
+          <a:solidFill>
+            <a:srgbClr val="1E8449"/>
+          </a:solidFill>
+          <a:ln/>
+        </p:spPr>
+      </p:sp>
+      <p:sp>
+        <p:nvSpPr>
+          <p:cNvPr id="72" name="Text 70"/>
+          <p:cNvSpPr txBox="1"/>
+          <p:nvPr/>
+        </p:nvSpPr>
+        <p:spPr>
+          <a:xfrm>
+            <a:off x="9835652" y="1819656"/>
+            <a:ext cx="1862267" cy="128016"/>
+          </a:xfrm>
+          <a:prstGeom prst="rect">
+            <a:avLst/>
+          </a:prstGeom>
+          <a:noFill/>
+          <a:ln/>
+        </p:spPr>
+        <p:txBody>
+          <a:bodyPr wrap="square" lIns="0" tIns="0" rIns="0" bIns="0" rtlCol="0" anchor="ctr"/>
+          <a:lstStyle/>
+          <a:p>
+            <a:pPr algn="l" indent="0" marL="0">
+              <a:buNone/>
+            </a:pPr>
+            <a:r>
+              <a:rPr lang="en-US" sz="760" b="1" dirty="0">
+                <a:solidFill>
+                  <a:srgbClr val="1E8449"/>
+                </a:solidFill>
+                <a:latin typeface="Calibri" pitchFamily="34" charset="0"/>
+                <a:ea typeface="Calibri" pitchFamily="34" charset="-122"/>
+                <a:cs typeface="Calibri" pitchFamily="34" charset="-120"/>
+              </a:rPr>
+              <a:t>82.4% Nota 4</a:t>
+            </a:r>
+            <a:endParaRPr lang="en-US" sz="760" dirty="0"/>
+          </a:p>
+        </p:txBody>
+      </p:sp>
+      <p:sp>
+        <p:nvSpPr>
+          <p:cNvPr id="73" name="Shape 71"/>
+          <p:cNvSpPr/>
+          <p:nvPr/>
+        </p:nvSpPr>
+        <p:spPr>
+          <a:xfrm>
+            <a:off x="9735068" y="1997964"/>
+            <a:ext cx="54864" cy="54864"/>
+          </a:xfrm>
+          <a:prstGeom prst="ellipse">
+            <a:avLst/>
+          </a:prstGeom>
+          <a:solidFill>
+            <a:srgbClr val="A6650F"/>
+          </a:solidFill>
+          <a:ln/>
+        </p:spPr>
+      </p:sp>
+      <p:sp>
+        <p:nvSpPr>
+          <p:cNvPr id="74" name="Text 72"/>
+          <p:cNvSpPr txBox="1"/>
+          <p:nvPr/>
+        </p:nvSpPr>
+        <p:spPr>
+          <a:xfrm>
+            <a:off x="9835652" y="1961388"/>
+            <a:ext cx="1862267" cy="128016"/>
+          </a:xfrm>
+          <a:prstGeom prst="rect">
+            <a:avLst/>
+          </a:prstGeom>
+          <a:noFill/>
+          <a:ln/>
+        </p:spPr>
+        <p:txBody>
+          <a:bodyPr wrap="square" lIns="0" tIns="0" rIns="0" bIns="0" rtlCol="0" anchor="ctr"/>
+          <a:lstStyle/>
+          <a:p>
+            <a:pPr algn="l" indent="0" marL="0">
+              <a:buNone/>
+            </a:pPr>
+            <a:r>
+              <a:rPr lang="en-US" sz="760" b="1" dirty="0">
+                <a:solidFill>
+                  <a:srgbClr val="A6650F"/>
+                </a:solidFill>
+                <a:latin typeface="Calibri" pitchFamily="34" charset="0"/>
+                <a:ea typeface="Calibri" pitchFamily="34" charset="-122"/>
+                <a:cs typeface="Calibri" pitchFamily="34" charset="-120"/>
+              </a:rPr>
+              <a:t>17.6% Nota 3</a:t>
+            </a:r>
+            <a:endParaRPr lang="en-US" sz="760" dirty="0"/>
+          </a:p>
+        </p:txBody>
+      </p:sp>
+      <p:sp>
+        <p:nvSpPr>
+          <p:cNvPr id="75" name="Shape 73"/>
+          <p:cNvSpPr/>
+          <p:nvPr/>
+        </p:nvSpPr>
+        <p:spPr>
+          <a:xfrm>
+            <a:off x="9735068" y="2139696"/>
+            <a:ext cx="54864" cy="54864"/>
+          </a:xfrm>
+          <a:prstGeom prst="ellipse">
+            <a:avLst/>
+          </a:prstGeom>
+          <a:solidFill>
+            <a:srgbClr val="133B6C"/>
+          </a:solidFill>
+          <a:ln/>
+        </p:spPr>
+      </p:sp>
+      <p:sp>
+        <p:nvSpPr>
+          <p:cNvPr id="76" name="Text 74"/>
+          <p:cNvSpPr txBox="1"/>
+          <p:nvPr/>
+        </p:nvSpPr>
+        <p:spPr>
+          <a:xfrm>
+            <a:off x="9835652" y="2103120"/>
+            <a:ext cx="1862267" cy="128016"/>
+          </a:xfrm>
+          <a:prstGeom prst="rect">
+            <a:avLst/>
+          </a:prstGeom>
+          <a:noFill/>
+          <a:ln/>
+        </p:spPr>
+        <p:txBody>
+          <a:bodyPr wrap="square" lIns="0" tIns="0" rIns="0" bIns="0" rtlCol="0" anchor="ctr"/>
+          <a:lstStyle/>
+          <a:p>
+            <a:pPr algn="l" indent="0" marL="0">
+              <a:buNone/>
+            </a:pPr>
+            <a:r>
+              <a:rPr lang="en-US" sz="760" b="1" dirty="0">
+                <a:solidFill>
+                  <a:srgbClr val="133B6C"/>
+                </a:solidFill>
+                <a:latin typeface="Calibri" pitchFamily="34" charset="0"/>
+                <a:ea typeface="Calibri" pitchFamily="34" charset="-122"/>
+                <a:cs typeface="Calibri" pitchFamily="34" charset="-120"/>
+              </a:rPr>
+              <a:t>Promedio: 3.82 / 5</a:t>
+            </a:r>
+            <a:endParaRPr lang="en-US" sz="760" dirty="0"/>
+          </a:p>
+        </p:txBody>
+      </p:sp>
+      <p:sp>
+        <p:nvSpPr>
+          <p:cNvPr id="77" name="Shape 75"/>
+          <p:cNvSpPr/>
+          <p:nvPr/>
+        </p:nvSpPr>
+        <p:spPr>
+          <a:xfrm>
+            <a:off x="384048" y="2487168"/>
+            <a:ext cx="11423599" cy="384048"/>
+          </a:xfrm>
+          <a:prstGeom prst="roundRect">
+            <a:avLst>
+              <a:gd name="adj" fmla="val 14286"/>
+            </a:avLst>
+          </a:prstGeom>
+          <a:solidFill>
+            <a:srgbClr val="133B6C"/>
+          </a:solidFill>
+          <a:ln/>
+        </p:spPr>
+      </p:sp>
+      <p:sp>
+        <p:nvSpPr>
+          <p:cNvPr id="78" name="Text 76"/>
+          <p:cNvSpPr txBox="1"/>
+          <p:nvPr/>
+        </p:nvSpPr>
+        <p:spPr>
+          <a:xfrm>
+            <a:off x="548640" y="2487168"/>
+            <a:ext cx="11094415" cy="384048"/>
+          </a:xfrm>
+          <a:prstGeom prst="rect">
+            <a:avLst/>
+          </a:prstGeom>
+          <a:noFill/>
+          <a:ln/>
+        </p:spPr>
+        <p:txBody>
+          <a:bodyPr wrap="square" lIns="0" tIns="0" rIns="0" bIns="0" rtlCol="0" anchor="ctr"/>
+          <a:lstStyle/>
+          <a:p>
+            <a:pPr algn="l" indent="0" marL="0">
+              <a:buNone/>
+            </a:pPr>
+            <a:r>
+              <a:rPr lang="en-US" sz="1200" b="1" dirty="0">
+                <a:solidFill>
+                  <a:srgbClr val="FFFFFF"/>
+                </a:solidFill>
+                <a:latin typeface="Calibri" pitchFamily="34" charset="0"/>
+                <a:ea typeface="Calibri" pitchFamily="34" charset="-122"/>
+                <a:cs typeface="Calibri" pitchFamily="34" charset="-120"/>
+              </a:rPr>
+              <a:t>Pregunta Abierta   </a:t>
+            </a:r>
+            <a:pPr algn="l" indent="0" marL="0">
+              <a:buNone/>
+            </a:pPr>
+            <a:r>
+              <a:rPr lang="en-US" sz="1000" i="1" dirty="0">
+                <a:solidFill>
+                  <a:srgbClr val="97D8DB"/>
+                </a:solidFill>
+                <a:latin typeface="Calibri" pitchFamily="34" charset="0"/>
+                <a:ea typeface="Calibri" pitchFamily="34" charset="-122"/>
+                <a:cs typeface="Calibri" pitchFamily="34" charset="-120"/>
+              </a:rPr>
+              <a:t>"¿Qué problemas, inconvenientes o situaciones relacionadas con el procesamiento de tarjetas de crédito considera que deberían mejorarse?" — 17 respuestas</a:t>
+            </a:r>
+            <a:endParaRPr lang="en-US" sz="1200" dirty="0"/>
+          </a:p>
+        </p:txBody>
+      </p:sp>
+      <p:sp>
+        <p:nvSpPr>
+          <p:cNvPr id="79" name="Shape 77"/>
+          <p:cNvSpPr/>
+          <p:nvPr/>
+        </p:nvSpPr>
+        <p:spPr>
+          <a:xfrm>
+            <a:off x="384048" y="2871216"/>
+            <a:ext cx="11423599" cy="3840480"/>
+          </a:xfrm>
+          <a:prstGeom prst="rect">
+            <a:avLst/>
+          </a:prstGeom>
+          <a:solidFill>
+            <a:srgbClr val="FFFFFF"/>
+          </a:solidFill>
+          <a:ln w="9525">
+            <a:solidFill>
+              <a:srgbClr val="E7EAF0"/>
+            </a:solidFill>
+            <a:prstDash val="solid"/>
+          </a:ln>
+        </p:spPr>
+      </p:sp>
+      <p:sp>
+        <p:nvSpPr>
+          <p:cNvPr id="80" name="Text 78"/>
+          <p:cNvSpPr txBox="1"/>
+          <p:nvPr/>
+        </p:nvSpPr>
+        <p:spPr>
+          <a:xfrm>
+            <a:off x="566928" y="2999232"/>
+            <a:ext cx="5391760" cy="3621024"/>
+          </a:xfrm>
+          <a:prstGeom prst="rect">
+            <a:avLst/>
+          </a:prstGeom>
+          <a:noFill/>
+          <a:ln/>
+        </p:spPr>
+        <p:txBody>
+          <a:bodyPr wrap="square" lIns="0" tIns="0" rIns="0" bIns="0" rtlCol="0" anchor="t"/>
+          <a:lstStyle/>
+          <a:p>
+            <a:pPr algn="l" indent="0" marL="0">
+              <a:lnSpc>
+                <a:spcPct val="112000"/>
+              </a:lnSpc>
+              <a:buNone/>
+            </a:pPr>
+            <a:r>
+              <a:rPr lang="en-US" sz="900" b="1" dirty="0">
+                <a:solidFill>
+                  <a:srgbClr val="133B6C"/>
+                </a:solidFill>
+                <a:latin typeface="Calibri" pitchFamily="34" charset="0"/>
+                <a:ea typeface="Calibri" pitchFamily="34" charset="-122"/>
+                <a:cs typeface="Calibri" pitchFamily="34" charset="-120"/>
+              </a:rPr>
+              <a:t>San Miguel: </a:t>
+            </a:r>
+            <a:pPr algn="l" indent="0" marL="0">
+              <a:lnSpc>
+                <a:spcPct val="112000"/>
+              </a:lnSpc>
+              <a:buNone/>
+            </a:pPr>
+            <a:r>
+              <a:rPr lang="en-US" sz="900" dirty="0">
+                <a:solidFill>
+                  <a:srgbClr val="243044"/>
+                </a:solidFill>
+                <a:latin typeface="Calibri" pitchFamily="34" charset="0"/>
+                <a:ea typeface="Calibri" pitchFamily="34" charset="-122"/>
+                <a:cs typeface="Calibri" pitchFamily="34" charset="-120"/>
+              </a:rPr>
+              <a:t>La comunicación con la plataforma de EVERTEC, principalmente en el monto de reversas —en ocasiones EVERTEC no las acepta, pero en nuestro sistema sí se realizó la reversa— así como la duplicidad de pagos debido a la fluctuación de la plataforma.</a:t>
+            </a:r>
+            <a:endParaRPr lang="en-US" sz="900" dirty="0"/>
+          </a:p>
+          <a:p>
+            <a:pPr algn="l" indent="0" marL="0">
+              <a:lnSpc>
+                <a:spcPct val="112000"/>
+              </a:lnSpc>
+              <a:buNone/>
+            </a:pPr>
+            <a:endParaRPr lang="en-US" sz="900" dirty="0"/>
+          </a:p>
+          <a:p>
+            <a:pPr algn="l" indent="0" marL="0">
+              <a:lnSpc>
+                <a:spcPct val="112000"/>
+              </a:lnSpc>
+              <a:buNone/>
+            </a:pPr>
+            <a:r>
+              <a:rPr lang="en-US" sz="900" b="1" dirty="0">
+                <a:solidFill>
+                  <a:srgbClr val="133B6C"/>
+                </a:solidFill>
+                <a:latin typeface="Calibri" pitchFamily="34" charset="0"/>
+                <a:ea typeface="Calibri" pitchFamily="34" charset="-122"/>
+                <a:cs typeface="Calibri" pitchFamily="34" charset="-120"/>
+              </a:rPr>
+              <a:t>Colonia Médica: </a:t>
+            </a:r>
+            <a:pPr algn="l" indent="0" marL="0">
+              <a:lnSpc>
+                <a:spcPct val="112000"/>
+              </a:lnSpc>
+              <a:buNone/>
+            </a:pPr>
+            <a:r>
+              <a:rPr lang="en-US" sz="900" dirty="0">
+                <a:solidFill>
+                  <a:srgbClr val="243044"/>
+                </a:solidFill>
+                <a:latin typeface="Calibri" pitchFamily="34" charset="0"/>
+                <a:ea typeface="Calibri" pitchFamily="34" charset="-122"/>
+                <a:cs typeface="Calibri" pitchFamily="34" charset="-120"/>
+              </a:rPr>
+              <a:t>Comunicación con EVERTEC.</a:t>
+            </a:r>
+            <a:endParaRPr lang="en-US" sz="900" dirty="0"/>
+          </a:p>
+          <a:p>
+            <a:pPr algn="l" indent="0" marL="0">
+              <a:lnSpc>
+                <a:spcPct val="112000"/>
+              </a:lnSpc>
+              <a:buNone/>
+            </a:pPr>
+            <a:endParaRPr lang="en-US" sz="900" dirty="0"/>
+          </a:p>
+          <a:p>
+            <a:pPr algn="l" indent="0" marL="0">
+              <a:lnSpc>
+                <a:spcPct val="112000"/>
+              </a:lnSpc>
+              <a:buNone/>
+            </a:pPr>
+            <a:r>
+              <a:rPr lang="en-US" sz="900" b="1" dirty="0">
+                <a:solidFill>
+                  <a:srgbClr val="133B6C"/>
+                </a:solidFill>
+                <a:latin typeface="Calibri" pitchFamily="34" charset="0"/>
+                <a:ea typeface="Calibri" pitchFamily="34" charset="-122"/>
+                <a:cs typeface="Calibri" pitchFamily="34" charset="-120"/>
+              </a:rPr>
+              <a:t>Sonsonate: </a:t>
+            </a:r>
+            <a:pPr algn="l" indent="0" marL="0">
+              <a:lnSpc>
+                <a:spcPct val="112000"/>
+              </a:lnSpc>
+              <a:buNone/>
+            </a:pPr>
+            <a:r>
+              <a:rPr lang="en-US" sz="900" dirty="0">
+                <a:solidFill>
+                  <a:srgbClr val="243044"/>
+                </a:solidFill>
+                <a:latin typeface="Calibri" pitchFamily="34" charset="0"/>
+                <a:ea typeface="Calibri" pitchFamily="34" charset="-122"/>
+                <a:cs typeface="Calibri" pitchFamily="34" charset="-120"/>
+              </a:rPr>
+              <a:t>N/A.</a:t>
+            </a:r>
+            <a:endParaRPr lang="en-US" sz="900" dirty="0"/>
+          </a:p>
+          <a:p>
+            <a:pPr algn="l" indent="0" marL="0">
+              <a:lnSpc>
+                <a:spcPct val="112000"/>
+              </a:lnSpc>
+              <a:buNone/>
+            </a:pPr>
+            <a:endParaRPr lang="en-US" sz="900" dirty="0"/>
+          </a:p>
+          <a:p>
+            <a:pPr algn="l" indent="0" marL="0">
+              <a:lnSpc>
+                <a:spcPct val="112000"/>
+              </a:lnSpc>
+              <a:buNone/>
+            </a:pPr>
+            <a:r>
+              <a:rPr lang="en-US" sz="900" b="1" dirty="0">
+                <a:solidFill>
+                  <a:srgbClr val="133B6C"/>
+                </a:solidFill>
+                <a:latin typeface="Calibri" pitchFamily="34" charset="0"/>
+                <a:ea typeface="Calibri" pitchFamily="34" charset="-122"/>
+                <a:cs typeface="Calibri" pitchFamily="34" charset="-120"/>
+              </a:rPr>
+              <a:t>Santa Ana: </a:t>
+            </a:r>
+            <a:pPr algn="l" indent="0" marL="0">
+              <a:lnSpc>
+                <a:spcPct val="112000"/>
+              </a:lnSpc>
+              <a:buNone/>
+            </a:pPr>
+            <a:r>
+              <a:rPr lang="en-US" sz="900" dirty="0">
+                <a:solidFill>
+                  <a:srgbClr val="243044"/>
+                </a:solidFill>
+                <a:latin typeface="Calibri" pitchFamily="34" charset="0"/>
+                <a:ea typeface="Calibri" pitchFamily="34" charset="-122"/>
+                <a:cs typeface="Calibri" pitchFamily="34" charset="-120"/>
+              </a:rPr>
+              <a:t>Siempre recibo ayuda.</a:t>
+            </a:r>
+            <a:endParaRPr lang="en-US" sz="900" dirty="0"/>
+          </a:p>
+          <a:p>
+            <a:pPr algn="l" indent="0" marL="0">
+              <a:lnSpc>
+                <a:spcPct val="112000"/>
+              </a:lnSpc>
+              <a:buNone/>
+            </a:pPr>
+            <a:endParaRPr lang="en-US" sz="900" dirty="0"/>
+          </a:p>
+          <a:p>
+            <a:pPr algn="l" indent="0" marL="0">
+              <a:lnSpc>
+                <a:spcPct val="112000"/>
+              </a:lnSpc>
+              <a:buNone/>
+            </a:pPr>
+            <a:r>
+              <a:rPr lang="en-US" sz="900" b="1" dirty="0">
+                <a:solidFill>
+                  <a:srgbClr val="133B6C"/>
+                </a:solidFill>
+                <a:latin typeface="Calibri" pitchFamily="34" charset="0"/>
+                <a:ea typeface="Calibri" pitchFamily="34" charset="-122"/>
+                <a:cs typeface="Calibri" pitchFamily="34" charset="-120"/>
+              </a:rPr>
+              <a:t>Colonia Médica: </a:t>
+            </a:r>
+            <a:pPr algn="l" indent="0" marL="0">
+              <a:lnSpc>
+                <a:spcPct val="112000"/>
+              </a:lnSpc>
+              <a:buNone/>
+            </a:pPr>
+            <a:r>
+              <a:rPr lang="en-US" sz="900" dirty="0">
+                <a:solidFill>
+                  <a:srgbClr val="243044"/>
+                </a:solidFill>
+                <a:latin typeface="Calibri" pitchFamily="34" charset="0"/>
+                <a:ea typeface="Calibri" pitchFamily="34" charset="-122"/>
+                <a:cs typeface="Calibri" pitchFamily="34" charset="-120"/>
+              </a:rPr>
+              <a:t>Que cuando se olvida a los cajeros la clave, EVERTEC la reinicie, porque a veces cuesta que nos solucionen en tarjeta.</a:t>
+            </a:r>
+            <a:endParaRPr lang="en-US" sz="900" dirty="0"/>
+          </a:p>
+          <a:p>
+            <a:pPr algn="l" indent="0" marL="0">
+              <a:lnSpc>
+                <a:spcPct val="112000"/>
+              </a:lnSpc>
+              <a:buNone/>
+            </a:pPr>
+            <a:endParaRPr lang="en-US" sz="900" dirty="0"/>
+          </a:p>
+          <a:p>
+            <a:pPr algn="l" indent="0" marL="0">
+              <a:lnSpc>
+                <a:spcPct val="112000"/>
+              </a:lnSpc>
+              <a:buNone/>
+            </a:pPr>
+            <a:r>
+              <a:rPr lang="en-US" sz="900" b="1" dirty="0">
+                <a:solidFill>
+                  <a:srgbClr val="133B6C"/>
+                </a:solidFill>
+                <a:latin typeface="Calibri" pitchFamily="34" charset="0"/>
+                <a:ea typeface="Calibri" pitchFamily="34" charset="-122"/>
+                <a:cs typeface="Calibri" pitchFamily="34" charset="-120"/>
+              </a:rPr>
+              <a:t>Sonsonate: </a:t>
+            </a:r>
+            <a:pPr algn="l" indent="0" marL="0">
+              <a:lnSpc>
+                <a:spcPct val="112000"/>
+              </a:lnSpc>
+              <a:buNone/>
+            </a:pPr>
+            <a:r>
+              <a:rPr lang="en-US" sz="900" dirty="0">
+                <a:solidFill>
+                  <a:srgbClr val="243044"/>
+                </a:solidFill>
+                <a:latin typeface="Calibri" pitchFamily="34" charset="0"/>
+                <a:ea typeface="Calibri" pitchFamily="34" charset="-122"/>
+                <a:cs typeface="Calibri" pitchFamily="34" charset="-120"/>
+              </a:rPr>
+              <a:t>No contestan los números de soporte que están en la TC; se pierde frecuentemente la comunicación con EVERTEC. Los asociados indican que los plásticos dan bastante inconveniente al querer realizar compras; se realizan reposiciones muy frecuentemente porque el plástico no funciona, y el proceso de reposición es muy tardado.</a:t>
+            </a:r>
+            <a:endParaRPr lang="en-US" sz="900" dirty="0"/>
+          </a:p>
+          <a:p>
+            <a:pPr algn="l" indent="0" marL="0">
+              <a:lnSpc>
+                <a:spcPct val="112000"/>
+              </a:lnSpc>
+              <a:buNone/>
+            </a:pPr>
+            <a:endParaRPr lang="en-US" sz="900" dirty="0"/>
+          </a:p>
+          <a:p>
+            <a:pPr algn="l" indent="0" marL="0">
+              <a:lnSpc>
+                <a:spcPct val="112000"/>
+              </a:lnSpc>
+              <a:buNone/>
+            </a:pPr>
+            <a:r>
+              <a:rPr lang="en-US" sz="900" b="1" dirty="0">
+                <a:solidFill>
+                  <a:srgbClr val="133B6C"/>
+                </a:solidFill>
+                <a:latin typeface="Calibri" pitchFamily="34" charset="0"/>
+                <a:ea typeface="Calibri" pitchFamily="34" charset="-122"/>
+                <a:cs typeface="Calibri" pitchFamily="34" charset="-120"/>
+              </a:rPr>
+              <a:t>Plaza Mundo: </a:t>
+            </a:r>
+            <a:pPr algn="l" indent="0" marL="0">
+              <a:lnSpc>
+                <a:spcPct val="112000"/>
+              </a:lnSpc>
+              <a:buNone/>
+            </a:pPr>
+            <a:r>
+              <a:rPr lang="en-US" sz="900" dirty="0">
+                <a:solidFill>
+                  <a:srgbClr val="243044"/>
+                </a:solidFill>
+                <a:latin typeface="Calibri" pitchFamily="34" charset="0"/>
+                <a:ea typeface="Calibri" pitchFamily="34" charset="-122"/>
+                <a:cs typeface="Calibri" pitchFamily="34" charset="-120"/>
+              </a:rPr>
+              <a:t>Se recomienda que las promociones por descuentos en supermercados y combustible se reflejen en el estado de cuenta con una descripción específica del beneficio otorgado. Actualmente se registran solo como "Nota de Crédito", lo que genera confusión sobre el origen del descuento.</a:t>
+            </a:r>
+            <a:endParaRPr lang="en-US" sz="900" dirty="0"/>
+          </a:p>
+          <a:p>
+            <a:pPr algn="l" indent="0" marL="0">
+              <a:lnSpc>
+                <a:spcPct val="112000"/>
+              </a:lnSpc>
+              <a:buNone/>
+            </a:pPr>
+            <a:endParaRPr lang="en-US" sz="900" dirty="0"/>
+          </a:p>
+          <a:p>
+            <a:pPr algn="l" indent="0" marL="0">
+              <a:lnSpc>
+                <a:spcPct val="112000"/>
+              </a:lnSpc>
+              <a:buNone/>
+            </a:pPr>
+            <a:r>
+              <a:rPr lang="en-US" sz="900" b="1" dirty="0">
+                <a:solidFill>
+                  <a:srgbClr val="133B6C"/>
+                </a:solidFill>
+                <a:latin typeface="Calibri" pitchFamily="34" charset="0"/>
+                <a:ea typeface="Calibri" pitchFamily="34" charset="-122"/>
+                <a:cs typeface="Calibri" pitchFamily="34" charset="-120"/>
+              </a:rPr>
+              <a:t>Santa Ana: </a:t>
+            </a:r>
+            <a:pPr algn="l" indent="0" marL="0">
+              <a:lnSpc>
+                <a:spcPct val="112000"/>
+              </a:lnSpc>
+              <a:buNone/>
+            </a:pPr>
+            <a:r>
+              <a:rPr lang="en-US" sz="900" dirty="0">
+                <a:solidFill>
+                  <a:srgbClr val="243044"/>
+                </a:solidFill>
+                <a:latin typeface="Calibri" pitchFamily="34" charset="0"/>
+                <a:ea typeface="Calibri" pitchFamily="34" charset="-122"/>
+                <a:cs typeface="Calibri" pitchFamily="34" charset="-120"/>
+              </a:rPr>
+              <a:t>La conexión con EVERTEC algunas veces falla.</a:t>
+            </a:r>
+            <a:endParaRPr lang="en-US" sz="900" dirty="0"/>
+          </a:p>
+        </p:txBody>
+      </p:sp>
+      <p:sp>
+        <p:nvSpPr>
+          <p:cNvPr id="81" name="Text 79"/>
+          <p:cNvSpPr txBox="1"/>
+          <p:nvPr/>
+        </p:nvSpPr>
+        <p:spPr>
+          <a:xfrm>
+            <a:off x="6233008" y="2999232"/>
+            <a:ext cx="5391760" cy="3621024"/>
+          </a:xfrm>
+          <a:prstGeom prst="rect">
+            <a:avLst/>
+          </a:prstGeom>
+          <a:noFill/>
+          <a:ln/>
+        </p:spPr>
+        <p:txBody>
+          <a:bodyPr wrap="square" lIns="0" tIns="0" rIns="0" bIns="0" rtlCol="0" anchor="t"/>
+          <a:lstStyle/>
+          <a:p>
+            <a:pPr algn="l" indent="0" marL="0">
+              <a:lnSpc>
+                <a:spcPct val="112000"/>
+              </a:lnSpc>
+              <a:buNone/>
+            </a:pPr>
+            <a:r>
+              <a:rPr lang="en-US" sz="900" b="1" dirty="0">
+                <a:solidFill>
+                  <a:srgbClr val="133B6C"/>
+                </a:solidFill>
+                <a:latin typeface="Calibri" pitchFamily="34" charset="0"/>
+                <a:ea typeface="Calibri" pitchFamily="34" charset="-122"/>
+                <a:cs typeface="Calibri" pitchFamily="34" charset="-120"/>
+              </a:rPr>
+              <a:t>Plaza Merliot: </a:t>
+            </a:r>
+            <a:pPr algn="l" indent="0" marL="0">
+              <a:lnSpc>
+                <a:spcPct val="112000"/>
+              </a:lnSpc>
+              <a:buNone/>
+            </a:pPr>
+            <a:r>
+              <a:rPr lang="en-US" sz="900" dirty="0">
+                <a:solidFill>
+                  <a:srgbClr val="243044"/>
+                </a:solidFill>
+                <a:latin typeface="Calibri" pitchFamily="34" charset="0"/>
+                <a:ea typeface="Calibri" pitchFamily="34" charset="-122"/>
+                <a:cs typeface="Calibri" pitchFamily="34" charset="-120"/>
+              </a:rPr>
+              <a:t>Tiempos de respuesta en fechas de pago.</a:t>
+            </a:r>
+            <a:endParaRPr lang="en-US" sz="900" dirty="0"/>
+          </a:p>
+          <a:p>
+            <a:pPr algn="l" indent="0" marL="0">
+              <a:lnSpc>
+                <a:spcPct val="112000"/>
+              </a:lnSpc>
+              <a:buNone/>
+            </a:pPr>
+            <a:endParaRPr lang="en-US" sz="900" dirty="0"/>
+          </a:p>
+          <a:p>
+            <a:pPr algn="l" indent="0" marL="0">
+              <a:lnSpc>
+                <a:spcPct val="112000"/>
+              </a:lnSpc>
+              <a:buNone/>
+            </a:pPr>
+            <a:r>
+              <a:rPr lang="en-US" sz="900" b="1" dirty="0">
+                <a:solidFill>
+                  <a:srgbClr val="133B6C"/>
+                </a:solidFill>
+                <a:latin typeface="Calibri" pitchFamily="34" charset="0"/>
+                <a:ea typeface="Calibri" pitchFamily="34" charset="-122"/>
+                <a:cs typeface="Calibri" pitchFamily="34" charset="-120"/>
+              </a:rPr>
+              <a:t>Colegio Médico: </a:t>
+            </a:r>
+            <a:pPr algn="l" indent="0" marL="0">
+              <a:lnSpc>
+                <a:spcPct val="112000"/>
+              </a:lnSpc>
+              <a:buNone/>
+            </a:pPr>
+            <a:r>
+              <a:rPr lang="en-US" sz="900" dirty="0">
+                <a:solidFill>
+                  <a:srgbClr val="243044"/>
+                </a:solidFill>
+                <a:latin typeface="Calibri" pitchFamily="34" charset="0"/>
+                <a:ea typeface="Calibri" pitchFamily="34" charset="-122"/>
+                <a:cs typeface="Calibri" pitchFamily="34" charset="-120"/>
+              </a:rPr>
+              <a:t>Caídas de sistema que a veces no se resuelven pronto.</a:t>
+            </a:r>
+            <a:endParaRPr lang="en-US" sz="900" dirty="0"/>
+          </a:p>
+          <a:p>
+            <a:pPr algn="l" indent="0" marL="0">
+              <a:lnSpc>
+                <a:spcPct val="112000"/>
+              </a:lnSpc>
+              <a:buNone/>
+            </a:pPr>
+            <a:endParaRPr lang="en-US" sz="900" dirty="0"/>
+          </a:p>
+          <a:p>
+            <a:pPr algn="l" indent="0" marL="0">
+              <a:lnSpc>
+                <a:spcPct val="112000"/>
+              </a:lnSpc>
+              <a:buNone/>
+            </a:pPr>
+            <a:r>
+              <a:rPr lang="en-US" sz="900" b="1" dirty="0">
+                <a:solidFill>
+                  <a:srgbClr val="133B6C"/>
+                </a:solidFill>
+                <a:latin typeface="Calibri" pitchFamily="34" charset="0"/>
+                <a:ea typeface="Calibri" pitchFamily="34" charset="-122"/>
+                <a:cs typeface="Calibri" pitchFamily="34" charset="-120"/>
+              </a:rPr>
+              <a:t>Plaza Mundo: </a:t>
+            </a:r>
+            <a:pPr algn="l" indent="0" marL="0">
+              <a:lnSpc>
+                <a:spcPct val="112000"/>
+              </a:lnSpc>
+              <a:buNone/>
+            </a:pPr>
+            <a:r>
+              <a:rPr lang="en-US" sz="900" dirty="0">
+                <a:solidFill>
+                  <a:srgbClr val="243044"/>
+                </a:solidFill>
+                <a:latin typeface="Calibri" pitchFamily="34" charset="0"/>
+                <a:ea typeface="Calibri" pitchFamily="34" charset="-122"/>
+                <a:cs typeface="Calibri" pitchFamily="34" charset="-120"/>
+              </a:rPr>
+              <a:t>El tiempo de resolución; aprobaciones automáticas para asociados calificados sin tanta documentación; tiempo de entrega; acreditación de puntos por promociones dentro de las fechas correspondientes.</a:t>
+            </a:r>
+            <a:endParaRPr lang="en-US" sz="900" dirty="0"/>
+          </a:p>
+          <a:p>
+            <a:pPr algn="l" indent="0" marL="0">
+              <a:lnSpc>
+                <a:spcPct val="112000"/>
+              </a:lnSpc>
+              <a:buNone/>
+            </a:pPr>
+            <a:endParaRPr lang="en-US" sz="900" dirty="0"/>
+          </a:p>
+          <a:p>
+            <a:pPr algn="l" indent="0" marL="0">
+              <a:lnSpc>
+                <a:spcPct val="112000"/>
+              </a:lnSpc>
+              <a:buNone/>
+            </a:pPr>
+            <a:r>
+              <a:rPr lang="en-US" sz="900" b="1" dirty="0">
+                <a:solidFill>
+                  <a:srgbClr val="133B6C"/>
+                </a:solidFill>
+                <a:latin typeface="Calibri" pitchFamily="34" charset="0"/>
+                <a:ea typeface="Calibri" pitchFamily="34" charset="-122"/>
+                <a:cs typeface="Calibri" pitchFamily="34" charset="-120"/>
+              </a:rPr>
+              <a:t>Colegio Médico: </a:t>
+            </a:r>
+            <a:pPr algn="l" indent="0" marL="0">
+              <a:lnSpc>
+                <a:spcPct val="112000"/>
+              </a:lnSpc>
+              <a:buNone/>
+            </a:pPr>
+            <a:r>
+              <a:rPr lang="en-US" sz="900" dirty="0">
+                <a:solidFill>
+                  <a:srgbClr val="243044"/>
+                </a:solidFill>
+                <a:latin typeface="Calibri" pitchFamily="34" charset="0"/>
+                <a:ea typeface="Calibri" pitchFamily="34" charset="-122"/>
+                <a:cs typeface="Calibri" pitchFamily="34" charset="-120"/>
+              </a:rPr>
+              <a:t>Las duplicidades en los pagos cuando hay caídas de sistema: en SISCARD lo toma y en el sistema de COMÉDICA no aparece procesado.</a:t>
+            </a:r>
+            <a:endParaRPr lang="en-US" sz="900" dirty="0"/>
+          </a:p>
+          <a:p>
+            <a:pPr algn="l" indent="0" marL="0">
+              <a:lnSpc>
+                <a:spcPct val="112000"/>
+              </a:lnSpc>
+              <a:buNone/>
+            </a:pPr>
+            <a:endParaRPr lang="en-US" sz="900" dirty="0"/>
+          </a:p>
+          <a:p>
+            <a:pPr algn="l" indent="0" marL="0">
+              <a:lnSpc>
+                <a:spcPct val="112000"/>
+              </a:lnSpc>
+              <a:buNone/>
+            </a:pPr>
+            <a:r>
+              <a:rPr lang="en-US" sz="900" b="1" dirty="0">
+                <a:solidFill>
+                  <a:srgbClr val="133B6C"/>
+                </a:solidFill>
+                <a:latin typeface="Calibri" pitchFamily="34" charset="0"/>
+                <a:ea typeface="Calibri" pitchFamily="34" charset="-122"/>
+                <a:cs typeface="Calibri" pitchFamily="34" charset="-120"/>
+              </a:rPr>
+              <a:t>Usulután: </a:t>
+            </a:r>
+            <a:pPr algn="l" indent="0" marL="0">
+              <a:lnSpc>
+                <a:spcPct val="112000"/>
+              </a:lnSpc>
+              <a:buNone/>
+            </a:pPr>
+            <a:r>
+              <a:rPr lang="en-US" sz="900" dirty="0">
+                <a:solidFill>
+                  <a:srgbClr val="243044"/>
+                </a:solidFill>
+                <a:latin typeface="Calibri" pitchFamily="34" charset="0"/>
+                <a:ea typeface="Calibri" pitchFamily="34" charset="-122"/>
+                <a:cs typeface="Calibri" pitchFamily="34" charset="-120"/>
+              </a:rPr>
+              <a:t>Mejorar la rapidez de respuesta del sistema al cambiar de pantalla o seleccionar las diferentes opciones dentro del módulo.</a:t>
+            </a:r>
+            <a:endParaRPr lang="en-US" sz="900" dirty="0"/>
+          </a:p>
+          <a:p>
+            <a:pPr algn="l" indent="0" marL="0">
+              <a:lnSpc>
+                <a:spcPct val="112000"/>
+              </a:lnSpc>
+              <a:buNone/>
+            </a:pPr>
+            <a:endParaRPr lang="en-US" sz="900" dirty="0"/>
+          </a:p>
+          <a:p>
+            <a:pPr algn="l" indent="0" marL="0">
+              <a:lnSpc>
+                <a:spcPct val="112000"/>
+              </a:lnSpc>
+              <a:buNone/>
+            </a:pPr>
+            <a:r>
+              <a:rPr lang="en-US" sz="900" b="1" dirty="0">
+                <a:solidFill>
+                  <a:srgbClr val="133B6C"/>
+                </a:solidFill>
+                <a:latin typeface="Calibri" pitchFamily="34" charset="0"/>
+                <a:ea typeface="Calibri" pitchFamily="34" charset="-122"/>
+                <a:cs typeface="Calibri" pitchFamily="34" charset="-120"/>
+              </a:rPr>
+              <a:t>Usulután: </a:t>
+            </a:r>
+            <a:pPr algn="l" indent="0" marL="0">
+              <a:lnSpc>
+                <a:spcPct val="112000"/>
+              </a:lnSpc>
+              <a:buNone/>
+            </a:pPr>
+            <a:r>
+              <a:rPr lang="en-US" sz="900" dirty="0">
+                <a:solidFill>
+                  <a:srgbClr val="243044"/>
+                </a:solidFill>
+                <a:latin typeface="Calibri" pitchFamily="34" charset="0"/>
+                <a:ea typeface="Calibri" pitchFamily="34" charset="-122"/>
+                <a:cs typeface="Calibri" pitchFamily="34" charset="-120"/>
+              </a:rPr>
+              <a:t>El tiempo de respuesta para aplicación de compras en flotantes, tanto de TC como TD.</a:t>
+            </a:r>
+            <a:endParaRPr lang="en-US" sz="900" dirty="0"/>
+          </a:p>
+          <a:p>
+            <a:pPr algn="l" indent="0" marL="0">
+              <a:lnSpc>
+                <a:spcPct val="112000"/>
+              </a:lnSpc>
+              <a:buNone/>
+            </a:pPr>
+            <a:endParaRPr lang="en-US" sz="900" dirty="0"/>
+          </a:p>
+          <a:p>
+            <a:pPr algn="l" indent="0" marL="0">
+              <a:lnSpc>
+                <a:spcPct val="112000"/>
+              </a:lnSpc>
+              <a:buNone/>
+            </a:pPr>
+            <a:r>
+              <a:rPr lang="en-US" sz="900" b="1" dirty="0">
+                <a:solidFill>
+                  <a:srgbClr val="133B6C"/>
+                </a:solidFill>
+                <a:latin typeface="Calibri" pitchFamily="34" charset="0"/>
+                <a:ea typeface="Calibri" pitchFamily="34" charset="-122"/>
+                <a:cs typeface="Calibri" pitchFamily="34" charset="-120"/>
+              </a:rPr>
+              <a:t>Central: </a:t>
+            </a:r>
+            <a:pPr algn="l" indent="0" marL="0">
+              <a:lnSpc>
+                <a:spcPct val="112000"/>
+              </a:lnSpc>
+              <a:buNone/>
+            </a:pPr>
+            <a:r>
+              <a:rPr lang="en-US" sz="900" dirty="0">
+                <a:solidFill>
+                  <a:srgbClr val="243044"/>
+                </a:solidFill>
+                <a:latin typeface="Calibri" pitchFamily="34" charset="0"/>
+                <a:ea typeface="Calibri" pitchFamily="34" charset="-122"/>
+                <a:cs typeface="Calibri" pitchFamily="34" charset="-120"/>
+              </a:rPr>
+              <a:t>Todo bien.</a:t>
+            </a:r>
+            <a:endParaRPr lang="en-US" sz="900" dirty="0"/>
+          </a:p>
+          <a:p>
+            <a:pPr algn="l" indent="0" marL="0">
+              <a:lnSpc>
+                <a:spcPct val="112000"/>
+              </a:lnSpc>
+              <a:buNone/>
+            </a:pPr>
+            <a:endParaRPr lang="en-US" sz="900" dirty="0"/>
+          </a:p>
+          <a:p>
+            <a:pPr algn="l" indent="0" marL="0">
+              <a:lnSpc>
+                <a:spcPct val="112000"/>
+              </a:lnSpc>
+              <a:buNone/>
+            </a:pPr>
+            <a:r>
+              <a:rPr lang="en-US" sz="900" b="1" dirty="0">
+                <a:solidFill>
+                  <a:srgbClr val="133B6C"/>
+                </a:solidFill>
+                <a:latin typeface="Calibri" pitchFamily="34" charset="0"/>
+                <a:ea typeface="Calibri" pitchFamily="34" charset="-122"/>
+                <a:cs typeface="Calibri" pitchFamily="34" charset="-120"/>
+              </a:rPr>
+              <a:t>Jefe Móvil: </a:t>
+            </a:r>
+            <a:pPr algn="l" indent="0" marL="0">
+              <a:lnSpc>
+                <a:spcPct val="112000"/>
+              </a:lnSpc>
+              <a:buNone/>
+            </a:pPr>
+            <a:r>
+              <a:rPr lang="en-US" sz="900" dirty="0">
+                <a:solidFill>
+                  <a:srgbClr val="243044"/>
+                </a:solidFill>
+                <a:latin typeface="Calibri" pitchFamily="34" charset="0"/>
+                <a:ea typeface="Calibri" pitchFamily="34" charset="-122"/>
+                <a:cs typeface="Calibri" pitchFamily="34" charset="-120"/>
+              </a:rPr>
+              <a:t>Las reversas de transacción.</a:t>
+            </a:r>
+            <a:endParaRPr lang="en-US" sz="900" dirty="0"/>
+          </a:p>
+          <a:p>
+            <a:pPr algn="l" indent="0" marL="0">
+              <a:lnSpc>
+                <a:spcPct val="112000"/>
+              </a:lnSpc>
+              <a:buNone/>
+            </a:pPr>
+            <a:endParaRPr lang="en-US" sz="900" dirty="0"/>
+          </a:p>
+          <a:p>
+            <a:pPr algn="l" indent="0" marL="0">
+              <a:lnSpc>
+                <a:spcPct val="112000"/>
+              </a:lnSpc>
+              <a:buNone/>
+            </a:pPr>
+            <a:r>
+              <a:rPr lang="en-US" sz="900" b="1" dirty="0">
+                <a:solidFill>
+                  <a:srgbClr val="133B6C"/>
+                </a:solidFill>
+                <a:latin typeface="Calibri" pitchFamily="34" charset="0"/>
+                <a:ea typeface="Calibri" pitchFamily="34" charset="-122"/>
+                <a:cs typeface="Calibri" pitchFamily="34" charset="-120"/>
+              </a:rPr>
+              <a:t>Central: </a:t>
+            </a:r>
+            <a:pPr algn="l" indent="0" marL="0">
+              <a:lnSpc>
+                <a:spcPct val="112000"/>
+              </a:lnSpc>
+              <a:buNone/>
+            </a:pPr>
+            <a:r>
+              <a:rPr lang="en-US" sz="900" dirty="0">
+                <a:solidFill>
+                  <a:srgbClr val="243044"/>
+                </a:solidFill>
+                <a:latin typeface="Calibri" pitchFamily="34" charset="0"/>
+                <a:ea typeface="Calibri" pitchFamily="34" charset="-122"/>
+                <a:cs typeface="Calibri" pitchFamily="34" charset="-120"/>
+              </a:rPr>
+              <a:t>Los cajeros no tienen acceso para ver el saldo de tarjetas de crédito adicionales; los reclamos por contracargos deberían ser atendidos solo por el depto. de TC; y mejorar la gestión de fraude y el reporte de compras fraudulentas.</a:t>
+            </a:r>
+            <a:endParaRPr lang="en-US" sz="900" dirty="0"/>
           </a:p>
         </p:txBody>
       </p:sp>

</xml_diff>

<commit_message>
Replace hand-drawn stacked bars with native PowerPoint charts
Slide 2's 5 question tiles now use pptxgenjs native bar charts
(editable in PowerPoint) instead of custom-drawn stacked-bar shapes
with a manual dot legend, for a more polished and standard chart look.

Co-Authored-By: Claude Sonnet 5 <noreply@anthropic.com>
Claude-Session: https://claude.ai/code/session_01KND4cYnTdx53ydNLfQdR3S
</commit_message>
<xml_diff>
--- a/Dashboard_Ejecutivo_EVERTEC_JuntaDirectiva.pptx
+++ b/Dashboard_Ejecutivo_EVERTEC_JuntaDirectiva.pptx
@@ -106,6 +106,1374 @@
     </a:lvl9pPr>
   </p:defaultTextStyle>
 </p:presentation>
+</file>
+
+<file path=ppt/charts/chart1.xml><?xml version="1.0" encoding="utf-8"?>
+<c:chartSpace xmlns:c="http://schemas.openxmlformats.org/drawingml/2006/chart" xmlns:a="http://schemas.openxmlformats.org/drawingml/2006/main" xmlns:r="http://schemas.openxmlformats.org/officeDocument/2006/relationships">
+  <c:date1904 val="0"/>
+  <c:roundedCorners val="1"/>
+  <c:chart>
+    <c:autoTitleDeleted val="1"/>
+    <c:plotArea>
+      <c:layout/>
+      <c:barChart>
+        <c:barDir val="bar"/>
+        <c:grouping val="clustered"/>
+        <c:varyColors val="0"/>
+        <c:ser>
+          <c:idx val="0"/>
+          <c:order val="0"/>
+          <c:tx>
+            <c:strRef>
+              <c:f>Sheet1!$B$1</c:f>
+              <c:strCache>
+                <c:ptCount val="1"/>
+                <c:pt idx="0">
+                  <c:v/>
+                </c:pt>
+              </c:strCache>
+            </c:strRef>
+          </c:tx>
+          <c:spPr>
+            <a:solidFill>
+              <a:srgbClr val="E0392B"/>
+            </a:solidFill>
+            <a:ln w="9525" cap="flat">
+              <a:solidFill>
+                <a:srgbClr val="FFFFFF"/>
+              </a:solidFill>
+              <a:prstDash val="solid"/>
+              <a:round/>
+            </a:ln>
+            <a:effectLst/>
+          </c:spPr>
+          <c:invertIfNegative val="0"/>
+          <c:dLbls>
+            <c:numFmt formatCode="0.0&quot;%&quot;" sourceLinked="0"/>
+            <c:txPr>
+              <a:bodyPr/>
+              <a:lstStyle/>
+              <a:p>
+                <a:pPr>
+                  <a:defRPr b="0" i="0" strike="noStrike" sz="800" u="none">
+                    <a:solidFill>
+                      <a:srgbClr val="243044"/>
+                    </a:solidFill>
+                    <a:latin typeface="Calibri"/>
+                  </a:defRPr>
+                </a:pPr>
+              </a:p>
+            </c:txPr>
+            <c:showLegendKey val="0"/>
+            <c:showVal val="1"/>
+            <c:showCatName val="0"/>
+            <c:showSerName val="0"/>
+            <c:showPercent val="0"/>
+            <c:showBubbleSize val="0"/>
+            <c:showLeaderLines val="0"/>
+          </c:dLbls>
+          <c:dPt>
+            <c:idx val="0"/>
+            <c:invertIfNegative val="0"/>
+            <c:bubble3D val="0"/>
+            <c:spPr>
+              <a:solidFill>
+                <a:srgbClr val="E0392B"/>
+              </a:solidFill>
+              <a:effectLst/>
+            </c:spPr>
+          </c:dPt>
+          <c:dPt>
+            <c:idx val="1"/>
+            <c:invertIfNegative val="0"/>
+            <c:bubble3D val="0"/>
+            <c:spPr>
+              <a:solidFill>
+                <a:srgbClr val="A6650F"/>
+              </a:solidFill>
+              <a:effectLst/>
+            </c:spPr>
+          </c:dPt>
+          <c:dPt>
+            <c:idx val="2"/>
+            <c:invertIfNegative val="0"/>
+            <c:bubble3D val="0"/>
+            <c:spPr>
+              <a:solidFill>
+                <a:srgbClr val="1E8449"/>
+              </a:solidFill>
+              <a:effectLst/>
+            </c:spPr>
+          </c:dPt>
+          <c:cat>
+            <c:multiLvlStrRef>
+              <c:f>Sheet1!$A$2:$A$4</c:f>
+              <c:multiLvlStrCache>
+                <c:ptCount val="3"/>
+                <c:lvl>
+                  <c:pt idx="0">
+                    <c:v>Frecuente</c:v>
+                  </c:pt>
+                  <c:pt idx="1">
+                    <c:v>Algunas veces</c:v>
+                  </c:pt>
+                  <c:pt idx="2">
+                    <c:v>Rara vez</c:v>
+                  </c:pt>
+                </c:lvl>
+              </c:multiLvlStrCache>
+            </c:multiLvlStrRef>
+          </c:cat>
+          <c:val>
+            <c:numRef>
+              <c:f>Sheet1!$B$2:$B$4</c:f>
+              <c:numCache>
+                <c:formatCode>General</c:formatCode>
+                <c:ptCount val="3"/>
+                <c:pt idx="0">
+                  <c:v>35.3</c:v>
+                </c:pt>
+                <c:pt idx="1">
+                  <c:v>52.9</c:v>
+                </c:pt>
+                <c:pt idx="2">
+                  <c:v>11.8</c:v>
+                </c:pt>
+              </c:numCache>
+            </c:numRef>
+          </c:val>
+        </c:ser>
+        <c:dLbls>
+          <c:numFmt formatCode="0.0&quot;%&quot;" sourceLinked="0"/>
+          <c:txPr>
+            <a:bodyPr/>
+            <a:lstStyle/>
+            <a:p>
+              <a:pPr>
+                <a:defRPr b="0" i="0" strike="noStrike" sz="800" u="none">
+                  <a:solidFill>
+                    <a:srgbClr val="243044"/>
+                  </a:solidFill>
+                  <a:latin typeface="Calibri"/>
+                </a:defRPr>
+              </a:pPr>
+            </a:p>
+          </c:txPr>
+          <c:showLegendKey val="0"/>
+          <c:showVal val="1"/>
+          <c:showCatName val="0"/>
+          <c:showSerName val="0"/>
+          <c:showPercent val="0"/>
+          <c:showBubbleSize val="0"/>
+          <c:showLeaderLines val="0"/>
+        </c:dLbls>
+        <c:gapWidth val="35"/>
+        <c:overlap val="0"/>
+        <c:axId val="2094734554"/>
+        <c:axId val="2094734552"/>
+        <c:axId val="2094734556"/>
+      </c:barChart>
+      <c:catAx>
+        <c:axId val="2094734554"/>
+        <c:scaling>
+          <c:orientation val="minMax"/>
+        </c:scaling>
+        <c:delete val="0"/>
+        <c:axPos val="l"/>
+        <c:numFmt formatCode="General" sourceLinked="1"/>
+        <c:majorTickMark val="none"/>
+        <c:minorTickMark val="none"/>
+        <c:tickLblPos val="nextTo"/>
+        <c:spPr>
+          <a:ln w="12700" cap="flat">
+            <a:noFill/>
+            <a:prstDash val="solid"/>
+            <a:round/>
+          </a:ln>
+        </c:spPr>
+        <c:txPr>
+          <a:bodyPr/>
+          <a:lstStyle/>
+          <a:p>
+            <a:pPr>
+              <a:defRPr sz="800" b="0" i="0" u="none" strike="noStrike">
+                <a:solidFill>
+                  <a:srgbClr val="33415A"/>
+                </a:solidFill>
+                <a:latin typeface="Calibri"/>
+              </a:defRPr>
+            </a:pPr>
+            <a:endParaRPr lang="en-US"/>
+          </a:p>
+        </c:txPr>
+        <c:crossAx val="2094734552"/>
+        <c:crosses val="autoZero"/>
+        <c:auto val="1"/>
+        <c:lblAlgn val="ctr"/>
+        <c:noMultiLvlLbl val="1"/>
+      </c:catAx>
+      <c:valAx>
+        <c:axId val="2094734552"/>
+        <c:scaling>
+          <c:orientation val="minMax"/>
+          <c:max val="100"/>
+          <c:min val="0"/>
+        </c:scaling>
+        <c:delete val="1"/>
+        <c:axPos val="b"/>
+        <c:numFmt formatCode="General" sourceLinked="0"/>
+        <c:majorTickMark val="out"/>
+        <c:minorTickMark val="none"/>
+        <c:tickLblPos val="low"/>
+        <c:spPr>
+          <a:ln w="12700" cap="flat">
+            <a:solidFill>
+              <a:srgbClr val="888888"/>
+            </a:solidFill>
+            <a:prstDash val="solid"/>
+            <a:round/>
+          </a:ln>
+        </c:spPr>
+        <c:txPr>
+          <a:bodyPr/>
+          <a:lstStyle/>
+          <a:p>
+            <a:pPr>
+              <a:defRPr sz="1200" b="0" i="0" u="none" strike="noStrike">
+                <a:solidFill>
+                  <a:srgbClr val="000000"/>
+                </a:solidFill>
+                <a:latin typeface="Arial"/>
+              </a:defRPr>
+            </a:pPr>
+            <a:endParaRPr lang="en-US"/>
+          </a:p>
+        </c:txPr>
+        <c:crossAx val="2094734554"/>
+        <c:crosses val="autoZero"/>
+        <c:crossBetween val="between"/>
+      </c:valAx>
+      <c:spPr>
+        <a:solidFill>
+          <a:srgbClr val="FFFFFF">
+            <a:alpha val="0"/>
+          </a:srgbClr>
+        </a:solidFill>
+        <a:ln>
+          <a:noFill/>
+        </a:ln>
+        <a:effectLst/>
+      </c:spPr>
+    </c:plotArea>
+    <c:plotVisOnly val="1"/>
+    <c:dispBlanksAs val="span"/>
+  </c:chart>
+  <c:spPr>
+    <a:solidFill>
+      <a:srgbClr val="FFFFFF">
+        <a:alpha val="0"/>
+      </a:srgbClr>
+    </a:solidFill>
+    <a:ln>
+      <a:noFill/>
+    </a:ln>
+    <a:effectLst/>
+  </c:spPr>
+  <c:externalData r:id="rId1">
+    <c:autoUpdate val="0"/>
+  </c:externalData>
+</c:chartSpace>
+</file>
+
+<file path=ppt/charts/chart2.xml><?xml version="1.0" encoding="utf-8"?>
+<c:chartSpace xmlns:c="http://schemas.openxmlformats.org/drawingml/2006/chart" xmlns:a="http://schemas.openxmlformats.org/drawingml/2006/main" xmlns:r="http://schemas.openxmlformats.org/officeDocument/2006/relationships">
+  <c:date1904 val="0"/>
+  <c:roundedCorners val="1"/>
+  <c:chart>
+    <c:autoTitleDeleted val="1"/>
+    <c:plotArea>
+      <c:layout/>
+      <c:barChart>
+        <c:barDir val="bar"/>
+        <c:grouping val="clustered"/>
+        <c:varyColors val="0"/>
+        <c:ser>
+          <c:idx val="0"/>
+          <c:order val="0"/>
+          <c:tx>
+            <c:strRef>
+              <c:f>Sheet1!$B$1</c:f>
+              <c:strCache>
+                <c:ptCount val="1"/>
+                <c:pt idx="0">
+                  <c:v/>
+                </c:pt>
+              </c:strCache>
+            </c:strRef>
+          </c:tx>
+          <c:spPr>
+            <a:solidFill>
+              <a:srgbClr val="1E8449"/>
+            </a:solidFill>
+            <a:ln w="9525" cap="flat">
+              <a:solidFill>
+                <a:srgbClr val="FFFFFF"/>
+              </a:solidFill>
+              <a:prstDash val="solid"/>
+              <a:round/>
+            </a:ln>
+            <a:effectLst/>
+          </c:spPr>
+          <c:invertIfNegative val="0"/>
+          <c:dLbls>
+            <c:numFmt formatCode="0.0&quot;%&quot;" sourceLinked="0"/>
+            <c:txPr>
+              <a:bodyPr/>
+              <a:lstStyle/>
+              <a:p>
+                <a:pPr>
+                  <a:defRPr b="0" i="0" strike="noStrike" sz="800" u="none">
+                    <a:solidFill>
+                      <a:srgbClr val="243044"/>
+                    </a:solidFill>
+                    <a:latin typeface="Calibri"/>
+                  </a:defRPr>
+                </a:pPr>
+              </a:p>
+            </c:txPr>
+            <c:showLegendKey val="0"/>
+            <c:showVal val="1"/>
+            <c:showCatName val="0"/>
+            <c:showSerName val="0"/>
+            <c:showPercent val="0"/>
+            <c:showBubbleSize val="0"/>
+            <c:showLeaderLines val="0"/>
+          </c:dLbls>
+          <c:dPt>
+            <c:idx val="0"/>
+            <c:invertIfNegative val="0"/>
+            <c:bubble3D val="0"/>
+            <c:spPr>
+              <a:solidFill>
+                <a:srgbClr val="1E8449"/>
+              </a:solidFill>
+              <a:effectLst/>
+            </c:spPr>
+          </c:dPt>
+          <c:dPt>
+            <c:idx val="1"/>
+            <c:invertIfNegative val="0"/>
+            <c:bubble3D val="0"/>
+            <c:spPr>
+              <a:solidFill>
+                <a:srgbClr val="A6650F"/>
+              </a:solidFill>
+              <a:effectLst/>
+            </c:spPr>
+          </c:dPt>
+          <c:dPt>
+            <c:idx val="2"/>
+            <c:invertIfNegative val="0"/>
+            <c:bubble3D val="0"/>
+            <c:spPr>
+              <a:solidFill>
+                <a:srgbClr val="1D63A1"/>
+              </a:solidFill>
+              <a:effectLst/>
+            </c:spPr>
+          </c:dPt>
+          <c:cat>
+            <c:multiLvlStrRef>
+              <c:f>Sheet1!$A$2:$A$4</c:f>
+              <c:multiLvlStrCache>
+                <c:ptCount val="3"/>
+                <c:lvl>
+                  <c:pt idx="0">
+                    <c:v>Oportuno</c:v>
+                  </c:pt>
+                  <c:pt idx="1">
+                    <c:v>Regular</c:v>
+                  </c:pt>
+                  <c:pt idx="2">
+                    <c:v>Muy oport.</c:v>
+                  </c:pt>
+                </c:lvl>
+              </c:multiLvlStrCache>
+            </c:multiLvlStrRef>
+          </c:cat>
+          <c:val>
+            <c:numRef>
+              <c:f>Sheet1!$B$2:$B$4</c:f>
+              <c:numCache>
+                <c:formatCode>General</c:formatCode>
+                <c:ptCount val="3"/>
+                <c:pt idx="0">
+                  <c:v>70.6</c:v>
+                </c:pt>
+                <c:pt idx="1">
+                  <c:v>17.6</c:v>
+                </c:pt>
+                <c:pt idx="2">
+                  <c:v>11.8</c:v>
+                </c:pt>
+              </c:numCache>
+            </c:numRef>
+          </c:val>
+        </c:ser>
+        <c:dLbls>
+          <c:numFmt formatCode="0.0&quot;%&quot;" sourceLinked="0"/>
+          <c:txPr>
+            <a:bodyPr/>
+            <a:lstStyle/>
+            <a:p>
+              <a:pPr>
+                <a:defRPr b="0" i="0" strike="noStrike" sz="800" u="none">
+                  <a:solidFill>
+                    <a:srgbClr val="243044"/>
+                  </a:solidFill>
+                  <a:latin typeface="Calibri"/>
+                </a:defRPr>
+              </a:pPr>
+            </a:p>
+          </c:txPr>
+          <c:showLegendKey val="0"/>
+          <c:showVal val="1"/>
+          <c:showCatName val="0"/>
+          <c:showSerName val="0"/>
+          <c:showPercent val="0"/>
+          <c:showBubbleSize val="0"/>
+          <c:showLeaderLines val="0"/>
+        </c:dLbls>
+        <c:gapWidth val="35"/>
+        <c:overlap val="0"/>
+        <c:axId val="2094734554"/>
+        <c:axId val="2094734552"/>
+        <c:axId val="2094734556"/>
+      </c:barChart>
+      <c:catAx>
+        <c:axId val="2094734554"/>
+        <c:scaling>
+          <c:orientation val="minMax"/>
+        </c:scaling>
+        <c:delete val="0"/>
+        <c:axPos val="l"/>
+        <c:numFmt formatCode="General" sourceLinked="1"/>
+        <c:majorTickMark val="none"/>
+        <c:minorTickMark val="none"/>
+        <c:tickLblPos val="nextTo"/>
+        <c:spPr>
+          <a:ln w="12700" cap="flat">
+            <a:noFill/>
+            <a:prstDash val="solid"/>
+            <a:round/>
+          </a:ln>
+        </c:spPr>
+        <c:txPr>
+          <a:bodyPr/>
+          <a:lstStyle/>
+          <a:p>
+            <a:pPr>
+              <a:defRPr sz="800" b="0" i="0" u="none" strike="noStrike">
+                <a:solidFill>
+                  <a:srgbClr val="33415A"/>
+                </a:solidFill>
+                <a:latin typeface="Calibri"/>
+              </a:defRPr>
+            </a:pPr>
+            <a:endParaRPr lang="en-US"/>
+          </a:p>
+        </c:txPr>
+        <c:crossAx val="2094734552"/>
+        <c:crosses val="autoZero"/>
+        <c:auto val="1"/>
+        <c:lblAlgn val="ctr"/>
+        <c:noMultiLvlLbl val="1"/>
+      </c:catAx>
+      <c:valAx>
+        <c:axId val="2094734552"/>
+        <c:scaling>
+          <c:orientation val="minMax"/>
+          <c:max val="100"/>
+          <c:min val="0"/>
+        </c:scaling>
+        <c:delete val="1"/>
+        <c:axPos val="b"/>
+        <c:numFmt formatCode="General" sourceLinked="0"/>
+        <c:majorTickMark val="out"/>
+        <c:minorTickMark val="none"/>
+        <c:tickLblPos val="low"/>
+        <c:spPr>
+          <a:ln w="12700" cap="flat">
+            <a:solidFill>
+              <a:srgbClr val="888888"/>
+            </a:solidFill>
+            <a:prstDash val="solid"/>
+            <a:round/>
+          </a:ln>
+        </c:spPr>
+        <c:txPr>
+          <a:bodyPr/>
+          <a:lstStyle/>
+          <a:p>
+            <a:pPr>
+              <a:defRPr sz="1200" b="0" i="0" u="none" strike="noStrike">
+                <a:solidFill>
+                  <a:srgbClr val="000000"/>
+                </a:solidFill>
+                <a:latin typeface="Arial"/>
+              </a:defRPr>
+            </a:pPr>
+            <a:endParaRPr lang="en-US"/>
+          </a:p>
+        </c:txPr>
+        <c:crossAx val="2094734554"/>
+        <c:crosses val="autoZero"/>
+        <c:crossBetween val="between"/>
+      </c:valAx>
+      <c:spPr>
+        <a:solidFill>
+          <a:srgbClr val="FFFFFF">
+            <a:alpha val="0"/>
+          </a:srgbClr>
+        </a:solidFill>
+        <a:ln>
+          <a:noFill/>
+        </a:ln>
+        <a:effectLst/>
+      </c:spPr>
+    </c:plotArea>
+    <c:plotVisOnly val="1"/>
+    <c:dispBlanksAs val="span"/>
+  </c:chart>
+  <c:spPr>
+    <a:solidFill>
+      <a:srgbClr val="FFFFFF">
+        <a:alpha val="0"/>
+      </a:srgbClr>
+    </a:solidFill>
+    <a:ln>
+      <a:noFill/>
+    </a:ln>
+    <a:effectLst/>
+  </c:spPr>
+  <c:externalData r:id="rId1">
+    <c:autoUpdate val="0"/>
+  </c:externalData>
+</c:chartSpace>
+</file>
+
+<file path=ppt/charts/chart3.xml><?xml version="1.0" encoding="utf-8"?>
+<c:chartSpace xmlns:c="http://schemas.openxmlformats.org/drawingml/2006/chart" xmlns:a="http://schemas.openxmlformats.org/drawingml/2006/main" xmlns:r="http://schemas.openxmlformats.org/officeDocument/2006/relationships">
+  <c:date1904 val="0"/>
+  <c:roundedCorners val="1"/>
+  <c:chart>
+    <c:autoTitleDeleted val="1"/>
+    <c:plotArea>
+      <c:layout/>
+      <c:barChart>
+        <c:barDir val="bar"/>
+        <c:grouping val="clustered"/>
+        <c:varyColors val="0"/>
+        <c:ser>
+          <c:idx val="0"/>
+          <c:order val="0"/>
+          <c:tx>
+            <c:strRef>
+              <c:f>Sheet1!$B$1</c:f>
+              <c:strCache>
+                <c:ptCount val="1"/>
+                <c:pt idx="0">
+                  <c:v/>
+                </c:pt>
+              </c:strCache>
+            </c:strRef>
+          </c:tx>
+          <c:spPr>
+            <a:solidFill>
+              <a:srgbClr val="E0392B"/>
+            </a:solidFill>
+            <a:ln w="9525" cap="flat">
+              <a:solidFill>
+                <a:srgbClr val="FFFFFF"/>
+              </a:solidFill>
+              <a:prstDash val="solid"/>
+              <a:round/>
+            </a:ln>
+            <a:effectLst/>
+          </c:spPr>
+          <c:invertIfNegative val="0"/>
+          <c:dLbls>
+            <c:numFmt formatCode="0.0&quot;%&quot;" sourceLinked="0"/>
+            <c:txPr>
+              <a:bodyPr/>
+              <a:lstStyle/>
+              <a:p>
+                <a:pPr>
+                  <a:defRPr b="0" i="0" strike="noStrike" sz="800" u="none">
+                    <a:solidFill>
+                      <a:srgbClr val="243044"/>
+                    </a:solidFill>
+                    <a:latin typeface="Calibri"/>
+                  </a:defRPr>
+                </a:pPr>
+              </a:p>
+            </c:txPr>
+            <c:showLegendKey val="0"/>
+            <c:showVal val="1"/>
+            <c:showCatName val="0"/>
+            <c:showSerName val="0"/>
+            <c:showPercent val="0"/>
+            <c:showBubbleSize val="0"/>
+            <c:showLeaderLines val="0"/>
+          </c:dLbls>
+          <c:dPt>
+            <c:idx val="0"/>
+            <c:invertIfNegative val="0"/>
+            <c:bubble3D val="0"/>
+            <c:spPr>
+              <a:solidFill>
+                <a:srgbClr val="E0392B"/>
+              </a:solidFill>
+              <a:effectLst/>
+            </c:spPr>
+          </c:dPt>
+          <c:dPt>
+            <c:idx val="1"/>
+            <c:invertIfNegative val="0"/>
+            <c:bubble3D val="0"/>
+            <c:spPr>
+              <a:solidFill>
+                <a:srgbClr val="A6650F"/>
+              </a:solidFill>
+              <a:effectLst/>
+            </c:spPr>
+          </c:dPt>
+          <c:dPt>
+            <c:idx val="2"/>
+            <c:invertIfNegative val="0"/>
+            <c:bubble3D val="0"/>
+            <c:spPr>
+              <a:solidFill>
+                <a:srgbClr val="1E8449"/>
+              </a:solidFill>
+              <a:effectLst/>
+            </c:spPr>
+          </c:dPt>
+          <c:cat>
+            <c:multiLvlStrRef>
+              <c:f>Sheet1!$A$2:$A$4</c:f>
+              <c:multiLvlStrCache>
+                <c:ptCount val="3"/>
+                <c:lvl>
+                  <c:pt idx="0">
+                    <c:v>Frecuente</c:v>
+                  </c:pt>
+                  <c:pt idx="1">
+                    <c:v>Algunas veces</c:v>
+                  </c:pt>
+                  <c:pt idx="2">
+                    <c:v>Rara vez</c:v>
+                  </c:pt>
+                </c:lvl>
+              </c:multiLvlStrCache>
+            </c:multiLvlStrRef>
+          </c:cat>
+          <c:val>
+            <c:numRef>
+              <c:f>Sheet1!$B$2:$B$4</c:f>
+              <c:numCache>
+                <c:formatCode>General</c:formatCode>
+                <c:ptCount val="3"/>
+                <c:pt idx="0">
+                  <c:v>41.2</c:v>
+                </c:pt>
+                <c:pt idx="1">
+                  <c:v>35.3</c:v>
+                </c:pt>
+                <c:pt idx="2">
+                  <c:v>23.5</c:v>
+                </c:pt>
+              </c:numCache>
+            </c:numRef>
+          </c:val>
+        </c:ser>
+        <c:dLbls>
+          <c:numFmt formatCode="0.0&quot;%&quot;" sourceLinked="0"/>
+          <c:txPr>
+            <a:bodyPr/>
+            <a:lstStyle/>
+            <a:p>
+              <a:pPr>
+                <a:defRPr b="0" i="0" strike="noStrike" sz="800" u="none">
+                  <a:solidFill>
+                    <a:srgbClr val="243044"/>
+                  </a:solidFill>
+                  <a:latin typeface="Calibri"/>
+                </a:defRPr>
+              </a:pPr>
+            </a:p>
+          </c:txPr>
+          <c:showLegendKey val="0"/>
+          <c:showVal val="1"/>
+          <c:showCatName val="0"/>
+          <c:showSerName val="0"/>
+          <c:showPercent val="0"/>
+          <c:showBubbleSize val="0"/>
+          <c:showLeaderLines val="0"/>
+        </c:dLbls>
+        <c:gapWidth val="35"/>
+        <c:overlap val="0"/>
+        <c:axId val="2094734554"/>
+        <c:axId val="2094734552"/>
+        <c:axId val="2094734556"/>
+      </c:barChart>
+      <c:catAx>
+        <c:axId val="2094734554"/>
+        <c:scaling>
+          <c:orientation val="minMax"/>
+        </c:scaling>
+        <c:delete val="0"/>
+        <c:axPos val="l"/>
+        <c:numFmt formatCode="General" sourceLinked="1"/>
+        <c:majorTickMark val="none"/>
+        <c:minorTickMark val="none"/>
+        <c:tickLblPos val="nextTo"/>
+        <c:spPr>
+          <a:ln w="12700" cap="flat">
+            <a:noFill/>
+            <a:prstDash val="solid"/>
+            <a:round/>
+          </a:ln>
+        </c:spPr>
+        <c:txPr>
+          <a:bodyPr/>
+          <a:lstStyle/>
+          <a:p>
+            <a:pPr>
+              <a:defRPr sz="800" b="0" i="0" u="none" strike="noStrike">
+                <a:solidFill>
+                  <a:srgbClr val="33415A"/>
+                </a:solidFill>
+                <a:latin typeface="Calibri"/>
+              </a:defRPr>
+            </a:pPr>
+            <a:endParaRPr lang="en-US"/>
+          </a:p>
+        </c:txPr>
+        <c:crossAx val="2094734552"/>
+        <c:crosses val="autoZero"/>
+        <c:auto val="1"/>
+        <c:lblAlgn val="ctr"/>
+        <c:noMultiLvlLbl val="1"/>
+      </c:catAx>
+      <c:valAx>
+        <c:axId val="2094734552"/>
+        <c:scaling>
+          <c:orientation val="minMax"/>
+          <c:max val="100"/>
+          <c:min val="0"/>
+        </c:scaling>
+        <c:delete val="1"/>
+        <c:axPos val="b"/>
+        <c:numFmt formatCode="General" sourceLinked="0"/>
+        <c:majorTickMark val="out"/>
+        <c:minorTickMark val="none"/>
+        <c:tickLblPos val="low"/>
+        <c:spPr>
+          <a:ln w="12700" cap="flat">
+            <a:solidFill>
+              <a:srgbClr val="888888"/>
+            </a:solidFill>
+            <a:prstDash val="solid"/>
+            <a:round/>
+          </a:ln>
+        </c:spPr>
+        <c:txPr>
+          <a:bodyPr/>
+          <a:lstStyle/>
+          <a:p>
+            <a:pPr>
+              <a:defRPr sz="1200" b="0" i="0" u="none" strike="noStrike">
+                <a:solidFill>
+                  <a:srgbClr val="000000"/>
+                </a:solidFill>
+                <a:latin typeface="Arial"/>
+              </a:defRPr>
+            </a:pPr>
+            <a:endParaRPr lang="en-US"/>
+          </a:p>
+        </c:txPr>
+        <c:crossAx val="2094734554"/>
+        <c:crosses val="autoZero"/>
+        <c:crossBetween val="between"/>
+      </c:valAx>
+      <c:spPr>
+        <a:solidFill>
+          <a:srgbClr val="FFFFFF">
+            <a:alpha val="0"/>
+          </a:srgbClr>
+        </a:solidFill>
+        <a:ln>
+          <a:noFill/>
+        </a:ln>
+        <a:effectLst/>
+      </c:spPr>
+    </c:plotArea>
+    <c:plotVisOnly val="1"/>
+    <c:dispBlanksAs val="span"/>
+  </c:chart>
+  <c:spPr>
+    <a:solidFill>
+      <a:srgbClr val="FFFFFF">
+        <a:alpha val="0"/>
+      </a:srgbClr>
+    </a:solidFill>
+    <a:ln>
+      <a:noFill/>
+    </a:ln>
+    <a:effectLst/>
+  </c:spPr>
+  <c:externalData r:id="rId1">
+    <c:autoUpdate val="0"/>
+  </c:externalData>
+</c:chartSpace>
+</file>
+
+<file path=ppt/charts/chart4.xml><?xml version="1.0" encoding="utf-8"?>
+<c:chartSpace xmlns:c="http://schemas.openxmlformats.org/drawingml/2006/chart" xmlns:a="http://schemas.openxmlformats.org/drawingml/2006/main" xmlns:r="http://schemas.openxmlformats.org/officeDocument/2006/relationships">
+  <c:date1904 val="0"/>
+  <c:roundedCorners val="1"/>
+  <c:chart>
+    <c:autoTitleDeleted val="1"/>
+    <c:plotArea>
+      <c:layout/>
+      <c:barChart>
+        <c:barDir val="bar"/>
+        <c:grouping val="clustered"/>
+        <c:varyColors val="0"/>
+        <c:ser>
+          <c:idx val="0"/>
+          <c:order val="0"/>
+          <c:tx>
+            <c:strRef>
+              <c:f>Sheet1!$B$1</c:f>
+              <c:strCache>
+                <c:ptCount val="1"/>
+                <c:pt idx="0">
+                  <c:v/>
+                </c:pt>
+              </c:strCache>
+            </c:strRef>
+          </c:tx>
+          <c:spPr>
+            <a:solidFill>
+              <a:srgbClr val="A6650F"/>
+            </a:solidFill>
+            <a:ln w="9525" cap="flat">
+              <a:solidFill>
+                <a:srgbClr val="FFFFFF"/>
+              </a:solidFill>
+              <a:prstDash val="solid"/>
+              <a:round/>
+            </a:ln>
+            <a:effectLst/>
+          </c:spPr>
+          <c:invertIfNegative val="0"/>
+          <c:dLbls>
+            <c:numFmt formatCode="0.0&quot;%&quot;" sourceLinked="0"/>
+            <c:txPr>
+              <a:bodyPr/>
+              <a:lstStyle/>
+              <a:p>
+                <a:pPr>
+                  <a:defRPr b="0" i="0" strike="noStrike" sz="800" u="none">
+                    <a:solidFill>
+                      <a:srgbClr val="243044"/>
+                    </a:solidFill>
+                    <a:latin typeface="Calibri"/>
+                  </a:defRPr>
+                </a:pPr>
+              </a:p>
+            </c:txPr>
+            <c:showLegendKey val="0"/>
+            <c:showVal val="1"/>
+            <c:showCatName val="0"/>
+            <c:showSerName val="0"/>
+            <c:showPercent val="0"/>
+            <c:showBubbleSize val="0"/>
+            <c:showLeaderLines val="0"/>
+          </c:dLbls>
+          <c:dPt>
+            <c:idx val="0"/>
+            <c:invertIfNegative val="0"/>
+            <c:bubble3D val="0"/>
+            <c:spPr>
+              <a:solidFill>
+                <a:srgbClr val="A6650F"/>
+              </a:solidFill>
+              <a:effectLst/>
+            </c:spPr>
+          </c:dPt>
+          <c:dPt>
+            <c:idx val="1"/>
+            <c:invertIfNegative val="0"/>
+            <c:bubble3D val="0"/>
+            <c:spPr>
+              <a:solidFill>
+                <a:srgbClr val="1E8449"/>
+              </a:solidFill>
+              <a:effectLst/>
+            </c:spPr>
+          </c:dPt>
+          <c:dPt>
+            <c:idx val="2"/>
+            <c:invertIfNegative val="0"/>
+            <c:bubble3D val="0"/>
+            <c:spPr>
+              <a:solidFill>
+                <a:srgbClr val="5B6B82"/>
+              </a:solidFill>
+              <a:effectLst/>
+            </c:spPr>
+          </c:dPt>
+          <c:cat>
+            <c:multiLvlStrRef>
+              <c:f>Sheet1!$A$2:$A$4</c:f>
+              <c:multiLvlStrCache>
+                <c:ptCount val="3"/>
+                <c:lvl>
+                  <c:pt idx="0">
+                    <c:v>Regular</c:v>
+                  </c:pt>
+                  <c:pt idx="1">
+                    <c:v>Fácil</c:v>
+                  </c:pt>
+                  <c:pt idx="2">
+                    <c:v>Difícil</c:v>
+                  </c:pt>
+                </c:lvl>
+              </c:multiLvlStrCache>
+            </c:multiLvlStrRef>
+          </c:cat>
+          <c:val>
+            <c:numRef>
+              <c:f>Sheet1!$B$2:$B$4</c:f>
+              <c:numCache>
+                <c:formatCode>General</c:formatCode>
+                <c:ptCount val="3"/>
+                <c:pt idx="0">
+                  <c:v>52.9</c:v>
+                </c:pt>
+                <c:pt idx="1">
+                  <c:v>35.3</c:v>
+                </c:pt>
+                <c:pt idx="2">
+                  <c:v>11.8</c:v>
+                </c:pt>
+              </c:numCache>
+            </c:numRef>
+          </c:val>
+        </c:ser>
+        <c:dLbls>
+          <c:numFmt formatCode="0.0&quot;%&quot;" sourceLinked="0"/>
+          <c:txPr>
+            <a:bodyPr/>
+            <a:lstStyle/>
+            <a:p>
+              <a:pPr>
+                <a:defRPr b="0" i="0" strike="noStrike" sz="800" u="none">
+                  <a:solidFill>
+                    <a:srgbClr val="243044"/>
+                  </a:solidFill>
+                  <a:latin typeface="Calibri"/>
+                </a:defRPr>
+              </a:pPr>
+            </a:p>
+          </c:txPr>
+          <c:showLegendKey val="0"/>
+          <c:showVal val="1"/>
+          <c:showCatName val="0"/>
+          <c:showSerName val="0"/>
+          <c:showPercent val="0"/>
+          <c:showBubbleSize val="0"/>
+          <c:showLeaderLines val="0"/>
+        </c:dLbls>
+        <c:gapWidth val="35"/>
+        <c:overlap val="0"/>
+        <c:axId val="2094734554"/>
+        <c:axId val="2094734552"/>
+        <c:axId val="2094734556"/>
+      </c:barChart>
+      <c:catAx>
+        <c:axId val="2094734554"/>
+        <c:scaling>
+          <c:orientation val="minMax"/>
+        </c:scaling>
+        <c:delete val="0"/>
+        <c:axPos val="l"/>
+        <c:numFmt formatCode="General" sourceLinked="1"/>
+        <c:majorTickMark val="none"/>
+        <c:minorTickMark val="none"/>
+        <c:tickLblPos val="nextTo"/>
+        <c:spPr>
+          <a:ln w="12700" cap="flat">
+            <a:noFill/>
+            <a:prstDash val="solid"/>
+            <a:round/>
+          </a:ln>
+        </c:spPr>
+        <c:txPr>
+          <a:bodyPr/>
+          <a:lstStyle/>
+          <a:p>
+            <a:pPr>
+              <a:defRPr sz="800" b="0" i="0" u="none" strike="noStrike">
+                <a:solidFill>
+                  <a:srgbClr val="33415A"/>
+                </a:solidFill>
+                <a:latin typeface="Calibri"/>
+              </a:defRPr>
+            </a:pPr>
+            <a:endParaRPr lang="en-US"/>
+          </a:p>
+        </c:txPr>
+        <c:crossAx val="2094734552"/>
+        <c:crosses val="autoZero"/>
+        <c:auto val="1"/>
+        <c:lblAlgn val="ctr"/>
+        <c:noMultiLvlLbl val="1"/>
+      </c:catAx>
+      <c:valAx>
+        <c:axId val="2094734552"/>
+        <c:scaling>
+          <c:orientation val="minMax"/>
+          <c:max val="100"/>
+          <c:min val="0"/>
+        </c:scaling>
+        <c:delete val="1"/>
+        <c:axPos val="b"/>
+        <c:numFmt formatCode="General" sourceLinked="0"/>
+        <c:majorTickMark val="out"/>
+        <c:minorTickMark val="none"/>
+        <c:tickLblPos val="low"/>
+        <c:spPr>
+          <a:ln w="12700" cap="flat">
+            <a:solidFill>
+              <a:srgbClr val="888888"/>
+            </a:solidFill>
+            <a:prstDash val="solid"/>
+            <a:round/>
+          </a:ln>
+        </c:spPr>
+        <c:txPr>
+          <a:bodyPr/>
+          <a:lstStyle/>
+          <a:p>
+            <a:pPr>
+              <a:defRPr sz="1200" b="0" i="0" u="none" strike="noStrike">
+                <a:solidFill>
+                  <a:srgbClr val="000000"/>
+                </a:solidFill>
+                <a:latin typeface="Arial"/>
+              </a:defRPr>
+            </a:pPr>
+            <a:endParaRPr lang="en-US"/>
+          </a:p>
+        </c:txPr>
+        <c:crossAx val="2094734554"/>
+        <c:crosses val="autoZero"/>
+        <c:crossBetween val="between"/>
+      </c:valAx>
+      <c:spPr>
+        <a:solidFill>
+          <a:srgbClr val="FFFFFF">
+            <a:alpha val="0"/>
+          </a:srgbClr>
+        </a:solidFill>
+        <a:ln>
+          <a:noFill/>
+        </a:ln>
+        <a:effectLst/>
+      </c:spPr>
+    </c:plotArea>
+    <c:plotVisOnly val="1"/>
+    <c:dispBlanksAs val="span"/>
+  </c:chart>
+  <c:spPr>
+    <a:solidFill>
+      <a:srgbClr val="FFFFFF">
+        <a:alpha val="0"/>
+      </a:srgbClr>
+    </a:solidFill>
+    <a:ln>
+      <a:noFill/>
+    </a:ln>
+    <a:effectLst/>
+  </c:spPr>
+  <c:externalData r:id="rId1">
+    <c:autoUpdate val="0"/>
+  </c:externalData>
+</c:chartSpace>
+</file>
+
+<file path=ppt/charts/chart5.xml><?xml version="1.0" encoding="utf-8"?>
+<c:chartSpace xmlns:c="http://schemas.openxmlformats.org/drawingml/2006/chart" xmlns:a="http://schemas.openxmlformats.org/drawingml/2006/main" xmlns:r="http://schemas.openxmlformats.org/officeDocument/2006/relationships">
+  <c:date1904 val="0"/>
+  <c:roundedCorners val="1"/>
+  <c:chart>
+    <c:autoTitleDeleted val="1"/>
+    <c:plotArea>
+      <c:layout/>
+      <c:barChart>
+        <c:barDir val="bar"/>
+        <c:grouping val="clustered"/>
+        <c:varyColors val="0"/>
+        <c:ser>
+          <c:idx val="0"/>
+          <c:order val="0"/>
+          <c:tx>
+            <c:strRef>
+              <c:f>Sheet1!$B$1</c:f>
+              <c:strCache>
+                <c:ptCount val="1"/>
+                <c:pt idx="0">
+                  <c:v/>
+                </c:pt>
+              </c:strCache>
+            </c:strRef>
+          </c:tx>
+          <c:spPr>
+            <a:solidFill>
+              <a:srgbClr val="1E8449"/>
+            </a:solidFill>
+            <a:ln w="9525" cap="flat">
+              <a:solidFill>
+                <a:srgbClr val="FFFFFF"/>
+              </a:solidFill>
+              <a:prstDash val="solid"/>
+              <a:round/>
+            </a:ln>
+            <a:effectLst/>
+          </c:spPr>
+          <c:invertIfNegative val="0"/>
+          <c:dLbls>
+            <c:numFmt formatCode="0.0&quot;%&quot;" sourceLinked="0"/>
+            <c:txPr>
+              <a:bodyPr/>
+              <a:lstStyle/>
+              <a:p>
+                <a:pPr>
+                  <a:defRPr b="0" i="0" strike="noStrike" sz="800" u="none">
+                    <a:solidFill>
+                      <a:srgbClr val="243044"/>
+                    </a:solidFill>
+                    <a:latin typeface="Calibri"/>
+                  </a:defRPr>
+                </a:pPr>
+              </a:p>
+            </c:txPr>
+            <c:showLegendKey val="0"/>
+            <c:showVal val="1"/>
+            <c:showCatName val="0"/>
+            <c:showSerName val="0"/>
+            <c:showPercent val="0"/>
+            <c:showBubbleSize val="0"/>
+            <c:showLeaderLines val="0"/>
+          </c:dLbls>
+          <c:dPt>
+            <c:idx val="0"/>
+            <c:invertIfNegative val="0"/>
+            <c:bubble3D val="0"/>
+            <c:spPr>
+              <a:solidFill>
+                <a:srgbClr val="1E8449"/>
+              </a:solidFill>
+              <a:effectLst/>
+            </c:spPr>
+          </c:dPt>
+          <c:dPt>
+            <c:idx val="1"/>
+            <c:invertIfNegative val="0"/>
+            <c:bubble3D val="0"/>
+            <c:spPr>
+              <a:solidFill>
+                <a:srgbClr val="A6650F"/>
+              </a:solidFill>
+              <a:effectLst/>
+            </c:spPr>
+          </c:dPt>
+          <c:cat>
+            <c:multiLvlStrRef>
+              <c:f>Sheet1!$A$2:$A$3</c:f>
+              <c:multiLvlStrCache>
+                <c:ptCount val="2"/>
+                <c:lvl>
+                  <c:pt idx="0">
+                    <c:v>Nota 4</c:v>
+                  </c:pt>
+                  <c:pt idx="1">
+                    <c:v>Nota 3</c:v>
+                  </c:pt>
+                </c:lvl>
+              </c:multiLvlStrCache>
+            </c:multiLvlStrRef>
+          </c:cat>
+          <c:val>
+            <c:numRef>
+              <c:f>Sheet1!$B$2:$B$3</c:f>
+              <c:numCache>
+                <c:formatCode>General</c:formatCode>
+                <c:ptCount val="2"/>
+                <c:pt idx="0">
+                  <c:v>82.4</c:v>
+                </c:pt>
+                <c:pt idx="1">
+                  <c:v>17.6</c:v>
+                </c:pt>
+              </c:numCache>
+            </c:numRef>
+          </c:val>
+        </c:ser>
+        <c:dLbls>
+          <c:numFmt formatCode="0.0&quot;%&quot;" sourceLinked="0"/>
+          <c:txPr>
+            <a:bodyPr/>
+            <a:lstStyle/>
+            <a:p>
+              <a:pPr>
+                <a:defRPr b="0" i="0" strike="noStrike" sz="800" u="none">
+                  <a:solidFill>
+                    <a:srgbClr val="243044"/>
+                  </a:solidFill>
+                  <a:latin typeface="Calibri"/>
+                </a:defRPr>
+              </a:pPr>
+            </a:p>
+          </c:txPr>
+          <c:showLegendKey val="0"/>
+          <c:showVal val="1"/>
+          <c:showCatName val="0"/>
+          <c:showSerName val="0"/>
+          <c:showPercent val="0"/>
+          <c:showBubbleSize val="0"/>
+          <c:showLeaderLines val="0"/>
+        </c:dLbls>
+        <c:gapWidth val="35"/>
+        <c:overlap val="0"/>
+        <c:axId val="2094734554"/>
+        <c:axId val="2094734552"/>
+        <c:axId val="2094734556"/>
+      </c:barChart>
+      <c:catAx>
+        <c:axId val="2094734554"/>
+        <c:scaling>
+          <c:orientation val="minMax"/>
+        </c:scaling>
+        <c:delete val="0"/>
+        <c:axPos val="l"/>
+        <c:numFmt formatCode="General" sourceLinked="1"/>
+        <c:majorTickMark val="none"/>
+        <c:minorTickMark val="none"/>
+        <c:tickLblPos val="nextTo"/>
+        <c:spPr>
+          <a:ln w="12700" cap="flat">
+            <a:noFill/>
+            <a:prstDash val="solid"/>
+            <a:round/>
+          </a:ln>
+        </c:spPr>
+        <c:txPr>
+          <a:bodyPr/>
+          <a:lstStyle/>
+          <a:p>
+            <a:pPr>
+              <a:defRPr sz="800" b="0" i="0" u="none" strike="noStrike">
+                <a:solidFill>
+                  <a:srgbClr val="33415A"/>
+                </a:solidFill>
+                <a:latin typeface="Calibri"/>
+              </a:defRPr>
+            </a:pPr>
+            <a:endParaRPr lang="en-US"/>
+          </a:p>
+        </c:txPr>
+        <c:crossAx val="2094734552"/>
+        <c:crosses val="autoZero"/>
+        <c:auto val="1"/>
+        <c:lblAlgn val="ctr"/>
+        <c:noMultiLvlLbl val="1"/>
+      </c:catAx>
+      <c:valAx>
+        <c:axId val="2094734552"/>
+        <c:scaling>
+          <c:orientation val="minMax"/>
+          <c:max val="100"/>
+          <c:min val="0"/>
+        </c:scaling>
+        <c:delete val="1"/>
+        <c:axPos val="b"/>
+        <c:numFmt formatCode="General" sourceLinked="0"/>
+        <c:majorTickMark val="out"/>
+        <c:minorTickMark val="none"/>
+        <c:tickLblPos val="low"/>
+        <c:spPr>
+          <a:ln w="12700" cap="flat">
+            <a:solidFill>
+              <a:srgbClr val="888888"/>
+            </a:solidFill>
+            <a:prstDash val="solid"/>
+            <a:round/>
+          </a:ln>
+        </c:spPr>
+        <c:txPr>
+          <a:bodyPr/>
+          <a:lstStyle/>
+          <a:p>
+            <a:pPr>
+              <a:defRPr sz="1200" b="0" i="0" u="none" strike="noStrike">
+                <a:solidFill>
+                  <a:srgbClr val="000000"/>
+                </a:solidFill>
+                <a:latin typeface="Arial"/>
+              </a:defRPr>
+            </a:pPr>
+            <a:endParaRPr lang="en-US"/>
+          </a:p>
+        </c:txPr>
+        <c:crossAx val="2094734554"/>
+        <c:crosses val="autoZero"/>
+        <c:crossBetween val="between"/>
+      </c:valAx>
+      <c:spPr>
+        <a:solidFill>
+          <a:srgbClr val="FFFFFF">
+            <a:alpha val="0"/>
+          </a:srgbClr>
+        </a:solidFill>
+        <a:ln>
+          <a:noFill/>
+        </a:ln>
+        <a:effectLst/>
+      </c:spPr>
+    </c:plotArea>
+    <c:plotVisOnly val="1"/>
+    <c:dispBlanksAs val="span"/>
+  </c:chart>
+  <c:spPr>
+    <a:solidFill>
+      <a:srgbClr val="FFFFFF">
+        <a:alpha val="0"/>
+      </a:srgbClr>
+    </a:solidFill>
+    <a:ln>
+      <a:noFill/>
+    </a:ln>
+    <a:effectLst/>
+  </c:spPr>
+  <c:externalData r:id="rId1">
+    <c:autoUpdate val="0"/>
+  </c:externalData>
+</c:chartSpace>
 </file>
 
 <file path=ppt/notesMasters/notesMaster1.xml><?xml version="1.0" encoding="utf-8"?>
@@ -5251,11 +6619,11 @@
         <p:spPr>
           <a:xfrm>
             <a:off x="384048" y="1133856"/>
-            <a:ext cx="2182307" cy="1207008"/>
+            <a:ext cx="2182307" cy="1600200"/>
           </a:xfrm>
           <a:prstGeom prst="roundRect">
             <a:avLst>
-              <a:gd name="adj" fmla="val 4545"/>
+              <a:gd name="adj" fmla="val 3429"/>
             </a:avLst>
           </a:prstGeom>
           <a:solidFill>
@@ -5344,7 +6712,7 @@
         <p:spPr>
           <a:xfrm>
             <a:off x="740664" y="1207008"/>
-            <a:ext cx="1715963" cy="457200"/>
+            <a:ext cx="1715963" cy="420624"/>
           </a:xfrm>
           <a:prstGeom prst="rect">
             <a:avLst/>
@@ -5358,12 +6726,12 @@
           <a:p>
             <a:pPr algn="l" indent="0" marL="0">
               <a:lnSpc>
-                <a:spcPct val="112000"/>
+                <a:spcPct val="110000"/>
               </a:lnSpc>
               <a:buNone/>
             </a:pPr>
             <a:r>
-              <a:rPr lang="en-US" sz="950" b="1" dirty="0">
+              <a:rPr lang="en-US" sz="900" b="1" dirty="0">
                 <a:solidFill>
                   <a:srgbClr val="17223A"/>
                 </a:solidFill>
@@ -5373,283 +6741,40 @@
               </a:rPr>
               <a:t>¿Con qué frecuencia se presentan fallas del sistema?</a:t>
             </a:r>
-            <a:endParaRPr lang="en-US" sz="950" dirty="0"/>
+            <a:endParaRPr lang="en-US" sz="900" dirty="0"/>
           </a:p>
         </p:txBody>
       </p:sp>
-      <p:sp>
-        <p:nvSpPr>
-          <p:cNvPr id="12" name="Shape 10"/>
+      <p:graphicFrame>
+        <p:nvGraphicFramePr>
+          <p:cNvPr id="12" name="Chart 0" descr=""/>
+          <p:cNvGraphicFramePr/>
+          <p:nvPr/>
+        </p:nvGraphicFramePr>
+        <p:xfrm>
+          <a:off x="402336" y="1645920"/>
+          <a:ext cx="2145731" cy="1033272"/>
+        </p:xfrm>
+        <a:graphic xmlns:a="http://schemas.openxmlformats.org/drawingml/2006/main">
+          <a:graphicData uri="http://schemas.openxmlformats.org/drawingml/2006/chart">
+            <c:chart xmlns:c="http://schemas.openxmlformats.org/drawingml/2006/chart" r:id="rId1"/>
+          </a:graphicData>
+        </a:graphic>
+      </p:graphicFrame>
+      <p:sp>
+        <p:nvSpPr>
+          <p:cNvPr id="13" name="Shape 10"/>
           <p:cNvSpPr/>
           <p:nvPr/>
         </p:nvSpPr>
         <p:spPr>
           <a:xfrm>
-            <a:off x="493776" y="1664208"/>
-            <a:ext cx="1962851" cy="118872"/>
+            <a:off x="2694371" y="1133856"/>
+            <a:ext cx="2182307" cy="1600200"/>
           </a:xfrm>
           <a:prstGeom prst="roundRect">
             <a:avLst>
-              <a:gd name="adj" fmla="val 15385"/>
-            </a:avLst>
-          </a:prstGeom>
-          <a:solidFill>
-            <a:srgbClr val="EEF1F5"/>
-          </a:solidFill>
-          <a:ln/>
-        </p:spPr>
-      </p:sp>
-      <p:sp>
-        <p:nvSpPr>
-          <p:cNvPr id="13" name="Shape 11"/>
-          <p:cNvSpPr/>
-          <p:nvPr/>
-        </p:nvSpPr>
-        <p:spPr>
-          <a:xfrm>
-            <a:off x="493776" y="1664208"/>
-            <a:ext cx="692886" cy="118872"/>
-          </a:xfrm>
-          <a:prstGeom prst="rect">
-            <a:avLst/>
-          </a:prstGeom>
-          <a:solidFill>
-            <a:srgbClr val="E0392B"/>
-          </a:solidFill>
-          <a:ln/>
-        </p:spPr>
-      </p:sp>
-      <p:sp>
-        <p:nvSpPr>
-          <p:cNvPr id="14" name="Shape 12"/>
-          <p:cNvSpPr/>
-          <p:nvPr/>
-        </p:nvSpPr>
-        <p:spPr>
-          <a:xfrm>
-            <a:off x="1186662" y="1664208"/>
-            <a:ext cx="1038348" cy="118872"/>
-          </a:xfrm>
-          <a:prstGeom prst="rect">
-            <a:avLst/>
-          </a:prstGeom>
-          <a:solidFill>
-            <a:srgbClr val="A6650F"/>
-          </a:solidFill>
-          <a:ln/>
-        </p:spPr>
-      </p:sp>
-      <p:sp>
-        <p:nvSpPr>
-          <p:cNvPr id="15" name="Shape 13"/>
-          <p:cNvSpPr/>
-          <p:nvPr/>
-        </p:nvSpPr>
-        <p:spPr>
-          <a:xfrm>
-            <a:off x="2225011" y="1664208"/>
-            <a:ext cx="231616" cy="118872"/>
-          </a:xfrm>
-          <a:prstGeom prst="rect">
-            <a:avLst/>
-          </a:prstGeom>
-          <a:solidFill>
-            <a:srgbClr val="1E8449"/>
-          </a:solidFill>
-          <a:ln/>
-        </p:spPr>
-      </p:sp>
-      <p:sp>
-        <p:nvSpPr>
-          <p:cNvPr id="16" name="Shape 14"/>
-          <p:cNvSpPr/>
-          <p:nvPr/>
-        </p:nvSpPr>
-        <p:spPr>
-          <a:xfrm>
-            <a:off x="493776" y="1856232"/>
-            <a:ext cx="54864" cy="54864"/>
-          </a:xfrm>
-          <a:prstGeom prst="ellipse">
-            <a:avLst/>
-          </a:prstGeom>
-          <a:solidFill>
-            <a:srgbClr val="E0392B"/>
-          </a:solidFill>
-          <a:ln/>
-        </p:spPr>
-      </p:sp>
-      <p:sp>
-        <p:nvSpPr>
-          <p:cNvPr id="17" name="Text 15"/>
-          <p:cNvSpPr txBox="1"/>
-          <p:nvPr/>
-        </p:nvSpPr>
-        <p:spPr>
-          <a:xfrm>
-            <a:off x="594360" y="1819656"/>
-            <a:ext cx="1862267" cy="128016"/>
-          </a:xfrm>
-          <a:prstGeom prst="rect">
-            <a:avLst/>
-          </a:prstGeom>
-          <a:noFill/>
-          <a:ln/>
-        </p:spPr>
-        <p:txBody>
-          <a:bodyPr wrap="square" lIns="0" tIns="0" rIns="0" bIns="0" rtlCol="0" anchor="ctr"/>
-          <a:lstStyle/>
-          <a:p>
-            <a:pPr algn="l" indent="0" marL="0">
-              <a:buNone/>
-            </a:pPr>
-            <a:r>
-              <a:rPr lang="en-US" sz="760" b="1" dirty="0">
-                <a:solidFill>
-                  <a:srgbClr val="E0392B"/>
-                </a:solidFill>
-                <a:latin typeface="Calibri" pitchFamily="34" charset="0"/>
-                <a:ea typeface="Calibri" pitchFamily="34" charset="-122"/>
-                <a:cs typeface="Calibri" pitchFamily="34" charset="-120"/>
-              </a:rPr>
-              <a:t>35.3% Frecuente</a:t>
-            </a:r>
-            <a:endParaRPr lang="en-US" sz="760" dirty="0"/>
-          </a:p>
-        </p:txBody>
-      </p:sp>
-      <p:sp>
-        <p:nvSpPr>
-          <p:cNvPr id="18" name="Shape 16"/>
-          <p:cNvSpPr/>
-          <p:nvPr/>
-        </p:nvSpPr>
-        <p:spPr>
-          <a:xfrm>
-            <a:off x="493776" y="1997964"/>
-            <a:ext cx="54864" cy="54864"/>
-          </a:xfrm>
-          <a:prstGeom prst="ellipse">
-            <a:avLst/>
-          </a:prstGeom>
-          <a:solidFill>
-            <a:srgbClr val="A6650F"/>
-          </a:solidFill>
-          <a:ln/>
-        </p:spPr>
-      </p:sp>
-      <p:sp>
-        <p:nvSpPr>
-          <p:cNvPr id="19" name="Text 17"/>
-          <p:cNvSpPr txBox="1"/>
-          <p:nvPr/>
-        </p:nvSpPr>
-        <p:spPr>
-          <a:xfrm>
-            <a:off x="594360" y="1961388"/>
-            <a:ext cx="1862267" cy="128016"/>
-          </a:xfrm>
-          <a:prstGeom prst="rect">
-            <a:avLst/>
-          </a:prstGeom>
-          <a:noFill/>
-          <a:ln/>
-        </p:spPr>
-        <p:txBody>
-          <a:bodyPr wrap="square" lIns="0" tIns="0" rIns="0" bIns="0" rtlCol="0" anchor="ctr"/>
-          <a:lstStyle/>
-          <a:p>
-            <a:pPr algn="l" indent="0" marL="0">
-              <a:buNone/>
-            </a:pPr>
-            <a:r>
-              <a:rPr lang="en-US" sz="760" b="1" dirty="0">
-                <a:solidFill>
-                  <a:srgbClr val="A6650F"/>
-                </a:solidFill>
-                <a:latin typeface="Calibri" pitchFamily="34" charset="0"/>
-                <a:ea typeface="Calibri" pitchFamily="34" charset="-122"/>
-                <a:cs typeface="Calibri" pitchFamily="34" charset="-120"/>
-              </a:rPr>
-              <a:t>52.9% Algunas veces</a:t>
-            </a:r>
-            <a:endParaRPr lang="en-US" sz="760" dirty="0"/>
-          </a:p>
-        </p:txBody>
-      </p:sp>
-      <p:sp>
-        <p:nvSpPr>
-          <p:cNvPr id="20" name="Shape 18"/>
-          <p:cNvSpPr/>
-          <p:nvPr/>
-        </p:nvSpPr>
-        <p:spPr>
-          <a:xfrm>
-            <a:off x="493776" y="2139696"/>
-            <a:ext cx="54864" cy="54864"/>
-          </a:xfrm>
-          <a:prstGeom prst="ellipse">
-            <a:avLst/>
-          </a:prstGeom>
-          <a:solidFill>
-            <a:srgbClr val="1E8449"/>
-          </a:solidFill>
-          <a:ln/>
-        </p:spPr>
-      </p:sp>
-      <p:sp>
-        <p:nvSpPr>
-          <p:cNvPr id="21" name="Text 19"/>
-          <p:cNvSpPr txBox="1"/>
-          <p:nvPr/>
-        </p:nvSpPr>
-        <p:spPr>
-          <a:xfrm>
-            <a:off x="594360" y="2103120"/>
-            <a:ext cx="1862267" cy="128016"/>
-          </a:xfrm>
-          <a:prstGeom prst="rect">
-            <a:avLst/>
-          </a:prstGeom>
-          <a:noFill/>
-          <a:ln/>
-        </p:spPr>
-        <p:txBody>
-          <a:bodyPr wrap="square" lIns="0" tIns="0" rIns="0" bIns="0" rtlCol="0" anchor="ctr"/>
-          <a:lstStyle/>
-          <a:p>
-            <a:pPr algn="l" indent="0" marL="0">
-              <a:buNone/>
-            </a:pPr>
-            <a:r>
-              <a:rPr lang="en-US" sz="760" b="1" dirty="0">
-                <a:solidFill>
-                  <a:srgbClr val="1E8449"/>
-                </a:solidFill>
-                <a:latin typeface="Calibri" pitchFamily="34" charset="0"/>
-                <a:ea typeface="Calibri" pitchFamily="34" charset="-122"/>
-                <a:cs typeface="Calibri" pitchFamily="34" charset="-120"/>
-              </a:rPr>
-              <a:t>11.8% Rara vez</a:t>
-            </a:r>
-            <a:endParaRPr lang="en-US" sz="760" dirty="0"/>
-          </a:p>
-        </p:txBody>
-      </p:sp>
-      <p:sp>
-        <p:nvSpPr>
-          <p:cNvPr id="22" name="Shape 20"/>
-          <p:cNvSpPr/>
-          <p:nvPr/>
-        </p:nvSpPr>
-        <p:spPr>
-          <a:xfrm>
-            <a:off x="2694371" y="1133856"/>
-            <a:ext cx="2182307" cy="1207008"/>
-          </a:xfrm>
-          <a:prstGeom prst="roundRect">
-            <a:avLst>
-              <a:gd name="adj" fmla="val 4545"/>
+              <a:gd name="adj" fmla="val 3429"/>
             </a:avLst>
           </a:prstGeom>
           <a:solidFill>
@@ -5672,7 +6797,7 @@
       </p:sp>
       <p:sp>
         <p:nvSpPr>
-          <p:cNvPr id="23" name="Shape 21"/>
+          <p:cNvPr id="14" name="Shape 11"/>
           <p:cNvSpPr/>
           <p:nvPr/>
         </p:nvSpPr>
@@ -5692,7 +6817,7 @@
       </p:sp>
       <p:sp>
         <p:nvSpPr>
-          <p:cNvPr id="24" name="Text 22"/>
+          <p:cNvPr id="15" name="Text 12"/>
           <p:cNvSpPr txBox="1"/>
           <p:nvPr/>
         </p:nvSpPr>
@@ -5731,14 +6856,14 @@
       </p:sp>
       <p:sp>
         <p:nvSpPr>
-          <p:cNvPr id="25" name="Text 23"/>
+          <p:cNvPr id="16" name="Text 13"/>
           <p:cNvSpPr txBox="1"/>
           <p:nvPr/>
         </p:nvSpPr>
         <p:spPr>
           <a:xfrm>
             <a:off x="3050987" y="1207008"/>
-            <a:ext cx="1715963" cy="457200"/>
+            <a:ext cx="1715963" cy="420624"/>
           </a:xfrm>
           <a:prstGeom prst="rect">
             <a:avLst/>
@@ -5752,12 +6877,12 @@
           <a:p>
             <a:pPr algn="l" indent="0" marL="0">
               <a:lnSpc>
-                <a:spcPct val="112000"/>
+                <a:spcPct val="110000"/>
               </a:lnSpc>
               <a:buNone/>
             </a:pPr>
             <a:r>
-              <a:rPr lang="en-US" sz="950" b="1" dirty="0">
+              <a:rPr lang="en-US" sz="900" b="1" dirty="0">
                 <a:solidFill>
                   <a:srgbClr val="17223A"/>
                 </a:solidFill>
@@ -5767,283 +6892,40 @@
               </a:rPr>
               <a:t>¿El soporte de EVERTEC atiende oportunamente?</a:t>
             </a:r>
-            <a:endParaRPr lang="en-US" sz="950" dirty="0"/>
+            <a:endParaRPr lang="en-US" sz="900" dirty="0"/>
           </a:p>
         </p:txBody>
       </p:sp>
-      <p:sp>
-        <p:nvSpPr>
-          <p:cNvPr id="26" name="Shape 24"/>
+      <p:graphicFrame>
+        <p:nvGraphicFramePr>
+          <p:cNvPr id="17" name="Chart 1" descr=""/>
+          <p:cNvGraphicFramePr/>
+          <p:nvPr/>
+        </p:nvGraphicFramePr>
+        <p:xfrm>
+          <a:off x="2712659" y="1645920"/>
+          <a:ext cx="2145731" cy="1033272"/>
+        </p:xfrm>
+        <a:graphic xmlns:a="http://schemas.openxmlformats.org/drawingml/2006/main">
+          <a:graphicData uri="http://schemas.openxmlformats.org/drawingml/2006/chart">
+            <c:chart xmlns:c="http://schemas.openxmlformats.org/drawingml/2006/chart" r:id="rId2"/>
+          </a:graphicData>
+        </a:graphic>
+      </p:graphicFrame>
+      <p:sp>
+        <p:nvSpPr>
+          <p:cNvPr id="18" name="Shape 14"/>
           <p:cNvSpPr/>
           <p:nvPr/>
         </p:nvSpPr>
         <p:spPr>
           <a:xfrm>
-            <a:off x="2804099" y="1664208"/>
-            <a:ext cx="1962851" cy="118872"/>
+            <a:off x="5004694" y="1133856"/>
+            <a:ext cx="2182307" cy="1600200"/>
           </a:xfrm>
           <a:prstGeom prst="roundRect">
             <a:avLst>
-              <a:gd name="adj" fmla="val 15385"/>
-            </a:avLst>
-          </a:prstGeom>
-          <a:solidFill>
-            <a:srgbClr val="EEF1F5"/>
-          </a:solidFill>
-          <a:ln/>
-        </p:spPr>
-      </p:sp>
-      <p:sp>
-        <p:nvSpPr>
-          <p:cNvPr id="27" name="Shape 25"/>
-          <p:cNvSpPr/>
-          <p:nvPr/>
-        </p:nvSpPr>
-        <p:spPr>
-          <a:xfrm>
-            <a:off x="2804099" y="1664208"/>
-            <a:ext cx="1385773" cy="118872"/>
-          </a:xfrm>
-          <a:prstGeom prst="rect">
-            <a:avLst/>
-          </a:prstGeom>
-          <a:solidFill>
-            <a:srgbClr val="1E8449"/>
-          </a:solidFill>
-          <a:ln/>
-        </p:spPr>
-      </p:sp>
-      <p:sp>
-        <p:nvSpPr>
-          <p:cNvPr id="28" name="Shape 26"/>
-          <p:cNvSpPr/>
-          <p:nvPr/>
-        </p:nvSpPr>
-        <p:spPr>
-          <a:xfrm>
-            <a:off x="4189872" y="1664208"/>
-            <a:ext cx="345462" cy="118872"/>
-          </a:xfrm>
-          <a:prstGeom prst="rect">
-            <a:avLst/>
-          </a:prstGeom>
-          <a:solidFill>
-            <a:srgbClr val="A6650F"/>
-          </a:solidFill>
-          <a:ln/>
-        </p:spPr>
-      </p:sp>
-      <p:sp>
-        <p:nvSpPr>
-          <p:cNvPr id="29" name="Shape 27"/>
-          <p:cNvSpPr/>
-          <p:nvPr/>
-        </p:nvSpPr>
-        <p:spPr>
-          <a:xfrm>
-            <a:off x="4535334" y="1664208"/>
-            <a:ext cx="231616" cy="118872"/>
-          </a:xfrm>
-          <a:prstGeom prst="rect">
-            <a:avLst/>
-          </a:prstGeom>
-          <a:solidFill>
-            <a:srgbClr val="1D63A1"/>
-          </a:solidFill>
-          <a:ln/>
-        </p:spPr>
-      </p:sp>
-      <p:sp>
-        <p:nvSpPr>
-          <p:cNvPr id="30" name="Shape 28"/>
-          <p:cNvSpPr/>
-          <p:nvPr/>
-        </p:nvSpPr>
-        <p:spPr>
-          <a:xfrm>
-            <a:off x="2804099" y="1856232"/>
-            <a:ext cx="54864" cy="54864"/>
-          </a:xfrm>
-          <a:prstGeom prst="ellipse">
-            <a:avLst/>
-          </a:prstGeom>
-          <a:solidFill>
-            <a:srgbClr val="1E8449"/>
-          </a:solidFill>
-          <a:ln/>
-        </p:spPr>
-      </p:sp>
-      <p:sp>
-        <p:nvSpPr>
-          <p:cNvPr id="31" name="Text 29"/>
-          <p:cNvSpPr txBox="1"/>
-          <p:nvPr/>
-        </p:nvSpPr>
-        <p:spPr>
-          <a:xfrm>
-            <a:off x="2904683" y="1819656"/>
-            <a:ext cx="1862267" cy="128016"/>
-          </a:xfrm>
-          <a:prstGeom prst="rect">
-            <a:avLst/>
-          </a:prstGeom>
-          <a:noFill/>
-          <a:ln/>
-        </p:spPr>
-        <p:txBody>
-          <a:bodyPr wrap="square" lIns="0" tIns="0" rIns="0" bIns="0" rtlCol="0" anchor="ctr"/>
-          <a:lstStyle/>
-          <a:p>
-            <a:pPr algn="l" indent="0" marL="0">
-              <a:buNone/>
-            </a:pPr>
-            <a:r>
-              <a:rPr lang="en-US" sz="760" b="1" dirty="0">
-                <a:solidFill>
-                  <a:srgbClr val="1E8449"/>
-                </a:solidFill>
-                <a:latin typeface="Calibri" pitchFamily="34" charset="0"/>
-                <a:ea typeface="Calibri" pitchFamily="34" charset="-122"/>
-                <a:cs typeface="Calibri" pitchFamily="34" charset="-120"/>
-              </a:rPr>
-              <a:t>70.6% Oportuno</a:t>
-            </a:r>
-            <a:endParaRPr lang="en-US" sz="760" dirty="0"/>
-          </a:p>
-        </p:txBody>
-      </p:sp>
-      <p:sp>
-        <p:nvSpPr>
-          <p:cNvPr id="32" name="Shape 30"/>
-          <p:cNvSpPr/>
-          <p:nvPr/>
-        </p:nvSpPr>
-        <p:spPr>
-          <a:xfrm>
-            <a:off x="2804099" y="1997964"/>
-            <a:ext cx="54864" cy="54864"/>
-          </a:xfrm>
-          <a:prstGeom prst="ellipse">
-            <a:avLst/>
-          </a:prstGeom>
-          <a:solidFill>
-            <a:srgbClr val="A6650F"/>
-          </a:solidFill>
-          <a:ln/>
-        </p:spPr>
-      </p:sp>
-      <p:sp>
-        <p:nvSpPr>
-          <p:cNvPr id="33" name="Text 31"/>
-          <p:cNvSpPr txBox="1"/>
-          <p:nvPr/>
-        </p:nvSpPr>
-        <p:spPr>
-          <a:xfrm>
-            <a:off x="2904683" y="1961388"/>
-            <a:ext cx="1862267" cy="128016"/>
-          </a:xfrm>
-          <a:prstGeom prst="rect">
-            <a:avLst/>
-          </a:prstGeom>
-          <a:noFill/>
-          <a:ln/>
-        </p:spPr>
-        <p:txBody>
-          <a:bodyPr wrap="square" lIns="0" tIns="0" rIns="0" bIns="0" rtlCol="0" anchor="ctr"/>
-          <a:lstStyle/>
-          <a:p>
-            <a:pPr algn="l" indent="0" marL="0">
-              <a:buNone/>
-            </a:pPr>
-            <a:r>
-              <a:rPr lang="en-US" sz="760" b="1" dirty="0">
-                <a:solidFill>
-                  <a:srgbClr val="A6650F"/>
-                </a:solidFill>
-                <a:latin typeface="Calibri" pitchFamily="34" charset="0"/>
-                <a:ea typeface="Calibri" pitchFamily="34" charset="-122"/>
-                <a:cs typeface="Calibri" pitchFamily="34" charset="-120"/>
-              </a:rPr>
-              <a:t>17.6% Regular</a:t>
-            </a:r>
-            <a:endParaRPr lang="en-US" sz="760" dirty="0"/>
-          </a:p>
-        </p:txBody>
-      </p:sp>
-      <p:sp>
-        <p:nvSpPr>
-          <p:cNvPr id="34" name="Shape 32"/>
-          <p:cNvSpPr/>
-          <p:nvPr/>
-        </p:nvSpPr>
-        <p:spPr>
-          <a:xfrm>
-            <a:off x="2804099" y="2139696"/>
-            <a:ext cx="54864" cy="54864"/>
-          </a:xfrm>
-          <a:prstGeom prst="ellipse">
-            <a:avLst/>
-          </a:prstGeom>
-          <a:solidFill>
-            <a:srgbClr val="1D63A1"/>
-          </a:solidFill>
-          <a:ln/>
-        </p:spPr>
-      </p:sp>
-      <p:sp>
-        <p:nvSpPr>
-          <p:cNvPr id="35" name="Text 33"/>
-          <p:cNvSpPr txBox="1"/>
-          <p:nvPr/>
-        </p:nvSpPr>
-        <p:spPr>
-          <a:xfrm>
-            <a:off x="2904683" y="2103120"/>
-            <a:ext cx="1862267" cy="128016"/>
-          </a:xfrm>
-          <a:prstGeom prst="rect">
-            <a:avLst/>
-          </a:prstGeom>
-          <a:noFill/>
-          <a:ln/>
-        </p:spPr>
-        <p:txBody>
-          <a:bodyPr wrap="square" lIns="0" tIns="0" rIns="0" bIns="0" rtlCol="0" anchor="ctr"/>
-          <a:lstStyle/>
-          <a:p>
-            <a:pPr algn="l" indent="0" marL="0">
-              <a:buNone/>
-            </a:pPr>
-            <a:r>
-              <a:rPr lang="en-US" sz="760" b="1" dirty="0">
-                <a:solidFill>
-                  <a:srgbClr val="1D63A1"/>
-                </a:solidFill>
-                <a:latin typeface="Calibri" pitchFamily="34" charset="0"/>
-                <a:ea typeface="Calibri" pitchFamily="34" charset="-122"/>
-                <a:cs typeface="Calibri" pitchFamily="34" charset="-120"/>
-              </a:rPr>
-              <a:t>11.8% Muy oportuno</a:t>
-            </a:r>
-            <a:endParaRPr lang="en-US" sz="760" dirty="0"/>
-          </a:p>
-        </p:txBody>
-      </p:sp>
-      <p:sp>
-        <p:nvSpPr>
-          <p:cNvPr id="36" name="Shape 34"/>
-          <p:cNvSpPr/>
-          <p:nvPr/>
-        </p:nvSpPr>
-        <p:spPr>
-          <a:xfrm>
-            <a:off x="5004694" y="1133856"/>
-            <a:ext cx="2182307" cy="1207008"/>
-          </a:xfrm>
-          <a:prstGeom prst="roundRect">
-            <a:avLst>
-              <a:gd name="adj" fmla="val 4545"/>
+              <a:gd name="adj" fmla="val 3429"/>
             </a:avLst>
           </a:prstGeom>
           <a:solidFill>
@@ -6066,7 +6948,7 @@
       </p:sp>
       <p:sp>
         <p:nvSpPr>
-          <p:cNvPr id="37" name="Shape 35"/>
+          <p:cNvPr id="19" name="Shape 15"/>
           <p:cNvSpPr/>
           <p:nvPr/>
         </p:nvSpPr>
@@ -6086,7 +6968,7 @@
       </p:sp>
       <p:sp>
         <p:nvSpPr>
-          <p:cNvPr id="38" name="Text 36"/>
+          <p:cNvPr id="20" name="Text 16"/>
           <p:cNvSpPr txBox="1"/>
           <p:nvPr/>
         </p:nvSpPr>
@@ -6125,14 +7007,14 @@
       </p:sp>
       <p:sp>
         <p:nvSpPr>
-          <p:cNvPr id="39" name="Text 37"/>
+          <p:cNvPr id="21" name="Text 17"/>
           <p:cNvSpPr txBox="1"/>
           <p:nvPr/>
         </p:nvSpPr>
         <p:spPr>
           <a:xfrm>
             <a:off x="5361310" y="1207008"/>
-            <a:ext cx="1715963" cy="457200"/>
+            <a:ext cx="1715963" cy="420624"/>
           </a:xfrm>
           <a:prstGeom prst="rect">
             <a:avLst/>
@@ -6146,12 +7028,12 @@
           <a:p>
             <a:pPr algn="l" indent="0" marL="0">
               <a:lnSpc>
-                <a:spcPct val="112000"/>
+                <a:spcPct val="110000"/>
               </a:lnSpc>
               <a:buNone/>
             </a:pPr>
             <a:r>
-              <a:rPr lang="en-US" sz="950" b="1" dirty="0">
+              <a:rPr lang="en-US" sz="900" b="1" dirty="0">
                 <a:solidFill>
                   <a:srgbClr val="17223A"/>
                 </a:solidFill>
@@ -6161,283 +7043,40 @@
               </a:rPr>
               <a:t>¿Con qué frecuencia hay reclamos de asociados?</a:t>
             </a:r>
-            <a:endParaRPr lang="en-US" sz="950" dirty="0"/>
+            <a:endParaRPr lang="en-US" sz="900" dirty="0"/>
           </a:p>
         </p:txBody>
       </p:sp>
-      <p:sp>
-        <p:nvSpPr>
-          <p:cNvPr id="40" name="Shape 38"/>
+      <p:graphicFrame>
+        <p:nvGraphicFramePr>
+          <p:cNvPr id="22" name="Chart 2" descr=""/>
+          <p:cNvGraphicFramePr/>
+          <p:nvPr/>
+        </p:nvGraphicFramePr>
+        <p:xfrm>
+          <a:off x="5022982" y="1645920"/>
+          <a:ext cx="2145731" cy="1033272"/>
+        </p:xfrm>
+        <a:graphic xmlns:a="http://schemas.openxmlformats.org/drawingml/2006/main">
+          <a:graphicData uri="http://schemas.openxmlformats.org/drawingml/2006/chart">
+            <c:chart xmlns:c="http://schemas.openxmlformats.org/drawingml/2006/chart" r:id="rId3"/>
+          </a:graphicData>
+        </a:graphic>
+      </p:graphicFrame>
+      <p:sp>
+        <p:nvSpPr>
+          <p:cNvPr id="23" name="Shape 18"/>
           <p:cNvSpPr/>
           <p:nvPr/>
         </p:nvSpPr>
         <p:spPr>
           <a:xfrm>
-            <a:off x="5114422" y="1664208"/>
-            <a:ext cx="1962851" cy="118872"/>
+            <a:off x="7315017" y="1133856"/>
+            <a:ext cx="2182307" cy="1600200"/>
           </a:xfrm>
           <a:prstGeom prst="roundRect">
             <a:avLst>
-              <a:gd name="adj" fmla="val 15385"/>
-            </a:avLst>
-          </a:prstGeom>
-          <a:solidFill>
-            <a:srgbClr val="EEF1F5"/>
-          </a:solidFill>
-          <a:ln/>
-        </p:spPr>
-      </p:sp>
-      <p:sp>
-        <p:nvSpPr>
-          <p:cNvPr id="41" name="Shape 39"/>
-          <p:cNvSpPr/>
-          <p:nvPr/>
-        </p:nvSpPr>
-        <p:spPr>
-          <a:xfrm>
-            <a:off x="5114422" y="1664208"/>
-            <a:ext cx="808695" cy="118872"/>
-          </a:xfrm>
-          <a:prstGeom prst="rect">
-            <a:avLst/>
-          </a:prstGeom>
-          <a:solidFill>
-            <a:srgbClr val="E0392B"/>
-          </a:solidFill>
-          <a:ln/>
-        </p:spPr>
-      </p:sp>
-      <p:sp>
-        <p:nvSpPr>
-          <p:cNvPr id="42" name="Shape 40"/>
-          <p:cNvSpPr/>
-          <p:nvPr/>
-        </p:nvSpPr>
-        <p:spPr>
-          <a:xfrm>
-            <a:off x="5923117" y="1664208"/>
-            <a:ext cx="692886" cy="118872"/>
-          </a:xfrm>
-          <a:prstGeom prst="rect">
-            <a:avLst/>
-          </a:prstGeom>
-          <a:solidFill>
-            <a:srgbClr val="A6650F"/>
-          </a:solidFill>
-          <a:ln/>
-        </p:spPr>
-      </p:sp>
-      <p:sp>
-        <p:nvSpPr>
-          <p:cNvPr id="43" name="Shape 41"/>
-          <p:cNvSpPr/>
-          <p:nvPr/>
-        </p:nvSpPr>
-        <p:spPr>
-          <a:xfrm>
-            <a:off x="6616003" y="1664208"/>
-            <a:ext cx="461270" cy="118872"/>
-          </a:xfrm>
-          <a:prstGeom prst="rect">
-            <a:avLst/>
-          </a:prstGeom>
-          <a:solidFill>
-            <a:srgbClr val="1E8449"/>
-          </a:solidFill>
-          <a:ln/>
-        </p:spPr>
-      </p:sp>
-      <p:sp>
-        <p:nvSpPr>
-          <p:cNvPr id="44" name="Shape 42"/>
-          <p:cNvSpPr/>
-          <p:nvPr/>
-        </p:nvSpPr>
-        <p:spPr>
-          <a:xfrm>
-            <a:off x="5114422" y="1856232"/>
-            <a:ext cx="54864" cy="54864"/>
-          </a:xfrm>
-          <a:prstGeom prst="ellipse">
-            <a:avLst/>
-          </a:prstGeom>
-          <a:solidFill>
-            <a:srgbClr val="E0392B"/>
-          </a:solidFill>
-          <a:ln/>
-        </p:spPr>
-      </p:sp>
-      <p:sp>
-        <p:nvSpPr>
-          <p:cNvPr id="45" name="Text 43"/>
-          <p:cNvSpPr txBox="1"/>
-          <p:nvPr/>
-        </p:nvSpPr>
-        <p:spPr>
-          <a:xfrm>
-            <a:off x="5215006" y="1819656"/>
-            <a:ext cx="1862267" cy="128016"/>
-          </a:xfrm>
-          <a:prstGeom prst="rect">
-            <a:avLst/>
-          </a:prstGeom>
-          <a:noFill/>
-          <a:ln/>
-        </p:spPr>
-        <p:txBody>
-          <a:bodyPr wrap="square" lIns="0" tIns="0" rIns="0" bIns="0" rtlCol="0" anchor="ctr"/>
-          <a:lstStyle/>
-          <a:p>
-            <a:pPr algn="l" indent="0" marL="0">
-              <a:buNone/>
-            </a:pPr>
-            <a:r>
-              <a:rPr lang="en-US" sz="760" b="1" dirty="0">
-                <a:solidFill>
-                  <a:srgbClr val="E0392B"/>
-                </a:solidFill>
-                <a:latin typeface="Calibri" pitchFamily="34" charset="0"/>
-                <a:ea typeface="Calibri" pitchFamily="34" charset="-122"/>
-                <a:cs typeface="Calibri" pitchFamily="34" charset="-120"/>
-              </a:rPr>
-              <a:t>41.2% Frecuente</a:t>
-            </a:r>
-            <a:endParaRPr lang="en-US" sz="760" dirty="0"/>
-          </a:p>
-        </p:txBody>
-      </p:sp>
-      <p:sp>
-        <p:nvSpPr>
-          <p:cNvPr id="46" name="Shape 44"/>
-          <p:cNvSpPr/>
-          <p:nvPr/>
-        </p:nvSpPr>
-        <p:spPr>
-          <a:xfrm>
-            <a:off x="5114422" y="1997964"/>
-            <a:ext cx="54864" cy="54864"/>
-          </a:xfrm>
-          <a:prstGeom prst="ellipse">
-            <a:avLst/>
-          </a:prstGeom>
-          <a:solidFill>
-            <a:srgbClr val="A6650F"/>
-          </a:solidFill>
-          <a:ln/>
-        </p:spPr>
-      </p:sp>
-      <p:sp>
-        <p:nvSpPr>
-          <p:cNvPr id="47" name="Text 45"/>
-          <p:cNvSpPr txBox="1"/>
-          <p:nvPr/>
-        </p:nvSpPr>
-        <p:spPr>
-          <a:xfrm>
-            <a:off x="5215006" y="1961388"/>
-            <a:ext cx="1862267" cy="128016"/>
-          </a:xfrm>
-          <a:prstGeom prst="rect">
-            <a:avLst/>
-          </a:prstGeom>
-          <a:noFill/>
-          <a:ln/>
-        </p:spPr>
-        <p:txBody>
-          <a:bodyPr wrap="square" lIns="0" tIns="0" rIns="0" bIns="0" rtlCol="0" anchor="ctr"/>
-          <a:lstStyle/>
-          <a:p>
-            <a:pPr algn="l" indent="0" marL="0">
-              <a:buNone/>
-            </a:pPr>
-            <a:r>
-              <a:rPr lang="en-US" sz="760" b="1" dirty="0">
-                <a:solidFill>
-                  <a:srgbClr val="A6650F"/>
-                </a:solidFill>
-                <a:latin typeface="Calibri" pitchFamily="34" charset="0"/>
-                <a:ea typeface="Calibri" pitchFamily="34" charset="-122"/>
-                <a:cs typeface="Calibri" pitchFamily="34" charset="-120"/>
-              </a:rPr>
-              <a:t>35.3% Algunas veces</a:t>
-            </a:r>
-            <a:endParaRPr lang="en-US" sz="760" dirty="0"/>
-          </a:p>
-        </p:txBody>
-      </p:sp>
-      <p:sp>
-        <p:nvSpPr>
-          <p:cNvPr id="48" name="Shape 46"/>
-          <p:cNvSpPr/>
-          <p:nvPr/>
-        </p:nvSpPr>
-        <p:spPr>
-          <a:xfrm>
-            <a:off x="5114422" y="2139696"/>
-            <a:ext cx="54864" cy="54864"/>
-          </a:xfrm>
-          <a:prstGeom prst="ellipse">
-            <a:avLst/>
-          </a:prstGeom>
-          <a:solidFill>
-            <a:srgbClr val="1E8449"/>
-          </a:solidFill>
-          <a:ln/>
-        </p:spPr>
-      </p:sp>
-      <p:sp>
-        <p:nvSpPr>
-          <p:cNvPr id="49" name="Text 47"/>
-          <p:cNvSpPr txBox="1"/>
-          <p:nvPr/>
-        </p:nvSpPr>
-        <p:spPr>
-          <a:xfrm>
-            <a:off x="5215006" y="2103120"/>
-            <a:ext cx="1862267" cy="128016"/>
-          </a:xfrm>
-          <a:prstGeom prst="rect">
-            <a:avLst/>
-          </a:prstGeom>
-          <a:noFill/>
-          <a:ln/>
-        </p:spPr>
-        <p:txBody>
-          <a:bodyPr wrap="square" lIns="0" tIns="0" rIns="0" bIns="0" rtlCol="0" anchor="ctr"/>
-          <a:lstStyle/>
-          <a:p>
-            <a:pPr algn="l" indent="0" marL="0">
-              <a:buNone/>
-            </a:pPr>
-            <a:r>
-              <a:rPr lang="en-US" sz="760" b="1" dirty="0">
-                <a:solidFill>
-                  <a:srgbClr val="1E8449"/>
-                </a:solidFill>
-                <a:latin typeface="Calibri" pitchFamily="34" charset="0"/>
-                <a:ea typeface="Calibri" pitchFamily="34" charset="-122"/>
-                <a:cs typeface="Calibri" pitchFamily="34" charset="-120"/>
-              </a:rPr>
-              <a:t>23.5% Rara vez</a:t>
-            </a:r>
-            <a:endParaRPr lang="en-US" sz="760" dirty="0"/>
-          </a:p>
-        </p:txBody>
-      </p:sp>
-      <p:sp>
-        <p:nvSpPr>
-          <p:cNvPr id="50" name="Shape 48"/>
-          <p:cNvSpPr/>
-          <p:nvPr/>
-        </p:nvSpPr>
-        <p:spPr>
-          <a:xfrm>
-            <a:off x="7315017" y="1133856"/>
-            <a:ext cx="2182307" cy="1207008"/>
-          </a:xfrm>
-          <a:prstGeom prst="roundRect">
-            <a:avLst>
-              <a:gd name="adj" fmla="val 4545"/>
+              <a:gd name="adj" fmla="val 3429"/>
             </a:avLst>
           </a:prstGeom>
           <a:solidFill>
@@ -6460,7 +7099,7 @@
       </p:sp>
       <p:sp>
         <p:nvSpPr>
-          <p:cNvPr id="51" name="Shape 49"/>
+          <p:cNvPr id="24" name="Shape 19"/>
           <p:cNvSpPr/>
           <p:nvPr/>
         </p:nvSpPr>
@@ -6480,7 +7119,7 @@
       </p:sp>
       <p:sp>
         <p:nvSpPr>
-          <p:cNvPr id="52" name="Text 50"/>
+          <p:cNvPr id="25" name="Text 20"/>
           <p:cNvSpPr txBox="1"/>
           <p:nvPr/>
         </p:nvSpPr>
@@ -6519,14 +7158,14 @@
       </p:sp>
       <p:sp>
         <p:nvSpPr>
-          <p:cNvPr id="53" name="Text 51"/>
+          <p:cNvPr id="26" name="Text 21"/>
           <p:cNvSpPr txBox="1"/>
           <p:nvPr/>
         </p:nvSpPr>
         <p:spPr>
           <a:xfrm>
             <a:off x="7671633" y="1207008"/>
-            <a:ext cx="1715963" cy="457200"/>
+            <a:ext cx="1715963" cy="420624"/>
           </a:xfrm>
           <a:prstGeom prst="rect">
             <a:avLst/>
@@ -6540,12 +7179,12 @@
           <a:p>
             <a:pPr algn="l" indent="0" marL="0">
               <a:lnSpc>
-                <a:spcPct val="112000"/>
+                <a:spcPct val="110000"/>
               </a:lnSpc>
               <a:buNone/>
             </a:pPr>
             <a:r>
-              <a:rPr lang="en-US" sz="950" b="1" dirty="0">
+              <a:rPr lang="en-US" sz="900" b="1" dirty="0">
                 <a:solidFill>
                   <a:srgbClr val="17223A"/>
                 </a:solidFill>
@@ -6555,283 +7194,40 @@
               </a:rPr>
               <a:t>¿Qué tan fácil es gestionar incidencias/reversas?</a:t>
             </a:r>
-            <a:endParaRPr lang="en-US" sz="950" dirty="0"/>
+            <a:endParaRPr lang="en-US" sz="900" dirty="0"/>
           </a:p>
         </p:txBody>
       </p:sp>
-      <p:sp>
-        <p:nvSpPr>
-          <p:cNvPr id="54" name="Shape 52"/>
+      <p:graphicFrame>
+        <p:nvGraphicFramePr>
+          <p:cNvPr id="27" name="Chart 3" descr=""/>
+          <p:cNvGraphicFramePr/>
+          <p:nvPr/>
+        </p:nvGraphicFramePr>
+        <p:xfrm>
+          <a:off x="7333305" y="1645920"/>
+          <a:ext cx="2145731" cy="1033272"/>
+        </p:xfrm>
+        <a:graphic xmlns:a="http://schemas.openxmlformats.org/drawingml/2006/main">
+          <a:graphicData uri="http://schemas.openxmlformats.org/drawingml/2006/chart">
+            <c:chart xmlns:c="http://schemas.openxmlformats.org/drawingml/2006/chart" r:id="rId4"/>
+          </a:graphicData>
+        </a:graphic>
+      </p:graphicFrame>
+      <p:sp>
+        <p:nvSpPr>
+          <p:cNvPr id="28" name="Shape 22"/>
           <p:cNvSpPr/>
           <p:nvPr/>
         </p:nvSpPr>
         <p:spPr>
           <a:xfrm>
-            <a:off x="7424745" y="1664208"/>
-            <a:ext cx="1962851" cy="118872"/>
+            <a:off x="9625340" y="1133856"/>
+            <a:ext cx="2182307" cy="1600200"/>
           </a:xfrm>
           <a:prstGeom prst="roundRect">
             <a:avLst>
-              <a:gd name="adj" fmla="val 15385"/>
-            </a:avLst>
-          </a:prstGeom>
-          <a:solidFill>
-            <a:srgbClr val="EEF1F5"/>
-          </a:solidFill>
-          <a:ln/>
-        </p:spPr>
-      </p:sp>
-      <p:sp>
-        <p:nvSpPr>
-          <p:cNvPr id="55" name="Shape 53"/>
-          <p:cNvSpPr/>
-          <p:nvPr/>
-        </p:nvSpPr>
-        <p:spPr>
-          <a:xfrm>
-            <a:off x="7424745" y="1664208"/>
-            <a:ext cx="1038348" cy="118872"/>
-          </a:xfrm>
-          <a:prstGeom prst="rect">
-            <a:avLst/>
-          </a:prstGeom>
-          <a:solidFill>
-            <a:srgbClr val="A6650F"/>
-          </a:solidFill>
-          <a:ln/>
-        </p:spPr>
-      </p:sp>
-      <p:sp>
-        <p:nvSpPr>
-          <p:cNvPr id="56" name="Shape 54"/>
-          <p:cNvSpPr/>
-          <p:nvPr/>
-        </p:nvSpPr>
-        <p:spPr>
-          <a:xfrm>
-            <a:off x="8463093" y="1664208"/>
-            <a:ext cx="692886" cy="118872"/>
-          </a:xfrm>
-          <a:prstGeom prst="rect">
-            <a:avLst/>
-          </a:prstGeom>
-          <a:solidFill>
-            <a:srgbClr val="1E8449"/>
-          </a:solidFill>
-          <a:ln/>
-        </p:spPr>
-      </p:sp>
-      <p:sp>
-        <p:nvSpPr>
-          <p:cNvPr id="57" name="Shape 55"/>
-          <p:cNvSpPr/>
-          <p:nvPr/>
-        </p:nvSpPr>
-        <p:spPr>
-          <a:xfrm>
-            <a:off x="9155980" y="1664208"/>
-            <a:ext cx="231616" cy="118872"/>
-          </a:xfrm>
-          <a:prstGeom prst="rect">
-            <a:avLst/>
-          </a:prstGeom>
-          <a:solidFill>
-            <a:srgbClr val="5B6B82"/>
-          </a:solidFill>
-          <a:ln/>
-        </p:spPr>
-      </p:sp>
-      <p:sp>
-        <p:nvSpPr>
-          <p:cNvPr id="58" name="Shape 56"/>
-          <p:cNvSpPr/>
-          <p:nvPr/>
-        </p:nvSpPr>
-        <p:spPr>
-          <a:xfrm>
-            <a:off x="7424745" y="1856232"/>
-            <a:ext cx="54864" cy="54864"/>
-          </a:xfrm>
-          <a:prstGeom prst="ellipse">
-            <a:avLst/>
-          </a:prstGeom>
-          <a:solidFill>
-            <a:srgbClr val="A6650F"/>
-          </a:solidFill>
-          <a:ln/>
-        </p:spPr>
-      </p:sp>
-      <p:sp>
-        <p:nvSpPr>
-          <p:cNvPr id="59" name="Text 57"/>
-          <p:cNvSpPr txBox="1"/>
-          <p:nvPr/>
-        </p:nvSpPr>
-        <p:spPr>
-          <a:xfrm>
-            <a:off x="7525329" y="1819656"/>
-            <a:ext cx="1862267" cy="128016"/>
-          </a:xfrm>
-          <a:prstGeom prst="rect">
-            <a:avLst/>
-          </a:prstGeom>
-          <a:noFill/>
-          <a:ln/>
-        </p:spPr>
-        <p:txBody>
-          <a:bodyPr wrap="square" lIns="0" tIns="0" rIns="0" bIns="0" rtlCol="0" anchor="ctr"/>
-          <a:lstStyle/>
-          <a:p>
-            <a:pPr algn="l" indent="0" marL="0">
-              <a:buNone/>
-            </a:pPr>
-            <a:r>
-              <a:rPr lang="en-US" sz="760" b="1" dirty="0">
-                <a:solidFill>
-                  <a:srgbClr val="A6650F"/>
-                </a:solidFill>
-                <a:latin typeface="Calibri" pitchFamily="34" charset="0"/>
-                <a:ea typeface="Calibri" pitchFamily="34" charset="-122"/>
-                <a:cs typeface="Calibri" pitchFamily="34" charset="-120"/>
-              </a:rPr>
-              <a:t>52.9% Regular</a:t>
-            </a:r>
-            <a:endParaRPr lang="en-US" sz="760" dirty="0"/>
-          </a:p>
-        </p:txBody>
-      </p:sp>
-      <p:sp>
-        <p:nvSpPr>
-          <p:cNvPr id="60" name="Shape 58"/>
-          <p:cNvSpPr/>
-          <p:nvPr/>
-        </p:nvSpPr>
-        <p:spPr>
-          <a:xfrm>
-            <a:off x="7424745" y="1997964"/>
-            <a:ext cx="54864" cy="54864"/>
-          </a:xfrm>
-          <a:prstGeom prst="ellipse">
-            <a:avLst/>
-          </a:prstGeom>
-          <a:solidFill>
-            <a:srgbClr val="1E8449"/>
-          </a:solidFill>
-          <a:ln/>
-        </p:spPr>
-      </p:sp>
-      <p:sp>
-        <p:nvSpPr>
-          <p:cNvPr id="61" name="Text 59"/>
-          <p:cNvSpPr txBox="1"/>
-          <p:nvPr/>
-        </p:nvSpPr>
-        <p:spPr>
-          <a:xfrm>
-            <a:off x="7525329" y="1961388"/>
-            <a:ext cx="1862267" cy="128016"/>
-          </a:xfrm>
-          <a:prstGeom prst="rect">
-            <a:avLst/>
-          </a:prstGeom>
-          <a:noFill/>
-          <a:ln/>
-        </p:spPr>
-        <p:txBody>
-          <a:bodyPr wrap="square" lIns="0" tIns="0" rIns="0" bIns="0" rtlCol="0" anchor="ctr"/>
-          <a:lstStyle/>
-          <a:p>
-            <a:pPr algn="l" indent="0" marL="0">
-              <a:buNone/>
-            </a:pPr>
-            <a:r>
-              <a:rPr lang="en-US" sz="760" b="1" dirty="0">
-                <a:solidFill>
-                  <a:srgbClr val="1E8449"/>
-                </a:solidFill>
-                <a:latin typeface="Calibri" pitchFamily="34" charset="0"/>
-                <a:ea typeface="Calibri" pitchFamily="34" charset="-122"/>
-                <a:cs typeface="Calibri" pitchFamily="34" charset="-120"/>
-              </a:rPr>
-              <a:t>35.3% Fácil</a:t>
-            </a:r>
-            <a:endParaRPr lang="en-US" sz="760" dirty="0"/>
-          </a:p>
-        </p:txBody>
-      </p:sp>
-      <p:sp>
-        <p:nvSpPr>
-          <p:cNvPr id="62" name="Shape 60"/>
-          <p:cNvSpPr/>
-          <p:nvPr/>
-        </p:nvSpPr>
-        <p:spPr>
-          <a:xfrm>
-            <a:off x="7424745" y="2139696"/>
-            <a:ext cx="54864" cy="54864"/>
-          </a:xfrm>
-          <a:prstGeom prst="ellipse">
-            <a:avLst/>
-          </a:prstGeom>
-          <a:solidFill>
-            <a:srgbClr val="5B6B82"/>
-          </a:solidFill>
-          <a:ln/>
-        </p:spPr>
-      </p:sp>
-      <p:sp>
-        <p:nvSpPr>
-          <p:cNvPr id="63" name="Text 61"/>
-          <p:cNvSpPr txBox="1"/>
-          <p:nvPr/>
-        </p:nvSpPr>
-        <p:spPr>
-          <a:xfrm>
-            <a:off x="7525329" y="2103120"/>
-            <a:ext cx="1862267" cy="128016"/>
-          </a:xfrm>
-          <a:prstGeom prst="rect">
-            <a:avLst/>
-          </a:prstGeom>
-          <a:noFill/>
-          <a:ln/>
-        </p:spPr>
-        <p:txBody>
-          <a:bodyPr wrap="square" lIns="0" tIns="0" rIns="0" bIns="0" rtlCol="0" anchor="ctr"/>
-          <a:lstStyle/>
-          <a:p>
-            <a:pPr algn="l" indent="0" marL="0">
-              <a:buNone/>
-            </a:pPr>
-            <a:r>
-              <a:rPr lang="en-US" sz="760" b="1" dirty="0">
-                <a:solidFill>
-                  <a:srgbClr val="5B6B82"/>
-                </a:solidFill>
-                <a:latin typeface="Calibri" pitchFamily="34" charset="0"/>
-                <a:ea typeface="Calibri" pitchFamily="34" charset="-122"/>
-                <a:cs typeface="Calibri" pitchFamily="34" charset="-120"/>
-              </a:rPr>
-              <a:t>11.8% Difícil</a:t>
-            </a:r>
-            <a:endParaRPr lang="en-US" sz="760" dirty="0"/>
-          </a:p>
-        </p:txBody>
-      </p:sp>
-      <p:sp>
-        <p:nvSpPr>
-          <p:cNvPr id="64" name="Shape 62"/>
-          <p:cNvSpPr/>
-          <p:nvPr/>
-        </p:nvSpPr>
-        <p:spPr>
-          <a:xfrm>
-            <a:off x="9625340" y="1133856"/>
-            <a:ext cx="2182307" cy="1207008"/>
-          </a:xfrm>
-          <a:prstGeom prst="roundRect">
-            <a:avLst>
-              <a:gd name="adj" fmla="val 4545"/>
+              <a:gd name="adj" fmla="val 3429"/>
             </a:avLst>
           </a:prstGeom>
           <a:solidFill>
@@ -6854,7 +7250,7 @@
       </p:sp>
       <p:sp>
         <p:nvSpPr>
-          <p:cNvPr id="65" name="Shape 63"/>
+          <p:cNvPr id="29" name="Shape 23"/>
           <p:cNvSpPr/>
           <p:nvPr/>
         </p:nvSpPr>
@@ -6874,7 +7270,7 @@
       </p:sp>
       <p:sp>
         <p:nvSpPr>
-          <p:cNvPr id="66" name="Text 64"/>
+          <p:cNvPr id="30" name="Text 24"/>
           <p:cNvSpPr txBox="1"/>
           <p:nvPr/>
         </p:nvSpPr>
@@ -6913,14 +7309,14 @@
       </p:sp>
       <p:sp>
         <p:nvSpPr>
-          <p:cNvPr id="67" name="Text 65"/>
+          <p:cNvPr id="31" name="Text 25"/>
           <p:cNvSpPr txBox="1"/>
           <p:nvPr/>
         </p:nvSpPr>
         <p:spPr>
           <a:xfrm>
             <a:off x="9981956" y="1207008"/>
-            <a:ext cx="1715963" cy="457200"/>
+            <a:ext cx="1715963" cy="420624"/>
           </a:xfrm>
           <a:prstGeom prst="rect">
             <a:avLst/>
@@ -6934,12 +7330,12 @@
           <a:p>
             <a:pPr algn="l" indent="0" marL="0">
               <a:lnSpc>
-                <a:spcPct val="112000"/>
+                <a:spcPct val="110000"/>
               </a:lnSpc>
               <a:buNone/>
             </a:pPr>
             <a:r>
-              <a:rPr lang="en-US" sz="950" b="1" dirty="0">
+              <a:rPr lang="en-US" sz="900" b="1" dirty="0">
                 <a:solidFill>
                   <a:srgbClr val="17223A"/>
                 </a:solidFill>
@@ -6949,102 +7345,36 @@
               </a:rPr>
               <a:t>Calificación general del servicio (escala 1–5)</a:t>
             </a:r>
-            <a:endParaRPr lang="en-US" sz="950" dirty="0"/>
+            <a:endParaRPr lang="en-US" sz="900" dirty="0"/>
           </a:p>
         </p:txBody>
       </p:sp>
-      <p:sp>
-        <p:nvSpPr>
-          <p:cNvPr id="68" name="Shape 66"/>
-          <p:cNvSpPr/>
-          <p:nvPr/>
-        </p:nvSpPr>
-        <p:spPr>
-          <a:xfrm>
-            <a:off x="9735068" y="1664208"/>
-            <a:ext cx="1962851" cy="118872"/>
-          </a:xfrm>
-          <a:prstGeom prst="roundRect">
-            <a:avLst>
-              <a:gd name="adj" fmla="val 15385"/>
-            </a:avLst>
-          </a:prstGeom>
-          <a:solidFill>
-            <a:srgbClr val="EEF1F5"/>
-          </a:solidFill>
-          <a:ln/>
-        </p:spPr>
-      </p:sp>
-      <p:sp>
-        <p:nvSpPr>
-          <p:cNvPr id="69" name="Shape 67"/>
-          <p:cNvSpPr/>
-          <p:nvPr/>
-        </p:nvSpPr>
-        <p:spPr>
-          <a:xfrm>
-            <a:off x="9735068" y="1664208"/>
-            <a:ext cx="1617389" cy="118872"/>
-          </a:xfrm>
-          <a:prstGeom prst="rect">
-            <a:avLst/>
-          </a:prstGeom>
-          <a:solidFill>
-            <a:srgbClr val="1E8449"/>
-          </a:solidFill>
-          <a:ln/>
-        </p:spPr>
-      </p:sp>
-      <p:sp>
-        <p:nvSpPr>
-          <p:cNvPr id="70" name="Shape 68"/>
-          <p:cNvSpPr/>
-          <p:nvPr/>
-        </p:nvSpPr>
-        <p:spPr>
-          <a:xfrm>
-            <a:off x="11352457" y="1664208"/>
-            <a:ext cx="345462" cy="118872"/>
-          </a:xfrm>
-          <a:prstGeom prst="rect">
-            <a:avLst/>
-          </a:prstGeom>
-          <a:solidFill>
-            <a:srgbClr val="A6650F"/>
-          </a:solidFill>
-          <a:ln/>
-        </p:spPr>
-      </p:sp>
-      <p:sp>
-        <p:nvSpPr>
-          <p:cNvPr id="71" name="Shape 69"/>
-          <p:cNvSpPr/>
-          <p:nvPr/>
-        </p:nvSpPr>
-        <p:spPr>
-          <a:xfrm>
-            <a:off x="9735068" y="1856232"/>
-            <a:ext cx="54864" cy="54864"/>
-          </a:xfrm>
-          <a:prstGeom prst="ellipse">
-            <a:avLst/>
-          </a:prstGeom>
-          <a:solidFill>
-            <a:srgbClr val="1E8449"/>
-          </a:solidFill>
-          <a:ln/>
-        </p:spPr>
-      </p:sp>
-      <p:sp>
-        <p:nvSpPr>
-          <p:cNvPr id="72" name="Text 70"/>
+      <p:graphicFrame>
+        <p:nvGraphicFramePr>
+          <p:cNvPr id="32" name="Chart 4" descr=""/>
+          <p:cNvGraphicFramePr/>
+          <p:nvPr/>
+        </p:nvGraphicFramePr>
+        <p:xfrm>
+          <a:off x="9643628" y="1645920"/>
+          <a:ext cx="2145731" cy="905256"/>
+        </p:xfrm>
+        <a:graphic xmlns:a="http://schemas.openxmlformats.org/drawingml/2006/main">
+          <a:graphicData uri="http://schemas.openxmlformats.org/drawingml/2006/chart">
+            <c:chart xmlns:c="http://schemas.openxmlformats.org/drawingml/2006/chart" r:id="rId5"/>
+          </a:graphicData>
+        </a:graphic>
+      </p:graphicFrame>
+      <p:sp>
+        <p:nvSpPr>
+          <p:cNvPr id="33" name="Text 26"/>
           <p:cNvSpPr txBox="1"/>
           <p:nvPr/>
         </p:nvSpPr>
         <p:spPr>
           <a:xfrm>
-            <a:off x="9835652" y="1819656"/>
-            <a:ext cx="1862267" cy="128016"/>
+            <a:off x="9735068" y="2551176"/>
+            <a:ext cx="1962851" cy="164592"/>
           </a:xfrm>
           <a:prstGeom prst="rect">
             <a:avLst/>
@@ -7056,151 +7386,33 @@
           <a:bodyPr wrap="square" lIns="0" tIns="0" rIns="0" bIns="0" rtlCol="0" anchor="ctr"/>
           <a:lstStyle/>
           <a:p>
-            <a:pPr algn="l" indent="0" marL="0">
-              <a:buNone/>
-            </a:pPr>
-            <a:r>
-              <a:rPr lang="en-US" sz="760" b="1" dirty="0">
-                <a:solidFill>
-                  <a:srgbClr val="1E8449"/>
-                </a:solidFill>
-                <a:latin typeface="Calibri" pitchFamily="34" charset="0"/>
-                <a:ea typeface="Calibri" pitchFamily="34" charset="-122"/>
-                <a:cs typeface="Calibri" pitchFamily="34" charset="-120"/>
-              </a:rPr>
-              <a:t>82.4% Nota 4</a:t>
-            </a:r>
-            <a:endParaRPr lang="en-US" sz="760" dirty="0"/>
+            <a:pPr algn="ctr" indent="0" marL="0">
+              <a:buNone/>
+            </a:pPr>
+            <a:r>
+              <a:rPr lang="en-US" sz="800" b="1" dirty="0">
+                <a:solidFill>
+                  <a:srgbClr val="133B6C"/>
+                </a:solidFill>
+                <a:latin typeface="Calibri" pitchFamily="34" charset="0"/>
+                <a:ea typeface="Calibri" pitchFamily="34" charset="-122"/>
+                <a:cs typeface="Calibri" pitchFamily="34" charset="-120"/>
+              </a:rPr>
+              <a:t>Promedio: 3.82 / 5</a:t>
+            </a:r>
+            <a:endParaRPr lang="en-US" sz="800" dirty="0"/>
           </a:p>
         </p:txBody>
       </p:sp>
       <p:sp>
         <p:nvSpPr>
-          <p:cNvPr id="73" name="Shape 71"/>
+          <p:cNvPr id="34" name="Shape 27"/>
           <p:cNvSpPr/>
           <p:nvPr/>
         </p:nvSpPr>
         <p:spPr>
           <a:xfrm>
-            <a:off x="9735068" y="1997964"/>
-            <a:ext cx="54864" cy="54864"/>
-          </a:xfrm>
-          <a:prstGeom prst="ellipse">
-            <a:avLst/>
-          </a:prstGeom>
-          <a:solidFill>
-            <a:srgbClr val="A6650F"/>
-          </a:solidFill>
-          <a:ln/>
-        </p:spPr>
-      </p:sp>
-      <p:sp>
-        <p:nvSpPr>
-          <p:cNvPr id="74" name="Text 72"/>
-          <p:cNvSpPr txBox="1"/>
-          <p:nvPr/>
-        </p:nvSpPr>
-        <p:spPr>
-          <a:xfrm>
-            <a:off x="9835652" y="1961388"/>
-            <a:ext cx="1862267" cy="128016"/>
-          </a:xfrm>
-          <a:prstGeom prst="rect">
-            <a:avLst/>
-          </a:prstGeom>
-          <a:noFill/>
-          <a:ln/>
-        </p:spPr>
-        <p:txBody>
-          <a:bodyPr wrap="square" lIns="0" tIns="0" rIns="0" bIns="0" rtlCol="0" anchor="ctr"/>
-          <a:lstStyle/>
-          <a:p>
-            <a:pPr algn="l" indent="0" marL="0">
-              <a:buNone/>
-            </a:pPr>
-            <a:r>
-              <a:rPr lang="en-US" sz="760" b="1" dirty="0">
-                <a:solidFill>
-                  <a:srgbClr val="A6650F"/>
-                </a:solidFill>
-                <a:latin typeface="Calibri" pitchFamily="34" charset="0"/>
-                <a:ea typeface="Calibri" pitchFamily="34" charset="-122"/>
-                <a:cs typeface="Calibri" pitchFamily="34" charset="-120"/>
-              </a:rPr>
-              <a:t>17.6% Nota 3</a:t>
-            </a:r>
-            <a:endParaRPr lang="en-US" sz="760" dirty="0"/>
-          </a:p>
-        </p:txBody>
-      </p:sp>
-      <p:sp>
-        <p:nvSpPr>
-          <p:cNvPr id="75" name="Shape 73"/>
-          <p:cNvSpPr/>
-          <p:nvPr/>
-        </p:nvSpPr>
-        <p:spPr>
-          <a:xfrm>
-            <a:off x="9735068" y="2139696"/>
-            <a:ext cx="54864" cy="54864"/>
-          </a:xfrm>
-          <a:prstGeom prst="ellipse">
-            <a:avLst/>
-          </a:prstGeom>
-          <a:solidFill>
-            <a:srgbClr val="133B6C"/>
-          </a:solidFill>
-          <a:ln/>
-        </p:spPr>
-      </p:sp>
-      <p:sp>
-        <p:nvSpPr>
-          <p:cNvPr id="76" name="Text 74"/>
-          <p:cNvSpPr txBox="1"/>
-          <p:nvPr/>
-        </p:nvSpPr>
-        <p:spPr>
-          <a:xfrm>
-            <a:off x="9835652" y="2103120"/>
-            <a:ext cx="1862267" cy="128016"/>
-          </a:xfrm>
-          <a:prstGeom prst="rect">
-            <a:avLst/>
-          </a:prstGeom>
-          <a:noFill/>
-          <a:ln/>
-        </p:spPr>
-        <p:txBody>
-          <a:bodyPr wrap="square" lIns="0" tIns="0" rIns="0" bIns="0" rtlCol="0" anchor="ctr"/>
-          <a:lstStyle/>
-          <a:p>
-            <a:pPr algn="l" indent="0" marL="0">
-              <a:buNone/>
-            </a:pPr>
-            <a:r>
-              <a:rPr lang="en-US" sz="760" b="1" dirty="0">
-                <a:solidFill>
-                  <a:srgbClr val="133B6C"/>
-                </a:solidFill>
-                <a:latin typeface="Calibri" pitchFamily="34" charset="0"/>
-                <a:ea typeface="Calibri" pitchFamily="34" charset="-122"/>
-                <a:cs typeface="Calibri" pitchFamily="34" charset="-120"/>
-              </a:rPr>
-              <a:t>Promedio: 3.82 / 5</a:t>
-            </a:r>
-            <a:endParaRPr lang="en-US" sz="760" dirty="0"/>
-          </a:p>
-        </p:txBody>
-      </p:sp>
-      <p:sp>
-        <p:nvSpPr>
-          <p:cNvPr id="77" name="Shape 75"/>
-          <p:cNvSpPr/>
-          <p:nvPr/>
-        </p:nvSpPr>
-        <p:spPr>
-          <a:xfrm>
-            <a:off x="384048" y="2487168"/>
+            <a:off x="384048" y="2880360"/>
             <a:ext cx="11423599" cy="384048"/>
           </a:xfrm>
           <a:prstGeom prst="roundRect">
@@ -7216,13 +7428,13 @@
       </p:sp>
       <p:sp>
         <p:nvSpPr>
-          <p:cNvPr id="78" name="Text 76"/>
+          <p:cNvPr id="35" name="Text 28"/>
           <p:cNvSpPr txBox="1"/>
           <p:nvPr/>
         </p:nvSpPr>
         <p:spPr>
           <a:xfrm>
-            <a:off x="548640" y="2487168"/>
+            <a:off x="548640" y="2880360"/>
             <a:ext cx="11094415" cy="384048"/>
           </a:xfrm>
           <a:prstGeom prst="rect">
@@ -7269,14 +7481,14 @@
       </p:sp>
       <p:sp>
         <p:nvSpPr>
-          <p:cNvPr id="79" name="Shape 77"/>
+          <p:cNvPr id="36" name="Shape 29"/>
           <p:cNvSpPr/>
           <p:nvPr/>
         </p:nvSpPr>
         <p:spPr>
           <a:xfrm>
-            <a:off x="384048" y="2871216"/>
-            <a:ext cx="11423599" cy="3840480"/>
+            <a:off x="384048" y="3264408"/>
+            <a:ext cx="11423599" cy="3447288"/>
           </a:xfrm>
           <a:prstGeom prst="rect">
             <a:avLst/>
@@ -7294,14 +7506,14 @@
       </p:sp>
       <p:sp>
         <p:nvSpPr>
-          <p:cNvPr id="80" name="Text 78"/>
+          <p:cNvPr id="37" name="Text 30"/>
           <p:cNvSpPr txBox="1"/>
           <p:nvPr/>
         </p:nvSpPr>
         <p:spPr>
           <a:xfrm>
-            <a:off x="566928" y="2999232"/>
-            <a:ext cx="5391760" cy="3621024"/>
+            <a:off x="566928" y="3392424"/>
+            <a:ext cx="5391760" cy="3227832"/>
           </a:xfrm>
           <a:prstGeom prst="rect">
             <a:avLst/>
@@ -7675,14 +7887,14 @@
       </p:sp>
       <p:sp>
         <p:nvSpPr>
-          <p:cNvPr id="81" name="Text 79"/>
+          <p:cNvPr id="38" name="Text 31"/>
           <p:cNvSpPr txBox="1"/>
           <p:nvPr/>
         </p:nvSpPr>
         <p:spPr>
           <a:xfrm>
-            <a:off x="6233008" y="2999232"/>
-            <a:ext cx="5391760" cy="3621024"/>
+            <a:off x="6233008" y="3392424"/>
+            <a:ext cx="5391760" cy="3227832"/>
           </a:xfrm>
           <a:prstGeom prst="rect">
             <a:avLst/>

</xml_diff>

<commit_message>
Fix chart category order and label wrapping; tidy agency tag font
Reverse each chart's category order so horizontal bars read top-to-
bottom in the intended sequence (PowerPoint plots the first array
item at the bottom by default). Widen the value axis headroom so
outEnd percentage labels no longer wrap onto two lines, and shrink
the agency-tag font slightly so none of the 9 tags wrap.

Co-Authored-By: Claude Sonnet 5 <noreply@anthropic.com>
Claude-Session: https://claude.ai/code/session_01KND4cYnTdx53ydNLfQdR3S
</commit_message>
<xml_diff>
--- a/Dashboard_Ejecutivo_EVERTEC_JuntaDirectiva.pptx
+++ b/Dashboard_Ejecutivo_EVERTEC_JuntaDirectiva.pptx
@@ -136,7 +136,7 @@
           </c:tx>
           <c:spPr>
             <a:solidFill>
-              <a:srgbClr val="E0392B"/>
+              <a:srgbClr val="1E8449"/>
             </a:solidFill>
             <a:ln w="9525" cap="flat">
               <a:solidFill>
@@ -155,7 +155,7 @@
               <a:lstStyle/>
               <a:p>
                 <a:pPr>
-                  <a:defRPr b="0" i="0" strike="noStrike" sz="800" u="none">
+                  <a:defRPr b="0" i="0" strike="noStrike" sz="750" u="none">
                     <a:solidFill>
                       <a:srgbClr val="243044"/>
                     </a:solidFill>
@@ -178,7 +178,7 @@
             <c:bubble3D val="0"/>
             <c:spPr>
               <a:solidFill>
-                <a:srgbClr val="E0392B"/>
+                <a:srgbClr val="1E8449"/>
               </a:solidFill>
               <a:effectLst/>
             </c:spPr>
@@ -200,7 +200,7 @@
             <c:bubble3D val="0"/>
             <c:spPr>
               <a:solidFill>
-                <a:srgbClr val="1E8449"/>
+                <a:srgbClr val="E0392B"/>
               </a:solidFill>
               <a:effectLst/>
             </c:spPr>
@@ -212,13 +212,13 @@
                 <c:ptCount val="3"/>
                 <c:lvl>
                   <c:pt idx="0">
-                    <c:v>Frecuente</c:v>
+                    <c:v>Rara vez</c:v>
                   </c:pt>
                   <c:pt idx="1">
                     <c:v>Algunas veces</c:v>
                   </c:pt>
                   <c:pt idx="2">
-                    <c:v>Rara vez</c:v>
+                    <c:v>Frecuente</c:v>
                   </c:pt>
                 </c:lvl>
               </c:multiLvlStrCache>
@@ -231,13 +231,13 @@
                 <c:formatCode>General</c:formatCode>
                 <c:ptCount val="3"/>
                 <c:pt idx="0">
-                  <c:v>35.3</c:v>
+                  <c:v>11.8</c:v>
                 </c:pt>
                 <c:pt idx="1">
                   <c:v>52.9</c:v>
                 </c:pt>
                 <c:pt idx="2">
-                  <c:v>11.8</c:v>
+                  <c:v>35.3</c:v>
                 </c:pt>
               </c:numCache>
             </c:numRef>
@@ -250,7 +250,7 @@
             <a:lstStyle/>
             <a:p>
               <a:pPr>
-                <a:defRPr b="0" i="0" strike="noStrike" sz="800" u="none">
+                <a:defRPr b="0" i="0" strike="noStrike" sz="750" u="none">
                   <a:solidFill>
                     <a:srgbClr val="243044"/>
                   </a:solidFill>
@@ -316,7 +316,7 @@
         <c:axId val="2094734552"/>
         <c:scaling>
           <c:orientation val="minMax"/>
-          <c:max val="100"/>
+          <c:max val="130"/>
           <c:min val="0"/>
         </c:scaling>
         <c:delete val="1"/>
@@ -413,7 +413,7 @@
           </c:tx>
           <c:spPr>
             <a:solidFill>
-              <a:srgbClr val="1E8449"/>
+              <a:srgbClr val="1D63A1"/>
             </a:solidFill>
             <a:ln w="9525" cap="flat">
               <a:solidFill>
@@ -432,7 +432,7 @@
               <a:lstStyle/>
               <a:p>
                 <a:pPr>
-                  <a:defRPr b="0" i="0" strike="noStrike" sz="800" u="none">
+                  <a:defRPr b="0" i="0" strike="noStrike" sz="750" u="none">
                     <a:solidFill>
                       <a:srgbClr val="243044"/>
                     </a:solidFill>
@@ -455,7 +455,7 @@
             <c:bubble3D val="0"/>
             <c:spPr>
               <a:solidFill>
-                <a:srgbClr val="1E8449"/>
+                <a:srgbClr val="1D63A1"/>
               </a:solidFill>
               <a:effectLst/>
             </c:spPr>
@@ -477,7 +477,7 @@
             <c:bubble3D val="0"/>
             <c:spPr>
               <a:solidFill>
-                <a:srgbClr val="1D63A1"/>
+                <a:srgbClr val="1E8449"/>
               </a:solidFill>
               <a:effectLst/>
             </c:spPr>
@@ -489,13 +489,13 @@
                 <c:ptCount val="3"/>
                 <c:lvl>
                   <c:pt idx="0">
-                    <c:v>Oportuno</c:v>
+                    <c:v>Muy oport.</c:v>
                   </c:pt>
                   <c:pt idx="1">
                     <c:v>Regular</c:v>
                   </c:pt>
                   <c:pt idx="2">
-                    <c:v>Muy oport.</c:v>
+                    <c:v>Oportuno</c:v>
                   </c:pt>
                 </c:lvl>
               </c:multiLvlStrCache>
@@ -508,13 +508,13 @@
                 <c:formatCode>General</c:formatCode>
                 <c:ptCount val="3"/>
                 <c:pt idx="0">
-                  <c:v>70.6</c:v>
+                  <c:v>11.8</c:v>
                 </c:pt>
                 <c:pt idx="1">
                   <c:v>17.6</c:v>
                 </c:pt>
                 <c:pt idx="2">
-                  <c:v>11.8</c:v>
+                  <c:v>70.6</c:v>
                 </c:pt>
               </c:numCache>
             </c:numRef>
@@ -527,7 +527,7 @@
             <a:lstStyle/>
             <a:p>
               <a:pPr>
-                <a:defRPr b="0" i="0" strike="noStrike" sz="800" u="none">
+                <a:defRPr b="0" i="0" strike="noStrike" sz="750" u="none">
                   <a:solidFill>
                     <a:srgbClr val="243044"/>
                   </a:solidFill>
@@ -593,7 +593,7 @@
         <c:axId val="2094734552"/>
         <c:scaling>
           <c:orientation val="minMax"/>
-          <c:max val="100"/>
+          <c:max val="130"/>
           <c:min val="0"/>
         </c:scaling>
         <c:delete val="1"/>
@@ -690,7 +690,7 @@
           </c:tx>
           <c:spPr>
             <a:solidFill>
-              <a:srgbClr val="E0392B"/>
+              <a:srgbClr val="1E8449"/>
             </a:solidFill>
             <a:ln w="9525" cap="flat">
               <a:solidFill>
@@ -709,7 +709,7 @@
               <a:lstStyle/>
               <a:p>
                 <a:pPr>
-                  <a:defRPr b="0" i="0" strike="noStrike" sz="800" u="none">
+                  <a:defRPr b="0" i="0" strike="noStrike" sz="750" u="none">
                     <a:solidFill>
                       <a:srgbClr val="243044"/>
                     </a:solidFill>
@@ -732,7 +732,7 @@
             <c:bubble3D val="0"/>
             <c:spPr>
               <a:solidFill>
-                <a:srgbClr val="E0392B"/>
+                <a:srgbClr val="1E8449"/>
               </a:solidFill>
               <a:effectLst/>
             </c:spPr>
@@ -754,7 +754,7 @@
             <c:bubble3D val="0"/>
             <c:spPr>
               <a:solidFill>
-                <a:srgbClr val="1E8449"/>
+                <a:srgbClr val="E0392B"/>
               </a:solidFill>
               <a:effectLst/>
             </c:spPr>
@@ -766,13 +766,13 @@
                 <c:ptCount val="3"/>
                 <c:lvl>
                   <c:pt idx="0">
-                    <c:v>Frecuente</c:v>
+                    <c:v>Rara vez</c:v>
                   </c:pt>
                   <c:pt idx="1">
                     <c:v>Algunas veces</c:v>
                   </c:pt>
                   <c:pt idx="2">
-                    <c:v>Rara vez</c:v>
+                    <c:v>Frecuente</c:v>
                   </c:pt>
                 </c:lvl>
               </c:multiLvlStrCache>
@@ -785,13 +785,13 @@
                 <c:formatCode>General</c:formatCode>
                 <c:ptCount val="3"/>
                 <c:pt idx="0">
-                  <c:v>41.2</c:v>
+                  <c:v>23.5</c:v>
                 </c:pt>
                 <c:pt idx="1">
                   <c:v>35.3</c:v>
                 </c:pt>
                 <c:pt idx="2">
-                  <c:v>23.5</c:v>
+                  <c:v>41.2</c:v>
                 </c:pt>
               </c:numCache>
             </c:numRef>
@@ -804,7 +804,7 @@
             <a:lstStyle/>
             <a:p>
               <a:pPr>
-                <a:defRPr b="0" i="0" strike="noStrike" sz="800" u="none">
+                <a:defRPr b="0" i="0" strike="noStrike" sz="750" u="none">
                   <a:solidFill>
                     <a:srgbClr val="243044"/>
                   </a:solidFill>
@@ -870,7 +870,7 @@
         <c:axId val="2094734552"/>
         <c:scaling>
           <c:orientation val="minMax"/>
-          <c:max val="100"/>
+          <c:max val="130"/>
           <c:min val="0"/>
         </c:scaling>
         <c:delete val="1"/>
@@ -967,7 +967,7 @@
           </c:tx>
           <c:spPr>
             <a:solidFill>
-              <a:srgbClr val="A6650F"/>
+              <a:srgbClr val="5B6B82"/>
             </a:solidFill>
             <a:ln w="9525" cap="flat">
               <a:solidFill>
@@ -986,7 +986,7 @@
               <a:lstStyle/>
               <a:p>
                 <a:pPr>
-                  <a:defRPr b="0" i="0" strike="noStrike" sz="800" u="none">
+                  <a:defRPr b="0" i="0" strike="noStrike" sz="750" u="none">
                     <a:solidFill>
                       <a:srgbClr val="243044"/>
                     </a:solidFill>
@@ -1009,7 +1009,7 @@
             <c:bubble3D val="0"/>
             <c:spPr>
               <a:solidFill>
-                <a:srgbClr val="A6650F"/>
+                <a:srgbClr val="5B6B82"/>
               </a:solidFill>
               <a:effectLst/>
             </c:spPr>
@@ -1031,7 +1031,7 @@
             <c:bubble3D val="0"/>
             <c:spPr>
               <a:solidFill>
-                <a:srgbClr val="5B6B82"/>
+                <a:srgbClr val="A6650F"/>
               </a:solidFill>
               <a:effectLst/>
             </c:spPr>
@@ -1043,13 +1043,13 @@
                 <c:ptCount val="3"/>
                 <c:lvl>
                   <c:pt idx="0">
-                    <c:v>Regular</c:v>
+                    <c:v>Difícil</c:v>
                   </c:pt>
                   <c:pt idx="1">
                     <c:v>Fácil</c:v>
                   </c:pt>
                   <c:pt idx="2">
-                    <c:v>Difícil</c:v>
+                    <c:v>Regular</c:v>
                   </c:pt>
                 </c:lvl>
               </c:multiLvlStrCache>
@@ -1062,13 +1062,13 @@
                 <c:formatCode>General</c:formatCode>
                 <c:ptCount val="3"/>
                 <c:pt idx="0">
-                  <c:v>52.9</c:v>
+                  <c:v>11.8</c:v>
                 </c:pt>
                 <c:pt idx="1">
                   <c:v>35.3</c:v>
                 </c:pt>
                 <c:pt idx="2">
-                  <c:v>11.8</c:v>
+                  <c:v>52.9</c:v>
                 </c:pt>
               </c:numCache>
             </c:numRef>
@@ -1081,7 +1081,7 @@
             <a:lstStyle/>
             <a:p>
               <a:pPr>
-                <a:defRPr b="0" i="0" strike="noStrike" sz="800" u="none">
+                <a:defRPr b="0" i="0" strike="noStrike" sz="750" u="none">
                   <a:solidFill>
                     <a:srgbClr val="243044"/>
                   </a:solidFill>
@@ -1147,7 +1147,7 @@
         <c:axId val="2094734552"/>
         <c:scaling>
           <c:orientation val="minMax"/>
-          <c:max val="100"/>
+          <c:max val="130"/>
           <c:min val="0"/>
         </c:scaling>
         <c:delete val="1"/>
@@ -1244,7 +1244,7 @@
           </c:tx>
           <c:spPr>
             <a:solidFill>
-              <a:srgbClr val="1E8449"/>
+              <a:srgbClr val="A6650F"/>
             </a:solidFill>
             <a:ln w="9525" cap="flat">
               <a:solidFill>
@@ -1263,7 +1263,7 @@
               <a:lstStyle/>
               <a:p>
                 <a:pPr>
-                  <a:defRPr b="0" i="0" strike="noStrike" sz="800" u="none">
+                  <a:defRPr b="0" i="0" strike="noStrike" sz="750" u="none">
                     <a:solidFill>
                       <a:srgbClr val="243044"/>
                     </a:solidFill>
@@ -1286,7 +1286,7 @@
             <c:bubble3D val="0"/>
             <c:spPr>
               <a:solidFill>
-                <a:srgbClr val="1E8449"/>
+                <a:srgbClr val="A6650F"/>
               </a:solidFill>
               <a:effectLst/>
             </c:spPr>
@@ -1297,7 +1297,7 @@
             <c:bubble3D val="0"/>
             <c:spPr>
               <a:solidFill>
-                <a:srgbClr val="A6650F"/>
+                <a:srgbClr val="1E8449"/>
               </a:solidFill>
               <a:effectLst/>
             </c:spPr>
@@ -1309,10 +1309,10 @@
                 <c:ptCount val="2"/>
                 <c:lvl>
                   <c:pt idx="0">
-                    <c:v>Nota 4</c:v>
+                    <c:v>Nota 3</c:v>
                   </c:pt>
                   <c:pt idx="1">
-                    <c:v>Nota 3</c:v>
+                    <c:v>Nota 4</c:v>
                   </c:pt>
                 </c:lvl>
               </c:multiLvlStrCache>
@@ -1325,10 +1325,10 @@
                 <c:formatCode>General</c:formatCode>
                 <c:ptCount val="2"/>
                 <c:pt idx="0">
-                  <c:v>82.4</c:v>
+                  <c:v>17.6</c:v>
                 </c:pt>
                 <c:pt idx="1">
-                  <c:v>17.6</c:v>
+                  <c:v>82.4</c:v>
                 </c:pt>
               </c:numCache>
             </c:numRef>
@@ -1341,7 +1341,7 @@
             <a:lstStyle/>
             <a:p>
               <a:pPr>
-                <a:defRPr b="0" i="0" strike="noStrike" sz="800" u="none">
+                <a:defRPr b="0" i="0" strike="noStrike" sz="750" u="none">
                   <a:solidFill>
                     <a:srgbClr val="243044"/>
                   </a:solidFill>
@@ -1407,7 +1407,7 @@
         <c:axId val="2094734552"/>
         <c:scaling>
           <c:orientation val="minMax"/>
-          <c:max val="100"/>
+          <c:max val="130"/>
           <c:min val="0"/>
         </c:scaling>
         <c:delete val="1"/>
@@ -3243,7 +3243,7 @@
               <a:buNone/>
             </a:pPr>
             <a:r>
-              <a:rPr lang="en-US" sz="730" b="1" dirty="0">
+              <a:rPr lang="en-US" sz="660" b="1" dirty="0">
                 <a:solidFill>
                   <a:srgbClr val="243044"/>
                 </a:solidFill>
@@ -3253,7 +3253,7 @@
               </a:rPr>
               <a:t>San Miguel</a:t>
             </a:r>
-            <a:endParaRPr lang="en-US" sz="730" dirty="0"/>
+            <a:endParaRPr lang="en-US" sz="660" dirty="0"/>
           </a:p>
         </p:txBody>
       </p:sp>
@@ -3304,7 +3304,7 @@
               <a:buNone/>
             </a:pPr>
             <a:r>
-              <a:rPr lang="en-US" sz="730" b="1" dirty="0">
+              <a:rPr lang="en-US" sz="660" b="1" dirty="0">
                 <a:solidFill>
                   <a:srgbClr val="243044"/>
                 </a:solidFill>
@@ -3314,7 +3314,7 @@
               </a:rPr>
               <a:t>Colonia Médica</a:t>
             </a:r>
-            <a:endParaRPr lang="en-US" sz="730" dirty="0"/>
+            <a:endParaRPr lang="en-US" sz="660" dirty="0"/>
           </a:p>
         </p:txBody>
       </p:sp>
@@ -3365,7 +3365,7 @@
               <a:buNone/>
             </a:pPr>
             <a:r>
-              <a:rPr lang="en-US" sz="730" b="1" dirty="0">
+              <a:rPr lang="en-US" sz="660" b="1" dirty="0">
                 <a:solidFill>
                   <a:srgbClr val="243044"/>
                 </a:solidFill>
@@ -3375,7 +3375,7 @@
               </a:rPr>
               <a:t>Sonsonate</a:t>
             </a:r>
-            <a:endParaRPr lang="en-US" sz="730" dirty="0"/>
+            <a:endParaRPr lang="en-US" sz="660" dirty="0"/>
           </a:p>
         </p:txBody>
       </p:sp>
@@ -3426,7 +3426,7 @@
               <a:buNone/>
             </a:pPr>
             <a:r>
-              <a:rPr lang="en-US" sz="730" b="1" dirty="0">
+              <a:rPr lang="en-US" sz="660" b="1" dirty="0">
                 <a:solidFill>
                   <a:srgbClr val="243044"/>
                 </a:solidFill>
@@ -3436,7 +3436,7 @@
               </a:rPr>
               <a:t>Santa Ana</a:t>
             </a:r>
-            <a:endParaRPr lang="en-US" sz="730" dirty="0"/>
+            <a:endParaRPr lang="en-US" sz="660" dirty="0"/>
           </a:p>
         </p:txBody>
       </p:sp>
@@ -3487,7 +3487,7 @@
               <a:buNone/>
             </a:pPr>
             <a:r>
-              <a:rPr lang="en-US" sz="730" b="1" dirty="0">
+              <a:rPr lang="en-US" sz="660" b="1" dirty="0">
                 <a:solidFill>
                   <a:srgbClr val="243044"/>
                 </a:solidFill>
@@ -3497,7 +3497,7 @@
               </a:rPr>
               <a:t>Plaza Mundo</a:t>
             </a:r>
-            <a:endParaRPr lang="en-US" sz="730" dirty="0"/>
+            <a:endParaRPr lang="en-US" sz="660" dirty="0"/>
           </a:p>
         </p:txBody>
       </p:sp>
@@ -3548,7 +3548,7 @@
               <a:buNone/>
             </a:pPr>
             <a:r>
-              <a:rPr lang="en-US" sz="730" b="1" dirty="0">
+              <a:rPr lang="en-US" sz="660" b="1" dirty="0">
                 <a:solidFill>
                   <a:srgbClr val="243044"/>
                 </a:solidFill>
@@ -3558,7 +3558,7 @@
               </a:rPr>
               <a:t>Plaza Merliot</a:t>
             </a:r>
-            <a:endParaRPr lang="en-US" sz="730" dirty="0"/>
+            <a:endParaRPr lang="en-US" sz="660" dirty="0"/>
           </a:p>
         </p:txBody>
       </p:sp>
@@ -3609,7 +3609,7 @@
               <a:buNone/>
             </a:pPr>
             <a:r>
-              <a:rPr lang="en-US" sz="730" b="1" dirty="0">
+              <a:rPr lang="en-US" sz="660" b="1" dirty="0">
                 <a:solidFill>
                   <a:srgbClr val="243044"/>
                 </a:solidFill>
@@ -3619,7 +3619,7 @@
               </a:rPr>
               <a:t>Colegio Médico</a:t>
             </a:r>
-            <a:endParaRPr lang="en-US" sz="730" dirty="0"/>
+            <a:endParaRPr lang="en-US" sz="660" dirty="0"/>
           </a:p>
         </p:txBody>
       </p:sp>
@@ -3670,7 +3670,7 @@
               <a:buNone/>
             </a:pPr>
             <a:r>
-              <a:rPr lang="en-US" sz="730" b="1" dirty="0">
+              <a:rPr lang="en-US" sz="660" b="1" dirty="0">
                 <a:solidFill>
                   <a:srgbClr val="243044"/>
                 </a:solidFill>
@@ -3680,7 +3680,7 @@
               </a:rPr>
               <a:t>Usulután</a:t>
             </a:r>
-            <a:endParaRPr lang="en-US" sz="730" dirty="0"/>
+            <a:endParaRPr lang="en-US" sz="660" dirty="0"/>
           </a:p>
         </p:txBody>
       </p:sp>
@@ -3731,7 +3731,7 @@
               <a:buNone/>
             </a:pPr>
             <a:r>
-              <a:rPr lang="en-US" sz="730" b="1" dirty="0">
+              <a:rPr lang="en-US" sz="660" b="1" dirty="0">
                 <a:solidFill>
                   <a:srgbClr val="243044"/>
                 </a:solidFill>
@@ -3741,7 +3741,7 @@
               </a:rPr>
               <a:t>Central</a:t>
             </a:r>
-            <a:endParaRPr lang="en-US" sz="730" dirty="0"/>
+            <a:endParaRPr lang="en-US" sz="660" dirty="0"/>
           </a:p>
         </p:txBody>
       </p:sp>

</xml_diff>

<commit_message>
Enlarge the 5 question charts and shrink the open-question panel
Bigger chart tiles (taller, larger fonts, thicker bars) per user
feedback that the charts felt too small. Compensated by tightening
the open-question header and comment text so all 17 responses still
fit without any being cut off (verified by rendering to images).

Co-Authored-By: Claude Sonnet 5 <noreply@anthropic.com>
Claude-Session: https://claude.ai/code/session_01KND4cYnTdx53ydNLfQdR3S
</commit_message>
<xml_diff>
--- a/Dashboard_Ejecutivo_EVERTEC_JuntaDirectiva.pptx
+++ b/Dashboard_Ejecutivo_EVERTEC_JuntaDirectiva.pptx
@@ -155,7 +155,7 @@
               <a:lstStyle/>
               <a:p>
                 <a:pPr>
-                  <a:defRPr b="0" i="0" strike="noStrike" sz="750" u="none">
+                  <a:defRPr b="0" i="0" strike="noStrike" sz="1000" u="none">
                     <a:solidFill>
                       <a:srgbClr val="243044"/>
                     </a:solidFill>
@@ -250,7 +250,7 @@
             <a:lstStyle/>
             <a:p>
               <a:pPr>
-                <a:defRPr b="0" i="0" strike="noStrike" sz="750" u="none">
+                <a:defRPr b="0" i="0" strike="noStrike" sz="1000" u="none">
                   <a:solidFill>
                     <a:srgbClr val="243044"/>
                   </a:solidFill>
@@ -267,7 +267,7 @@
           <c:showBubbleSize val="0"/>
           <c:showLeaderLines val="0"/>
         </c:dLbls>
-        <c:gapWidth val="35"/>
+        <c:gapWidth val="22"/>
         <c:overlap val="0"/>
         <c:axId val="2094734554"/>
         <c:axId val="2094734552"/>
@@ -296,7 +296,7 @@
           <a:lstStyle/>
           <a:p>
             <a:pPr>
-              <a:defRPr sz="800" b="0" i="0" u="none" strike="noStrike">
+              <a:defRPr sz="1000" b="0" i="0" u="none" strike="noStrike">
                 <a:solidFill>
                   <a:srgbClr val="33415A"/>
                 </a:solidFill>
@@ -432,7 +432,7 @@
               <a:lstStyle/>
               <a:p>
                 <a:pPr>
-                  <a:defRPr b="0" i="0" strike="noStrike" sz="750" u="none">
+                  <a:defRPr b="0" i="0" strike="noStrike" sz="1000" u="none">
                     <a:solidFill>
                       <a:srgbClr val="243044"/>
                     </a:solidFill>
@@ -527,7 +527,7 @@
             <a:lstStyle/>
             <a:p>
               <a:pPr>
-                <a:defRPr b="0" i="0" strike="noStrike" sz="750" u="none">
+                <a:defRPr b="0" i="0" strike="noStrike" sz="1000" u="none">
                   <a:solidFill>
                     <a:srgbClr val="243044"/>
                   </a:solidFill>
@@ -544,7 +544,7 @@
           <c:showBubbleSize val="0"/>
           <c:showLeaderLines val="0"/>
         </c:dLbls>
-        <c:gapWidth val="35"/>
+        <c:gapWidth val="22"/>
         <c:overlap val="0"/>
         <c:axId val="2094734554"/>
         <c:axId val="2094734552"/>
@@ -573,7 +573,7 @@
           <a:lstStyle/>
           <a:p>
             <a:pPr>
-              <a:defRPr sz="800" b="0" i="0" u="none" strike="noStrike">
+              <a:defRPr sz="1000" b="0" i="0" u="none" strike="noStrike">
                 <a:solidFill>
                   <a:srgbClr val="33415A"/>
                 </a:solidFill>
@@ -709,7 +709,7 @@
               <a:lstStyle/>
               <a:p>
                 <a:pPr>
-                  <a:defRPr b="0" i="0" strike="noStrike" sz="750" u="none">
+                  <a:defRPr b="0" i="0" strike="noStrike" sz="1000" u="none">
                     <a:solidFill>
                       <a:srgbClr val="243044"/>
                     </a:solidFill>
@@ -804,7 +804,7 @@
             <a:lstStyle/>
             <a:p>
               <a:pPr>
-                <a:defRPr b="0" i="0" strike="noStrike" sz="750" u="none">
+                <a:defRPr b="0" i="0" strike="noStrike" sz="1000" u="none">
                   <a:solidFill>
                     <a:srgbClr val="243044"/>
                   </a:solidFill>
@@ -821,7 +821,7 @@
           <c:showBubbleSize val="0"/>
           <c:showLeaderLines val="0"/>
         </c:dLbls>
-        <c:gapWidth val="35"/>
+        <c:gapWidth val="22"/>
         <c:overlap val="0"/>
         <c:axId val="2094734554"/>
         <c:axId val="2094734552"/>
@@ -850,7 +850,7 @@
           <a:lstStyle/>
           <a:p>
             <a:pPr>
-              <a:defRPr sz="800" b="0" i="0" u="none" strike="noStrike">
+              <a:defRPr sz="1000" b="0" i="0" u="none" strike="noStrike">
                 <a:solidFill>
                   <a:srgbClr val="33415A"/>
                 </a:solidFill>
@@ -986,7 +986,7 @@
               <a:lstStyle/>
               <a:p>
                 <a:pPr>
-                  <a:defRPr b="0" i="0" strike="noStrike" sz="750" u="none">
+                  <a:defRPr b="0" i="0" strike="noStrike" sz="1000" u="none">
                     <a:solidFill>
                       <a:srgbClr val="243044"/>
                     </a:solidFill>
@@ -1081,7 +1081,7 @@
             <a:lstStyle/>
             <a:p>
               <a:pPr>
-                <a:defRPr b="0" i="0" strike="noStrike" sz="750" u="none">
+                <a:defRPr b="0" i="0" strike="noStrike" sz="1000" u="none">
                   <a:solidFill>
                     <a:srgbClr val="243044"/>
                   </a:solidFill>
@@ -1098,7 +1098,7 @@
           <c:showBubbleSize val="0"/>
           <c:showLeaderLines val="0"/>
         </c:dLbls>
-        <c:gapWidth val="35"/>
+        <c:gapWidth val="22"/>
         <c:overlap val="0"/>
         <c:axId val="2094734554"/>
         <c:axId val="2094734552"/>
@@ -1127,7 +1127,7 @@
           <a:lstStyle/>
           <a:p>
             <a:pPr>
-              <a:defRPr sz="800" b="0" i="0" u="none" strike="noStrike">
+              <a:defRPr sz="1000" b="0" i="0" u="none" strike="noStrike">
                 <a:solidFill>
                   <a:srgbClr val="33415A"/>
                 </a:solidFill>
@@ -1263,7 +1263,7 @@
               <a:lstStyle/>
               <a:p>
                 <a:pPr>
-                  <a:defRPr b="0" i="0" strike="noStrike" sz="750" u="none">
+                  <a:defRPr b="0" i="0" strike="noStrike" sz="1000" u="none">
                     <a:solidFill>
                       <a:srgbClr val="243044"/>
                     </a:solidFill>
@@ -1341,7 +1341,7 @@
             <a:lstStyle/>
             <a:p>
               <a:pPr>
-                <a:defRPr b="0" i="0" strike="noStrike" sz="750" u="none">
+                <a:defRPr b="0" i="0" strike="noStrike" sz="1000" u="none">
                   <a:solidFill>
                     <a:srgbClr val="243044"/>
                   </a:solidFill>
@@ -1358,7 +1358,7 @@
           <c:showBubbleSize val="0"/>
           <c:showLeaderLines val="0"/>
         </c:dLbls>
-        <c:gapWidth val="35"/>
+        <c:gapWidth val="22"/>
         <c:overlap val="0"/>
         <c:axId val="2094734554"/>
         <c:axId val="2094734552"/>
@@ -1387,7 +1387,7 @@
           <a:lstStyle/>
           <a:p>
             <a:pPr>
-              <a:defRPr sz="800" b="0" i="0" u="none" strike="noStrike">
+              <a:defRPr sz="1000" b="0" i="0" u="none" strike="noStrike">
                 <a:solidFill>
                   <a:srgbClr val="33415A"/>
                 </a:solidFill>
@@ -6619,11 +6619,11 @@
         <p:spPr>
           <a:xfrm>
             <a:off x="384048" y="1133856"/>
-            <a:ext cx="2182307" cy="1600200"/>
+            <a:ext cx="2182307" cy="2148840"/>
           </a:xfrm>
           <a:prstGeom prst="roundRect">
             <a:avLst>
-              <a:gd name="adj" fmla="val 3429"/>
+              <a:gd name="adj" fmla="val 2979"/>
             </a:avLst>
           </a:prstGeom>
           <a:solidFill>
@@ -6636,9 +6636,9 @@
             <a:prstDash val="solid"/>
           </a:ln>
           <a:effectLst>
-            <a:outerShdw sx="100000" sy="100000" kx="0" ky="0" algn="bl" rotWithShape="0" blurRad="63500" dist="19050" dir="5400000">
+            <a:outerShdw sx="100000" sy="100000" kx="0" ky="0" algn="bl" rotWithShape="0" blurRad="76200" dist="19050" dir="5400000">
               <a:srgbClr val="0F2F4E">
-                <a:alpha val="9000"/>
+                <a:alpha val="10000"/>
               </a:srgbClr>
             </a:outerShdw>
           </a:effectLst>
@@ -6652,8 +6652,8 @@
         </p:nvSpPr>
         <p:spPr>
           <a:xfrm>
-            <a:off x="493776" y="1225296"/>
-            <a:ext cx="173736" cy="173736"/>
+            <a:off x="512064" y="1243584"/>
+            <a:ext cx="201168" cy="201168"/>
           </a:xfrm>
           <a:prstGeom prst="ellipse">
             <a:avLst/>
@@ -6672,8 +6672,8 @@
         </p:nvSpPr>
         <p:spPr>
           <a:xfrm>
-            <a:off x="493776" y="1225296"/>
-            <a:ext cx="173736" cy="173736"/>
+            <a:off x="512064" y="1243584"/>
+            <a:ext cx="201168" cy="201168"/>
           </a:xfrm>
           <a:prstGeom prst="rect">
             <a:avLst/>
@@ -6689,7 +6689,7 @@
               <a:buNone/>
             </a:pPr>
             <a:r>
-              <a:rPr lang="en-US" sz="900" b="1" dirty="0">
+              <a:rPr lang="en-US" sz="1000" b="1" dirty="0">
                 <a:solidFill>
                   <a:srgbClr val="FFFFFF"/>
                 </a:solidFill>
@@ -6699,7 +6699,7 @@
               </a:rPr>
               <a:t>1</a:t>
             </a:r>
-            <a:endParaRPr lang="en-US" sz="900" dirty="0"/>
+            <a:endParaRPr lang="en-US" sz="1000" dirty="0"/>
           </a:p>
         </p:txBody>
       </p:sp>
@@ -6711,8 +6711,8 @@
         </p:nvSpPr>
         <p:spPr>
           <a:xfrm>
-            <a:off x="740664" y="1207008"/>
-            <a:ext cx="1715963" cy="420624"/>
+            <a:off x="795528" y="1225296"/>
+            <a:ext cx="1642811" cy="475488"/>
           </a:xfrm>
           <a:prstGeom prst="rect">
             <a:avLst/>
@@ -6726,12 +6726,12 @@
           <a:p>
             <a:pPr algn="l" indent="0" marL="0">
               <a:lnSpc>
-                <a:spcPct val="110000"/>
+                <a:spcPct val="112000"/>
               </a:lnSpc>
               <a:buNone/>
             </a:pPr>
             <a:r>
-              <a:rPr lang="en-US" sz="900" b="1" dirty="0">
+              <a:rPr lang="en-US" sz="1000" b="1" dirty="0">
                 <a:solidFill>
                   <a:srgbClr val="17223A"/>
                 </a:solidFill>
@@ -6741,7 +6741,7 @@
               </a:rPr>
               <a:t>¿Con qué frecuencia se presentan fallas del sistema?</a:t>
             </a:r>
-            <a:endParaRPr lang="en-US" sz="900" dirty="0"/>
+            <a:endParaRPr lang="en-US" sz="1000" dirty="0"/>
           </a:p>
         </p:txBody>
       </p:sp>
@@ -6752,8 +6752,8 @@
           <p:nvPr/>
         </p:nvGraphicFramePr>
         <p:xfrm>
-          <a:off x="402336" y="1645920"/>
-          <a:ext cx="2145731" cy="1033272"/>
+          <a:off x="411480" y="1737360"/>
+          <a:ext cx="2127443" cy="1472184"/>
         </p:xfrm>
         <a:graphic xmlns:a="http://schemas.openxmlformats.org/drawingml/2006/main">
           <a:graphicData uri="http://schemas.openxmlformats.org/drawingml/2006/chart">
@@ -6770,11 +6770,11 @@
         <p:spPr>
           <a:xfrm>
             <a:off x="2694371" y="1133856"/>
-            <a:ext cx="2182307" cy="1600200"/>
+            <a:ext cx="2182307" cy="2148840"/>
           </a:xfrm>
           <a:prstGeom prst="roundRect">
             <a:avLst>
-              <a:gd name="adj" fmla="val 3429"/>
+              <a:gd name="adj" fmla="val 2979"/>
             </a:avLst>
           </a:prstGeom>
           <a:solidFill>
@@ -6787,9 +6787,9 @@
             <a:prstDash val="solid"/>
           </a:ln>
           <a:effectLst>
-            <a:outerShdw sx="100000" sy="100000" kx="0" ky="0" algn="bl" rotWithShape="0" blurRad="63500" dist="19050" dir="5400000">
+            <a:outerShdw sx="100000" sy="100000" kx="0" ky="0" algn="bl" rotWithShape="0" blurRad="76200" dist="19050" dir="5400000">
               <a:srgbClr val="0F2F4E">
-                <a:alpha val="9000"/>
+                <a:alpha val="10000"/>
               </a:srgbClr>
             </a:outerShdw>
           </a:effectLst>
@@ -6803,8 +6803,8 @@
         </p:nvSpPr>
         <p:spPr>
           <a:xfrm>
-            <a:off x="2804099" y="1225296"/>
-            <a:ext cx="173736" cy="173736"/>
+            <a:off x="2822387" y="1243584"/>
+            <a:ext cx="201168" cy="201168"/>
           </a:xfrm>
           <a:prstGeom prst="ellipse">
             <a:avLst/>
@@ -6823,8 +6823,8 @@
         </p:nvSpPr>
         <p:spPr>
           <a:xfrm>
-            <a:off x="2804099" y="1225296"/>
-            <a:ext cx="173736" cy="173736"/>
+            <a:off x="2822387" y="1243584"/>
+            <a:ext cx="201168" cy="201168"/>
           </a:xfrm>
           <a:prstGeom prst="rect">
             <a:avLst/>
@@ -6840,7 +6840,7 @@
               <a:buNone/>
             </a:pPr>
             <a:r>
-              <a:rPr lang="en-US" sz="900" b="1" dirty="0">
+              <a:rPr lang="en-US" sz="1000" b="1" dirty="0">
                 <a:solidFill>
                   <a:srgbClr val="FFFFFF"/>
                 </a:solidFill>
@@ -6850,7 +6850,7 @@
               </a:rPr>
               <a:t>2</a:t>
             </a:r>
-            <a:endParaRPr lang="en-US" sz="900" dirty="0"/>
+            <a:endParaRPr lang="en-US" sz="1000" dirty="0"/>
           </a:p>
         </p:txBody>
       </p:sp>
@@ -6862,8 +6862,8 @@
         </p:nvSpPr>
         <p:spPr>
           <a:xfrm>
-            <a:off x="3050987" y="1207008"/>
-            <a:ext cx="1715963" cy="420624"/>
+            <a:off x="3105851" y="1225296"/>
+            <a:ext cx="1642811" cy="475488"/>
           </a:xfrm>
           <a:prstGeom prst="rect">
             <a:avLst/>
@@ -6877,12 +6877,12 @@
           <a:p>
             <a:pPr algn="l" indent="0" marL="0">
               <a:lnSpc>
-                <a:spcPct val="110000"/>
+                <a:spcPct val="112000"/>
               </a:lnSpc>
               <a:buNone/>
             </a:pPr>
             <a:r>
-              <a:rPr lang="en-US" sz="900" b="1" dirty="0">
+              <a:rPr lang="en-US" sz="1000" b="1" dirty="0">
                 <a:solidFill>
                   <a:srgbClr val="17223A"/>
                 </a:solidFill>
@@ -6892,7 +6892,7 @@
               </a:rPr>
               <a:t>¿El soporte de EVERTEC atiende oportunamente?</a:t>
             </a:r>
-            <a:endParaRPr lang="en-US" sz="900" dirty="0"/>
+            <a:endParaRPr lang="en-US" sz="1000" dirty="0"/>
           </a:p>
         </p:txBody>
       </p:sp>
@@ -6903,8 +6903,8 @@
           <p:nvPr/>
         </p:nvGraphicFramePr>
         <p:xfrm>
-          <a:off x="2712659" y="1645920"/>
-          <a:ext cx="2145731" cy="1033272"/>
+          <a:off x="2721803" y="1737360"/>
+          <a:ext cx="2127443" cy="1472184"/>
         </p:xfrm>
         <a:graphic xmlns:a="http://schemas.openxmlformats.org/drawingml/2006/main">
           <a:graphicData uri="http://schemas.openxmlformats.org/drawingml/2006/chart">
@@ -6921,11 +6921,11 @@
         <p:spPr>
           <a:xfrm>
             <a:off x="5004694" y="1133856"/>
-            <a:ext cx="2182307" cy="1600200"/>
+            <a:ext cx="2182307" cy="2148840"/>
           </a:xfrm>
           <a:prstGeom prst="roundRect">
             <a:avLst>
-              <a:gd name="adj" fmla="val 3429"/>
+              <a:gd name="adj" fmla="val 2979"/>
             </a:avLst>
           </a:prstGeom>
           <a:solidFill>
@@ -6938,9 +6938,9 @@
             <a:prstDash val="solid"/>
           </a:ln>
           <a:effectLst>
-            <a:outerShdw sx="100000" sy="100000" kx="0" ky="0" algn="bl" rotWithShape="0" blurRad="63500" dist="19050" dir="5400000">
+            <a:outerShdw sx="100000" sy="100000" kx="0" ky="0" algn="bl" rotWithShape="0" blurRad="76200" dist="19050" dir="5400000">
               <a:srgbClr val="0F2F4E">
-                <a:alpha val="9000"/>
+                <a:alpha val="10000"/>
               </a:srgbClr>
             </a:outerShdw>
           </a:effectLst>
@@ -6954,8 +6954,8 @@
         </p:nvSpPr>
         <p:spPr>
           <a:xfrm>
-            <a:off x="5114422" y="1225296"/>
-            <a:ext cx="173736" cy="173736"/>
+            <a:off x="5132710" y="1243584"/>
+            <a:ext cx="201168" cy="201168"/>
           </a:xfrm>
           <a:prstGeom prst="ellipse">
             <a:avLst/>
@@ -6974,8 +6974,8 @@
         </p:nvSpPr>
         <p:spPr>
           <a:xfrm>
-            <a:off x="5114422" y="1225296"/>
-            <a:ext cx="173736" cy="173736"/>
+            <a:off x="5132710" y="1243584"/>
+            <a:ext cx="201168" cy="201168"/>
           </a:xfrm>
           <a:prstGeom prst="rect">
             <a:avLst/>
@@ -6991,7 +6991,7 @@
               <a:buNone/>
             </a:pPr>
             <a:r>
-              <a:rPr lang="en-US" sz="900" b="1" dirty="0">
+              <a:rPr lang="en-US" sz="1000" b="1" dirty="0">
                 <a:solidFill>
                   <a:srgbClr val="FFFFFF"/>
                 </a:solidFill>
@@ -7001,7 +7001,7 @@
               </a:rPr>
               <a:t>3</a:t>
             </a:r>
-            <a:endParaRPr lang="en-US" sz="900" dirty="0"/>
+            <a:endParaRPr lang="en-US" sz="1000" dirty="0"/>
           </a:p>
         </p:txBody>
       </p:sp>
@@ -7013,8 +7013,8 @@
         </p:nvSpPr>
         <p:spPr>
           <a:xfrm>
-            <a:off x="5361310" y="1207008"/>
-            <a:ext cx="1715963" cy="420624"/>
+            <a:off x="5416174" y="1225296"/>
+            <a:ext cx="1642811" cy="475488"/>
           </a:xfrm>
           <a:prstGeom prst="rect">
             <a:avLst/>
@@ -7028,12 +7028,12 @@
           <a:p>
             <a:pPr algn="l" indent="0" marL="0">
               <a:lnSpc>
-                <a:spcPct val="110000"/>
+                <a:spcPct val="112000"/>
               </a:lnSpc>
               <a:buNone/>
             </a:pPr>
             <a:r>
-              <a:rPr lang="en-US" sz="900" b="1" dirty="0">
+              <a:rPr lang="en-US" sz="1000" b="1" dirty="0">
                 <a:solidFill>
                   <a:srgbClr val="17223A"/>
                 </a:solidFill>
@@ -7043,7 +7043,7 @@
               </a:rPr>
               <a:t>¿Con qué frecuencia hay reclamos de asociados?</a:t>
             </a:r>
-            <a:endParaRPr lang="en-US" sz="900" dirty="0"/>
+            <a:endParaRPr lang="en-US" sz="1000" dirty="0"/>
           </a:p>
         </p:txBody>
       </p:sp>
@@ -7054,8 +7054,8 @@
           <p:nvPr/>
         </p:nvGraphicFramePr>
         <p:xfrm>
-          <a:off x="5022982" y="1645920"/>
-          <a:ext cx="2145731" cy="1033272"/>
+          <a:off x="5032126" y="1737360"/>
+          <a:ext cx="2127443" cy="1472184"/>
         </p:xfrm>
         <a:graphic xmlns:a="http://schemas.openxmlformats.org/drawingml/2006/main">
           <a:graphicData uri="http://schemas.openxmlformats.org/drawingml/2006/chart">
@@ -7072,11 +7072,11 @@
         <p:spPr>
           <a:xfrm>
             <a:off x="7315017" y="1133856"/>
-            <a:ext cx="2182307" cy="1600200"/>
+            <a:ext cx="2182307" cy="2148840"/>
           </a:xfrm>
           <a:prstGeom prst="roundRect">
             <a:avLst>
-              <a:gd name="adj" fmla="val 3429"/>
+              <a:gd name="adj" fmla="val 2979"/>
             </a:avLst>
           </a:prstGeom>
           <a:solidFill>
@@ -7089,9 +7089,9 @@
             <a:prstDash val="solid"/>
           </a:ln>
           <a:effectLst>
-            <a:outerShdw sx="100000" sy="100000" kx="0" ky="0" algn="bl" rotWithShape="0" blurRad="63500" dist="19050" dir="5400000">
+            <a:outerShdw sx="100000" sy="100000" kx="0" ky="0" algn="bl" rotWithShape="0" blurRad="76200" dist="19050" dir="5400000">
               <a:srgbClr val="0F2F4E">
-                <a:alpha val="9000"/>
+                <a:alpha val="10000"/>
               </a:srgbClr>
             </a:outerShdw>
           </a:effectLst>
@@ -7105,8 +7105,8 @@
         </p:nvSpPr>
         <p:spPr>
           <a:xfrm>
-            <a:off x="7424745" y="1225296"/>
-            <a:ext cx="173736" cy="173736"/>
+            <a:off x="7443033" y="1243584"/>
+            <a:ext cx="201168" cy="201168"/>
           </a:xfrm>
           <a:prstGeom prst="ellipse">
             <a:avLst/>
@@ -7125,8 +7125,8 @@
         </p:nvSpPr>
         <p:spPr>
           <a:xfrm>
-            <a:off x="7424745" y="1225296"/>
-            <a:ext cx="173736" cy="173736"/>
+            <a:off x="7443033" y="1243584"/>
+            <a:ext cx="201168" cy="201168"/>
           </a:xfrm>
           <a:prstGeom prst="rect">
             <a:avLst/>
@@ -7142,7 +7142,7 @@
               <a:buNone/>
             </a:pPr>
             <a:r>
-              <a:rPr lang="en-US" sz="900" b="1" dirty="0">
+              <a:rPr lang="en-US" sz="1000" b="1" dirty="0">
                 <a:solidFill>
                   <a:srgbClr val="FFFFFF"/>
                 </a:solidFill>
@@ -7152,7 +7152,7 @@
               </a:rPr>
               <a:t>4</a:t>
             </a:r>
-            <a:endParaRPr lang="en-US" sz="900" dirty="0"/>
+            <a:endParaRPr lang="en-US" sz="1000" dirty="0"/>
           </a:p>
         </p:txBody>
       </p:sp>
@@ -7164,8 +7164,8 @@
         </p:nvSpPr>
         <p:spPr>
           <a:xfrm>
-            <a:off x="7671633" y="1207008"/>
-            <a:ext cx="1715963" cy="420624"/>
+            <a:off x="7726497" y="1225296"/>
+            <a:ext cx="1642811" cy="475488"/>
           </a:xfrm>
           <a:prstGeom prst="rect">
             <a:avLst/>
@@ -7179,12 +7179,12 @@
           <a:p>
             <a:pPr algn="l" indent="0" marL="0">
               <a:lnSpc>
-                <a:spcPct val="110000"/>
+                <a:spcPct val="112000"/>
               </a:lnSpc>
               <a:buNone/>
             </a:pPr>
             <a:r>
-              <a:rPr lang="en-US" sz="900" b="1" dirty="0">
+              <a:rPr lang="en-US" sz="1000" b="1" dirty="0">
                 <a:solidFill>
                   <a:srgbClr val="17223A"/>
                 </a:solidFill>
@@ -7194,7 +7194,7 @@
               </a:rPr>
               <a:t>¿Qué tan fácil es gestionar incidencias/reversas?</a:t>
             </a:r>
-            <a:endParaRPr lang="en-US" sz="900" dirty="0"/>
+            <a:endParaRPr lang="en-US" sz="1000" dirty="0"/>
           </a:p>
         </p:txBody>
       </p:sp>
@@ -7205,8 +7205,8 @@
           <p:nvPr/>
         </p:nvGraphicFramePr>
         <p:xfrm>
-          <a:off x="7333305" y="1645920"/>
-          <a:ext cx="2145731" cy="1033272"/>
+          <a:off x="7342449" y="1737360"/>
+          <a:ext cx="2127443" cy="1472184"/>
         </p:xfrm>
         <a:graphic xmlns:a="http://schemas.openxmlformats.org/drawingml/2006/main">
           <a:graphicData uri="http://schemas.openxmlformats.org/drawingml/2006/chart">
@@ -7223,11 +7223,11 @@
         <p:spPr>
           <a:xfrm>
             <a:off x="9625340" y="1133856"/>
-            <a:ext cx="2182307" cy="1600200"/>
+            <a:ext cx="2182307" cy="2148840"/>
           </a:xfrm>
           <a:prstGeom prst="roundRect">
             <a:avLst>
-              <a:gd name="adj" fmla="val 3429"/>
+              <a:gd name="adj" fmla="val 2979"/>
             </a:avLst>
           </a:prstGeom>
           <a:solidFill>
@@ -7240,9 +7240,9 @@
             <a:prstDash val="solid"/>
           </a:ln>
           <a:effectLst>
-            <a:outerShdw sx="100000" sy="100000" kx="0" ky="0" algn="bl" rotWithShape="0" blurRad="63500" dist="19050" dir="5400000">
+            <a:outerShdw sx="100000" sy="100000" kx="0" ky="0" algn="bl" rotWithShape="0" blurRad="76200" dist="19050" dir="5400000">
               <a:srgbClr val="0F2F4E">
-                <a:alpha val="9000"/>
+                <a:alpha val="10000"/>
               </a:srgbClr>
             </a:outerShdw>
           </a:effectLst>
@@ -7256,8 +7256,8 @@
         </p:nvSpPr>
         <p:spPr>
           <a:xfrm>
-            <a:off x="9735068" y="1225296"/>
-            <a:ext cx="173736" cy="173736"/>
+            <a:off x="9753356" y="1243584"/>
+            <a:ext cx="201168" cy="201168"/>
           </a:xfrm>
           <a:prstGeom prst="ellipse">
             <a:avLst/>
@@ -7276,8 +7276,8 @@
         </p:nvSpPr>
         <p:spPr>
           <a:xfrm>
-            <a:off x="9735068" y="1225296"/>
-            <a:ext cx="173736" cy="173736"/>
+            <a:off x="9753356" y="1243584"/>
+            <a:ext cx="201168" cy="201168"/>
           </a:xfrm>
           <a:prstGeom prst="rect">
             <a:avLst/>
@@ -7293,7 +7293,7 @@
               <a:buNone/>
             </a:pPr>
             <a:r>
-              <a:rPr lang="en-US" sz="900" b="1" dirty="0">
+              <a:rPr lang="en-US" sz="1000" b="1" dirty="0">
                 <a:solidFill>
                   <a:srgbClr val="FFFFFF"/>
                 </a:solidFill>
@@ -7303,7 +7303,7 @@
               </a:rPr>
               <a:t>5</a:t>
             </a:r>
-            <a:endParaRPr lang="en-US" sz="900" dirty="0"/>
+            <a:endParaRPr lang="en-US" sz="1000" dirty="0"/>
           </a:p>
         </p:txBody>
       </p:sp>
@@ -7315,8 +7315,8 @@
         </p:nvSpPr>
         <p:spPr>
           <a:xfrm>
-            <a:off x="9981956" y="1207008"/>
-            <a:ext cx="1715963" cy="420624"/>
+            <a:off x="10036820" y="1225296"/>
+            <a:ext cx="1642811" cy="475488"/>
           </a:xfrm>
           <a:prstGeom prst="rect">
             <a:avLst/>
@@ -7330,12 +7330,12 @@
           <a:p>
             <a:pPr algn="l" indent="0" marL="0">
               <a:lnSpc>
-                <a:spcPct val="110000"/>
+                <a:spcPct val="112000"/>
               </a:lnSpc>
               <a:buNone/>
             </a:pPr>
             <a:r>
-              <a:rPr lang="en-US" sz="900" b="1" dirty="0">
+              <a:rPr lang="en-US" sz="1000" b="1" dirty="0">
                 <a:solidFill>
                   <a:srgbClr val="17223A"/>
                 </a:solidFill>
@@ -7345,7 +7345,7 @@
               </a:rPr>
               <a:t>Calificación general del servicio (escala 1–5)</a:t>
             </a:r>
-            <a:endParaRPr lang="en-US" sz="900" dirty="0"/>
+            <a:endParaRPr lang="en-US" sz="1000" dirty="0"/>
           </a:p>
         </p:txBody>
       </p:sp>
@@ -7356,8 +7356,8 @@
           <p:nvPr/>
         </p:nvGraphicFramePr>
         <p:xfrm>
-          <a:off x="9643628" y="1645920"/>
-          <a:ext cx="2145731" cy="905256"/>
+          <a:off x="9652772" y="1737360"/>
+          <a:ext cx="2127443" cy="1325880"/>
         </p:xfrm>
         <a:graphic xmlns:a="http://schemas.openxmlformats.org/drawingml/2006/main">
           <a:graphicData uri="http://schemas.openxmlformats.org/drawingml/2006/chart">
@@ -7373,8 +7373,8 @@
         </p:nvSpPr>
         <p:spPr>
           <a:xfrm>
-            <a:off x="9735068" y="2551176"/>
-            <a:ext cx="1962851" cy="164592"/>
+            <a:off x="9753356" y="3063240"/>
+            <a:ext cx="1926275" cy="182880"/>
           </a:xfrm>
           <a:prstGeom prst="rect">
             <a:avLst/>
@@ -7390,7 +7390,7 @@
               <a:buNone/>
             </a:pPr>
             <a:r>
-              <a:rPr lang="en-US" sz="800" b="1" dirty="0">
+              <a:rPr lang="en-US" sz="950" b="1" dirty="0">
                 <a:solidFill>
                   <a:srgbClr val="133B6C"/>
                 </a:solidFill>
@@ -7400,7 +7400,7 @@
               </a:rPr>
               <a:t>Promedio: 3.82 / 5</a:t>
             </a:r>
-            <a:endParaRPr lang="en-US" sz="800" dirty="0"/>
+            <a:endParaRPr lang="en-US" sz="950" dirty="0"/>
           </a:p>
         </p:txBody>
       </p:sp>
@@ -7412,12 +7412,12 @@
         </p:nvSpPr>
         <p:spPr>
           <a:xfrm>
-            <a:off x="384048" y="2880360"/>
-            <a:ext cx="11423599" cy="384048"/>
+            <a:off x="384048" y="3410712"/>
+            <a:ext cx="11423599" cy="292608"/>
           </a:xfrm>
           <a:prstGeom prst="roundRect">
             <a:avLst>
-              <a:gd name="adj" fmla="val 14286"/>
+              <a:gd name="adj" fmla="val 18750"/>
             </a:avLst>
           </a:prstGeom>
           <a:solidFill>
@@ -7434,8 +7434,8 @@
         </p:nvSpPr>
         <p:spPr>
           <a:xfrm>
-            <a:off x="548640" y="2880360"/>
-            <a:ext cx="11094415" cy="384048"/>
+            <a:off x="530352" y="3410712"/>
+            <a:ext cx="11130991" cy="292608"/>
           </a:xfrm>
           <a:prstGeom prst="rect">
             <a:avLst/>
@@ -7451,7 +7451,7 @@
               <a:buNone/>
             </a:pPr>
             <a:r>
-              <a:rPr lang="en-US" sz="1200" b="1" dirty="0">
+              <a:rPr lang="en-US" sz="1000" b="1" dirty="0">
                 <a:solidFill>
                   <a:srgbClr val="FFFFFF"/>
                 </a:solidFill>
@@ -7465,7 +7465,7 @@
               <a:buNone/>
             </a:pPr>
             <a:r>
-              <a:rPr lang="en-US" sz="1000" i="1" dirty="0">
+              <a:rPr lang="en-US" sz="850" i="1" dirty="0">
                 <a:solidFill>
                   <a:srgbClr val="97D8DB"/>
                 </a:solidFill>
@@ -7475,7 +7475,7 @@
               </a:rPr>
               <a:t>"¿Qué problemas, inconvenientes o situaciones relacionadas con el procesamiento de tarjetas de crédito considera que deberían mejorarse?" — 17 respuestas</a:t>
             </a:r>
-            <a:endParaRPr lang="en-US" sz="1200" dirty="0"/>
+            <a:endParaRPr lang="en-US" sz="1000" dirty="0"/>
           </a:p>
         </p:txBody>
       </p:sp>
@@ -7487,8 +7487,8 @@
         </p:nvSpPr>
         <p:spPr>
           <a:xfrm>
-            <a:off x="384048" y="3264408"/>
-            <a:ext cx="11423599" cy="3447288"/>
+            <a:off x="384048" y="3703320"/>
+            <a:ext cx="11423599" cy="3026664"/>
           </a:xfrm>
           <a:prstGeom prst="rect">
             <a:avLst/>
@@ -7512,8 +7512,8 @@
         </p:nvSpPr>
         <p:spPr>
           <a:xfrm>
-            <a:off x="566928" y="3392424"/>
-            <a:ext cx="5391760" cy="3227832"/>
+            <a:off x="548640" y="3794760"/>
+            <a:ext cx="5419192" cy="2862072"/>
           </a:xfrm>
           <a:prstGeom prst="rect">
             <a:avLst/>
@@ -7527,12 +7527,12 @@
           <a:p>
             <a:pPr algn="l" indent="0" marL="0">
               <a:lnSpc>
-                <a:spcPct val="112000"/>
+                <a:spcPct val="106000"/>
               </a:lnSpc>
               <a:buNone/>
             </a:pPr>
             <a:r>
-              <a:rPr lang="en-US" sz="900" b="1" dirty="0">
+              <a:rPr lang="en-US" sz="820" b="1" dirty="0">
                 <a:solidFill>
                   <a:srgbClr val="133B6C"/>
                 </a:solidFill>
@@ -7544,12 +7544,12 @@
             </a:r>
             <a:pPr algn="l" indent="0" marL="0">
               <a:lnSpc>
-                <a:spcPct val="112000"/>
+                <a:spcPct val="106000"/>
               </a:lnSpc>
               <a:buNone/>
             </a:pPr>
             <a:r>
-              <a:rPr lang="en-US" sz="900" dirty="0">
+              <a:rPr lang="en-US" sz="820" dirty="0">
                 <a:solidFill>
                   <a:srgbClr val="243044"/>
                 </a:solidFill>
@@ -7559,26 +7559,26 @@
               </a:rPr>
               <a:t>La comunicación con la plataforma de EVERTEC, principalmente en el monto de reversas —en ocasiones EVERTEC no las acepta, pero en nuestro sistema sí se realizó la reversa— así como la duplicidad de pagos debido a la fluctuación de la plataforma.</a:t>
             </a:r>
-            <a:endParaRPr lang="en-US" sz="900" dirty="0"/>
+            <a:endParaRPr lang="en-US" sz="820" dirty="0"/>
           </a:p>
           <a:p>
             <a:pPr algn="l" indent="0" marL="0">
               <a:lnSpc>
-                <a:spcPct val="112000"/>
+                <a:spcPct val="106000"/>
               </a:lnSpc>
               <a:buNone/>
             </a:pPr>
-            <a:endParaRPr lang="en-US" sz="900" dirty="0"/>
+            <a:endParaRPr lang="en-US" sz="820" dirty="0"/>
           </a:p>
           <a:p>
             <a:pPr algn="l" indent="0" marL="0">
               <a:lnSpc>
-                <a:spcPct val="112000"/>
+                <a:spcPct val="106000"/>
               </a:lnSpc>
               <a:buNone/>
             </a:pPr>
             <a:r>
-              <a:rPr lang="en-US" sz="900" b="1" dirty="0">
+              <a:rPr lang="en-US" sz="820" b="1" dirty="0">
                 <a:solidFill>
                   <a:srgbClr val="133B6C"/>
                 </a:solidFill>
@@ -7590,12 +7590,12 @@
             </a:r>
             <a:pPr algn="l" indent="0" marL="0">
               <a:lnSpc>
-                <a:spcPct val="112000"/>
+                <a:spcPct val="106000"/>
               </a:lnSpc>
               <a:buNone/>
             </a:pPr>
             <a:r>
-              <a:rPr lang="en-US" sz="900" dirty="0">
+              <a:rPr lang="en-US" sz="820" dirty="0">
                 <a:solidFill>
                   <a:srgbClr val="243044"/>
                 </a:solidFill>
@@ -7605,26 +7605,26 @@
               </a:rPr>
               <a:t>Comunicación con EVERTEC.</a:t>
             </a:r>
-            <a:endParaRPr lang="en-US" sz="900" dirty="0"/>
+            <a:endParaRPr lang="en-US" sz="820" dirty="0"/>
           </a:p>
           <a:p>
             <a:pPr algn="l" indent="0" marL="0">
               <a:lnSpc>
-                <a:spcPct val="112000"/>
+                <a:spcPct val="106000"/>
               </a:lnSpc>
               <a:buNone/>
             </a:pPr>
-            <a:endParaRPr lang="en-US" sz="900" dirty="0"/>
+            <a:endParaRPr lang="en-US" sz="820" dirty="0"/>
           </a:p>
           <a:p>
             <a:pPr algn="l" indent="0" marL="0">
               <a:lnSpc>
-                <a:spcPct val="112000"/>
+                <a:spcPct val="106000"/>
               </a:lnSpc>
               <a:buNone/>
             </a:pPr>
             <a:r>
-              <a:rPr lang="en-US" sz="900" b="1" dirty="0">
+              <a:rPr lang="en-US" sz="820" b="1" dirty="0">
                 <a:solidFill>
                   <a:srgbClr val="133B6C"/>
                 </a:solidFill>
@@ -7636,12 +7636,12 @@
             </a:r>
             <a:pPr algn="l" indent="0" marL="0">
               <a:lnSpc>
-                <a:spcPct val="112000"/>
+                <a:spcPct val="106000"/>
               </a:lnSpc>
               <a:buNone/>
             </a:pPr>
             <a:r>
-              <a:rPr lang="en-US" sz="900" dirty="0">
+              <a:rPr lang="en-US" sz="820" dirty="0">
                 <a:solidFill>
                   <a:srgbClr val="243044"/>
                 </a:solidFill>
@@ -7651,26 +7651,26 @@
               </a:rPr>
               <a:t>N/A.</a:t>
             </a:r>
-            <a:endParaRPr lang="en-US" sz="900" dirty="0"/>
+            <a:endParaRPr lang="en-US" sz="820" dirty="0"/>
           </a:p>
           <a:p>
             <a:pPr algn="l" indent="0" marL="0">
               <a:lnSpc>
-                <a:spcPct val="112000"/>
+                <a:spcPct val="106000"/>
               </a:lnSpc>
               <a:buNone/>
             </a:pPr>
-            <a:endParaRPr lang="en-US" sz="900" dirty="0"/>
+            <a:endParaRPr lang="en-US" sz="820" dirty="0"/>
           </a:p>
           <a:p>
             <a:pPr algn="l" indent="0" marL="0">
               <a:lnSpc>
-                <a:spcPct val="112000"/>
+                <a:spcPct val="106000"/>
               </a:lnSpc>
               <a:buNone/>
             </a:pPr>
             <a:r>
-              <a:rPr lang="en-US" sz="900" b="1" dirty="0">
+              <a:rPr lang="en-US" sz="820" b="1" dirty="0">
                 <a:solidFill>
                   <a:srgbClr val="133B6C"/>
                 </a:solidFill>
@@ -7682,12 +7682,12 @@
             </a:r>
             <a:pPr algn="l" indent="0" marL="0">
               <a:lnSpc>
-                <a:spcPct val="112000"/>
+                <a:spcPct val="106000"/>
               </a:lnSpc>
               <a:buNone/>
             </a:pPr>
             <a:r>
-              <a:rPr lang="en-US" sz="900" dirty="0">
+              <a:rPr lang="en-US" sz="820" dirty="0">
                 <a:solidFill>
                   <a:srgbClr val="243044"/>
                 </a:solidFill>
@@ -7697,26 +7697,26 @@
               </a:rPr>
               <a:t>Siempre recibo ayuda.</a:t>
             </a:r>
-            <a:endParaRPr lang="en-US" sz="900" dirty="0"/>
+            <a:endParaRPr lang="en-US" sz="820" dirty="0"/>
           </a:p>
           <a:p>
             <a:pPr algn="l" indent="0" marL="0">
               <a:lnSpc>
-                <a:spcPct val="112000"/>
+                <a:spcPct val="106000"/>
               </a:lnSpc>
               <a:buNone/>
             </a:pPr>
-            <a:endParaRPr lang="en-US" sz="900" dirty="0"/>
+            <a:endParaRPr lang="en-US" sz="820" dirty="0"/>
           </a:p>
           <a:p>
             <a:pPr algn="l" indent="0" marL="0">
               <a:lnSpc>
-                <a:spcPct val="112000"/>
+                <a:spcPct val="106000"/>
               </a:lnSpc>
               <a:buNone/>
             </a:pPr>
             <a:r>
-              <a:rPr lang="en-US" sz="900" b="1" dirty="0">
+              <a:rPr lang="en-US" sz="820" b="1" dirty="0">
                 <a:solidFill>
                   <a:srgbClr val="133B6C"/>
                 </a:solidFill>
@@ -7728,12 +7728,12 @@
             </a:r>
             <a:pPr algn="l" indent="0" marL="0">
               <a:lnSpc>
-                <a:spcPct val="112000"/>
+                <a:spcPct val="106000"/>
               </a:lnSpc>
               <a:buNone/>
             </a:pPr>
             <a:r>
-              <a:rPr lang="en-US" sz="900" dirty="0">
+              <a:rPr lang="en-US" sz="820" dirty="0">
                 <a:solidFill>
                   <a:srgbClr val="243044"/>
                 </a:solidFill>
@@ -7743,26 +7743,26 @@
               </a:rPr>
               <a:t>Que cuando se olvida a los cajeros la clave, EVERTEC la reinicie, porque a veces cuesta que nos solucionen en tarjeta.</a:t>
             </a:r>
-            <a:endParaRPr lang="en-US" sz="900" dirty="0"/>
+            <a:endParaRPr lang="en-US" sz="820" dirty="0"/>
           </a:p>
           <a:p>
             <a:pPr algn="l" indent="0" marL="0">
               <a:lnSpc>
-                <a:spcPct val="112000"/>
+                <a:spcPct val="106000"/>
               </a:lnSpc>
               <a:buNone/>
             </a:pPr>
-            <a:endParaRPr lang="en-US" sz="900" dirty="0"/>
+            <a:endParaRPr lang="en-US" sz="820" dirty="0"/>
           </a:p>
           <a:p>
             <a:pPr algn="l" indent="0" marL="0">
               <a:lnSpc>
-                <a:spcPct val="112000"/>
+                <a:spcPct val="106000"/>
               </a:lnSpc>
               <a:buNone/>
             </a:pPr>
             <a:r>
-              <a:rPr lang="en-US" sz="900" b="1" dirty="0">
+              <a:rPr lang="en-US" sz="820" b="1" dirty="0">
                 <a:solidFill>
                   <a:srgbClr val="133B6C"/>
                 </a:solidFill>
@@ -7774,12 +7774,12 @@
             </a:r>
             <a:pPr algn="l" indent="0" marL="0">
               <a:lnSpc>
-                <a:spcPct val="112000"/>
+                <a:spcPct val="106000"/>
               </a:lnSpc>
               <a:buNone/>
             </a:pPr>
             <a:r>
-              <a:rPr lang="en-US" sz="900" dirty="0">
+              <a:rPr lang="en-US" sz="820" dirty="0">
                 <a:solidFill>
                   <a:srgbClr val="243044"/>
                 </a:solidFill>
@@ -7789,26 +7789,26 @@
               </a:rPr>
               <a:t>No contestan los números de soporte que están en la TC; se pierde frecuentemente la comunicación con EVERTEC. Los asociados indican que los plásticos dan bastante inconveniente al querer realizar compras; se realizan reposiciones muy frecuentemente porque el plástico no funciona, y el proceso de reposición es muy tardado.</a:t>
             </a:r>
-            <a:endParaRPr lang="en-US" sz="900" dirty="0"/>
+            <a:endParaRPr lang="en-US" sz="820" dirty="0"/>
           </a:p>
           <a:p>
             <a:pPr algn="l" indent="0" marL="0">
               <a:lnSpc>
-                <a:spcPct val="112000"/>
+                <a:spcPct val="106000"/>
               </a:lnSpc>
               <a:buNone/>
             </a:pPr>
-            <a:endParaRPr lang="en-US" sz="900" dirty="0"/>
+            <a:endParaRPr lang="en-US" sz="820" dirty="0"/>
           </a:p>
           <a:p>
             <a:pPr algn="l" indent="0" marL="0">
               <a:lnSpc>
-                <a:spcPct val="112000"/>
+                <a:spcPct val="106000"/>
               </a:lnSpc>
               <a:buNone/>
             </a:pPr>
             <a:r>
-              <a:rPr lang="en-US" sz="900" b="1" dirty="0">
+              <a:rPr lang="en-US" sz="820" b="1" dirty="0">
                 <a:solidFill>
                   <a:srgbClr val="133B6C"/>
                 </a:solidFill>
@@ -7820,12 +7820,12 @@
             </a:r>
             <a:pPr algn="l" indent="0" marL="0">
               <a:lnSpc>
-                <a:spcPct val="112000"/>
+                <a:spcPct val="106000"/>
               </a:lnSpc>
               <a:buNone/>
             </a:pPr>
             <a:r>
-              <a:rPr lang="en-US" sz="900" dirty="0">
+              <a:rPr lang="en-US" sz="820" dirty="0">
                 <a:solidFill>
                   <a:srgbClr val="243044"/>
                 </a:solidFill>
@@ -7835,26 +7835,26 @@
               </a:rPr>
               <a:t>Se recomienda que las promociones por descuentos en supermercados y combustible se reflejen en el estado de cuenta con una descripción específica del beneficio otorgado. Actualmente se registran solo como "Nota de Crédito", lo que genera confusión sobre el origen del descuento.</a:t>
             </a:r>
-            <a:endParaRPr lang="en-US" sz="900" dirty="0"/>
+            <a:endParaRPr lang="en-US" sz="820" dirty="0"/>
           </a:p>
           <a:p>
             <a:pPr algn="l" indent="0" marL="0">
               <a:lnSpc>
-                <a:spcPct val="112000"/>
+                <a:spcPct val="106000"/>
               </a:lnSpc>
               <a:buNone/>
             </a:pPr>
-            <a:endParaRPr lang="en-US" sz="900" dirty="0"/>
+            <a:endParaRPr lang="en-US" sz="820" dirty="0"/>
           </a:p>
           <a:p>
             <a:pPr algn="l" indent="0" marL="0">
               <a:lnSpc>
-                <a:spcPct val="112000"/>
+                <a:spcPct val="106000"/>
               </a:lnSpc>
               <a:buNone/>
             </a:pPr>
             <a:r>
-              <a:rPr lang="en-US" sz="900" b="1" dirty="0">
+              <a:rPr lang="en-US" sz="820" b="1" dirty="0">
                 <a:solidFill>
                   <a:srgbClr val="133B6C"/>
                 </a:solidFill>
@@ -7866,12 +7866,12 @@
             </a:r>
             <a:pPr algn="l" indent="0" marL="0">
               <a:lnSpc>
-                <a:spcPct val="112000"/>
+                <a:spcPct val="106000"/>
               </a:lnSpc>
               <a:buNone/>
             </a:pPr>
             <a:r>
-              <a:rPr lang="en-US" sz="900" dirty="0">
+              <a:rPr lang="en-US" sz="820" dirty="0">
                 <a:solidFill>
                   <a:srgbClr val="243044"/>
                 </a:solidFill>
@@ -7881,7 +7881,7 @@
               </a:rPr>
               <a:t>La conexión con EVERTEC algunas veces falla.</a:t>
             </a:r>
-            <a:endParaRPr lang="en-US" sz="900" dirty="0"/>
+            <a:endParaRPr lang="en-US" sz="820" dirty="0"/>
           </a:p>
         </p:txBody>
       </p:sp>
@@ -7893,8 +7893,8 @@
         </p:nvSpPr>
         <p:spPr>
           <a:xfrm>
-            <a:off x="6233008" y="3392424"/>
-            <a:ext cx="5391760" cy="3227832"/>
+            <a:off x="6223864" y="3794760"/>
+            <a:ext cx="5419192" cy="2862072"/>
           </a:xfrm>
           <a:prstGeom prst="rect">
             <a:avLst/>
@@ -7908,12 +7908,12 @@
           <a:p>
             <a:pPr algn="l" indent="0" marL="0">
               <a:lnSpc>
-                <a:spcPct val="112000"/>
+                <a:spcPct val="106000"/>
               </a:lnSpc>
               <a:buNone/>
             </a:pPr>
             <a:r>
-              <a:rPr lang="en-US" sz="900" b="1" dirty="0">
+              <a:rPr lang="en-US" sz="820" b="1" dirty="0">
                 <a:solidFill>
                   <a:srgbClr val="133B6C"/>
                 </a:solidFill>
@@ -7925,12 +7925,12 @@
             </a:r>
             <a:pPr algn="l" indent="0" marL="0">
               <a:lnSpc>
-                <a:spcPct val="112000"/>
+                <a:spcPct val="106000"/>
               </a:lnSpc>
               <a:buNone/>
             </a:pPr>
             <a:r>
-              <a:rPr lang="en-US" sz="900" dirty="0">
+              <a:rPr lang="en-US" sz="820" dirty="0">
                 <a:solidFill>
                   <a:srgbClr val="243044"/>
                 </a:solidFill>
@@ -7940,26 +7940,26 @@
               </a:rPr>
               <a:t>Tiempos de respuesta en fechas de pago.</a:t>
             </a:r>
-            <a:endParaRPr lang="en-US" sz="900" dirty="0"/>
+            <a:endParaRPr lang="en-US" sz="820" dirty="0"/>
           </a:p>
           <a:p>
             <a:pPr algn="l" indent="0" marL="0">
               <a:lnSpc>
-                <a:spcPct val="112000"/>
+                <a:spcPct val="106000"/>
               </a:lnSpc>
               <a:buNone/>
             </a:pPr>
-            <a:endParaRPr lang="en-US" sz="900" dirty="0"/>
+            <a:endParaRPr lang="en-US" sz="820" dirty="0"/>
           </a:p>
           <a:p>
             <a:pPr algn="l" indent="0" marL="0">
               <a:lnSpc>
-                <a:spcPct val="112000"/>
+                <a:spcPct val="106000"/>
               </a:lnSpc>
               <a:buNone/>
             </a:pPr>
             <a:r>
-              <a:rPr lang="en-US" sz="900" b="1" dirty="0">
+              <a:rPr lang="en-US" sz="820" b="1" dirty="0">
                 <a:solidFill>
                   <a:srgbClr val="133B6C"/>
                 </a:solidFill>
@@ -7971,12 +7971,12 @@
             </a:r>
             <a:pPr algn="l" indent="0" marL="0">
               <a:lnSpc>
-                <a:spcPct val="112000"/>
+                <a:spcPct val="106000"/>
               </a:lnSpc>
               <a:buNone/>
             </a:pPr>
             <a:r>
-              <a:rPr lang="en-US" sz="900" dirty="0">
+              <a:rPr lang="en-US" sz="820" dirty="0">
                 <a:solidFill>
                   <a:srgbClr val="243044"/>
                 </a:solidFill>
@@ -7986,26 +7986,26 @@
               </a:rPr>
               <a:t>Caídas de sistema que a veces no se resuelven pronto.</a:t>
             </a:r>
-            <a:endParaRPr lang="en-US" sz="900" dirty="0"/>
+            <a:endParaRPr lang="en-US" sz="820" dirty="0"/>
           </a:p>
           <a:p>
             <a:pPr algn="l" indent="0" marL="0">
               <a:lnSpc>
-                <a:spcPct val="112000"/>
+                <a:spcPct val="106000"/>
               </a:lnSpc>
               <a:buNone/>
             </a:pPr>
-            <a:endParaRPr lang="en-US" sz="900" dirty="0"/>
+            <a:endParaRPr lang="en-US" sz="820" dirty="0"/>
           </a:p>
           <a:p>
             <a:pPr algn="l" indent="0" marL="0">
               <a:lnSpc>
-                <a:spcPct val="112000"/>
+                <a:spcPct val="106000"/>
               </a:lnSpc>
               <a:buNone/>
             </a:pPr>
             <a:r>
-              <a:rPr lang="en-US" sz="900" b="1" dirty="0">
+              <a:rPr lang="en-US" sz="820" b="1" dirty="0">
                 <a:solidFill>
                   <a:srgbClr val="133B6C"/>
                 </a:solidFill>
@@ -8017,12 +8017,12 @@
             </a:r>
             <a:pPr algn="l" indent="0" marL="0">
               <a:lnSpc>
-                <a:spcPct val="112000"/>
+                <a:spcPct val="106000"/>
               </a:lnSpc>
               <a:buNone/>
             </a:pPr>
             <a:r>
-              <a:rPr lang="en-US" sz="900" dirty="0">
+              <a:rPr lang="en-US" sz="820" dirty="0">
                 <a:solidFill>
                   <a:srgbClr val="243044"/>
                 </a:solidFill>
@@ -8032,26 +8032,26 @@
               </a:rPr>
               <a:t>El tiempo de resolución; aprobaciones automáticas para asociados calificados sin tanta documentación; tiempo de entrega; acreditación de puntos por promociones dentro de las fechas correspondientes.</a:t>
             </a:r>
-            <a:endParaRPr lang="en-US" sz="900" dirty="0"/>
+            <a:endParaRPr lang="en-US" sz="820" dirty="0"/>
           </a:p>
           <a:p>
             <a:pPr algn="l" indent="0" marL="0">
               <a:lnSpc>
-                <a:spcPct val="112000"/>
+                <a:spcPct val="106000"/>
               </a:lnSpc>
               <a:buNone/>
             </a:pPr>
-            <a:endParaRPr lang="en-US" sz="900" dirty="0"/>
+            <a:endParaRPr lang="en-US" sz="820" dirty="0"/>
           </a:p>
           <a:p>
             <a:pPr algn="l" indent="0" marL="0">
               <a:lnSpc>
-                <a:spcPct val="112000"/>
+                <a:spcPct val="106000"/>
               </a:lnSpc>
               <a:buNone/>
             </a:pPr>
             <a:r>
-              <a:rPr lang="en-US" sz="900" b="1" dirty="0">
+              <a:rPr lang="en-US" sz="820" b="1" dirty="0">
                 <a:solidFill>
                   <a:srgbClr val="133B6C"/>
                 </a:solidFill>
@@ -8063,12 +8063,12 @@
             </a:r>
             <a:pPr algn="l" indent="0" marL="0">
               <a:lnSpc>
-                <a:spcPct val="112000"/>
+                <a:spcPct val="106000"/>
               </a:lnSpc>
               <a:buNone/>
             </a:pPr>
             <a:r>
-              <a:rPr lang="en-US" sz="900" dirty="0">
+              <a:rPr lang="en-US" sz="820" dirty="0">
                 <a:solidFill>
                   <a:srgbClr val="243044"/>
                 </a:solidFill>
@@ -8078,26 +8078,26 @@
               </a:rPr>
               <a:t>Las duplicidades en los pagos cuando hay caídas de sistema: en SISCARD lo toma y en el sistema de COMÉDICA no aparece procesado.</a:t>
             </a:r>
-            <a:endParaRPr lang="en-US" sz="900" dirty="0"/>
+            <a:endParaRPr lang="en-US" sz="820" dirty="0"/>
           </a:p>
           <a:p>
             <a:pPr algn="l" indent="0" marL="0">
               <a:lnSpc>
-                <a:spcPct val="112000"/>
+                <a:spcPct val="106000"/>
               </a:lnSpc>
               <a:buNone/>
             </a:pPr>
-            <a:endParaRPr lang="en-US" sz="900" dirty="0"/>
+            <a:endParaRPr lang="en-US" sz="820" dirty="0"/>
           </a:p>
           <a:p>
             <a:pPr algn="l" indent="0" marL="0">
               <a:lnSpc>
-                <a:spcPct val="112000"/>
+                <a:spcPct val="106000"/>
               </a:lnSpc>
               <a:buNone/>
             </a:pPr>
             <a:r>
-              <a:rPr lang="en-US" sz="900" b="1" dirty="0">
+              <a:rPr lang="en-US" sz="820" b="1" dirty="0">
                 <a:solidFill>
                   <a:srgbClr val="133B6C"/>
                 </a:solidFill>
@@ -8109,12 +8109,12 @@
             </a:r>
             <a:pPr algn="l" indent="0" marL="0">
               <a:lnSpc>
-                <a:spcPct val="112000"/>
+                <a:spcPct val="106000"/>
               </a:lnSpc>
               <a:buNone/>
             </a:pPr>
             <a:r>
-              <a:rPr lang="en-US" sz="900" dirty="0">
+              <a:rPr lang="en-US" sz="820" dirty="0">
                 <a:solidFill>
                   <a:srgbClr val="243044"/>
                 </a:solidFill>
@@ -8124,26 +8124,26 @@
               </a:rPr>
               <a:t>Mejorar la rapidez de respuesta del sistema al cambiar de pantalla o seleccionar las diferentes opciones dentro del módulo.</a:t>
             </a:r>
-            <a:endParaRPr lang="en-US" sz="900" dirty="0"/>
+            <a:endParaRPr lang="en-US" sz="820" dirty="0"/>
           </a:p>
           <a:p>
             <a:pPr algn="l" indent="0" marL="0">
               <a:lnSpc>
-                <a:spcPct val="112000"/>
+                <a:spcPct val="106000"/>
               </a:lnSpc>
               <a:buNone/>
             </a:pPr>
-            <a:endParaRPr lang="en-US" sz="900" dirty="0"/>
+            <a:endParaRPr lang="en-US" sz="820" dirty="0"/>
           </a:p>
           <a:p>
             <a:pPr algn="l" indent="0" marL="0">
               <a:lnSpc>
-                <a:spcPct val="112000"/>
+                <a:spcPct val="106000"/>
               </a:lnSpc>
               <a:buNone/>
             </a:pPr>
             <a:r>
-              <a:rPr lang="en-US" sz="900" b="1" dirty="0">
+              <a:rPr lang="en-US" sz="820" b="1" dirty="0">
                 <a:solidFill>
                   <a:srgbClr val="133B6C"/>
                 </a:solidFill>
@@ -8155,12 +8155,12 @@
             </a:r>
             <a:pPr algn="l" indent="0" marL="0">
               <a:lnSpc>
-                <a:spcPct val="112000"/>
+                <a:spcPct val="106000"/>
               </a:lnSpc>
               <a:buNone/>
             </a:pPr>
             <a:r>
-              <a:rPr lang="en-US" sz="900" dirty="0">
+              <a:rPr lang="en-US" sz="820" dirty="0">
                 <a:solidFill>
                   <a:srgbClr val="243044"/>
                 </a:solidFill>
@@ -8170,26 +8170,26 @@
               </a:rPr>
               <a:t>El tiempo de respuesta para aplicación de compras en flotantes, tanto de TC como TD.</a:t>
             </a:r>
-            <a:endParaRPr lang="en-US" sz="900" dirty="0"/>
+            <a:endParaRPr lang="en-US" sz="820" dirty="0"/>
           </a:p>
           <a:p>
             <a:pPr algn="l" indent="0" marL="0">
               <a:lnSpc>
-                <a:spcPct val="112000"/>
+                <a:spcPct val="106000"/>
               </a:lnSpc>
               <a:buNone/>
             </a:pPr>
-            <a:endParaRPr lang="en-US" sz="900" dirty="0"/>
+            <a:endParaRPr lang="en-US" sz="820" dirty="0"/>
           </a:p>
           <a:p>
             <a:pPr algn="l" indent="0" marL="0">
               <a:lnSpc>
-                <a:spcPct val="112000"/>
+                <a:spcPct val="106000"/>
               </a:lnSpc>
               <a:buNone/>
             </a:pPr>
             <a:r>
-              <a:rPr lang="en-US" sz="900" b="1" dirty="0">
+              <a:rPr lang="en-US" sz="820" b="1" dirty="0">
                 <a:solidFill>
                   <a:srgbClr val="133B6C"/>
                 </a:solidFill>
@@ -8201,12 +8201,12 @@
             </a:r>
             <a:pPr algn="l" indent="0" marL="0">
               <a:lnSpc>
-                <a:spcPct val="112000"/>
+                <a:spcPct val="106000"/>
               </a:lnSpc>
               <a:buNone/>
             </a:pPr>
             <a:r>
-              <a:rPr lang="en-US" sz="900" dirty="0">
+              <a:rPr lang="en-US" sz="820" dirty="0">
                 <a:solidFill>
                   <a:srgbClr val="243044"/>
                 </a:solidFill>
@@ -8216,26 +8216,26 @@
               </a:rPr>
               <a:t>Todo bien.</a:t>
             </a:r>
-            <a:endParaRPr lang="en-US" sz="900" dirty="0"/>
+            <a:endParaRPr lang="en-US" sz="820" dirty="0"/>
           </a:p>
           <a:p>
             <a:pPr algn="l" indent="0" marL="0">
               <a:lnSpc>
-                <a:spcPct val="112000"/>
+                <a:spcPct val="106000"/>
               </a:lnSpc>
               <a:buNone/>
             </a:pPr>
-            <a:endParaRPr lang="en-US" sz="900" dirty="0"/>
+            <a:endParaRPr lang="en-US" sz="820" dirty="0"/>
           </a:p>
           <a:p>
             <a:pPr algn="l" indent="0" marL="0">
               <a:lnSpc>
-                <a:spcPct val="112000"/>
+                <a:spcPct val="106000"/>
               </a:lnSpc>
               <a:buNone/>
             </a:pPr>
             <a:r>
-              <a:rPr lang="en-US" sz="900" b="1" dirty="0">
+              <a:rPr lang="en-US" sz="820" b="1" dirty="0">
                 <a:solidFill>
                   <a:srgbClr val="133B6C"/>
                 </a:solidFill>
@@ -8247,12 +8247,12 @@
             </a:r>
             <a:pPr algn="l" indent="0" marL="0">
               <a:lnSpc>
-                <a:spcPct val="112000"/>
+                <a:spcPct val="106000"/>
               </a:lnSpc>
               <a:buNone/>
             </a:pPr>
             <a:r>
-              <a:rPr lang="en-US" sz="900" dirty="0">
+              <a:rPr lang="en-US" sz="820" dirty="0">
                 <a:solidFill>
                   <a:srgbClr val="243044"/>
                 </a:solidFill>
@@ -8262,26 +8262,26 @@
               </a:rPr>
               <a:t>Las reversas de transacción.</a:t>
             </a:r>
-            <a:endParaRPr lang="en-US" sz="900" dirty="0"/>
+            <a:endParaRPr lang="en-US" sz="820" dirty="0"/>
           </a:p>
           <a:p>
             <a:pPr algn="l" indent="0" marL="0">
               <a:lnSpc>
-                <a:spcPct val="112000"/>
+                <a:spcPct val="106000"/>
               </a:lnSpc>
               <a:buNone/>
             </a:pPr>
-            <a:endParaRPr lang="en-US" sz="900" dirty="0"/>
+            <a:endParaRPr lang="en-US" sz="820" dirty="0"/>
           </a:p>
           <a:p>
             <a:pPr algn="l" indent="0" marL="0">
               <a:lnSpc>
-                <a:spcPct val="112000"/>
+                <a:spcPct val="106000"/>
               </a:lnSpc>
               <a:buNone/>
             </a:pPr>
             <a:r>
-              <a:rPr lang="en-US" sz="900" b="1" dirty="0">
+              <a:rPr lang="en-US" sz="820" b="1" dirty="0">
                 <a:solidFill>
                   <a:srgbClr val="133B6C"/>
                 </a:solidFill>
@@ -8293,12 +8293,12 @@
             </a:r>
             <a:pPr algn="l" indent="0" marL="0">
               <a:lnSpc>
-                <a:spcPct val="112000"/>
+                <a:spcPct val="106000"/>
               </a:lnSpc>
               <a:buNone/>
             </a:pPr>
             <a:r>
-              <a:rPr lang="en-US" sz="900" dirty="0">
+              <a:rPr lang="en-US" sz="820" dirty="0">
                 <a:solidFill>
                   <a:srgbClr val="243044"/>
                 </a:solidFill>
@@ -8308,7 +8308,7 @@
               </a:rPr>
               <a:t>Los cajeros no tienen acceso para ver el saldo de tarjetas de crédito adicionales; los reclamos por contracargos deberían ser atendidos solo por el depto. de TC; y mejorar la gestión de fraude y el reporte de compras fraudulentas.</a:t>
             </a:r>
-            <a:endParaRPr lang="en-US" sz="900" dirty="0"/>
+            <a:endParaRPr lang="en-US" sz="820" dirty="0"/>
           </a:p>
         </p:txBody>
       </p:sp>

</xml_diff>

<commit_message>
Add third slide with native charts summarizing slide 1's metrics
New slide 3: two doughnut charts (Calificación General 3.82/5,
Calificaciones Favorables 88%) and two horizontal bar charts
(Oportunidades de Mejora por Prioridad: Alta/Media/Baja counts;
Fortalezas vs. Oportunidades balance), all matching the deck's
established navy/red/amber/green style.

Co-Authored-By: Claude Sonnet 5 <noreply@anthropic.com>
Claude-Session: https://claude.ai/code/session_01KND4cYnTdx53ydNLfQdR3S
</commit_message>
<xml_diff>
--- a/Dashboard_Ejecutivo_EVERTEC_JuntaDirectiva.pptx
+++ b/Dashboard_Ejecutivo_EVERTEC_JuntaDirectiva.pptx
@@ -7,9 +7,10 @@
   <p:sldIdLst>
     <p:sldId id="256" r:id="rId2"/>
     <p:sldId id="257" r:id="rId3"/>
+    <p:sldId id="258" r:id="rId4"/>
   </p:sldIdLst>
   <p:notesMasterIdLst>
-    <p:notesMasterId r:id="rId4"/>
+    <p:notesMasterId r:id="rId5"/>
   </p:notesMasterIdLst>
   <p:sldSz cx="12191695" cy="6858000"/>
   <p:notesSz cx="6858000" cy="12191695"/>
@@ -1476,6 +1477,945 @@
 </c:chartSpace>
 </file>
 
+<file path=ppt/charts/chart6.xml><?xml version="1.0" encoding="utf-8"?>
+<c:chartSpace xmlns:c="http://schemas.openxmlformats.org/drawingml/2006/chart" xmlns:a="http://schemas.openxmlformats.org/drawingml/2006/main" xmlns:r="http://schemas.openxmlformats.org/officeDocument/2006/relationships">
+  <c:date1904 val="0"/>
+  <c:roundedCorners val="1"/>
+  <c:chart>
+    <c:autoTitleDeleted val="1"/>
+    <c:plotArea>
+      <c:layout/>
+      <c:doughnutChart>
+        <c:varyColors val="1"/>
+        <c:ser>
+          <c:idx val="0"/>
+          <c:order val="0"/>
+          <c:tx>
+            <c:strRef>
+              <c:f>Sheet1!$B$1</c:f>
+              <c:strCache>
+                <c:ptCount val="1"/>
+                <c:pt idx="0">
+                  <c:v/>
+                </c:pt>
+              </c:strCache>
+            </c:strRef>
+          </c:tx>
+          <c:spPr>
+            <a:solidFill>
+              <a:schemeClr val="accent1"/>
+            </a:solidFill>
+            <a:ln w="9525" cap="flat">
+              <a:solidFill>
+                <a:srgbClr val="F9F9F9"/>
+              </a:solidFill>
+              <a:prstDash val="solid"/>
+              <a:round/>
+            </a:ln>
+            <a:effectLst/>
+          </c:spPr>
+          <c:dPt>
+            <c:idx val="0"/>
+            <c:bubble3D val="0"/>
+            <c:spPr>
+              <a:solidFill>
+                <a:srgbClr val="A6650F"/>
+              </a:solidFill>
+              <a:ln w="19050" cap="flat">
+                <a:solidFill>
+                  <a:srgbClr val="FFFFFF"/>
+                </a:solidFill>
+                <a:prstDash val="solid"/>
+                <a:round/>
+              </a:ln>
+              <a:effectLst/>
+            </c:spPr>
+          </c:dPt>
+          <c:dPt>
+            <c:idx val="1"/>
+            <c:bubble3D val="0"/>
+            <c:spPr>
+              <a:solidFill>
+                <a:srgbClr val="EDEFF3"/>
+              </a:solidFill>
+              <a:ln w="19050" cap="flat">
+                <a:solidFill>
+                  <a:srgbClr val="FFFFFF"/>
+                </a:solidFill>
+                <a:prstDash val="solid"/>
+                <a:round/>
+              </a:ln>
+              <a:effectLst/>
+            </c:spPr>
+          </c:dPt>
+          <c:dLbls>
+            <c:dLbl>
+              <c:idx val="0"/>
+              <c:numFmt formatCode="General" sourceLinked="0"/>
+              <c:spPr/>
+              <c:txPr>
+                <a:bodyPr/>
+                <a:lstStyle/>
+                <a:p>
+                  <a:pPr>
+                    <a:defRPr sz="1200" b="0" i="0" u="none" strike="noStrike">
+                      <a:solidFill>
+                        <a:srgbClr val="000000"/>
+                      </a:solidFill>
+                      <a:latin typeface="Arial"/>
+                    </a:defRPr>
+                  </a:pPr>
+                </a:p>
+              </c:txPr>
+              <c:showLegendKey val="0"/>
+              <c:showVal val="0"/>
+              <c:showCatName val="0"/>
+              <c:showSerName val="0"/>
+              <c:showPercent val="0"/>
+              <c:showBubbleSize val="0"/>
+            </c:dLbl>
+            <c:dLbl>
+              <c:idx val="1"/>
+              <c:numFmt formatCode="General" sourceLinked="0"/>
+              <c:spPr/>
+              <c:txPr>
+                <a:bodyPr/>
+                <a:lstStyle/>
+                <a:p>
+                  <a:pPr>
+                    <a:defRPr sz="1200" b="0" i="0" u="none" strike="noStrike">
+                      <a:solidFill>
+                        <a:srgbClr val="000000"/>
+                      </a:solidFill>
+                      <a:latin typeface="Arial"/>
+                    </a:defRPr>
+                  </a:pPr>
+                </a:p>
+              </c:txPr>
+              <c:showLegendKey val="0"/>
+              <c:showVal val="0"/>
+              <c:showCatName val="0"/>
+              <c:showSerName val="0"/>
+              <c:showPercent val="0"/>
+              <c:showBubbleSize val="0"/>
+            </c:dLbl>
+            <c:numFmt formatCode="General" sourceLinked="0"/>
+            <c:txPr>
+              <a:bodyPr/>
+              <a:lstStyle/>
+              <a:p>
+                <a:pPr>
+                  <a:defRPr sz="1800" b="0" i="0" u="none" strike="noStrike">
+                    <a:solidFill>
+                      <a:srgbClr val="000000"/>
+                    </a:solidFill>
+                    <a:latin typeface="Arial"/>
+                  </a:defRPr>
+                </a:pPr>
+              </a:p>
+            </c:txPr>
+            <c:showLegendKey val="0"/>
+            <c:showVal val="0"/>
+            <c:showCatName val="1"/>
+            <c:showSerName val="0"/>
+            <c:showPercent val="1"/>
+            <c:showBubbleSize val="0"/>
+            <c:showLeaderLines val="0"/>
+          </c:dLbls>
+          <c:cat>
+            <c:strRef>
+              <c:f>Sheet1!$A$2:$A$3</c:f>
+              <c:strCache>
+                <c:ptCount val="2"/>
+                <c:pt idx="0">
+                  <c:v>Calificación General Promedio</c:v>
+                </c:pt>
+                <c:pt idx="1">
+                  <c:v/>
+                </c:pt>
+              </c:strCache>
+            </c:strRef>
+          </c:cat>
+          <c:val>
+            <c:numRef>
+              <c:f>Sheet1!$B$2:$B$3</c:f>
+              <c:numCache>
+                <c:ptCount val="2"/>
+                <c:pt idx="0">
+                  <c:v>76.4</c:v>
+                </c:pt>
+                <c:pt idx="1">
+                  <c:v>23.599999999999994</c:v>
+                </c:pt>
+              </c:numCache>
+            </c:numRef>
+          </c:val>
+        </c:ser>
+        <c:firstSliceAng val="0"/>
+        <c:holeSize val="68"/>
+      </c:doughnutChart>
+      <c:spPr>
+        <a:noFill/>
+        <a:ln>
+          <a:noFill/>
+        </a:ln>
+        <a:effectLst/>
+      </c:spPr>
+    </c:plotArea>
+    <c:plotVisOnly val="1"/>
+    <c:dispBlanksAs val="span"/>
+  </c:chart>
+  <c:spPr>
+    <a:noFill/>
+    <a:ln>
+      <a:noFill/>
+    </a:ln>
+    <a:effectLst/>
+  </c:spPr>
+  <c:externalData r:id="rId1">
+    <c:autoUpdate val="0"/>
+  </c:externalData>
+</c:chartSpace>
+</file>
+
+<file path=ppt/charts/chart7.xml><?xml version="1.0" encoding="utf-8"?>
+<c:chartSpace xmlns:c="http://schemas.openxmlformats.org/drawingml/2006/chart" xmlns:a="http://schemas.openxmlformats.org/drawingml/2006/main" xmlns:r="http://schemas.openxmlformats.org/officeDocument/2006/relationships">
+  <c:date1904 val="0"/>
+  <c:roundedCorners val="1"/>
+  <c:chart>
+    <c:autoTitleDeleted val="1"/>
+    <c:plotArea>
+      <c:layout/>
+      <c:doughnutChart>
+        <c:varyColors val="1"/>
+        <c:ser>
+          <c:idx val="0"/>
+          <c:order val="0"/>
+          <c:tx>
+            <c:strRef>
+              <c:f>Sheet1!$B$1</c:f>
+              <c:strCache>
+                <c:ptCount val="1"/>
+                <c:pt idx="0">
+                  <c:v/>
+                </c:pt>
+              </c:strCache>
+            </c:strRef>
+          </c:tx>
+          <c:spPr>
+            <a:solidFill>
+              <a:schemeClr val="accent1"/>
+            </a:solidFill>
+            <a:ln w="9525" cap="flat">
+              <a:solidFill>
+                <a:srgbClr val="F9F9F9"/>
+              </a:solidFill>
+              <a:prstDash val="solid"/>
+              <a:round/>
+            </a:ln>
+            <a:effectLst/>
+          </c:spPr>
+          <c:dPt>
+            <c:idx val="0"/>
+            <c:bubble3D val="0"/>
+            <c:spPr>
+              <a:solidFill>
+                <a:srgbClr val="1E8449"/>
+              </a:solidFill>
+              <a:ln w="19050" cap="flat">
+                <a:solidFill>
+                  <a:srgbClr val="FFFFFF"/>
+                </a:solidFill>
+                <a:prstDash val="solid"/>
+                <a:round/>
+              </a:ln>
+              <a:effectLst/>
+            </c:spPr>
+          </c:dPt>
+          <c:dPt>
+            <c:idx val="1"/>
+            <c:bubble3D val="0"/>
+            <c:spPr>
+              <a:solidFill>
+                <a:srgbClr val="EDEFF3"/>
+              </a:solidFill>
+              <a:ln w="19050" cap="flat">
+                <a:solidFill>
+                  <a:srgbClr val="FFFFFF"/>
+                </a:solidFill>
+                <a:prstDash val="solid"/>
+                <a:round/>
+              </a:ln>
+              <a:effectLst/>
+            </c:spPr>
+          </c:dPt>
+          <c:dLbls>
+            <c:dLbl>
+              <c:idx val="0"/>
+              <c:numFmt formatCode="General" sourceLinked="0"/>
+              <c:spPr/>
+              <c:txPr>
+                <a:bodyPr/>
+                <a:lstStyle/>
+                <a:p>
+                  <a:pPr>
+                    <a:defRPr sz="1200" b="0" i="0" u="none" strike="noStrike">
+                      <a:solidFill>
+                        <a:srgbClr val="000000"/>
+                      </a:solidFill>
+                      <a:latin typeface="Arial"/>
+                    </a:defRPr>
+                  </a:pPr>
+                </a:p>
+              </c:txPr>
+              <c:showLegendKey val="0"/>
+              <c:showVal val="0"/>
+              <c:showCatName val="0"/>
+              <c:showSerName val="0"/>
+              <c:showPercent val="0"/>
+              <c:showBubbleSize val="0"/>
+            </c:dLbl>
+            <c:dLbl>
+              <c:idx val="1"/>
+              <c:numFmt formatCode="General" sourceLinked="0"/>
+              <c:spPr/>
+              <c:txPr>
+                <a:bodyPr/>
+                <a:lstStyle/>
+                <a:p>
+                  <a:pPr>
+                    <a:defRPr sz="1200" b="0" i="0" u="none" strike="noStrike">
+                      <a:solidFill>
+                        <a:srgbClr val="000000"/>
+                      </a:solidFill>
+                      <a:latin typeface="Arial"/>
+                    </a:defRPr>
+                  </a:pPr>
+                </a:p>
+              </c:txPr>
+              <c:showLegendKey val="0"/>
+              <c:showVal val="0"/>
+              <c:showCatName val="0"/>
+              <c:showSerName val="0"/>
+              <c:showPercent val="0"/>
+              <c:showBubbleSize val="0"/>
+            </c:dLbl>
+            <c:numFmt formatCode="General" sourceLinked="0"/>
+            <c:txPr>
+              <a:bodyPr/>
+              <a:lstStyle/>
+              <a:p>
+                <a:pPr>
+                  <a:defRPr sz="1800" b="0" i="0" u="none" strike="noStrike">
+                    <a:solidFill>
+                      <a:srgbClr val="000000"/>
+                    </a:solidFill>
+                    <a:latin typeface="Arial"/>
+                  </a:defRPr>
+                </a:pPr>
+              </a:p>
+            </c:txPr>
+            <c:showLegendKey val="0"/>
+            <c:showVal val="0"/>
+            <c:showCatName val="1"/>
+            <c:showSerName val="0"/>
+            <c:showPercent val="1"/>
+            <c:showBubbleSize val="0"/>
+            <c:showLeaderLines val="0"/>
+          </c:dLbls>
+          <c:cat>
+            <c:strRef>
+              <c:f>Sheet1!$A$2:$A$3</c:f>
+              <c:strCache>
+                <c:ptCount val="2"/>
+                <c:pt idx="0">
+                  <c:v>Calificaciones Favorables</c:v>
+                </c:pt>
+                <c:pt idx="1">
+                  <c:v/>
+                </c:pt>
+              </c:strCache>
+            </c:strRef>
+          </c:cat>
+          <c:val>
+            <c:numRef>
+              <c:f>Sheet1!$B$2:$B$3</c:f>
+              <c:numCache>
+                <c:ptCount val="2"/>
+                <c:pt idx="0">
+                  <c:v>88</c:v>
+                </c:pt>
+                <c:pt idx="1">
+                  <c:v>12</c:v>
+                </c:pt>
+              </c:numCache>
+            </c:numRef>
+          </c:val>
+        </c:ser>
+        <c:firstSliceAng val="0"/>
+        <c:holeSize val="68"/>
+      </c:doughnutChart>
+      <c:spPr>
+        <a:noFill/>
+        <a:ln>
+          <a:noFill/>
+        </a:ln>
+        <a:effectLst/>
+      </c:spPr>
+    </c:plotArea>
+    <c:plotVisOnly val="1"/>
+    <c:dispBlanksAs val="span"/>
+  </c:chart>
+  <c:spPr>
+    <a:noFill/>
+    <a:ln>
+      <a:noFill/>
+    </a:ln>
+    <a:effectLst/>
+  </c:spPr>
+  <c:externalData r:id="rId1">
+    <c:autoUpdate val="0"/>
+  </c:externalData>
+</c:chartSpace>
+</file>
+
+<file path=ppt/charts/chart8.xml><?xml version="1.0" encoding="utf-8"?>
+<c:chartSpace xmlns:c="http://schemas.openxmlformats.org/drawingml/2006/chart" xmlns:a="http://schemas.openxmlformats.org/drawingml/2006/main" xmlns:r="http://schemas.openxmlformats.org/officeDocument/2006/relationships">
+  <c:date1904 val="0"/>
+  <c:roundedCorners val="1"/>
+  <c:chart>
+    <c:autoTitleDeleted val="1"/>
+    <c:plotArea>
+      <c:layout/>
+      <c:barChart>
+        <c:barDir val="bar"/>
+        <c:grouping val="clustered"/>
+        <c:varyColors val="0"/>
+        <c:ser>
+          <c:idx val="0"/>
+          <c:order val="0"/>
+          <c:tx>
+            <c:strRef>
+              <c:f>Sheet1!$B$1</c:f>
+              <c:strCache>
+                <c:ptCount val="1"/>
+                <c:pt idx="0">
+                  <c:v/>
+                </c:pt>
+              </c:strCache>
+            </c:strRef>
+          </c:tx>
+          <c:spPr>
+            <a:solidFill>
+              <a:srgbClr val="1E8449"/>
+            </a:solidFill>
+            <a:ln w="9525" cap="flat">
+              <a:solidFill>
+                <a:srgbClr val="FFFFFF"/>
+              </a:solidFill>
+              <a:prstDash val="solid"/>
+              <a:round/>
+            </a:ln>
+            <a:effectLst/>
+          </c:spPr>
+          <c:invertIfNegative val="0"/>
+          <c:dLbls>
+            <c:numFmt formatCode="0&quot; items&quot;" sourceLinked="0"/>
+            <c:txPr>
+              <a:bodyPr/>
+              <a:lstStyle/>
+              <a:p>
+                <a:pPr>
+                  <a:defRPr b="0" i="0" strike="noStrike" sz="1100" u="none">
+                    <a:solidFill>
+                      <a:srgbClr val="243044"/>
+                    </a:solidFill>
+                    <a:latin typeface="Calibri"/>
+                  </a:defRPr>
+                </a:pPr>
+              </a:p>
+            </c:txPr>
+            <c:showLegendKey val="0"/>
+            <c:showVal val="1"/>
+            <c:showCatName val="0"/>
+            <c:showSerName val="0"/>
+            <c:showPercent val="0"/>
+            <c:showBubbleSize val="0"/>
+            <c:showLeaderLines val="0"/>
+          </c:dLbls>
+          <c:dPt>
+            <c:idx val="0"/>
+            <c:invertIfNegative val="0"/>
+            <c:bubble3D val="0"/>
+            <c:spPr>
+              <a:solidFill>
+                <a:srgbClr val="1E8449"/>
+              </a:solidFill>
+              <a:effectLst/>
+            </c:spPr>
+          </c:dPt>
+          <c:dPt>
+            <c:idx val="1"/>
+            <c:invertIfNegative val="0"/>
+            <c:bubble3D val="0"/>
+            <c:spPr>
+              <a:solidFill>
+                <a:srgbClr val="A6650F"/>
+              </a:solidFill>
+              <a:effectLst/>
+            </c:spPr>
+          </c:dPt>
+          <c:dPt>
+            <c:idx val="2"/>
+            <c:invertIfNegative val="0"/>
+            <c:bubble3D val="0"/>
+            <c:spPr>
+              <a:solidFill>
+                <a:srgbClr val="E0392B"/>
+              </a:solidFill>
+              <a:effectLst/>
+            </c:spPr>
+          </c:dPt>
+          <c:cat>
+            <c:multiLvlStrRef>
+              <c:f>Sheet1!$A$2:$A$4</c:f>
+              <c:multiLvlStrCache>
+                <c:ptCount val="3"/>
+                <c:lvl>
+                  <c:pt idx="0">
+                    <c:v>Baja</c:v>
+                  </c:pt>
+                  <c:pt idx="1">
+                    <c:v>Media</c:v>
+                  </c:pt>
+                  <c:pt idx="2">
+                    <c:v>Alta</c:v>
+                  </c:pt>
+                </c:lvl>
+              </c:multiLvlStrCache>
+            </c:multiLvlStrRef>
+          </c:cat>
+          <c:val>
+            <c:numRef>
+              <c:f>Sheet1!$B$2:$B$4</c:f>
+              <c:numCache>
+                <c:formatCode>General</c:formatCode>
+                <c:ptCount val="3"/>
+                <c:pt idx="0">
+                  <c:v>2</c:v>
+                </c:pt>
+                <c:pt idx="1">
+                  <c:v>3</c:v>
+                </c:pt>
+                <c:pt idx="2">
+                  <c:v>4</c:v>
+                </c:pt>
+              </c:numCache>
+            </c:numRef>
+          </c:val>
+        </c:ser>
+        <c:dLbls>
+          <c:numFmt formatCode="0&quot; items&quot;" sourceLinked="0"/>
+          <c:txPr>
+            <a:bodyPr/>
+            <a:lstStyle/>
+            <a:p>
+              <a:pPr>
+                <a:defRPr b="0" i="0" strike="noStrike" sz="1100" u="none">
+                  <a:solidFill>
+                    <a:srgbClr val="243044"/>
+                  </a:solidFill>
+                  <a:latin typeface="Calibri"/>
+                </a:defRPr>
+              </a:pPr>
+            </a:p>
+          </c:txPr>
+          <c:showLegendKey val="0"/>
+          <c:showVal val="1"/>
+          <c:showCatName val="0"/>
+          <c:showSerName val="0"/>
+          <c:showPercent val="0"/>
+          <c:showBubbleSize val="0"/>
+          <c:showLeaderLines val="0"/>
+        </c:dLbls>
+        <c:gapWidth val="30"/>
+        <c:overlap val="0"/>
+        <c:axId val="2094734554"/>
+        <c:axId val="2094734552"/>
+        <c:axId val="2094734556"/>
+      </c:barChart>
+      <c:catAx>
+        <c:axId val="2094734554"/>
+        <c:scaling>
+          <c:orientation val="minMax"/>
+        </c:scaling>
+        <c:delete val="0"/>
+        <c:axPos val="l"/>
+        <c:numFmt formatCode="General" sourceLinked="1"/>
+        <c:majorTickMark val="none"/>
+        <c:minorTickMark val="none"/>
+        <c:tickLblPos val="nextTo"/>
+        <c:spPr>
+          <a:ln w="12700" cap="flat">
+            <a:noFill/>
+            <a:prstDash val="solid"/>
+            <a:round/>
+          </a:ln>
+        </c:spPr>
+        <c:txPr>
+          <a:bodyPr/>
+          <a:lstStyle/>
+          <a:p>
+            <a:pPr>
+              <a:defRPr sz="1100" b="0" i="0" u="none" strike="noStrike">
+                <a:solidFill>
+                  <a:srgbClr val="33415A"/>
+                </a:solidFill>
+                <a:latin typeface="Calibri"/>
+              </a:defRPr>
+            </a:pPr>
+            <a:endParaRPr lang="en-US"/>
+          </a:p>
+        </c:txPr>
+        <c:crossAx val="2094734552"/>
+        <c:crosses val="autoZero"/>
+        <c:auto val="1"/>
+        <c:lblAlgn val="ctr"/>
+        <c:noMultiLvlLbl val="1"/>
+      </c:catAx>
+      <c:valAx>
+        <c:axId val="2094734552"/>
+        <c:scaling>
+          <c:orientation val="minMax"/>
+          <c:max val="6"/>
+          <c:min val="0"/>
+        </c:scaling>
+        <c:delete val="1"/>
+        <c:axPos val="b"/>
+        <c:numFmt formatCode="General" sourceLinked="0"/>
+        <c:majorTickMark val="out"/>
+        <c:minorTickMark val="none"/>
+        <c:tickLblPos val="low"/>
+        <c:spPr>
+          <a:ln w="12700" cap="flat">
+            <a:solidFill>
+              <a:srgbClr val="888888"/>
+            </a:solidFill>
+            <a:prstDash val="solid"/>
+            <a:round/>
+          </a:ln>
+        </c:spPr>
+        <c:txPr>
+          <a:bodyPr/>
+          <a:lstStyle/>
+          <a:p>
+            <a:pPr>
+              <a:defRPr sz="1200" b="0" i="0" u="none" strike="noStrike">
+                <a:solidFill>
+                  <a:srgbClr val="000000"/>
+                </a:solidFill>
+                <a:latin typeface="Arial"/>
+              </a:defRPr>
+            </a:pPr>
+            <a:endParaRPr lang="en-US"/>
+          </a:p>
+        </c:txPr>
+        <c:crossAx val="2094734554"/>
+        <c:crosses val="autoZero"/>
+        <c:crossBetween val="between"/>
+      </c:valAx>
+      <c:spPr>
+        <a:solidFill>
+          <a:srgbClr val="FFFFFF">
+            <a:alpha val="0"/>
+          </a:srgbClr>
+        </a:solidFill>
+        <a:ln>
+          <a:noFill/>
+        </a:ln>
+        <a:effectLst/>
+      </c:spPr>
+    </c:plotArea>
+    <c:plotVisOnly val="1"/>
+    <c:dispBlanksAs val="span"/>
+  </c:chart>
+  <c:spPr>
+    <a:solidFill>
+      <a:srgbClr val="FFFFFF">
+        <a:alpha val="0"/>
+      </a:srgbClr>
+    </a:solidFill>
+    <a:ln>
+      <a:noFill/>
+    </a:ln>
+    <a:effectLst/>
+  </c:spPr>
+  <c:externalData r:id="rId1">
+    <c:autoUpdate val="0"/>
+  </c:externalData>
+</c:chartSpace>
+</file>
+
+<file path=ppt/charts/chart9.xml><?xml version="1.0" encoding="utf-8"?>
+<c:chartSpace xmlns:c="http://schemas.openxmlformats.org/drawingml/2006/chart" xmlns:a="http://schemas.openxmlformats.org/drawingml/2006/main" xmlns:r="http://schemas.openxmlformats.org/officeDocument/2006/relationships">
+  <c:date1904 val="0"/>
+  <c:roundedCorners val="1"/>
+  <c:chart>
+    <c:autoTitleDeleted val="1"/>
+    <c:plotArea>
+      <c:layout/>
+      <c:barChart>
+        <c:barDir val="bar"/>
+        <c:grouping val="clustered"/>
+        <c:varyColors val="0"/>
+        <c:ser>
+          <c:idx val="0"/>
+          <c:order val="0"/>
+          <c:tx>
+            <c:strRef>
+              <c:f>Sheet1!$B$1</c:f>
+              <c:strCache>
+                <c:ptCount val="1"/>
+                <c:pt idx="0">
+                  <c:v/>
+                </c:pt>
+              </c:strCache>
+            </c:strRef>
+          </c:tx>
+          <c:spPr>
+            <a:solidFill>
+              <a:srgbClr val="E0392B"/>
+            </a:solidFill>
+            <a:ln w="9525" cap="flat">
+              <a:solidFill>
+                <a:srgbClr val="FFFFFF"/>
+              </a:solidFill>
+              <a:prstDash val="solid"/>
+              <a:round/>
+            </a:ln>
+            <a:effectLst/>
+          </c:spPr>
+          <c:invertIfNegative val="0"/>
+          <c:dLbls>
+            <c:numFmt formatCode="0&quot; items&quot;" sourceLinked="0"/>
+            <c:txPr>
+              <a:bodyPr/>
+              <a:lstStyle/>
+              <a:p>
+                <a:pPr>
+                  <a:defRPr b="0" i="0" strike="noStrike" sz="1100" u="none">
+                    <a:solidFill>
+                      <a:srgbClr val="243044"/>
+                    </a:solidFill>
+                    <a:latin typeface="Calibri"/>
+                  </a:defRPr>
+                </a:pPr>
+              </a:p>
+            </c:txPr>
+            <c:showLegendKey val="0"/>
+            <c:showVal val="1"/>
+            <c:showCatName val="0"/>
+            <c:showSerName val="0"/>
+            <c:showPercent val="0"/>
+            <c:showBubbleSize val="0"/>
+            <c:showLeaderLines val="0"/>
+          </c:dLbls>
+          <c:dPt>
+            <c:idx val="0"/>
+            <c:invertIfNegative val="0"/>
+            <c:bubble3D val="0"/>
+            <c:spPr>
+              <a:solidFill>
+                <a:srgbClr val="E0392B"/>
+              </a:solidFill>
+              <a:effectLst/>
+            </c:spPr>
+          </c:dPt>
+          <c:dPt>
+            <c:idx val="1"/>
+            <c:invertIfNegative val="0"/>
+            <c:bubble3D val="0"/>
+            <c:spPr>
+              <a:solidFill>
+                <a:srgbClr val="1E8449"/>
+              </a:solidFill>
+              <a:effectLst/>
+            </c:spPr>
+          </c:dPt>
+          <c:cat>
+            <c:multiLvlStrRef>
+              <c:f>Sheet1!$A$2:$A$3</c:f>
+              <c:multiLvlStrCache>
+                <c:ptCount val="2"/>
+                <c:lvl>
+                  <c:pt idx="0">
+                    <c:v>Oportunidades de Mejora</c:v>
+                  </c:pt>
+                  <c:pt idx="1">
+                    <c:v>Fortalezas</c:v>
+                  </c:pt>
+                </c:lvl>
+              </c:multiLvlStrCache>
+            </c:multiLvlStrRef>
+          </c:cat>
+          <c:val>
+            <c:numRef>
+              <c:f>Sheet1!$B$2:$B$3</c:f>
+              <c:numCache>
+                <c:formatCode>General</c:formatCode>
+                <c:ptCount val="2"/>
+                <c:pt idx="0">
+                  <c:v>8</c:v>
+                </c:pt>
+                <c:pt idx="1">
+                  <c:v>5</c:v>
+                </c:pt>
+              </c:numCache>
+            </c:numRef>
+          </c:val>
+        </c:ser>
+        <c:dLbls>
+          <c:numFmt formatCode="0&quot; items&quot;" sourceLinked="0"/>
+          <c:txPr>
+            <a:bodyPr/>
+            <a:lstStyle/>
+            <a:p>
+              <a:pPr>
+                <a:defRPr b="0" i="0" strike="noStrike" sz="1100" u="none">
+                  <a:solidFill>
+                    <a:srgbClr val="243044"/>
+                  </a:solidFill>
+                  <a:latin typeface="Calibri"/>
+                </a:defRPr>
+              </a:pPr>
+            </a:p>
+          </c:txPr>
+          <c:showLegendKey val="0"/>
+          <c:showVal val="1"/>
+          <c:showCatName val="0"/>
+          <c:showSerName val="0"/>
+          <c:showPercent val="0"/>
+          <c:showBubbleSize val="0"/>
+          <c:showLeaderLines val="0"/>
+        </c:dLbls>
+        <c:gapWidth val="30"/>
+        <c:overlap val="0"/>
+        <c:axId val="2094734554"/>
+        <c:axId val="2094734552"/>
+        <c:axId val="2094734556"/>
+      </c:barChart>
+      <c:catAx>
+        <c:axId val="2094734554"/>
+        <c:scaling>
+          <c:orientation val="minMax"/>
+        </c:scaling>
+        <c:delete val="0"/>
+        <c:axPos val="l"/>
+        <c:numFmt formatCode="General" sourceLinked="1"/>
+        <c:majorTickMark val="none"/>
+        <c:minorTickMark val="none"/>
+        <c:tickLblPos val="nextTo"/>
+        <c:spPr>
+          <a:ln w="12700" cap="flat">
+            <a:noFill/>
+            <a:prstDash val="solid"/>
+            <a:round/>
+          </a:ln>
+        </c:spPr>
+        <c:txPr>
+          <a:bodyPr/>
+          <a:lstStyle/>
+          <a:p>
+            <a:pPr>
+              <a:defRPr sz="1100" b="0" i="0" u="none" strike="noStrike">
+                <a:solidFill>
+                  <a:srgbClr val="33415A"/>
+                </a:solidFill>
+                <a:latin typeface="Calibri"/>
+              </a:defRPr>
+            </a:pPr>
+            <a:endParaRPr lang="en-US"/>
+          </a:p>
+        </c:txPr>
+        <c:crossAx val="2094734552"/>
+        <c:crosses val="autoZero"/>
+        <c:auto val="1"/>
+        <c:lblAlgn val="ctr"/>
+        <c:noMultiLvlLbl val="1"/>
+      </c:catAx>
+      <c:valAx>
+        <c:axId val="2094734552"/>
+        <c:scaling>
+          <c:orientation val="minMax"/>
+          <c:max val="11"/>
+          <c:min val="0"/>
+        </c:scaling>
+        <c:delete val="1"/>
+        <c:axPos val="b"/>
+        <c:numFmt formatCode="General" sourceLinked="0"/>
+        <c:majorTickMark val="out"/>
+        <c:minorTickMark val="none"/>
+        <c:tickLblPos val="low"/>
+        <c:spPr>
+          <a:ln w="12700" cap="flat">
+            <a:solidFill>
+              <a:srgbClr val="888888"/>
+            </a:solidFill>
+            <a:prstDash val="solid"/>
+            <a:round/>
+          </a:ln>
+        </c:spPr>
+        <c:txPr>
+          <a:bodyPr/>
+          <a:lstStyle/>
+          <a:p>
+            <a:pPr>
+              <a:defRPr sz="1200" b="0" i="0" u="none" strike="noStrike">
+                <a:solidFill>
+                  <a:srgbClr val="000000"/>
+                </a:solidFill>
+                <a:latin typeface="Arial"/>
+              </a:defRPr>
+            </a:pPr>
+            <a:endParaRPr lang="en-US"/>
+          </a:p>
+        </c:txPr>
+        <c:crossAx val="2094734554"/>
+        <c:crosses val="autoZero"/>
+        <c:crossBetween val="between"/>
+      </c:valAx>
+      <c:spPr>
+        <a:solidFill>
+          <a:srgbClr val="FFFFFF">
+            <a:alpha val="0"/>
+          </a:srgbClr>
+        </a:solidFill>
+        <a:ln>
+          <a:noFill/>
+        </a:ln>
+        <a:effectLst/>
+      </c:spPr>
+    </c:plotArea>
+    <c:plotVisOnly val="1"/>
+    <c:dispBlanksAs val="span"/>
+  </c:chart>
+  <c:spPr>
+    <a:solidFill>
+      <a:srgbClr val="FFFFFF">
+        <a:alpha val="0"/>
+      </a:srgbClr>
+    </a:solidFill>
+    <a:ln>
+      <a:noFill/>
+    </a:ln>
+    <a:effectLst/>
+  </c:spPr>
+  <c:externalData r:id="rId1">
+    <c:autoUpdate val="0"/>
+  </c:externalData>
+</c:chartSpace>
+</file>
+
 <file path=ppt/notesMasters/notesMaster1.xml><?xml version="1.0" encoding="utf-8"?>
 <p:notesMaster xmlns:a="http://schemas.openxmlformats.org/drawingml/2006/main" xmlns:r="http://schemas.openxmlformats.org/officeDocument/2006/relationships" xmlns:p="http://schemas.openxmlformats.org/presentationml/2006/main">
   <p:cSld>
@@ -1983,6 +2923,94 @@
             <a:fld id="{F7021451-1387-4CA6-816F-3879F97B5CBC}" type="slidenum">
               <a:rPr lang="en-US"/>
               <a:t>2</a:t>
+            </a:fld>
+            <a:endParaRPr lang="en-US"/>
+          </a:p>
+        </p:txBody>
+      </p:sp>
+    </p:spTree>
+    <p:extLst>
+      <p:ext uri="{BB962C8B-B14F-4D97-AF65-F5344CB8AC3E}">
+        <p14:creationId xmlns:p14="http://schemas.microsoft.com/office/powerpoint/2010/main" val="1024086991"/>
+      </p:ext>
+    </p:extLst>
+  </p:cSld>
+  <p:clrMapOvr>
+    <a:masterClrMapping/>
+  </p:clrMapOvr>
+</p:notes>
+</file>
+
+<file path=ppt/notesSlides/notesSlide3.xml><?xml version="1.0" encoding="utf-8"?>
+<p:notes xmlns:a="http://schemas.openxmlformats.org/drawingml/2006/main" xmlns:r="http://schemas.openxmlformats.org/officeDocument/2006/relationships" xmlns:p="http://schemas.openxmlformats.org/presentationml/2006/main">
+  <p:cSld>
+    <p:spTree>
+      <p:nvGrpSpPr>
+        <p:cNvPr id="1" name=""/>
+        <p:cNvGrpSpPr/>
+        <p:nvPr/>
+      </p:nvGrpSpPr>
+      <p:grpSpPr>
+        <a:xfrm>
+          <a:off x="0" y="0"/>
+          <a:ext cx="0" cy="0"/>
+          <a:chOff x="0" y="0"/>
+          <a:chExt cx="0" cy="0"/>
+        </a:xfrm>
+      </p:grpSpPr>
+      <p:sp>
+        <p:nvSpPr>
+          <p:cNvPr id="2" name="Slide Image Placeholder 1"/>
+          <p:cNvSpPr>
+            <a:spLocks noGrp="1" noRot="1" noChangeAspect="1"/>
+          </p:cNvSpPr>
+          <p:nvPr>
+            <p:ph type="sldImg"/>
+          </p:nvPr>
+        </p:nvSpPr>
+        <p:spPr/>
+      </p:sp>
+      <p:sp>
+        <p:nvSpPr>
+          <p:cNvPr id="3" name="Notes Placeholder 2"/>
+          <p:cNvSpPr>
+            <a:spLocks noGrp="1"/>
+          </p:cNvSpPr>
+          <p:nvPr>
+            <p:ph type="body" idx="1"/>
+          </p:nvPr>
+        </p:nvSpPr>
+        <p:spPr/>
+        <p:txBody>
+          <a:bodyPr/>
+          <a:lstStyle/>
+          <a:p>
+            <a:r>
+              <a:rPr lang="en-US" dirty="0"/>
+              <a:t/>
+            </a:r>
+            <a:endParaRPr lang="en-US" dirty="0"/>
+          </a:p>
+        </p:txBody>
+      </p:sp>
+      <p:sp>
+        <p:nvSpPr>
+          <p:cNvPr id="4" name="Slide Number Placeholder 3"/>
+          <p:cNvSpPr>
+            <a:spLocks noGrp="1"/>
+          </p:cNvSpPr>
+          <p:nvPr>
+            <p:ph type="sldNum" sz="quarter" idx="10"/>
+          </p:nvPr>
+        </p:nvSpPr>
+        <p:spPr/>
+        <p:txBody>
+          <a:bodyPr/>
+          <a:lstStyle/>
+          <a:p>
+            <a:fld id="{F7021451-1387-4CA6-816F-3879F97B5CBC}" type="slidenum">
+              <a:rPr lang="en-US"/>
+              <a:t>3</a:t>
             </a:fld>
             <a:endParaRPr lang="en-US"/>
           </a:p>
@@ -8320,6 +9348,1004 @@
 </p:sld>
 </file>
 
+<file path=ppt/slides/slide3.xml><?xml version="1.0" encoding="utf-8"?>
+<p:sld xmlns:a="http://schemas.openxmlformats.org/drawingml/2006/main" xmlns:r="http://schemas.openxmlformats.org/officeDocument/2006/relationships" xmlns:p="http://schemas.openxmlformats.org/presentationml/2006/main">
+  <p:cSld name="Slide 3">
+    <p:bg>
+      <p:bgPr>
+        <a:solidFill>
+          <a:srgbClr val="FFFFFF"/>
+        </a:solidFill>
+      </p:bgPr>
+    </p:bg>
+    <p:spTree>
+      <p:nvGrpSpPr>
+        <p:cNvPr id="1" name=""/>
+        <p:cNvGrpSpPr/>
+        <p:nvPr/>
+      </p:nvGrpSpPr>
+      <p:grpSpPr>
+        <a:xfrm>
+          <a:off x="0" y="0"/>
+          <a:ext cx="0" cy="0"/>
+          <a:chOff x="0" y="0"/>
+          <a:chExt cx="0" cy="0"/>
+        </a:xfrm>
+      </p:grpSpPr>
+      <p:sp>
+        <p:nvSpPr>
+          <p:cNvPr id="2" name="Text 0"/>
+          <p:cNvSpPr txBox="1"/>
+          <p:nvPr/>
+        </p:nvSpPr>
+        <p:spPr>
+          <a:xfrm>
+            <a:off x="384048" y="219456"/>
+            <a:ext cx="8778240" cy="182880"/>
+          </a:xfrm>
+          <a:prstGeom prst="rect">
+            <a:avLst/>
+          </a:prstGeom>
+          <a:noFill/>
+          <a:ln/>
+        </p:spPr>
+        <p:txBody>
+          <a:bodyPr wrap="square" lIns="0" tIns="0" rIns="0" bIns="0" rtlCol="0" anchor="ctr"/>
+          <a:lstStyle/>
+          <a:p>
+            <a:pPr algn="l" indent="0" marL="0">
+              <a:buNone/>
+            </a:pPr>
+            <a:r>
+              <a:rPr lang="en-US" sz="950" b="1" spc="160" kern="0" dirty="0">
+                <a:solidFill>
+                  <a:srgbClr val="17A9B0"/>
+                </a:solidFill>
+                <a:latin typeface="Calibri" pitchFamily="34" charset="0"/>
+                <a:ea typeface="Calibri" pitchFamily="34" charset="-122"/>
+                <a:cs typeface="Calibri" pitchFamily="34" charset="-120"/>
+              </a:rPr>
+              <a:t>EVALUACIÓN DE SERVICIO  ·  GERENCIA DE TECNOLOGÍA</a:t>
+            </a:r>
+            <a:endParaRPr lang="en-US" sz="950" dirty="0"/>
+          </a:p>
+        </p:txBody>
+      </p:sp>
+      <p:sp>
+        <p:nvSpPr>
+          <p:cNvPr id="3" name="Text 1"/>
+          <p:cNvSpPr txBox="1"/>
+          <p:nvPr/>
+        </p:nvSpPr>
+        <p:spPr>
+          <a:xfrm>
+            <a:off x="384048" y="411480"/>
+            <a:ext cx="9418320" cy="329184"/>
+          </a:xfrm>
+          <a:prstGeom prst="rect">
+            <a:avLst/>
+          </a:prstGeom>
+          <a:noFill/>
+          <a:ln/>
+        </p:spPr>
+        <p:txBody>
+          <a:bodyPr wrap="square" lIns="0" tIns="0" rIns="0" bIns="0" rtlCol="0" anchor="t"/>
+          <a:lstStyle/>
+          <a:p>
+            <a:pPr algn="l" indent="0" marL="0">
+              <a:buNone/>
+            </a:pPr>
+            <a:r>
+              <a:rPr lang="en-US" sz="1700" b="1" dirty="0">
+                <a:solidFill>
+                  <a:srgbClr val="17223A"/>
+                </a:solidFill>
+                <a:latin typeface="Calibri" pitchFamily="34" charset="0"/>
+                <a:ea typeface="Calibri" pitchFamily="34" charset="-122"/>
+                <a:cs typeface="Calibri" pitchFamily="34" charset="-120"/>
+              </a:rPr>
+              <a:t>Resumen Gráfico del Diagnóstico General — EVERTEC</a:t>
+            </a:r>
+            <a:endParaRPr lang="en-US" sz="1700" dirty="0"/>
+          </a:p>
+        </p:txBody>
+      </p:sp>
+      <p:sp>
+        <p:nvSpPr>
+          <p:cNvPr id="4" name="Text 2"/>
+          <p:cNvSpPr txBox="1"/>
+          <p:nvPr/>
+        </p:nvSpPr>
+        <p:spPr>
+          <a:xfrm>
+            <a:off x="384048" y="749808"/>
+            <a:ext cx="9418320" cy="219456"/>
+          </a:xfrm>
+          <a:prstGeom prst="rect">
+            <a:avLst/>
+          </a:prstGeom>
+          <a:noFill/>
+          <a:ln/>
+        </p:spPr>
+        <p:txBody>
+          <a:bodyPr wrap="square" lIns="0" tIns="0" rIns="0" bIns="0" rtlCol="0" anchor="ctr"/>
+          <a:lstStyle/>
+          <a:p>
+            <a:pPr algn="l" indent="0" marL="0">
+              <a:buNone/>
+            </a:pPr>
+            <a:r>
+              <a:rPr lang="en-US" sz="1000" i="1" dirty="0">
+                <a:solidFill>
+                  <a:srgbClr val="5B6B82"/>
+                </a:solidFill>
+                <a:latin typeface="Calibri" pitchFamily="34" charset="0"/>
+                <a:ea typeface="Calibri" pitchFamily="34" charset="-122"/>
+                <a:cs typeface="Calibri" pitchFamily="34" charset="-120"/>
+              </a:rPr>
+              <a:t>Visualización de los indicadores y hallazgos consolidados de la diapositiva de resultados</a:t>
+            </a:r>
+            <a:endParaRPr lang="en-US" sz="1000" dirty="0"/>
+          </a:p>
+        </p:txBody>
+      </p:sp>
+      <p:sp>
+        <p:nvSpPr>
+          <p:cNvPr id="5" name="Shape 3"/>
+          <p:cNvSpPr/>
+          <p:nvPr/>
+        </p:nvSpPr>
+        <p:spPr>
+          <a:xfrm>
+            <a:off x="10436047" y="256032"/>
+            <a:ext cx="1371600" cy="329184"/>
+          </a:xfrm>
+          <a:prstGeom prst="roundRect">
+            <a:avLst>
+              <a:gd name="adj" fmla="val 16667"/>
+            </a:avLst>
+          </a:prstGeom>
+          <a:solidFill>
+            <a:srgbClr val="133B6C"/>
+          </a:solidFill>
+          <a:ln/>
+        </p:spPr>
+      </p:sp>
+      <p:sp>
+        <p:nvSpPr>
+          <p:cNvPr id="6" name="Text 4"/>
+          <p:cNvSpPr txBox="1"/>
+          <p:nvPr/>
+        </p:nvSpPr>
+        <p:spPr>
+          <a:xfrm>
+            <a:off x="10436047" y="256032"/>
+            <a:ext cx="1371600" cy="329184"/>
+          </a:xfrm>
+          <a:prstGeom prst="rect">
+            <a:avLst/>
+          </a:prstGeom>
+          <a:noFill/>
+          <a:ln/>
+        </p:spPr>
+        <p:txBody>
+          <a:bodyPr wrap="square" lIns="0" tIns="0" rIns="0" bIns="0" rtlCol="0" anchor="ctr"/>
+          <a:lstStyle/>
+          <a:p>
+            <a:pPr algn="ctr" indent="0" marL="0">
+              <a:buNone/>
+            </a:pPr>
+            <a:r>
+              <a:rPr lang="en-US" sz="900" b="1" dirty="0">
+                <a:solidFill>
+                  <a:srgbClr val="FFFFFF"/>
+                </a:solidFill>
+                <a:latin typeface="Calibri" pitchFamily="34" charset="0"/>
+                <a:ea typeface="Calibri" pitchFamily="34" charset="-122"/>
+                <a:cs typeface="Calibri" pitchFamily="34" charset="-120"/>
+              </a:rPr>
+              <a:t>17 RESPUESTAS</a:t>
+            </a:r>
+            <a:endParaRPr lang="en-US" sz="900" dirty="0"/>
+          </a:p>
+        </p:txBody>
+      </p:sp>
+      <p:sp>
+        <p:nvSpPr>
+          <p:cNvPr id="7" name="Shape 5"/>
+          <p:cNvSpPr/>
+          <p:nvPr/>
+        </p:nvSpPr>
+        <p:spPr>
+          <a:xfrm>
+            <a:off x="384048" y="1005840"/>
+            <a:ext cx="11423599" cy="16459"/>
+          </a:xfrm>
+          <a:prstGeom prst="rect">
+            <a:avLst/>
+          </a:prstGeom>
+          <a:solidFill>
+            <a:srgbClr val="17A9B0"/>
+          </a:solidFill>
+          <a:ln/>
+        </p:spPr>
+      </p:sp>
+      <p:sp>
+        <p:nvSpPr>
+          <p:cNvPr id="8" name="Shape 6"/>
+          <p:cNvSpPr/>
+          <p:nvPr/>
+        </p:nvSpPr>
+        <p:spPr>
+          <a:xfrm>
+            <a:off x="384048" y="1170432"/>
+            <a:ext cx="5620360" cy="2660904"/>
+          </a:xfrm>
+          <a:prstGeom prst="roundRect">
+            <a:avLst>
+              <a:gd name="adj" fmla="val 2749"/>
+            </a:avLst>
+          </a:prstGeom>
+          <a:solidFill>
+            <a:srgbClr val="FFFFFF"/>
+          </a:solidFill>
+          <a:ln w="9525">
+            <a:solidFill>
+              <a:srgbClr val="E7EAF0"/>
+            </a:solidFill>
+            <a:prstDash val="solid"/>
+          </a:ln>
+          <a:effectLst>
+            <a:outerShdw sx="100000" sy="100000" kx="0" ky="0" algn="bl" rotWithShape="0" blurRad="76200" dist="19050" dir="5400000">
+              <a:srgbClr val="0F2F4E">
+                <a:alpha val="10000"/>
+              </a:srgbClr>
+            </a:outerShdw>
+          </a:effectLst>
+        </p:spPr>
+      </p:sp>
+      <p:sp>
+        <p:nvSpPr>
+          <p:cNvPr id="9" name="Shape 7"/>
+          <p:cNvSpPr/>
+          <p:nvPr/>
+        </p:nvSpPr>
+        <p:spPr>
+          <a:xfrm>
+            <a:off x="384048" y="1170432"/>
+            <a:ext cx="5620360" cy="45720"/>
+          </a:xfrm>
+          <a:prstGeom prst="rect">
+            <a:avLst/>
+          </a:prstGeom>
+          <a:solidFill>
+            <a:srgbClr val="A6650F"/>
+          </a:solidFill>
+          <a:ln/>
+        </p:spPr>
+      </p:sp>
+      <p:sp>
+        <p:nvSpPr>
+          <p:cNvPr id="10" name="Shape 8"/>
+          <p:cNvSpPr/>
+          <p:nvPr/>
+        </p:nvSpPr>
+        <p:spPr>
+          <a:xfrm>
+            <a:off x="548640" y="1316736"/>
+            <a:ext cx="274320" cy="274320"/>
+          </a:xfrm>
+          <a:prstGeom prst="ellipse">
+            <a:avLst/>
+          </a:prstGeom>
+          <a:solidFill>
+            <a:srgbClr val="FCF1E0"/>
+          </a:solidFill>
+          <a:ln/>
+        </p:spPr>
+      </p:sp>
+      <p:pic>
+        <p:nvPicPr>
+          <p:cNvPr id="11" name="Image 0" descr="/tmp/claude-0/-home-user-riesgo/579fb8c8-70e5-51d5-80ec-6ed51cc2e8df/scratchpad/pptx-build/icons/star_A6650F.png">    </p:cNvPr>
+          <p:cNvPicPr>
+            <a:picLocks noChangeAspect="1"/>
+          </p:cNvPicPr>
+          <p:nvPr/>
+        </p:nvPicPr>
+        <p:blipFill>
+          <a:blip r:embed="rId1"/>
+          <a:stretch>
+            <a:fillRect/>
+          </a:stretch>
+        </p:blipFill>
+        <p:spPr>
+          <a:xfrm>
+            <a:off x="603504" y="1371600"/>
+            <a:ext cx="164592" cy="164592"/>
+          </a:xfrm>
+          <a:prstGeom prst="rect">
+            <a:avLst/>
+          </a:prstGeom>
+        </p:spPr>
+      </p:pic>
+      <p:sp>
+        <p:nvSpPr>
+          <p:cNvPr id="12" name="Text 9"/>
+          <p:cNvSpPr txBox="1"/>
+          <p:nvPr/>
+        </p:nvSpPr>
+        <p:spPr>
+          <a:xfrm>
+            <a:off x="932688" y="1307592"/>
+            <a:ext cx="4907128" cy="310896"/>
+          </a:xfrm>
+          <a:prstGeom prst="rect">
+            <a:avLst/>
+          </a:prstGeom>
+          <a:noFill/>
+          <a:ln/>
+        </p:spPr>
+        <p:txBody>
+          <a:bodyPr wrap="square" lIns="0" tIns="0" rIns="0" bIns="0" rtlCol="0" anchor="ctr"/>
+          <a:lstStyle/>
+          <a:p>
+            <a:pPr algn="l" indent="0" marL="0">
+              <a:buNone/>
+            </a:pPr>
+            <a:r>
+              <a:rPr lang="en-US" sz="1250" b="1" dirty="0">
+                <a:solidFill>
+                  <a:srgbClr val="A6650F"/>
+                </a:solidFill>
+                <a:latin typeface="Calibri" pitchFamily="34" charset="0"/>
+                <a:ea typeface="Calibri" pitchFamily="34" charset="-122"/>
+                <a:cs typeface="Calibri" pitchFamily="34" charset="-120"/>
+              </a:rPr>
+              <a:t>Calificación General Promedio</a:t>
+            </a:r>
+            <a:endParaRPr lang="en-US" sz="1250" dirty="0"/>
+          </a:p>
+        </p:txBody>
+      </p:sp>
+      <p:graphicFrame>
+        <p:nvGraphicFramePr>
+          <p:cNvPr id="13" name="Chart 0" descr=""/>
+          <p:cNvGraphicFramePr/>
+          <p:nvPr/>
+        </p:nvGraphicFramePr>
+        <p:xfrm>
+          <a:off x="2202104" y="1773936"/>
+          <a:ext cx="1984248" cy="1984248"/>
+        </p:xfrm>
+        <a:graphic xmlns:a="http://schemas.openxmlformats.org/drawingml/2006/main">
+          <a:graphicData uri="http://schemas.openxmlformats.org/drawingml/2006/chart">
+            <c:chart xmlns:c="http://schemas.openxmlformats.org/drawingml/2006/chart" r:id="rId2"/>
+          </a:graphicData>
+        </a:graphic>
+      </p:graphicFrame>
+      <p:sp>
+        <p:nvSpPr>
+          <p:cNvPr id="14" name="Text 10"/>
+          <p:cNvSpPr txBox="1"/>
+          <p:nvPr/>
+        </p:nvSpPr>
+        <p:spPr>
+          <a:xfrm>
+            <a:off x="2202104" y="2473452"/>
+            <a:ext cx="1984248" cy="365760"/>
+          </a:xfrm>
+          <a:prstGeom prst="rect">
+            <a:avLst/>
+          </a:prstGeom>
+          <a:noFill/>
+          <a:ln/>
+        </p:spPr>
+        <p:txBody>
+          <a:bodyPr wrap="square" lIns="0" tIns="0" rIns="0" bIns="0" rtlCol="0" anchor="ctr"/>
+          <a:lstStyle/>
+          <a:p>
+            <a:pPr algn="ctr" indent="0" marL="0">
+              <a:buNone/>
+            </a:pPr>
+            <a:r>
+              <a:rPr lang="en-US" sz="2400" b="1" dirty="0">
+                <a:solidFill>
+                  <a:srgbClr val="A6650F"/>
+                </a:solidFill>
+                <a:latin typeface="Calibri" pitchFamily="34" charset="0"/>
+                <a:ea typeface="Calibri" pitchFamily="34" charset="-122"/>
+                <a:cs typeface="Calibri" pitchFamily="34" charset="-120"/>
+              </a:rPr>
+              <a:t>3.82</a:t>
+            </a:r>
+            <a:endParaRPr lang="en-US" sz="2400" dirty="0"/>
+          </a:p>
+        </p:txBody>
+      </p:sp>
+      <p:sp>
+        <p:nvSpPr>
+          <p:cNvPr id="15" name="Text 11"/>
+          <p:cNvSpPr txBox="1"/>
+          <p:nvPr/>
+        </p:nvSpPr>
+        <p:spPr>
+          <a:xfrm>
+            <a:off x="2202104" y="2820924"/>
+            <a:ext cx="1984248" cy="182880"/>
+          </a:xfrm>
+          <a:prstGeom prst="rect">
+            <a:avLst/>
+          </a:prstGeom>
+          <a:noFill/>
+          <a:ln/>
+        </p:spPr>
+        <p:txBody>
+          <a:bodyPr wrap="square" lIns="0" tIns="0" rIns="0" bIns="0" rtlCol="0" anchor="ctr"/>
+          <a:lstStyle/>
+          <a:p>
+            <a:pPr algn="ctr" indent="0" marL="0">
+              <a:buNone/>
+            </a:pPr>
+            <a:r>
+              <a:rPr lang="en-US" sz="800" b="1" spc="30" kern="0" dirty="0">
+                <a:solidFill>
+                  <a:srgbClr val="5B6B82"/>
+                </a:solidFill>
+                <a:latin typeface="Calibri" pitchFamily="34" charset="0"/>
+                <a:ea typeface="Calibri" pitchFamily="34" charset="-122"/>
+                <a:cs typeface="Calibri" pitchFamily="34" charset="-120"/>
+              </a:rPr>
+              <a:t>DE 5.0</a:t>
+            </a:r>
+            <a:endParaRPr lang="en-US" sz="800" dirty="0"/>
+          </a:p>
+        </p:txBody>
+      </p:sp>
+      <p:sp>
+        <p:nvSpPr>
+          <p:cNvPr id="16" name="Shape 12"/>
+          <p:cNvSpPr/>
+          <p:nvPr/>
+        </p:nvSpPr>
+        <p:spPr>
+          <a:xfrm>
+            <a:off x="6187288" y="1170432"/>
+            <a:ext cx="5620360" cy="2660904"/>
+          </a:xfrm>
+          <a:prstGeom prst="roundRect">
+            <a:avLst>
+              <a:gd name="adj" fmla="val 2749"/>
+            </a:avLst>
+          </a:prstGeom>
+          <a:solidFill>
+            <a:srgbClr val="FFFFFF"/>
+          </a:solidFill>
+          <a:ln w="9525">
+            <a:solidFill>
+              <a:srgbClr val="E7EAF0"/>
+            </a:solidFill>
+            <a:prstDash val="solid"/>
+          </a:ln>
+          <a:effectLst>
+            <a:outerShdw sx="100000" sy="100000" kx="0" ky="0" algn="bl" rotWithShape="0" blurRad="76200" dist="19050" dir="5400000">
+              <a:srgbClr val="0F2F4E">
+                <a:alpha val="10000"/>
+              </a:srgbClr>
+            </a:outerShdw>
+          </a:effectLst>
+        </p:spPr>
+      </p:sp>
+      <p:sp>
+        <p:nvSpPr>
+          <p:cNvPr id="17" name="Shape 13"/>
+          <p:cNvSpPr/>
+          <p:nvPr/>
+        </p:nvSpPr>
+        <p:spPr>
+          <a:xfrm>
+            <a:off x="6187288" y="1170432"/>
+            <a:ext cx="5620360" cy="45720"/>
+          </a:xfrm>
+          <a:prstGeom prst="rect">
+            <a:avLst/>
+          </a:prstGeom>
+          <a:solidFill>
+            <a:srgbClr val="1E8449"/>
+          </a:solidFill>
+          <a:ln/>
+        </p:spPr>
+      </p:sp>
+      <p:sp>
+        <p:nvSpPr>
+          <p:cNvPr id="18" name="Shape 14"/>
+          <p:cNvSpPr/>
+          <p:nvPr/>
+        </p:nvSpPr>
+        <p:spPr>
+          <a:xfrm>
+            <a:off x="6351880" y="1316736"/>
+            <a:ext cx="274320" cy="274320"/>
+          </a:xfrm>
+          <a:prstGeom prst="ellipse">
+            <a:avLst/>
+          </a:prstGeom>
+          <a:solidFill>
+            <a:srgbClr val="E7F5EC"/>
+          </a:solidFill>
+          <a:ln/>
+        </p:spPr>
+      </p:sp>
+      <p:pic>
+        <p:nvPicPr>
+          <p:cNvPr id="19" name="Image 1" descr="/tmp/claude-0/-home-user-riesgo/579fb8c8-70e5-51d5-80ec-6ed51cc2e8df/scratchpad/pptx-build/icons/checkcircle_133B6C.png">    </p:cNvPr>
+          <p:cNvPicPr>
+            <a:picLocks noChangeAspect="1"/>
+          </p:cNvPicPr>
+          <p:nvPr/>
+        </p:nvPicPr>
+        <p:blipFill>
+          <a:blip r:embed="rId3"/>
+          <a:stretch>
+            <a:fillRect/>
+          </a:stretch>
+        </p:blipFill>
+        <p:spPr>
+          <a:xfrm>
+            <a:off x="6406744" y="1371600"/>
+            <a:ext cx="164592" cy="164592"/>
+          </a:xfrm>
+          <a:prstGeom prst="rect">
+            <a:avLst/>
+          </a:prstGeom>
+        </p:spPr>
+      </p:pic>
+      <p:sp>
+        <p:nvSpPr>
+          <p:cNvPr id="20" name="Text 15"/>
+          <p:cNvSpPr txBox="1"/>
+          <p:nvPr/>
+        </p:nvSpPr>
+        <p:spPr>
+          <a:xfrm>
+            <a:off x="6735928" y="1307592"/>
+            <a:ext cx="4907128" cy="310896"/>
+          </a:xfrm>
+          <a:prstGeom prst="rect">
+            <a:avLst/>
+          </a:prstGeom>
+          <a:noFill/>
+          <a:ln/>
+        </p:spPr>
+        <p:txBody>
+          <a:bodyPr wrap="square" lIns="0" tIns="0" rIns="0" bIns="0" rtlCol="0" anchor="ctr"/>
+          <a:lstStyle/>
+          <a:p>
+            <a:pPr algn="l" indent="0" marL="0">
+              <a:buNone/>
+            </a:pPr>
+            <a:r>
+              <a:rPr lang="en-US" sz="1250" b="1" dirty="0">
+                <a:solidFill>
+                  <a:srgbClr val="1E8449"/>
+                </a:solidFill>
+                <a:latin typeface="Calibri" pitchFamily="34" charset="0"/>
+                <a:ea typeface="Calibri" pitchFamily="34" charset="-122"/>
+                <a:cs typeface="Calibri" pitchFamily="34" charset="-120"/>
+              </a:rPr>
+              <a:t>Calificaciones Favorables</a:t>
+            </a:r>
+            <a:endParaRPr lang="en-US" sz="1250" dirty="0"/>
+          </a:p>
+        </p:txBody>
+      </p:sp>
+      <p:graphicFrame>
+        <p:nvGraphicFramePr>
+          <p:cNvPr id="21" name="Chart 1" descr=""/>
+          <p:cNvGraphicFramePr/>
+          <p:nvPr/>
+        </p:nvGraphicFramePr>
+        <p:xfrm>
+          <a:off x="8005343" y="1773936"/>
+          <a:ext cx="1984248" cy="1984248"/>
+        </p:xfrm>
+        <a:graphic xmlns:a="http://schemas.openxmlformats.org/drawingml/2006/main">
+          <a:graphicData uri="http://schemas.openxmlformats.org/drawingml/2006/chart">
+            <c:chart xmlns:c="http://schemas.openxmlformats.org/drawingml/2006/chart" r:id="rId4"/>
+          </a:graphicData>
+        </a:graphic>
+      </p:graphicFrame>
+      <p:sp>
+        <p:nvSpPr>
+          <p:cNvPr id="22" name="Text 16"/>
+          <p:cNvSpPr txBox="1"/>
+          <p:nvPr/>
+        </p:nvSpPr>
+        <p:spPr>
+          <a:xfrm>
+            <a:off x="8005343" y="2473452"/>
+            <a:ext cx="1984248" cy="365760"/>
+          </a:xfrm>
+          <a:prstGeom prst="rect">
+            <a:avLst/>
+          </a:prstGeom>
+          <a:noFill/>
+          <a:ln/>
+        </p:spPr>
+        <p:txBody>
+          <a:bodyPr wrap="square" lIns="0" tIns="0" rIns="0" bIns="0" rtlCol="0" anchor="ctr"/>
+          <a:lstStyle/>
+          <a:p>
+            <a:pPr algn="ctr" indent="0" marL="0">
+              <a:buNone/>
+            </a:pPr>
+            <a:r>
+              <a:rPr lang="en-US" sz="2400" b="1" dirty="0">
+                <a:solidFill>
+                  <a:srgbClr val="1E8449"/>
+                </a:solidFill>
+                <a:latin typeface="Calibri" pitchFamily="34" charset="0"/>
+                <a:ea typeface="Calibri" pitchFamily="34" charset="-122"/>
+                <a:cs typeface="Calibri" pitchFamily="34" charset="-120"/>
+              </a:rPr>
+              <a:t>88%</a:t>
+            </a:r>
+            <a:endParaRPr lang="en-US" sz="2400" dirty="0"/>
+          </a:p>
+        </p:txBody>
+      </p:sp>
+      <p:sp>
+        <p:nvSpPr>
+          <p:cNvPr id="23" name="Text 17"/>
+          <p:cNvSpPr txBox="1"/>
+          <p:nvPr/>
+        </p:nvSpPr>
+        <p:spPr>
+          <a:xfrm>
+            <a:off x="8005343" y="2820924"/>
+            <a:ext cx="1984248" cy="182880"/>
+          </a:xfrm>
+          <a:prstGeom prst="rect">
+            <a:avLst/>
+          </a:prstGeom>
+          <a:noFill/>
+          <a:ln/>
+        </p:spPr>
+        <p:txBody>
+          <a:bodyPr wrap="square" lIns="0" tIns="0" rIns="0" bIns="0" rtlCol="0" anchor="ctr"/>
+          <a:lstStyle/>
+          <a:p>
+            <a:pPr algn="ctr" indent="0" marL="0">
+              <a:buNone/>
+            </a:pPr>
+            <a:r>
+              <a:rPr lang="en-US" sz="800" b="1" spc="30" kern="0" dirty="0">
+                <a:solidFill>
+                  <a:srgbClr val="5B6B82"/>
+                </a:solidFill>
+                <a:latin typeface="Calibri" pitchFamily="34" charset="0"/>
+                <a:ea typeface="Calibri" pitchFamily="34" charset="-122"/>
+                <a:cs typeface="Calibri" pitchFamily="34" charset="-120"/>
+              </a:rPr>
+              <a:t>DE LAS AGENCIAS</a:t>
+            </a:r>
+            <a:endParaRPr lang="en-US" sz="800" dirty="0"/>
+          </a:p>
+        </p:txBody>
+      </p:sp>
+      <p:sp>
+        <p:nvSpPr>
+          <p:cNvPr id="24" name="Shape 18"/>
+          <p:cNvSpPr/>
+          <p:nvPr/>
+        </p:nvSpPr>
+        <p:spPr>
+          <a:xfrm>
+            <a:off x="384048" y="4014216"/>
+            <a:ext cx="5620360" cy="2660904"/>
+          </a:xfrm>
+          <a:prstGeom prst="roundRect">
+            <a:avLst>
+              <a:gd name="adj" fmla="val 2749"/>
+            </a:avLst>
+          </a:prstGeom>
+          <a:solidFill>
+            <a:srgbClr val="FFFFFF"/>
+          </a:solidFill>
+          <a:ln w="9525">
+            <a:solidFill>
+              <a:srgbClr val="E7EAF0"/>
+            </a:solidFill>
+            <a:prstDash val="solid"/>
+          </a:ln>
+          <a:effectLst>
+            <a:outerShdw sx="100000" sy="100000" kx="0" ky="0" algn="bl" rotWithShape="0" blurRad="76200" dist="19050" dir="5400000">
+              <a:srgbClr val="0F2F4E">
+                <a:alpha val="10000"/>
+              </a:srgbClr>
+            </a:outerShdw>
+          </a:effectLst>
+        </p:spPr>
+      </p:sp>
+      <p:sp>
+        <p:nvSpPr>
+          <p:cNvPr id="25" name="Shape 19"/>
+          <p:cNvSpPr/>
+          <p:nvPr/>
+        </p:nvSpPr>
+        <p:spPr>
+          <a:xfrm>
+            <a:off x="384048" y="4014216"/>
+            <a:ext cx="5620360" cy="45720"/>
+          </a:xfrm>
+          <a:prstGeom prst="rect">
+            <a:avLst/>
+          </a:prstGeom>
+          <a:solidFill>
+            <a:srgbClr val="133B6C"/>
+          </a:solidFill>
+          <a:ln/>
+        </p:spPr>
+      </p:sp>
+      <p:sp>
+        <p:nvSpPr>
+          <p:cNvPr id="26" name="Shape 20"/>
+          <p:cNvSpPr/>
+          <p:nvPr/>
+        </p:nvSpPr>
+        <p:spPr>
+          <a:xfrm>
+            <a:off x="548640" y="4160520"/>
+            <a:ext cx="274320" cy="274320"/>
+          </a:xfrm>
+          <a:prstGeom prst="ellipse">
+            <a:avLst/>
+          </a:prstGeom>
+          <a:solidFill>
+            <a:srgbClr val="E8F1FA"/>
+          </a:solidFill>
+          <a:ln/>
+        </p:spPr>
+      </p:sp>
+      <p:pic>
+        <p:nvPicPr>
+          <p:cNvPr id="27" name="Image 2" descr="/tmp/claude-0/-home-user-riesgo/579fb8c8-70e5-51d5-80ec-6ed51cc2e8df/scratchpad/pptx-build/icons/flag_133B6C.png">    </p:cNvPr>
+          <p:cNvPicPr>
+            <a:picLocks noChangeAspect="1"/>
+          </p:cNvPicPr>
+          <p:nvPr/>
+        </p:nvPicPr>
+        <p:blipFill>
+          <a:blip r:embed="rId5"/>
+          <a:stretch>
+            <a:fillRect/>
+          </a:stretch>
+        </p:blipFill>
+        <p:spPr>
+          <a:xfrm>
+            <a:off x="603504" y="4215384"/>
+            <a:ext cx="164592" cy="164592"/>
+          </a:xfrm>
+          <a:prstGeom prst="rect">
+            <a:avLst/>
+          </a:prstGeom>
+        </p:spPr>
+      </p:pic>
+      <p:sp>
+        <p:nvSpPr>
+          <p:cNvPr id="28" name="Text 21"/>
+          <p:cNvSpPr txBox="1"/>
+          <p:nvPr/>
+        </p:nvSpPr>
+        <p:spPr>
+          <a:xfrm>
+            <a:off x="932688" y="4151376"/>
+            <a:ext cx="4907128" cy="310896"/>
+          </a:xfrm>
+          <a:prstGeom prst="rect">
+            <a:avLst/>
+          </a:prstGeom>
+          <a:noFill/>
+          <a:ln/>
+        </p:spPr>
+        <p:txBody>
+          <a:bodyPr wrap="square" lIns="0" tIns="0" rIns="0" bIns="0" rtlCol="0" anchor="ctr"/>
+          <a:lstStyle/>
+          <a:p>
+            <a:pPr algn="l" indent="0" marL="0">
+              <a:buNone/>
+            </a:pPr>
+            <a:r>
+              <a:rPr lang="en-US" sz="1250" b="1" dirty="0">
+                <a:solidFill>
+                  <a:srgbClr val="133B6C"/>
+                </a:solidFill>
+                <a:latin typeface="Calibri" pitchFamily="34" charset="0"/>
+                <a:ea typeface="Calibri" pitchFamily="34" charset="-122"/>
+                <a:cs typeface="Calibri" pitchFamily="34" charset="-120"/>
+              </a:rPr>
+              <a:t>Oportunidades de Mejora por Prioridad</a:t>
+            </a:r>
+            <a:endParaRPr lang="en-US" sz="1250" dirty="0"/>
+          </a:p>
+        </p:txBody>
+      </p:sp>
+      <p:graphicFrame>
+        <p:nvGraphicFramePr>
+          <p:cNvPr id="29" name="Chart 2" descr=""/>
+          <p:cNvGraphicFramePr/>
+          <p:nvPr/>
+        </p:nvGraphicFramePr>
+        <p:xfrm>
+          <a:off x="548640" y="4617720"/>
+          <a:ext cx="5291176" cy="1929384"/>
+        </p:xfrm>
+        <a:graphic xmlns:a="http://schemas.openxmlformats.org/drawingml/2006/main">
+          <a:graphicData uri="http://schemas.openxmlformats.org/drawingml/2006/chart">
+            <c:chart xmlns:c="http://schemas.openxmlformats.org/drawingml/2006/chart" r:id="rId6"/>
+          </a:graphicData>
+        </a:graphic>
+      </p:graphicFrame>
+      <p:sp>
+        <p:nvSpPr>
+          <p:cNvPr id="30" name="Shape 22"/>
+          <p:cNvSpPr/>
+          <p:nvPr/>
+        </p:nvSpPr>
+        <p:spPr>
+          <a:xfrm>
+            <a:off x="6187288" y="4014216"/>
+            <a:ext cx="5620360" cy="2660904"/>
+          </a:xfrm>
+          <a:prstGeom prst="roundRect">
+            <a:avLst>
+              <a:gd name="adj" fmla="val 2749"/>
+            </a:avLst>
+          </a:prstGeom>
+          <a:solidFill>
+            <a:srgbClr val="FFFFFF"/>
+          </a:solidFill>
+          <a:ln w="9525">
+            <a:solidFill>
+              <a:srgbClr val="E7EAF0"/>
+            </a:solidFill>
+            <a:prstDash val="solid"/>
+          </a:ln>
+          <a:effectLst>
+            <a:outerShdw sx="100000" sy="100000" kx="0" ky="0" algn="bl" rotWithShape="0" blurRad="76200" dist="19050" dir="5400000">
+              <a:srgbClr val="0F2F4E">
+                <a:alpha val="10000"/>
+              </a:srgbClr>
+            </a:outerShdw>
+          </a:effectLst>
+        </p:spPr>
+      </p:sp>
+      <p:sp>
+        <p:nvSpPr>
+          <p:cNvPr id="31" name="Shape 23"/>
+          <p:cNvSpPr/>
+          <p:nvPr/>
+        </p:nvSpPr>
+        <p:spPr>
+          <a:xfrm>
+            <a:off x="6187288" y="4014216"/>
+            <a:ext cx="5620360" cy="45720"/>
+          </a:xfrm>
+          <a:prstGeom prst="rect">
+            <a:avLst/>
+          </a:prstGeom>
+          <a:solidFill>
+            <a:srgbClr val="1B4F91"/>
+          </a:solidFill>
+          <a:ln/>
+        </p:spPr>
+      </p:sp>
+      <p:sp>
+        <p:nvSpPr>
+          <p:cNvPr id="32" name="Shape 24"/>
+          <p:cNvSpPr/>
+          <p:nvPr/>
+        </p:nvSpPr>
+        <p:spPr>
+          <a:xfrm>
+            <a:off x="6351880" y="4160520"/>
+            <a:ext cx="274320" cy="274320"/>
+          </a:xfrm>
+          <a:prstGeom prst="ellipse">
+            <a:avLst/>
+          </a:prstGeom>
+          <a:solidFill>
+            <a:srgbClr val="EAF0F8"/>
+          </a:solidFill>
+          <a:ln/>
+        </p:spPr>
+      </p:sp>
+      <p:pic>
+        <p:nvPicPr>
+          <p:cNvPr id="33" name="Image 3" descr="/tmp/claude-0/-home-user-riesgo/579fb8c8-70e5-51d5-80ec-6ed51cc2e8df/scratchpad/pptx-build/icons/thumbsup_1E8449.png">    </p:cNvPr>
+          <p:cNvPicPr>
+            <a:picLocks noChangeAspect="1"/>
+          </p:cNvPicPr>
+          <p:nvPr/>
+        </p:nvPicPr>
+        <p:blipFill>
+          <a:blip r:embed="rId7"/>
+          <a:stretch>
+            <a:fillRect/>
+          </a:stretch>
+        </p:blipFill>
+        <p:spPr>
+          <a:xfrm>
+            <a:off x="6406744" y="4215384"/>
+            <a:ext cx="164592" cy="164592"/>
+          </a:xfrm>
+          <a:prstGeom prst="rect">
+            <a:avLst/>
+          </a:prstGeom>
+        </p:spPr>
+      </p:pic>
+      <p:sp>
+        <p:nvSpPr>
+          <p:cNvPr id="34" name="Text 25"/>
+          <p:cNvSpPr txBox="1"/>
+          <p:nvPr/>
+        </p:nvSpPr>
+        <p:spPr>
+          <a:xfrm>
+            <a:off x="6735928" y="4151376"/>
+            <a:ext cx="4907128" cy="310896"/>
+          </a:xfrm>
+          <a:prstGeom prst="rect">
+            <a:avLst/>
+          </a:prstGeom>
+          <a:noFill/>
+          <a:ln/>
+        </p:spPr>
+        <p:txBody>
+          <a:bodyPr wrap="square" lIns="0" tIns="0" rIns="0" bIns="0" rtlCol="0" anchor="ctr"/>
+          <a:lstStyle/>
+          <a:p>
+            <a:pPr algn="l" indent="0" marL="0">
+              <a:buNone/>
+            </a:pPr>
+            <a:r>
+              <a:rPr lang="en-US" sz="1250" b="1" dirty="0">
+                <a:solidFill>
+                  <a:srgbClr val="1B4F91"/>
+                </a:solidFill>
+                <a:latin typeface="Calibri" pitchFamily="34" charset="0"/>
+                <a:ea typeface="Calibri" pitchFamily="34" charset="-122"/>
+                <a:cs typeface="Calibri" pitchFamily="34" charset="-120"/>
+              </a:rPr>
+              <a:t>Balance del Servicio: Fortalezas vs. Oportunidades</a:t>
+            </a:r>
+            <a:endParaRPr lang="en-US" sz="1250" dirty="0"/>
+          </a:p>
+        </p:txBody>
+      </p:sp>
+      <p:graphicFrame>
+        <p:nvGraphicFramePr>
+          <p:cNvPr id="35" name="Chart 3" descr=""/>
+          <p:cNvGraphicFramePr/>
+          <p:nvPr/>
+        </p:nvGraphicFramePr>
+        <p:xfrm>
+          <a:off x="6351880" y="4617720"/>
+          <a:ext cx="5291176" cy="1929384"/>
+        </p:xfrm>
+        <a:graphic xmlns:a="http://schemas.openxmlformats.org/drawingml/2006/main">
+          <a:graphicData uri="http://schemas.openxmlformats.org/drawingml/2006/chart">
+            <c:chart xmlns:c="http://schemas.openxmlformats.org/drawingml/2006/chart" r:id="rId8"/>
+          </a:graphicData>
+        </a:graphic>
+      </p:graphicFrame>
+    </p:spTree>
+  </p:cSld>
+  <p:clrMapOvr>
+    <a:masterClrMapping/>
+  </p:clrMapOvr>
+</p:sld>
+</file>
+
 <file path=ppt/theme/theme1.xml><?xml version="1.0" encoding="utf-8"?>
 <a:theme xmlns:a="http://schemas.openxmlformats.org/drawingml/2006/main" name="Office Theme">
   <a:themeElements>

</xml_diff>